<commit_message>
Rebuild deck from full competitor differentiation history
Incorporate Cursor vs Copilot/Claude Code/Windsurf/Codex/shadow-AI
framing, enterprise value buckets, customer proof pointers, and
official workflow/context/execution positioning while keeping
verbatim speaker notes on all 21 slides.

Co-authored-by: dempseli01-stack <dempseli01-stack@users.noreply.github.com>
</commit_message>
<xml_diff>
--- a/Lindsey_Presentation.pptx
+++ b/Lindsey_Presentation.pptx
@@ -5388,8 +5388,8 @@
         </p:nvSpPr>
         <p:spPr>
           <a:xfrm>
-            <a:off x="0" y="5349240"/>
-            <a:ext cx="12191695" cy="1508760"/>
+            <a:off x="0" y="5212080"/>
+            <a:ext cx="12191695" cy="1645920"/>
           </a:xfrm>
           <a:prstGeom prst="rect">
             <a:avLst/>
@@ -5431,7 +5431,7 @@
         </p:nvSpPr>
         <p:spPr>
           <a:xfrm>
-            <a:off x="822960" y="2011680"/>
+            <a:off x="777240" y="1691640"/>
             <a:ext cx="1371600" cy="73152"/>
           </a:xfrm>
           <a:prstGeom prst="rect">
@@ -5474,8 +5474,8 @@
         </p:nvSpPr>
         <p:spPr>
           <a:xfrm>
-            <a:off x="822960" y="2194560"/>
-            <a:ext cx="10515600" cy="1097280"/>
+            <a:off x="777240" y="1920240"/>
+            <a:ext cx="10515600" cy="914400"/>
           </a:xfrm>
           <a:prstGeom prst="rect">
             <a:avLst/>
@@ -5490,13 +5490,13 @@
           <a:p>
             <a:pPr algn="l"/>
             <a:r>
-              <a:rPr sz="3800" b="1">
+              <a:rPr sz="4200" b="1">
                 <a:solidFill>
                   <a:srgbClr val="FFFFFF"/>
                 </a:solidFill>
                 <a:latin typeface="Georgia"/>
               </a:rPr>
-              <a:t>Up-leveling the EMEA SDR machine</a:t>
+              <a:t>Up-Level the Machine</a:t>
             </a:r>
           </a:p>
         </p:txBody>
@@ -5509,8 +5509,8 @@
         </p:nvSpPr>
         <p:spPr>
           <a:xfrm>
-            <a:off x="822960" y="3383280"/>
-            <a:ext cx="10058400" cy="640080"/>
+            <a:off x="777240" y="2926080"/>
+            <a:ext cx="10515600" cy="457200"/>
           </a:xfrm>
           <a:prstGeom prst="rect">
             <a:avLst/>
@@ -5527,11 +5527,11 @@
             <a:r>
               <a:rPr sz="2200" b="0">
                 <a:solidFill>
-                  <a:srgbClr val="E8EAE4"/>
+                  <a:srgbClr val="D6F26A"/>
                 </a:solidFill>
                 <a:latin typeface="Calibri"/>
               </a:rPr>
-              <a:t>Diagnose  ·  Protect  ·  Experiment  ·  Execute</a:t>
+              <a:t>Diagnose  →  Protect  →  Experiment  →  Execute</a:t>
             </a:r>
           </a:p>
         </p:txBody>
@@ -5544,8 +5544,8 @@
         </p:nvSpPr>
         <p:spPr>
           <a:xfrm>
-            <a:off x="822960" y="5715000"/>
-            <a:ext cx="10058400" cy="365760"/>
+            <a:off x="777240" y="3520440"/>
+            <a:ext cx="10515600" cy="457200"/>
           </a:xfrm>
           <a:prstGeom prst="rect">
             <a:avLst/>
@@ -5560,13 +5560,83 @@
           <a:p>
             <a:pPr algn="l"/>
             <a:r>
-              <a:rPr sz="1600" b="0">
-                <a:solidFill>
-                  <a:srgbClr val="F4F5F2"/>
+              <a:rPr sz="1800" b="0">
+                <a:solidFill>
+                  <a:srgbClr val="E8EAE4"/>
                 </a:solidFill>
                 <a:latin typeface="Calibri"/>
               </a:rPr>
-              <a:t>Lindsey Dempsey  ·  Player-coach interview</a:t>
+              <a:t>Player-coach plan for a high-performing EMEA SDR org</a:t>
+            </a:r>
+          </a:p>
+        </p:txBody>
+      </p:sp>
+      <p:sp>
+        <p:nvSpPr>
+          <p:cNvPr id="8" name="TextBox 7"/>
+          <p:cNvSpPr txBox="1"/>
+          <p:nvPr/>
+        </p:nvSpPr>
+        <p:spPr>
+          <a:xfrm>
+            <a:off x="777240" y="5577840"/>
+            <a:ext cx="10515600" cy="365760"/>
+          </a:xfrm>
+          <a:prstGeom prst="rect">
+            <a:avLst/>
+          </a:prstGeom>
+          <a:noFill/>
+        </p:spPr>
+        <p:txBody>
+          <a:bodyPr wrap="square" anchor="t">
+            <a:spAutoFit/>
+          </a:bodyPr>
+          <a:lstStyle/>
+          <a:p>
+            <a:pPr algn="l"/>
+            <a:r>
+              <a:rPr sz="1800" b="1">
+                <a:solidFill>
+                  <a:srgbClr val="FFFFFF"/>
+                </a:solidFill>
+                <a:latin typeface="Georgia"/>
+              </a:rPr>
+              <a:t>Lindsey Dempsey  ·  EMEA SDR Leader Candidate</a:t>
+            </a:r>
+          </a:p>
+        </p:txBody>
+      </p:sp>
+      <p:sp>
+        <p:nvSpPr>
+          <p:cNvPr id="9" name="TextBox 8"/>
+          <p:cNvSpPr txBox="1"/>
+          <p:nvPr/>
+        </p:nvSpPr>
+        <p:spPr>
+          <a:xfrm>
+            <a:off x="777240" y="5989320"/>
+            <a:ext cx="10515600" cy="320040"/>
+          </a:xfrm>
+          <a:prstGeom prst="rect">
+            <a:avLst/>
+          </a:prstGeom>
+          <a:noFill/>
+        </p:spPr>
+        <p:txBody>
+          <a:bodyPr wrap="square" anchor="t">
+            <a:spAutoFit/>
+          </a:bodyPr>
+          <a:lstStyle/>
+          <a:p>
+            <a:pPr algn="l"/>
+            <a:r>
+              <a:rPr sz="1400" b="0">
+                <a:solidFill>
+                  <a:srgbClr val="E8EAE4"/>
+                </a:solidFill>
+                <a:latin typeface="Calibri"/>
+              </a:rPr>
+              <a:t>Cursor wins on workflow · context · execution</a:t>
             </a:r>
           </a:p>
         </p:txBody>
@@ -5641,7 +5711,7 @@
         <p:spPr>
           <a:xfrm>
             <a:off x="0" y="0"/>
-            <a:ext cx="12191695" cy="1143000"/>
+            <a:ext cx="12191695" cy="1097280"/>
           </a:xfrm>
           <a:prstGeom prst="rect">
             <a:avLst/>
@@ -5683,8 +5753,8 @@
         </p:nvSpPr>
         <p:spPr>
           <a:xfrm>
-            <a:off x="777240" y="320040"/>
-            <a:ext cx="10515600" cy="594360"/>
+            <a:off x="731520" y="292608"/>
+            <a:ext cx="10698480" cy="548640"/>
           </a:xfrm>
           <a:prstGeom prst="rect">
             <a:avLst/>
@@ -5699,7 +5769,7 @@
           <a:p>
             <a:pPr algn="l"/>
             <a:r>
-              <a:rPr sz="2600" b="1">
+              <a:rPr sz="2400" b="1">
                 <a:solidFill>
                   <a:srgbClr val="FFFFFF"/>
                 </a:solidFill>
@@ -5718,8 +5788,8 @@
         </p:nvSpPr>
         <p:spPr>
           <a:xfrm>
-            <a:off x="640080" y="1417320"/>
-            <a:ext cx="5257800" cy="2148840"/>
+            <a:off x="594360" y="1325880"/>
+            <a:ext cx="5349240" cy="2148840"/>
           </a:xfrm>
           <a:prstGeom prst="rect">
             <a:avLst/>
@@ -5761,8 +5831,8 @@
         </p:nvSpPr>
         <p:spPr>
           <a:xfrm>
-            <a:off x="914400" y="1691640"/>
-            <a:ext cx="731520" cy="73152"/>
+            <a:off x="822960" y="1554480"/>
+            <a:ext cx="685800" cy="73152"/>
           </a:xfrm>
           <a:prstGeom prst="rect">
             <a:avLst/>
@@ -5804,8 +5874,8 @@
         </p:nvSpPr>
         <p:spPr>
           <a:xfrm>
-            <a:off x="914400" y="1874520"/>
-            <a:ext cx="914400" cy="320040"/>
+            <a:off x="822960" y="1737360"/>
+            <a:ext cx="822960" cy="320040"/>
           </a:xfrm>
           <a:prstGeom prst="rect">
             <a:avLst/>
@@ -5839,8 +5909,8 @@
         </p:nvSpPr>
         <p:spPr>
           <a:xfrm>
-            <a:off x="1737360" y="1874520"/>
-            <a:ext cx="3749039" cy="320040"/>
+            <a:off x="1645920" y="1737360"/>
+            <a:ext cx="3931920" cy="320040"/>
           </a:xfrm>
           <a:prstGeom prst="rect">
             <a:avLst/>
@@ -5855,7 +5925,7 @@
           <a:p>
             <a:pPr algn="l"/>
             <a:r>
-              <a:rPr sz="1800" b="1">
+              <a:rPr sz="1600" b="1">
                 <a:solidFill>
                   <a:srgbClr val="141618"/>
                 </a:solidFill>
@@ -5874,8 +5944,8 @@
         </p:nvSpPr>
         <p:spPr>
           <a:xfrm>
-            <a:off x="914400" y="2423160"/>
-            <a:ext cx="4663440" cy="868680"/>
+            <a:off x="822960" y="2286000"/>
+            <a:ext cx="4846320" cy="914400"/>
           </a:xfrm>
           <a:prstGeom prst="rect">
             <a:avLst/>
@@ -5890,13 +5960,13 @@
           <a:p>
             <a:pPr algn="l"/>
             <a:r>
-              <a:rPr sz="1500" b="0">
+              <a:rPr sz="1400" b="0">
                 <a:solidFill>
                   <a:srgbClr val="5E646B"/>
                 </a:solidFill>
                 <a:latin typeface="Calibri"/>
               </a:rPr>
-              <a:t>Best model changes. Buyers want flexibility — not single-vendor lock-in.</a:t>
+              <a:t>Best model changes. Flexibility over single-vendor lock-in. Labs can be suppliers and competitors.</a:t>
             </a:r>
           </a:p>
         </p:txBody>
@@ -5909,8 +5979,8 @@
         </p:nvSpPr>
         <p:spPr>
           <a:xfrm>
-            <a:off x="6263640" y="1417320"/>
-            <a:ext cx="5257800" cy="2148840"/>
+            <a:off x="6217920" y="1325880"/>
+            <a:ext cx="5349240" cy="2148840"/>
           </a:xfrm>
           <a:prstGeom prst="rect">
             <a:avLst/>
@@ -5952,8 +6022,8 @@
         </p:nvSpPr>
         <p:spPr>
           <a:xfrm>
-            <a:off x="6537960" y="1691640"/>
-            <a:ext cx="731520" cy="73152"/>
+            <a:off x="6446520" y="1554480"/>
+            <a:ext cx="685800" cy="73152"/>
           </a:xfrm>
           <a:prstGeom prst="rect">
             <a:avLst/>
@@ -5995,8 +6065,8 @@
         </p:nvSpPr>
         <p:spPr>
           <a:xfrm>
-            <a:off x="6537960" y="1874520"/>
-            <a:ext cx="914400" cy="320040"/>
+            <a:off x="6446520" y="1737360"/>
+            <a:ext cx="822960" cy="320040"/>
           </a:xfrm>
           <a:prstGeom prst="rect">
             <a:avLst/>
@@ -6030,8 +6100,8 @@
         </p:nvSpPr>
         <p:spPr>
           <a:xfrm>
-            <a:off x="7360920" y="1874520"/>
-            <a:ext cx="3749039" cy="320040"/>
+            <a:off x="7269480" y="1737360"/>
+            <a:ext cx="3931920" cy="320040"/>
           </a:xfrm>
           <a:prstGeom prst="rect">
             <a:avLst/>
@@ -6046,13 +6116,13 @@
           <a:p>
             <a:pPr algn="l"/>
             <a:r>
-              <a:rPr sz="1800" b="1">
+              <a:rPr sz="1600" b="1">
                 <a:solidFill>
                   <a:srgbClr val="141618"/>
                 </a:solidFill>
                 <a:latin typeface="Georgia"/>
               </a:rPr>
-              <a:t>Large codebase performance</a:t>
+              <a:t>Large codebase / harness</a:t>
             </a:r>
           </a:p>
         </p:txBody>
@@ -6065,8 +6135,8 @@
         </p:nvSpPr>
         <p:spPr>
           <a:xfrm>
-            <a:off x="6537960" y="2423160"/>
-            <a:ext cx="4663440" cy="868680"/>
+            <a:off x="6446520" y="2286000"/>
+            <a:ext cx="4846320" cy="914400"/>
           </a:xfrm>
           <a:prstGeom prst="rect">
             <a:avLst/>
@@ -6081,13 +6151,13 @@
           <a:p>
             <a:pPr algn="l"/>
             <a:r>
-              <a:rPr sz="1500" b="0">
+              <a:rPr sz="1400" b="0">
                 <a:solidFill>
                   <a:srgbClr val="5E646B"/>
                 </a:solidFill>
                 <a:latin typeface="Calibri"/>
               </a:rPr>
-              <a:t>Messy enterprise repos. Better finding + using context — not just wrapping a model.</a:t>
+              <a:t>Not just wrapping a model — better finding + using context in messy enterprise repos.</a:t>
             </a:r>
           </a:p>
         </p:txBody>
@@ -6100,8 +6170,8 @@
         </p:nvSpPr>
         <p:spPr>
           <a:xfrm>
-            <a:off x="640080" y="3794760"/>
-            <a:ext cx="5257800" cy="2148840"/>
+            <a:off x="594360" y="3703320"/>
+            <a:ext cx="5349240" cy="2148840"/>
           </a:xfrm>
           <a:prstGeom prst="rect">
             <a:avLst/>
@@ -6143,8 +6213,8 @@
         </p:nvSpPr>
         <p:spPr>
           <a:xfrm>
-            <a:off x="914400" y="4069080"/>
-            <a:ext cx="731520" cy="73152"/>
+            <a:off x="822960" y="3931920"/>
+            <a:ext cx="685800" cy="73152"/>
           </a:xfrm>
           <a:prstGeom prst="rect">
             <a:avLst/>
@@ -6186,8 +6256,8 @@
         </p:nvSpPr>
         <p:spPr>
           <a:xfrm>
-            <a:off x="914400" y="4251960"/>
-            <a:ext cx="914400" cy="320040"/>
+            <a:off x="822960" y="4114800"/>
+            <a:ext cx="822960" cy="320040"/>
           </a:xfrm>
           <a:prstGeom prst="rect">
             <a:avLst/>
@@ -6221,8 +6291,8 @@
         </p:nvSpPr>
         <p:spPr>
           <a:xfrm>
-            <a:off x="1737360" y="4251960"/>
-            <a:ext cx="3749039" cy="320040"/>
+            <a:off x="1645920" y="4114800"/>
+            <a:ext cx="3931920" cy="320040"/>
           </a:xfrm>
           <a:prstGeom prst="rect">
             <a:avLst/>
@@ -6237,7 +6307,7 @@
           <a:p>
             <a:pPr algn="l"/>
             <a:r>
-              <a:rPr sz="1800" b="1">
+              <a:rPr sz="1600" b="1">
                 <a:solidFill>
                   <a:srgbClr val="141618"/>
                 </a:solidFill>
@@ -6256,8 +6326,8 @@
         </p:nvSpPr>
         <p:spPr>
           <a:xfrm>
-            <a:off x="914400" y="4800600"/>
-            <a:ext cx="4663440" cy="868680"/>
+            <a:off x="822960" y="4663440"/>
+            <a:ext cx="4846320" cy="914400"/>
           </a:xfrm>
           <a:prstGeom prst="rect">
             <a:avLst/>
@@ -6272,7 +6342,7 @@
           <a:p>
             <a:pPr algn="l"/>
             <a:r>
-              <a:rPr sz="1500" b="0">
+              <a:rPr sz="1400" b="0">
                 <a:solidFill>
                   <a:srgbClr val="5E646B"/>
                 </a:solidFill>
@@ -6291,8 +6361,8 @@
         </p:nvSpPr>
         <p:spPr>
           <a:xfrm>
-            <a:off x="6263640" y="3794760"/>
-            <a:ext cx="5257800" cy="2148840"/>
+            <a:off x="6217920" y="3703320"/>
+            <a:ext cx="5349240" cy="2148840"/>
           </a:xfrm>
           <a:prstGeom prst="rect">
             <a:avLst/>
@@ -6334,8 +6404,8 @@
         </p:nvSpPr>
         <p:spPr>
           <a:xfrm>
-            <a:off x="6537960" y="4069080"/>
-            <a:ext cx="731520" cy="73152"/>
+            <a:off x="6446520" y="3931920"/>
+            <a:ext cx="685800" cy="73152"/>
           </a:xfrm>
           <a:prstGeom prst="rect">
             <a:avLst/>
@@ -6377,8 +6447,8 @@
         </p:nvSpPr>
         <p:spPr>
           <a:xfrm>
-            <a:off x="6537960" y="4251960"/>
-            <a:ext cx="914400" cy="320040"/>
+            <a:off x="6446520" y="4114800"/>
+            <a:ext cx="822960" cy="320040"/>
           </a:xfrm>
           <a:prstGeom prst="rect">
             <a:avLst/>
@@ -6412,8 +6482,8 @@
         </p:nvSpPr>
         <p:spPr>
           <a:xfrm>
-            <a:off x="7360920" y="4251960"/>
-            <a:ext cx="3749039" cy="320040"/>
+            <a:off x="7269480" y="4114800"/>
+            <a:ext cx="3931920" cy="320040"/>
           </a:xfrm>
           <a:prstGeom prst="rect">
             <a:avLst/>
@@ -6428,7 +6498,7 @@
           <a:p>
             <a:pPr algn="l"/>
             <a:r>
-              <a:rPr sz="1800" b="1">
+              <a:rPr sz="1600" b="1">
                 <a:solidFill>
                   <a:srgbClr val="141618"/>
                 </a:solidFill>
@@ -6447,8 +6517,8 @@
         </p:nvSpPr>
         <p:spPr>
           <a:xfrm>
-            <a:off x="6537960" y="4800600"/>
-            <a:ext cx="4663440" cy="868680"/>
+            <a:off x="6446520" y="4663440"/>
+            <a:ext cx="4846320" cy="914400"/>
           </a:xfrm>
           <a:prstGeom prst="rect">
             <a:avLst/>
@@ -6463,7 +6533,7 @@
           <a:p>
             <a:pPr algn="l"/>
             <a:r>
-              <a:rPr sz="1500" b="0">
+              <a:rPr sz="1400" b="0">
                 <a:solidFill>
                   <a:srgbClr val="5E646B"/>
                 </a:solidFill>
@@ -6544,7 +6614,7 @@
         <p:spPr>
           <a:xfrm>
             <a:off x="0" y="0"/>
-            <a:ext cx="12191695" cy="1143000"/>
+            <a:ext cx="12191695" cy="1097280"/>
           </a:xfrm>
           <a:prstGeom prst="rect">
             <a:avLst/>
@@ -6586,8 +6656,8 @@
         </p:nvSpPr>
         <p:spPr>
           <a:xfrm>
-            <a:off x="777240" y="320040"/>
-            <a:ext cx="10515600" cy="594360"/>
+            <a:off x="731520" y="292608"/>
+            <a:ext cx="10698480" cy="548640"/>
           </a:xfrm>
           <a:prstGeom prst="rect">
             <a:avLst/>
@@ -6602,7 +6672,7 @@
           <a:p>
             <a:pPr algn="l"/>
             <a:r>
-              <a:rPr sz="2600" b="1">
+              <a:rPr sz="2400" b="1">
                 <a:solidFill>
                   <a:srgbClr val="FFFFFF"/>
                 </a:solidFill>
@@ -6621,8 +6691,8 @@
         </p:nvSpPr>
         <p:spPr>
           <a:xfrm>
-            <a:off x="640080" y="1417320"/>
-            <a:ext cx="5257800" cy="4572000"/>
+            <a:off x="594360" y="1325880"/>
+            <a:ext cx="5349240" cy="4754880"/>
           </a:xfrm>
           <a:prstGeom prst="rect">
             <a:avLst/>
@@ -6664,8 +6734,8 @@
         </p:nvSpPr>
         <p:spPr>
           <a:xfrm>
-            <a:off x="914400" y="1691640"/>
-            <a:ext cx="822960" cy="73152"/>
+            <a:off x="868680" y="1554480"/>
+            <a:ext cx="777240" cy="73152"/>
           </a:xfrm>
           <a:prstGeom prst="rect">
             <a:avLst/>
@@ -6707,8 +6777,8 @@
         </p:nvSpPr>
         <p:spPr>
           <a:xfrm>
-            <a:off x="914400" y="1920240"/>
-            <a:ext cx="4663440" cy="365760"/>
+            <a:off x="868680" y="1783080"/>
+            <a:ext cx="4754880" cy="365760"/>
           </a:xfrm>
           <a:prstGeom prst="rect">
             <a:avLst/>
@@ -6723,7 +6793,7 @@
           <a:p>
             <a:pPr algn="l"/>
             <a:r>
-              <a:rPr sz="1800" b="1">
+              <a:rPr sz="1700" b="1">
                 <a:solidFill>
                   <a:srgbClr val="141618"/>
                 </a:solidFill>
@@ -6742,8 +6812,8 @@
         </p:nvSpPr>
         <p:spPr>
           <a:xfrm>
-            <a:off x="914400" y="2423160"/>
-            <a:ext cx="4663440" cy="3200400"/>
+            <a:off x="868680" y="2286000"/>
+            <a:ext cx="4754880" cy="3474720"/>
           </a:xfrm>
           <a:prstGeom prst="rect">
             <a:avLst/>
@@ -6758,11 +6828,11 @@
           <a:p>
             <a:pPr algn="l">
               <a:spcAft>
-                <a:spcPts val="900"/>
+                <a:spcPts val="800"/>
               </a:spcAft>
             </a:pPr>
             <a:r>
-              <a:rPr sz="1600" b="0">
+              <a:rPr sz="1500" b="0">
                 <a:solidFill>
                   <a:srgbClr val="1A1C1E"/>
                 </a:solidFill>
@@ -6774,11 +6844,11 @@
           <a:p>
             <a:pPr algn="l">
               <a:spcAft>
-                <a:spcPts val="900"/>
+                <a:spcPts val="800"/>
               </a:spcAft>
             </a:pPr>
             <a:r>
-              <a:rPr sz="1600" b="0">
+              <a:rPr sz="1500" b="0">
                 <a:solidFill>
                   <a:srgbClr val="1A1C1E"/>
                 </a:solidFill>
@@ -6790,11 +6860,11 @@
           <a:p>
             <a:pPr algn="l">
               <a:spcAft>
-                <a:spcPts val="900"/>
+                <a:spcPts val="800"/>
               </a:spcAft>
             </a:pPr>
             <a:r>
-              <a:rPr sz="1600" b="0">
+              <a:rPr sz="1500" b="0">
                 <a:solidFill>
                   <a:srgbClr val="1A1C1E"/>
                 </a:solidFill>
@@ -6813,8 +6883,8 @@
         </p:nvSpPr>
         <p:spPr>
           <a:xfrm>
-            <a:off x="6263640" y="1417320"/>
-            <a:ext cx="5257800" cy="4572000"/>
+            <a:off x="6217920" y="1325880"/>
+            <a:ext cx="5349240" cy="4754880"/>
           </a:xfrm>
           <a:prstGeom prst="rect">
             <a:avLst/>
@@ -6856,8 +6926,8 @@
         </p:nvSpPr>
         <p:spPr>
           <a:xfrm>
-            <a:off x="6537960" y="1691640"/>
-            <a:ext cx="822960" cy="73152"/>
+            <a:off x="6492240" y="1554480"/>
+            <a:ext cx="777240" cy="73152"/>
           </a:xfrm>
           <a:prstGeom prst="rect">
             <a:avLst/>
@@ -6899,8 +6969,8 @@
         </p:nvSpPr>
         <p:spPr>
           <a:xfrm>
-            <a:off x="6537960" y="1920240"/>
-            <a:ext cx="4663440" cy="365760"/>
+            <a:off x="6492240" y="1783080"/>
+            <a:ext cx="4754880" cy="365760"/>
           </a:xfrm>
           <a:prstGeom prst="rect">
             <a:avLst/>
@@ -6915,7 +6985,7 @@
           <a:p>
             <a:pPr algn="l"/>
             <a:r>
-              <a:rPr sz="1800" b="1">
+              <a:rPr sz="1700" b="1">
                 <a:solidFill>
                   <a:srgbClr val="141618"/>
                 </a:solidFill>
@@ -6934,8 +7004,8 @@
         </p:nvSpPr>
         <p:spPr>
           <a:xfrm>
-            <a:off x="6537960" y="2423160"/>
-            <a:ext cx="4663440" cy="3200400"/>
+            <a:off x="6492240" y="2286000"/>
+            <a:ext cx="4754880" cy="3474720"/>
           </a:xfrm>
           <a:prstGeom prst="rect">
             <a:avLst/>
@@ -6950,11 +7020,11 @@
           <a:p>
             <a:pPr algn="l">
               <a:spcAft>
-                <a:spcPts val="900"/>
+                <a:spcPts val="800"/>
               </a:spcAft>
             </a:pPr>
             <a:r>
-              <a:rPr sz="1600" b="0">
+              <a:rPr sz="1500" b="0">
                 <a:solidFill>
                   <a:srgbClr val="1A1C1E"/>
                 </a:solidFill>
@@ -6966,11 +7036,11 @@
           <a:p>
             <a:pPr algn="l">
               <a:spcAft>
-                <a:spcPts val="900"/>
+                <a:spcPts val="800"/>
               </a:spcAft>
             </a:pPr>
             <a:r>
-              <a:rPr sz="1600" b="0">
+              <a:rPr sz="1500" b="0">
                 <a:solidFill>
                   <a:srgbClr val="1A1C1E"/>
                 </a:solidFill>
@@ -6982,11 +7052,11 @@
           <a:p>
             <a:pPr algn="l">
               <a:spcAft>
-                <a:spcPts val="900"/>
+                <a:spcPts val="800"/>
               </a:spcAft>
             </a:pPr>
             <a:r>
-              <a:rPr sz="1600" b="0">
+              <a:rPr sz="1500" b="0">
                 <a:solidFill>
                   <a:srgbClr val="1A1C1E"/>
                 </a:solidFill>
@@ -7067,7 +7137,7 @@
         <p:spPr>
           <a:xfrm>
             <a:off x="0" y="0"/>
-            <a:ext cx="12191695" cy="1143000"/>
+            <a:ext cx="12191695" cy="1097280"/>
           </a:xfrm>
           <a:prstGeom prst="rect">
             <a:avLst/>
@@ -7109,8 +7179,8 @@
         </p:nvSpPr>
         <p:spPr>
           <a:xfrm>
-            <a:off x="777240" y="320040"/>
-            <a:ext cx="10515600" cy="594360"/>
+            <a:off x="731520" y="292608"/>
+            <a:ext cx="10698480" cy="548640"/>
           </a:xfrm>
           <a:prstGeom prst="rect">
             <a:avLst/>
@@ -7125,7 +7195,7 @@
           <a:p>
             <a:pPr algn="l"/>
             <a:r>
-              <a:rPr sz="2600" b="1">
+              <a:rPr sz="2400" b="1">
                 <a:solidFill>
                   <a:srgbClr val="FFFFFF"/>
                 </a:solidFill>
@@ -7144,8 +7214,8 @@
         </p:nvSpPr>
         <p:spPr>
           <a:xfrm>
-            <a:off x="822960" y="1554480"/>
-            <a:ext cx="10424160" cy="4297680"/>
+            <a:off x="777240" y="1417320"/>
+            <a:ext cx="10515600" cy="4572000"/>
           </a:xfrm>
           <a:prstGeom prst="rect">
             <a:avLst/>
@@ -7160,11 +7230,11 @@
           <a:p>
             <a:pPr algn="l">
               <a:spcAft>
-                <a:spcPts val="1300"/>
+                <a:spcPts val="1200"/>
               </a:spcAft>
             </a:pPr>
             <a:r>
-              <a:rPr sz="1900" b="0">
+              <a:rPr sz="1800" b="0">
                 <a:solidFill>
                   <a:srgbClr val="1A1C1E"/>
                 </a:solidFill>
@@ -7176,11 +7246,11 @@
           <a:p>
             <a:pPr algn="l">
               <a:spcAft>
-                <a:spcPts val="1300"/>
+                <a:spcPts val="1200"/>
               </a:spcAft>
             </a:pPr>
             <a:r>
-              <a:rPr sz="1900" b="0">
+              <a:rPr sz="1800" b="0">
                 <a:solidFill>
                   <a:srgbClr val="1A1C1E"/>
                 </a:solidFill>
@@ -7192,11 +7262,11 @@
           <a:p>
             <a:pPr algn="l">
               <a:spcAft>
-                <a:spcPts val="1300"/>
+                <a:spcPts val="1200"/>
               </a:spcAft>
             </a:pPr>
             <a:r>
-              <a:rPr sz="1900" b="0">
+              <a:rPr sz="1800" b="0">
                 <a:solidFill>
                   <a:srgbClr val="1A1C1E"/>
                 </a:solidFill>
@@ -7208,11 +7278,11 @@
           <a:p>
             <a:pPr algn="l">
               <a:spcAft>
-                <a:spcPts val="1300"/>
+                <a:spcPts val="1200"/>
               </a:spcAft>
             </a:pPr>
             <a:r>
-              <a:rPr sz="1900" b="0">
+              <a:rPr sz="1800" b="0">
                 <a:solidFill>
                   <a:srgbClr val="1A1C1E"/>
                 </a:solidFill>
@@ -7224,11 +7294,11 @@
           <a:p>
             <a:pPr algn="l">
               <a:spcAft>
-                <a:spcPts val="1300"/>
+                <a:spcPts val="1200"/>
               </a:spcAft>
             </a:pPr>
             <a:r>
-              <a:rPr sz="1900" b="0">
+              <a:rPr sz="1800" b="0">
                 <a:solidFill>
                   <a:srgbClr val="1A1C1E"/>
                 </a:solidFill>
@@ -7240,52 +7310,17 @@
           <a:p>
             <a:pPr algn="l">
               <a:spcAft>
-                <a:spcPts val="1300"/>
+                <a:spcPts val="1200"/>
               </a:spcAft>
             </a:pPr>
             <a:r>
-              <a:rPr sz="1900" b="0">
+              <a:rPr sz="1800" b="0">
                 <a:solidFill>
                   <a:srgbClr val="1A1C1E"/>
                 </a:solidFill>
                 <a:latin typeface="Calibri"/>
               </a:rPr>
-              <a:t>•  Every change gets a metric owner and a review date</a:t>
-            </a:r>
-          </a:p>
-        </p:txBody>
-      </p:sp>
-      <p:sp>
-        <p:nvSpPr>
-          <p:cNvPr id="6" name="TextBox 5"/>
-          <p:cNvSpPr txBox="1"/>
-          <p:nvPr/>
-        </p:nvSpPr>
-        <p:spPr>
-          <a:xfrm>
-            <a:off x="822960" y="6355080"/>
-            <a:ext cx="10058400" cy="274320"/>
-          </a:xfrm>
-          <a:prstGeom prst="rect">
-            <a:avLst/>
-          </a:prstGeom>
-          <a:noFill/>
-        </p:spPr>
-        <p:txBody>
-          <a:bodyPr wrap="square" anchor="t">
-            <a:spAutoFit/>
-          </a:bodyPr>
-          <a:lstStyle/>
-          <a:p>
-            <a:pPr algn="l"/>
-            <a:r>
-              <a:rPr sz="1100" b="0">
-                <a:solidFill>
-                  <a:srgbClr val="5E646B"/>
-                </a:solidFill>
-                <a:latin typeface="Calibri"/>
-              </a:rPr>
-              <a:t>Lindsey Dempsey  ·  EMEA SDR</a:t>
+              <a:t>•  Every change gets a metric owner and a review date — trains on time</a:t>
             </a:r>
           </a:p>
         </p:txBody>
@@ -7359,7 +7394,7 @@
         </p:nvSpPr>
         <p:spPr>
           <a:xfrm>
-            <a:off x="822960" y="2331720"/>
+            <a:off x="777240" y="2286000"/>
             <a:ext cx="1280160" cy="73152"/>
           </a:xfrm>
           <a:prstGeom prst="rect">
@@ -7402,8 +7437,8 @@
         </p:nvSpPr>
         <p:spPr>
           <a:xfrm>
-            <a:off x="822960" y="2514600"/>
-            <a:ext cx="10058400" cy="411480"/>
+            <a:off x="777240" y="2468880"/>
+            <a:ext cx="10058400" cy="365760"/>
           </a:xfrm>
           <a:prstGeom prst="rect">
             <a:avLst/>
@@ -7437,7 +7472,7 @@
         </p:nvSpPr>
         <p:spPr>
           <a:xfrm>
-            <a:off x="822960" y="2971800"/>
+            <a:off x="777240" y="2926080"/>
             <a:ext cx="10515600" cy="1097280"/>
           </a:xfrm>
           <a:prstGeom prst="rect">
@@ -7453,13 +7488,13 @@
           <a:p>
             <a:pPr algn="l"/>
             <a:r>
-              <a:rPr sz="3400" b="1">
+              <a:rPr sz="3200" b="1">
                 <a:solidFill>
                   <a:srgbClr val="FFFFFF"/>
                 </a:solidFill>
                 <a:latin typeface="Georgia"/>
               </a:rPr>
-              <a:t>Fundamentals — how I lead day to day</a:t>
+              <a:t>Fundamentals — how I lead day to day as a player-coach</a:t>
             </a:r>
           </a:p>
         </p:txBody>
@@ -7534,7 +7569,7 @@
         <p:spPr>
           <a:xfrm>
             <a:off x="0" y="0"/>
-            <a:ext cx="12191695" cy="1143000"/>
+            <a:ext cx="12191695" cy="1097280"/>
           </a:xfrm>
           <a:prstGeom prst="rect">
             <a:avLst/>
@@ -7576,8 +7611,8 @@
         </p:nvSpPr>
         <p:spPr>
           <a:xfrm>
-            <a:off x="777240" y="320040"/>
-            <a:ext cx="10515600" cy="594360"/>
+            <a:off x="731520" y="292608"/>
+            <a:ext cx="10698480" cy="548640"/>
           </a:xfrm>
           <a:prstGeom prst="rect">
             <a:avLst/>
@@ -7592,7 +7627,7 @@
           <a:p>
             <a:pPr algn="l"/>
             <a:r>
-              <a:rPr sz="2600" b="1">
+              <a:rPr sz="2400" b="1">
                 <a:solidFill>
                   <a:srgbClr val="FFFFFF"/>
                 </a:solidFill>
@@ -7611,8 +7646,8 @@
         </p:nvSpPr>
         <p:spPr>
           <a:xfrm>
-            <a:off x="822960" y="1554480"/>
-            <a:ext cx="10424160" cy="4297680"/>
+            <a:off x="777240" y="1417320"/>
+            <a:ext cx="10515600" cy="4572000"/>
           </a:xfrm>
           <a:prstGeom prst="rect">
             <a:avLst/>
@@ -7627,11 +7662,11 @@
           <a:p>
             <a:pPr algn="l">
               <a:spcAft>
-                <a:spcPts val="1300"/>
+                <a:spcPts val="1200"/>
               </a:spcAft>
             </a:pPr>
             <a:r>
-              <a:rPr sz="1900" b="0">
+              <a:rPr sz="1800" b="0">
                 <a:solidFill>
                   <a:srgbClr val="1A1C1E"/>
                 </a:solidFill>
@@ -7643,11 +7678,11 @@
           <a:p>
             <a:pPr algn="l">
               <a:spcAft>
-                <a:spcPts val="1300"/>
+                <a:spcPts val="1200"/>
               </a:spcAft>
             </a:pPr>
             <a:r>
-              <a:rPr sz="1900" b="0">
+              <a:rPr sz="1800" b="0">
                 <a:solidFill>
                   <a:srgbClr val="1A1C1E"/>
                 </a:solidFill>
@@ -7659,11 +7694,11 @@
           <a:p>
             <a:pPr algn="l">
               <a:spcAft>
-                <a:spcPts val="1300"/>
+                <a:spcPts val="1200"/>
               </a:spcAft>
             </a:pPr>
             <a:r>
-              <a:rPr sz="1900" b="0">
+              <a:rPr sz="1800" b="0">
                 <a:solidFill>
                   <a:srgbClr val="1A1C1E"/>
                 </a:solidFill>
@@ -7675,27 +7710,27 @@
           <a:p>
             <a:pPr algn="l">
               <a:spcAft>
-                <a:spcPts val="1300"/>
+                <a:spcPts val="1200"/>
               </a:spcAft>
             </a:pPr>
             <a:r>
-              <a:rPr sz="1900" b="0">
+              <a:rPr sz="1800" b="0">
                 <a:solidFill>
                   <a:srgbClr val="1A1C1E"/>
                 </a:solidFill>
                 <a:latin typeface="Calibri"/>
               </a:rPr>
-              <a:t>•  Competitive clarity — Copilot + Claude Code without trash talk</a:t>
+              <a:t>•  Competitive clarity — Copilot + Claude Code + Windsurf without trash talk</a:t>
             </a:r>
           </a:p>
           <a:p>
             <a:pPr algn="l">
               <a:spcAft>
-                <a:spcPts val="1300"/>
+                <a:spcPts val="1200"/>
               </a:spcAft>
             </a:pPr>
             <a:r>
-              <a:rPr sz="1900" b="0">
+              <a:rPr sz="1800" b="0">
                 <a:solidFill>
                   <a:srgbClr val="1A1C1E"/>
                 </a:solidFill>
@@ -7707,11 +7742,11 @@
           <a:p>
             <a:pPr algn="l">
               <a:spcAft>
-                <a:spcPts val="1300"/>
+                <a:spcPts val="1200"/>
               </a:spcAft>
             </a:pPr>
             <a:r>
-              <a:rPr sz="1900" b="0">
+              <a:rPr sz="1800" b="0">
                 <a:solidFill>
                   <a:srgbClr val="1A1C1E"/>
                 </a:solidFill>
@@ -7723,52 +7758,17 @@
           <a:p>
             <a:pPr algn="l">
               <a:spcAft>
-                <a:spcPts val="1300"/>
+                <a:spcPts val="1200"/>
               </a:spcAft>
             </a:pPr>
             <a:r>
-              <a:rPr sz="1900" b="0">
+              <a:rPr sz="1800" b="0">
                 <a:solidFill>
                   <a:srgbClr val="1A1C1E"/>
                 </a:solidFill>
                 <a:latin typeface="Calibri"/>
               </a:rPr>
               <a:t>•  Bar: diagnose the buyer’s constraint and match Cursor to it — don’t recite features</a:t>
-            </a:r>
-          </a:p>
-        </p:txBody>
-      </p:sp>
-      <p:sp>
-        <p:nvSpPr>
-          <p:cNvPr id="6" name="TextBox 5"/>
-          <p:cNvSpPr txBox="1"/>
-          <p:nvPr/>
-        </p:nvSpPr>
-        <p:spPr>
-          <a:xfrm>
-            <a:off x="822960" y="6355080"/>
-            <a:ext cx="10058400" cy="274320"/>
-          </a:xfrm>
-          <a:prstGeom prst="rect">
-            <a:avLst/>
-          </a:prstGeom>
-          <a:noFill/>
-        </p:spPr>
-        <p:txBody>
-          <a:bodyPr wrap="square" anchor="t">
-            <a:spAutoFit/>
-          </a:bodyPr>
-          <a:lstStyle/>
-          <a:p>
-            <a:pPr algn="l"/>
-            <a:r>
-              <a:rPr sz="1100" b="0">
-                <a:solidFill>
-                  <a:srgbClr val="5E646B"/>
-                </a:solidFill>
-                <a:latin typeface="Calibri"/>
-              </a:rPr>
-              <a:t>Lindsey Dempsey  ·  EMEA SDR</a:t>
             </a:r>
           </a:p>
         </p:txBody>
@@ -7843,7 +7843,7 @@
         <p:spPr>
           <a:xfrm>
             <a:off x="0" y="0"/>
-            <a:ext cx="12191695" cy="1143000"/>
+            <a:ext cx="12191695" cy="1097280"/>
           </a:xfrm>
           <a:prstGeom prst="rect">
             <a:avLst/>
@@ -7885,8 +7885,8 @@
         </p:nvSpPr>
         <p:spPr>
           <a:xfrm>
-            <a:off x="777240" y="320040"/>
-            <a:ext cx="10515600" cy="594360"/>
+            <a:off x="731520" y="292608"/>
+            <a:ext cx="10698480" cy="548640"/>
           </a:xfrm>
           <a:prstGeom prst="rect">
             <a:avLst/>
@@ -7901,7 +7901,7 @@
           <a:p>
             <a:pPr algn="l"/>
             <a:r>
-              <a:rPr sz="2600" b="1">
+              <a:rPr sz="2400" b="1">
                 <a:solidFill>
                   <a:srgbClr val="FFFFFF"/>
                 </a:solidFill>
@@ -7920,8 +7920,8 @@
         </p:nvSpPr>
         <p:spPr>
           <a:xfrm>
-            <a:off x="640080" y="1417320"/>
-            <a:ext cx="5257800" cy="4572000"/>
+            <a:off x="594360" y="1325880"/>
+            <a:ext cx="5349240" cy="4754880"/>
           </a:xfrm>
           <a:prstGeom prst="rect">
             <a:avLst/>
@@ -7963,8 +7963,8 @@
         </p:nvSpPr>
         <p:spPr>
           <a:xfrm>
-            <a:off x="914400" y="1691640"/>
-            <a:ext cx="822960" cy="73152"/>
+            <a:off x="868680" y="1554480"/>
+            <a:ext cx="777240" cy="73152"/>
           </a:xfrm>
           <a:prstGeom prst="rect">
             <a:avLst/>
@@ -8006,8 +8006,8 @@
         </p:nvSpPr>
         <p:spPr>
           <a:xfrm>
-            <a:off x="914400" y="1920240"/>
-            <a:ext cx="4663440" cy="365760"/>
+            <a:off x="868680" y="1783080"/>
+            <a:ext cx="4754880" cy="365760"/>
           </a:xfrm>
           <a:prstGeom prst="rect">
             <a:avLst/>
@@ -8022,7 +8022,7 @@
           <a:p>
             <a:pPr algn="l"/>
             <a:r>
-              <a:rPr sz="1800" b="1">
+              <a:rPr sz="1700" b="1">
                 <a:solidFill>
                   <a:srgbClr val="141618"/>
                 </a:solidFill>
@@ -8041,8 +8041,8 @@
         </p:nvSpPr>
         <p:spPr>
           <a:xfrm>
-            <a:off x="914400" y="2423160"/>
-            <a:ext cx="4663440" cy="3200400"/>
+            <a:off x="868680" y="2286000"/>
+            <a:ext cx="4754880" cy="3474720"/>
           </a:xfrm>
           <a:prstGeom prst="rect">
             <a:avLst/>
@@ -8057,11 +8057,11 @@
           <a:p>
             <a:pPr algn="l">
               <a:spcAft>
-                <a:spcPts val="900"/>
+                <a:spcPts val="800"/>
               </a:spcAft>
             </a:pPr>
             <a:r>
-              <a:rPr sz="1600" b="0">
+              <a:rPr sz="1500" b="0">
                 <a:solidFill>
                   <a:srgbClr val="1A1C1E"/>
                 </a:solidFill>
@@ -8073,11 +8073,11 @@
           <a:p>
             <a:pPr algn="l">
               <a:spcAft>
-                <a:spcPts val="900"/>
+                <a:spcPts val="800"/>
               </a:spcAft>
             </a:pPr>
             <a:r>
-              <a:rPr sz="1600" b="0">
+              <a:rPr sz="1500" b="0">
                 <a:solidFill>
                   <a:srgbClr val="1A1C1E"/>
                 </a:solidFill>
@@ -8089,11 +8089,11 @@
           <a:p>
             <a:pPr algn="l">
               <a:spcAft>
-                <a:spcPts val="900"/>
+                <a:spcPts val="800"/>
               </a:spcAft>
             </a:pPr>
             <a:r>
-              <a:rPr sz="1600" b="0">
+              <a:rPr sz="1500" b="0">
                 <a:solidFill>
                   <a:srgbClr val="1A1C1E"/>
                 </a:solidFill>
@@ -8112,8 +8112,8 @@
         </p:nvSpPr>
         <p:spPr>
           <a:xfrm>
-            <a:off x="6263640" y="1417320"/>
-            <a:ext cx="5257800" cy="4572000"/>
+            <a:off x="6217920" y="1325880"/>
+            <a:ext cx="5349240" cy="4754880"/>
           </a:xfrm>
           <a:prstGeom prst="rect">
             <a:avLst/>
@@ -8155,8 +8155,8 @@
         </p:nvSpPr>
         <p:spPr>
           <a:xfrm>
-            <a:off x="6537960" y="1691640"/>
-            <a:ext cx="822960" cy="73152"/>
+            <a:off x="6492240" y="1554480"/>
+            <a:ext cx="777240" cy="73152"/>
           </a:xfrm>
           <a:prstGeom prst="rect">
             <a:avLst/>
@@ -8198,8 +8198,8 @@
         </p:nvSpPr>
         <p:spPr>
           <a:xfrm>
-            <a:off x="6537960" y="1920240"/>
-            <a:ext cx="4663440" cy="365760"/>
+            <a:off x="6492240" y="1783080"/>
+            <a:ext cx="4754880" cy="365760"/>
           </a:xfrm>
           <a:prstGeom prst="rect">
             <a:avLst/>
@@ -8214,7 +8214,7 @@
           <a:p>
             <a:pPr algn="l"/>
             <a:r>
-              <a:rPr sz="1800" b="1">
+              <a:rPr sz="1700" b="1">
                 <a:solidFill>
                   <a:srgbClr val="141618"/>
                 </a:solidFill>
@@ -8233,8 +8233,8 @@
         </p:nvSpPr>
         <p:spPr>
           <a:xfrm>
-            <a:off x="6537960" y="2423160"/>
-            <a:ext cx="4663440" cy="3200400"/>
+            <a:off x="6492240" y="2286000"/>
+            <a:ext cx="4754880" cy="3474720"/>
           </a:xfrm>
           <a:prstGeom prst="rect">
             <a:avLst/>
@@ -8249,11 +8249,11 @@
           <a:p>
             <a:pPr algn="l">
               <a:spcAft>
-                <a:spcPts val="900"/>
+                <a:spcPts val="800"/>
               </a:spcAft>
             </a:pPr>
             <a:r>
-              <a:rPr sz="1600" b="0">
+              <a:rPr sz="1500" b="0">
                 <a:solidFill>
                   <a:srgbClr val="1A1C1E"/>
                 </a:solidFill>
@@ -8265,11 +8265,11 @@
           <a:p>
             <a:pPr algn="l">
               <a:spcAft>
-                <a:spcPts val="900"/>
+                <a:spcPts val="800"/>
               </a:spcAft>
             </a:pPr>
             <a:r>
-              <a:rPr sz="1600" b="0">
+              <a:rPr sz="1500" b="0">
                 <a:solidFill>
                   <a:srgbClr val="1A1C1E"/>
                 </a:solidFill>
@@ -8281,11 +8281,11 @@
           <a:p>
             <a:pPr algn="l">
               <a:spcAft>
-                <a:spcPts val="900"/>
+                <a:spcPts val="800"/>
               </a:spcAft>
             </a:pPr>
             <a:r>
-              <a:rPr sz="1600" b="0">
+              <a:rPr sz="1500" b="0">
                 <a:solidFill>
                   <a:srgbClr val="1A1C1E"/>
                 </a:solidFill>
@@ -8297,11 +8297,11 @@
           <a:p>
             <a:pPr algn="l">
               <a:spcAft>
-                <a:spcPts val="900"/>
+                <a:spcPts val="800"/>
               </a:spcAft>
             </a:pPr>
             <a:r>
-              <a:rPr sz="1600" b="0">
+              <a:rPr sz="1500" b="0">
                 <a:solidFill>
                   <a:srgbClr val="1A1C1E"/>
                 </a:solidFill>
@@ -8313,11 +8313,11 @@
           <a:p>
             <a:pPr algn="l">
               <a:spcAft>
-                <a:spcPts val="900"/>
+                <a:spcPts val="800"/>
               </a:spcAft>
             </a:pPr>
             <a:r>
-              <a:rPr sz="1600" b="0">
+              <a:rPr sz="1500" b="0">
                 <a:solidFill>
                   <a:srgbClr val="1A1C1E"/>
                 </a:solidFill>
@@ -8397,7 +8397,7 @@
         </p:nvSpPr>
         <p:spPr>
           <a:xfrm>
-            <a:off x="822960" y="2331720"/>
+            <a:off x="777240" y="2286000"/>
             <a:ext cx="1280160" cy="73152"/>
           </a:xfrm>
           <a:prstGeom prst="rect">
@@ -8440,8 +8440,8 @@
         </p:nvSpPr>
         <p:spPr>
           <a:xfrm>
-            <a:off x="822960" y="2514600"/>
-            <a:ext cx="10058400" cy="411480"/>
+            <a:off x="777240" y="2468880"/>
+            <a:ext cx="10058400" cy="365760"/>
           </a:xfrm>
           <a:prstGeom prst="rect">
             <a:avLst/>
@@ -8475,7 +8475,7 @@
         </p:nvSpPr>
         <p:spPr>
           <a:xfrm>
-            <a:off x="822960" y="2971800"/>
+            <a:off x="777240" y="2926080"/>
             <a:ext cx="10515600" cy="1097280"/>
           </a:xfrm>
           <a:prstGeom prst="rect">
@@ -8491,7 +8491,7 @@
           <a:p>
             <a:pPr algn="l"/>
             <a:r>
-              <a:rPr sz="3400" b="1">
+              <a:rPr sz="3200" b="1">
                 <a:solidFill>
                   <a:srgbClr val="FFFFFF"/>
                 </a:solidFill>
@@ -8572,7 +8572,7 @@
         <p:spPr>
           <a:xfrm>
             <a:off x="0" y="0"/>
-            <a:ext cx="12191695" cy="1143000"/>
+            <a:ext cx="12191695" cy="1097280"/>
           </a:xfrm>
           <a:prstGeom prst="rect">
             <a:avLst/>
@@ -8614,8 +8614,8 @@
         </p:nvSpPr>
         <p:spPr>
           <a:xfrm>
-            <a:off x="777240" y="320040"/>
-            <a:ext cx="10515600" cy="594360"/>
+            <a:off x="731520" y="292608"/>
+            <a:ext cx="10698480" cy="548640"/>
           </a:xfrm>
           <a:prstGeom prst="rect">
             <a:avLst/>
@@ -8630,7 +8630,7 @@
           <a:p>
             <a:pPr algn="l"/>
             <a:r>
-              <a:rPr sz="2600" b="1">
+              <a:rPr sz="2400" b="1">
                 <a:solidFill>
                   <a:srgbClr val="FFFFFF"/>
                 </a:solidFill>
@@ -8649,7 +8649,7 @@
         </p:nvSpPr>
         <p:spPr>
           <a:xfrm>
-            <a:off x="822960" y="1371600"/>
+            <a:off x="777240" y="1325880"/>
             <a:ext cx="640080" cy="320040"/>
           </a:xfrm>
           <a:prstGeom prst="rect">
@@ -8665,7 +8665,7 @@
           <a:p>
             <a:pPr algn="l"/>
             <a:r>
-              <a:rPr sz="1800" b="1">
+              <a:rPr sz="1700" b="1">
                 <a:solidFill>
                   <a:srgbClr val="141618"/>
                 </a:solidFill>
@@ -8684,7 +8684,7 @@
         </p:nvSpPr>
         <p:spPr>
           <a:xfrm>
-            <a:off x="1463040" y="1371600"/>
+            <a:off x="1417320" y="1325880"/>
             <a:ext cx="9875520" cy="292608"/>
           </a:xfrm>
           <a:prstGeom prst="rect">
@@ -8700,7 +8700,7 @@
           <a:p>
             <a:pPr algn="l"/>
             <a:r>
-              <a:rPr sz="1700" b="1">
+              <a:rPr sz="1600" b="1">
                 <a:solidFill>
                   <a:srgbClr val="141618"/>
                 </a:solidFill>
@@ -8719,7 +8719,7 @@
         </p:nvSpPr>
         <p:spPr>
           <a:xfrm>
-            <a:off x="1463040" y="1664208"/>
+            <a:off x="1417320" y="1618488"/>
             <a:ext cx="9875520" cy="457200"/>
           </a:xfrm>
           <a:prstGeom prst="rect">
@@ -8754,7 +8754,7 @@
         </p:nvSpPr>
         <p:spPr>
           <a:xfrm>
-            <a:off x="822960" y="2423160"/>
+            <a:off x="777240" y="2377440"/>
             <a:ext cx="640080" cy="320040"/>
           </a:xfrm>
           <a:prstGeom prst="rect">
@@ -8770,7 +8770,7 @@
           <a:p>
             <a:pPr algn="l"/>
             <a:r>
-              <a:rPr sz="1800" b="1">
+              <a:rPr sz="1700" b="1">
                 <a:solidFill>
                   <a:srgbClr val="141618"/>
                 </a:solidFill>
@@ -8789,7 +8789,7 @@
         </p:nvSpPr>
         <p:spPr>
           <a:xfrm>
-            <a:off x="1463040" y="2423160"/>
+            <a:off x="1417320" y="2377440"/>
             <a:ext cx="9875520" cy="292608"/>
           </a:xfrm>
           <a:prstGeom prst="rect">
@@ -8805,7 +8805,7 @@
           <a:p>
             <a:pPr algn="l"/>
             <a:r>
-              <a:rPr sz="1700" b="1">
+              <a:rPr sz="1600" b="1">
                 <a:solidFill>
                   <a:srgbClr val="141618"/>
                 </a:solidFill>
@@ -8824,7 +8824,7 @@
         </p:nvSpPr>
         <p:spPr>
           <a:xfrm>
-            <a:off x="1463040" y="2715768"/>
+            <a:off x="1417320" y="2670048"/>
             <a:ext cx="9875520" cy="457200"/>
           </a:xfrm>
           <a:prstGeom prst="rect">
@@ -8859,7 +8859,7 @@
         </p:nvSpPr>
         <p:spPr>
           <a:xfrm>
-            <a:off x="822960" y="3474720"/>
+            <a:off x="777240" y="3429000"/>
             <a:ext cx="640080" cy="320040"/>
           </a:xfrm>
           <a:prstGeom prst="rect">
@@ -8875,7 +8875,7 @@
           <a:p>
             <a:pPr algn="l"/>
             <a:r>
-              <a:rPr sz="1800" b="1">
+              <a:rPr sz="1700" b="1">
                 <a:solidFill>
                   <a:srgbClr val="141618"/>
                 </a:solidFill>
@@ -8894,7 +8894,7 @@
         </p:nvSpPr>
         <p:spPr>
           <a:xfrm>
-            <a:off x="1463040" y="3474720"/>
+            <a:off x="1417320" y="3429000"/>
             <a:ext cx="9875520" cy="292608"/>
           </a:xfrm>
           <a:prstGeom prst="rect">
@@ -8910,7 +8910,7 @@
           <a:p>
             <a:pPr algn="l"/>
             <a:r>
-              <a:rPr sz="1700" b="1">
+              <a:rPr sz="1600" b="1">
                 <a:solidFill>
                   <a:srgbClr val="141618"/>
                 </a:solidFill>
@@ -8929,7 +8929,7 @@
         </p:nvSpPr>
         <p:spPr>
           <a:xfrm>
-            <a:off x="1463040" y="3767328"/>
+            <a:off x="1417320" y="3721608"/>
             <a:ext cx="9875520" cy="457200"/>
           </a:xfrm>
           <a:prstGeom prst="rect">
@@ -8964,7 +8964,7 @@
         </p:nvSpPr>
         <p:spPr>
           <a:xfrm>
-            <a:off x="822960" y="4526280"/>
+            <a:off x="777240" y="4480560"/>
             <a:ext cx="640080" cy="320040"/>
           </a:xfrm>
           <a:prstGeom prst="rect">
@@ -8980,7 +8980,7 @@
           <a:p>
             <a:pPr algn="l"/>
             <a:r>
-              <a:rPr sz="1800" b="1">
+              <a:rPr sz="1700" b="1">
                 <a:solidFill>
                   <a:srgbClr val="141618"/>
                 </a:solidFill>
@@ -8999,7 +8999,7 @@
         </p:nvSpPr>
         <p:spPr>
           <a:xfrm>
-            <a:off x="1463040" y="4526280"/>
+            <a:off x="1417320" y="4480560"/>
             <a:ext cx="9875520" cy="292608"/>
           </a:xfrm>
           <a:prstGeom prst="rect">
@@ -9015,7 +9015,7 @@
           <a:p>
             <a:pPr algn="l"/>
             <a:r>
-              <a:rPr sz="1700" b="1">
+              <a:rPr sz="1600" b="1">
                 <a:solidFill>
                   <a:srgbClr val="141618"/>
                 </a:solidFill>
@@ -9034,7 +9034,7 @@
         </p:nvSpPr>
         <p:spPr>
           <a:xfrm>
-            <a:off x="1463040" y="4818888"/>
+            <a:off x="1417320" y="4773168"/>
             <a:ext cx="9875520" cy="457200"/>
           </a:xfrm>
           <a:prstGeom prst="rect">
@@ -9131,7 +9131,7 @@
         <p:spPr>
           <a:xfrm>
             <a:off x="0" y="0"/>
-            <a:ext cx="12191695" cy="1143000"/>
+            <a:ext cx="12191695" cy="1097280"/>
           </a:xfrm>
           <a:prstGeom prst="rect">
             <a:avLst/>
@@ -9173,8 +9173,8 @@
         </p:nvSpPr>
         <p:spPr>
           <a:xfrm>
-            <a:off x="777240" y="320040"/>
-            <a:ext cx="10515600" cy="594360"/>
+            <a:off x="731520" y="292608"/>
+            <a:ext cx="10698480" cy="548640"/>
           </a:xfrm>
           <a:prstGeom prst="rect">
             <a:avLst/>
@@ -9189,7 +9189,7 @@
           <a:p>
             <a:pPr algn="l"/>
             <a:r>
-              <a:rPr sz="2600" b="1">
+              <a:rPr sz="2400" b="1">
                 <a:solidFill>
                   <a:srgbClr val="FFFFFF"/>
                 </a:solidFill>
@@ -9208,8 +9208,8 @@
         </p:nvSpPr>
         <p:spPr>
           <a:xfrm>
-            <a:off x="822960" y="1554480"/>
-            <a:ext cx="10424160" cy="4297680"/>
+            <a:off x="777240" y="1417320"/>
+            <a:ext cx="10515600" cy="4572000"/>
           </a:xfrm>
           <a:prstGeom prst="rect">
             <a:avLst/>
@@ -9224,11 +9224,11 @@
           <a:p>
             <a:pPr algn="l">
               <a:spcAft>
-                <a:spcPts val="1300"/>
+                <a:spcPts val="1200"/>
               </a:spcAft>
             </a:pPr>
             <a:r>
-              <a:rPr sz="1900" b="0">
+              <a:rPr sz="1600" b="0">
                 <a:solidFill>
                   <a:srgbClr val="1A1C1E"/>
                 </a:solidFill>
@@ -9240,11 +9240,11 @@
           <a:p>
             <a:pPr algn="l">
               <a:spcAft>
-                <a:spcPts val="1300"/>
+                <a:spcPts val="1200"/>
               </a:spcAft>
             </a:pPr>
             <a:r>
-              <a:rPr sz="1900" b="0">
+              <a:rPr sz="1600" b="0">
                 <a:solidFill>
                   <a:srgbClr val="1A1C1E"/>
                 </a:solidFill>
@@ -9256,11 +9256,11 @@
           <a:p>
             <a:pPr algn="l">
               <a:spcAft>
-                <a:spcPts val="1300"/>
+                <a:spcPts val="1200"/>
               </a:spcAft>
             </a:pPr>
             <a:r>
-              <a:rPr sz="1900" b="0">
+              <a:rPr sz="1600" b="0">
                 <a:solidFill>
                   <a:srgbClr val="1A1C1E"/>
                 </a:solidFill>
@@ -9272,11 +9272,11 @@
           <a:p>
             <a:pPr algn="l">
               <a:spcAft>
-                <a:spcPts val="1300"/>
+                <a:spcPts val="1200"/>
               </a:spcAft>
             </a:pPr>
             <a:r>
-              <a:rPr sz="1900" b="0">
+              <a:rPr sz="1600" b="0">
                 <a:solidFill>
                   <a:srgbClr val="1A1C1E"/>
                 </a:solidFill>
@@ -9288,11 +9288,11 @@
           <a:p>
             <a:pPr algn="l">
               <a:spcAft>
-                <a:spcPts val="1300"/>
+                <a:spcPts val="1200"/>
               </a:spcAft>
             </a:pPr>
             <a:r>
-              <a:rPr sz="1900" b="0">
+              <a:rPr sz="1600" b="0">
                 <a:solidFill>
                   <a:srgbClr val="1A1C1E"/>
                 </a:solidFill>
@@ -9301,39 +9301,20 @@
               <a:t>•  What fails: generic “quick chat” spam and fake personalization</a:t>
             </a:r>
           </a:p>
-        </p:txBody>
-      </p:sp>
-      <p:sp>
-        <p:nvSpPr>
-          <p:cNvPr id="6" name="TextBox 5"/>
-          <p:cNvSpPr txBox="1"/>
-          <p:nvPr/>
-        </p:nvSpPr>
-        <p:spPr>
-          <a:xfrm>
-            <a:off x="822960" y="6355080"/>
-            <a:ext cx="10058400" cy="274320"/>
-          </a:xfrm>
-          <a:prstGeom prst="rect">
-            <a:avLst/>
-          </a:prstGeom>
-          <a:noFill/>
-        </p:spPr>
-        <p:txBody>
-          <a:bodyPr wrap="square" anchor="t">
-            <a:spAutoFit/>
-          </a:bodyPr>
-          <a:lstStyle/>
-          <a:p>
-            <a:pPr algn="l"/>
-            <a:r>
-              <a:rPr sz="1100" b="0">
-                <a:solidFill>
-                  <a:srgbClr val="5E646B"/>
+          <a:p>
+            <a:pPr algn="l">
+              <a:spcAft>
+                <a:spcPts val="1200"/>
+              </a:spcAft>
+            </a:pPr>
+            <a:r>
+              <a:rPr sz="1600" b="0">
+                <a:solidFill>
+                  <a:srgbClr val="1A1C1E"/>
                 </a:solidFill>
                 <a:latin typeface="Calibri"/>
               </a:rPr>
-              <a:t>Lindsey Dempsey  ·  EMEA SDR</a:t>
+              <a:t>•  Proof to arm reps: Coinbase (agent-first), Stripe (rollout), PayPal (enterprise velocity)</a:t>
             </a:r>
           </a:p>
         </p:txBody>
@@ -9408,7 +9389,7 @@
         <p:spPr>
           <a:xfrm>
             <a:off x="0" y="0"/>
-            <a:ext cx="12191695" cy="1143000"/>
+            <a:ext cx="12191695" cy="1097280"/>
           </a:xfrm>
           <a:prstGeom prst="rect">
             <a:avLst/>
@@ -9450,8 +9431,8 @@
         </p:nvSpPr>
         <p:spPr>
           <a:xfrm>
-            <a:off x="777240" y="320040"/>
-            <a:ext cx="10515600" cy="594360"/>
+            <a:off x="731520" y="292608"/>
+            <a:ext cx="10698480" cy="548640"/>
           </a:xfrm>
           <a:prstGeom prst="rect">
             <a:avLst/>
@@ -9466,7 +9447,7 @@
           <a:p>
             <a:pPr algn="l"/>
             <a:r>
-              <a:rPr sz="2600" b="1">
+              <a:rPr sz="2400" b="1">
                 <a:solidFill>
                   <a:srgbClr val="FFFFFF"/>
                 </a:solidFill>
@@ -9485,8 +9466,8 @@
         </p:nvSpPr>
         <p:spPr>
           <a:xfrm>
-            <a:off x="640080" y="1325880"/>
-            <a:ext cx="10881360" cy="777240"/>
+            <a:off x="502920" y="1234440"/>
+            <a:ext cx="11109960" cy="731520"/>
           </a:xfrm>
           <a:prstGeom prst="rect">
             <a:avLst/>
@@ -9528,8 +9509,8 @@
         </p:nvSpPr>
         <p:spPr>
           <a:xfrm>
-            <a:off x="868680" y="1417320"/>
-            <a:ext cx="10424160" cy="594360"/>
+            <a:off x="685800" y="1325880"/>
+            <a:ext cx="10698480" cy="548640"/>
           </a:xfrm>
           <a:prstGeom prst="rect">
             <a:avLst/>
@@ -9550,7 +9531,7 @@
                 </a:solidFill>
                 <a:latin typeface="Calibri"/>
               </a:rPr>
-              <a:t>We don’t win by claiming exclusive smarter intelligence forever. We win by applying intelligence better — workflow, codebase context, integrated SDLC — with model neutrality as models and economics change.</a:t>
+              <a:t>We don’t win by claiming exclusive smarter intelligence forever. We win by applying intelligence better — workflow, codebase context, integrated SDLC — with model neutrality.</a:t>
             </a:r>
           </a:p>
         </p:txBody>
@@ -9563,8 +9544,8 @@
         </p:nvSpPr>
         <p:spPr>
           <a:xfrm>
-            <a:off x="640080" y="2286000"/>
-            <a:ext cx="3611880" cy="3749039"/>
+            <a:off x="502920" y="2148840"/>
+            <a:ext cx="2743200" cy="3886200"/>
           </a:xfrm>
           <a:prstGeom prst="rect">
             <a:avLst/>
@@ -9606,8 +9587,8 @@
         </p:nvSpPr>
         <p:spPr>
           <a:xfrm>
-            <a:off x="640080" y="2286000"/>
-            <a:ext cx="3611880" cy="502920"/>
+            <a:off x="502920" y="2148840"/>
+            <a:ext cx="2743200" cy="457200"/>
           </a:xfrm>
           <a:prstGeom prst="rect">
             <a:avLst/>
@@ -9649,8 +9630,8 @@
         </p:nvSpPr>
         <p:spPr>
           <a:xfrm>
-            <a:off x="822960" y="2359152"/>
-            <a:ext cx="3200400" cy="365760"/>
+            <a:off x="612648" y="2212848"/>
+            <a:ext cx="2514600" cy="347472"/>
           </a:xfrm>
           <a:prstGeom prst="rect">
             <a:avLst/>
@@ -9665,7 +9646,7 @@
           <a:p>
             <a:pPr algn="l"/>
             <a:r>
-              <a:rPr sz="1500" b="1">
+              <a:rPr sz="1200" b="1">
                 <a:solidFill>
                   <a:srgbClr val="D6F26A"/>
                 </a:solidFill>
@@ -9684,8 +9665,8 @@
         </p:nvSpPr>
         <p:spPr>
           <a:xfrm>
-            <a:off x="822960" y="2971800"/>
-            <a:ext cx="3200400" cy="2834640"/>
+            <a:off x="612648" y="2788920"/>
+            <a:ext cx="2514600" cy="3017520"/>
           </a:xfrm>
           <a:prstGeom prst="rect">
             <a:avLst/>
@@ -9700,27 +9681,27 @@
           <a:p>
             <a:pPr algn="l">
               <a:spcAft>
-                <a:spcPts val="700"/>
+                <a:spcPts val="500"/>
               </a:spcAft>
             </a:pPr>
             <a:r>
-              <a:rPr sz="1300" b="0">
+              <a:rPr sz="1100" b="0">
                 <a:solidFill>
                   <a:srgbClr val="1A1C1E"/>
                 </a:solidFill>
                 <a:latin typeface="Calibri"/>
               </a:rPr>
-              <a:t>•  Agentic coding platform</a:t>
+              <a:t>•  AI-native IDE + enterprise platform</a:t>
             </a:r>
           </a:p>
           <a:p>
             <a:pPr algn="l">
               <a:spcAft>
-                <a:spcPts val="700"/>
+                <a:spcPts val="500"/>
               </a:spcAft>
             </a:pPr>
             <a:r>
-              <a:rPr sz="1300" b="0">
+              <a:rPr sz="1100" b="0">
                 <a:solidFill>
                   <a:srgbClr val="1A1C1E"/>
                 </a:solidFill>
@@ -9732,11 +9713,11 @@
           <a:p>
             <a:pPr algn="l">
               <a:spcAft>
-                <a:spcPts val="700"/>
+                <a:spcPts val="500"/>
               </a:spcAft>
             </a:pPr>
             <a:r>
-              <a:rPr sz="1300" b="0">
+              <a:rPr sz="1100" b="0">
                 <a:solidFill>
                   <a:srgbClr val="1A1C1E"/>
                 </a:solidFill>
@@ -9748,11 +9729,11 @@
           <a:p>
             <a:pPr algn="l">
               <a:spcAft>
-                <a:spcPts val="700"/>
+                <a:spcPts val="500"/>
               </a:spcAft>
             </a:pPr>
             <a:r>
-              <a:rPr sz="1300" b="0">
+              <a:rPr sz="1100" b="0">
                 <a:solidFill>
                   <a:srgbClr val="1A1C1E"/>
                 </a:solidFill>
@@ -9764,33 +9745,33 @@
           <a:p>
             <a:pPr algn="l">
               <a:spcAft>
-                <a:spcPts val="700"/>
+                <a:spcPts val="500"/>
               </a:spcAft>
             </a:pPr>
             <a:r>
-              <a:rPr sz="1300" b="0">
+              <a:rPr sz="1100" b="0">
                 <a:solidFill>
                   <a:srgbClr val="1A1C1E"/>
                 </a:solidFill>
                 <a:latin typeface="Calibri"/>
               </a:rPr>
-              <a:t>•  Model neutrality + Composer path</a:t>
+              <a:t>•  Multi-model + Composer path</a:t>
             </a:r>
           </a:p>
           <a:p>
             <a:pPr algn="l">
               <a:spcAft>
-                <a:spcPts val="700"/>
+                <a:spcPts val="500"/>
               </a:spcAft>
             </a:pPr>
             <a:r>
-              <a:rPr sz="1300" b="0">
+              <a:rPr sz="1100" b="0">
                 <a:solidFill>
                   <a:srgbClr val="1A1C1E"/>
                 </a:solidFill>
                 <a:latin typeface="Calibri"/>
               </a:rPr>
-              <a:t>•  SDLC: plan → write → review → ship</a:t>
+              <a:t>•  Bugbot / review clears PR bottleneck</a:t>
             </a:r>
           </a:p>
         </p:txBody>
@@ -9803,8 +9784,8 @@
         </p:nvSpPr>
         <p:spPr>
           <a:xfrm>
-            <a:off x="4434840" y="2286000"/>
-            <a:ext cx="3611880" cy="3749039"/>
+            <a:off x="3383280" y="2148840"/>
+            <a:ext cx="2743200" cy="3886200"/>
           </a:xfrm>
           <a:prstGeom prst="rect">
             <a:avLst/>
@@ -9846,8 +9827,8 @@
         </p:nvSpPr>
         <p:spPr>
           <a:xfrm>
-            <a:off x="4434840" y="2286000"/>
-            <a:ext cx="3611880" cy="502920"/>
+            <a:off x="3383280" y="2148840"/>
+            <a:ext cx="2743200" cy="457200"/>
           </a:xfrm>
           <a:prstGeom prst="rect">
             <a:avLst/>
@@ -9889,8 +9870,8 @@
         </p:nvSpPr>
         <p:spPr>
           <a:xfrm>
-            <a:off x="4617720" y="2359152"/>
-            <a:ext cx="3200400" cy="365760"/>
+            <a:off x="3493008" y="2212848"/>
+            <a:ext cx="2514600" cy="347472"/>
           </a:xfrm>
           <a:prstGeom prst="rect">
             <a:avLst/>
@@ -9905,7 +9886,7 @@
           <a:p>
             <a:pPr algn="l"/>
             <a:r>
-              <a:rPr sz="1500" b="1">
+              <a:rPr sz="1200" b="1">
                 <a:solidFill>
                   <a:srgbClr val="FFFFFF"/>
                 </a:solidFill>
@@ -9924,8 +9905,8 @@
         </p:nvSpPr>
         <p:spPr>
           <a:xfrm>
-            <a:off x="4617720" y="2971800"/>
-            <a:ext cx="3200400" cy="2834640"/>
+            <a:off x="3493008" y="2788920"/>
+            <a:ext cx="2514600" cy="3017520"/>
           </a:xfrm>
           <a:prstGeom prst="rect">
             <a:avLst/>
@@ -9940,11 +9921,11 @@
           <a:p>
             <a:pPr algn="l">
               <a:spcAft>
-                <a:spcPts val="700"/>
+                <a:spcPts val="500"/>
               </a:spcAft>
             </a:pPr>
             <a:r>
-              <a:rPr sz="1300" b="0">
+              <a:rPr sz="1100" b="0">
                 <a:solidFill>
                   <a:srgbClr val="1A1C1E"/>
                 </a:solidFill>
@@ -9956,11 +9937,11 @@
           <a:p>
             <a:pPr algn="l">
               <a:spcAft>
-                <a:spcPts val="700"/>
+                <a:spcPts val="500"/>
               </a:spcAft>
             </a:pPr>
             <a:r>
-              <a:rPr sz="1300" b="0">
+              <a:rPr sz="1100" b="0">
                 <a:solidFill>
                   <a:srgbClr val="1A1C1E"/>
                 </a:solidFill>
@@ -9972,27 +9953,27 @@
           <a:p>
             <a:pPr algn="l">
               <a:spcAft>
-                <a:spcPts val="700"/>
+                <a:spcPts val="500"/>
               </a:spcAft>
             </a:pPr>
             <a:r>
-              <a:rPr sz="1300" b="0">
+              <a:rPr sz="1100" b="0">
                 <a:solidFill>
                   <a:srgbClr val="1A1C1E"/>
                 </a:solidFill>
                 <a:latin typeface="Calibri"/>
               </a:rPr>
-              <a:t>•  Point solution in many stacks</a:t>
+              <a:t>•  Wins: GitHub ecosystem + friction</a:t>
             </a:r>
           </a:p>
           <a:p>
             <a:pPr algn="l">
               <a:spcAft>
-                <a:spcPts val="700"/>
+                <a:spcPts val="500"/>
               </a:spcAft>
             </a:pPr>
             <a:r>
-              <a:rPr sz="1300" b="0">
+              <a:rPr sz="1100" b="0">
                 <a:solidFill>
                   <a:srgbClr val="1A1C1E"/>
                 </a:solidFill>
@@ -10004,11 +9985,11 @@
           <a:p>
             <a:pPr algn="l">
               <a:spcAft>
-                <a:spcPts val="700"/>
+                <a:spcPts val="500"/>
               </a:spcAft>
             </a:pPr>
             <a:r>
-              <a:rPr sz="1300" b="0">
+              <a:rPr sz="1100" b="0">
                 <a:solidFill>
                   <a:srgbClr val="1A1C1E"/>
                 </a:solidFill>
@@ -10020,11 +10001,11 @@
           <a:p>
             <a:pPr algn="l">
               <a:spcAft>
-                <a:spcPts val="700"/>
+                <a:spcPts val="500"/>
               </a:spcAft>
             </a:pPr>
             <a:r>
-              <a:rPr sz="1300" b="0">
+              <a:rPr sz="1100" b="0">
                 <a:solidFill>
                   <a:srgbClr val="1A1C1E"/>
                 </a:solidFill>
@@ -10043,8 +10024,8 @@
         </p:nvSpPr>
         <p:spPr>
           <a:xfrm>
-            <a:off x="8229600" y="2286000"/>
-            <a:ext cx="3611880" cy="3749039"/>
+            <a:off x="6263640" y="2148840"/>
+            <a:ext cx="2743200" cy="3886200"/>
           </a:xfrm>
           <a:prstGeom prst="rect">
             <a:avLst/>
@@ -10086,8 +10067,8 @@
         </p:nvSpPr>
         <p:spPr>
           <a:xfrm>
-            <a:off x="8229600" y="2286000"/>
-            <a:ext cx="3611880" cy="502920"/>
+            <a:off x="6263640" y="2148840"/>
+            <a:ext cx="2743200" cy="457200"/>
           </a:xfrm>
           <a:prstGeom prst="rect">
             <a:avLst/>
@@ -10129,8 +10110,8 @@
         </p:nvSpPr>
         <p:spPr>
           <a:xfrm>
-            <a:off x="8412480" y="2359152"/>
-            <a:ext cx="3200400" cy="365760"/>
+            <a:off x="6373368" y="2212848"/>
+            <a:ext cx="2514600" cy="347472"/>
           </a:xfrm>
           <a:prstGeom prst="rect">
             <a:avLst/>
@@ -10145,7 +10126,7 @@
           <a:p>
             <a:pPr algn="l"/>
             <a:r>
-              <a:rPr sz="1500" b="1">
+              <a:rPr sz="1200" b="1">
                 <a:solidFill>
                   <a:srgbClr val="FFFFFF"/>
                 </a:solidFill>
@@ -10164,8 +10145,8 @@
         </p:nvSpPr>
         <p:spPr>
           <a:xfrm>
-            <a:off x="8412480" y="2971800"/>
-            <a:ext cx="3200400" cy="2834640"/>
+            <a:off x="6373368" y="2788920"/>
+            <a:ext cx="2514600" cy="3017520"/>
           </a:xfrm>
           <a:prstGeom prst="rect">
             <a:avLst/>
@@ -10180,11 +10161,11 @@
           <a:p>
             <a:pPr algn="l">
               <a:spcAft>
-                <a:spcPts val="700"/>
+                <a:spcPts val="500"/>
               </a:spcAft>
             </a:pPr>
             <a:r>
-              <a:rPr sz="1300" b="0">
+              <a:rPr sz="1100" b="0">
                 <a:solidFill>
                   <a:srgbClr val="1A1C1E"/>
                 </a:solidFill>
@@ -10196,81 +10177,321 @@
           <a:p>
             <a:pPr algn="l">
               <a:spcAft>
-                <a:spcPts val="700"/>
+                <a:spcPts val="500"/>
               </a:spcAft>
             </a:pPr>
             <a:r>
-              <a:rPr sz="1300" b="0">
+              <a:rPr sz="1100" b="0">
                 <a:solidFill>
                   <a:srgbClr val="1A1C1E"/>
                 </a:solidFill>
                 <a:latin typeface="Calibri"/>
               </a:rPr>
-              <a:t>•  Not a “smarter model” war</a:t>
+              <a:t>•  Terminal-first agent shape</a:t>
             </a:r>
           </a:p>
           <a:p>
             <a:pPr algn="l">
               <a:spcAft>
-                <a:spcPts val="700"/>
+                <a:spcPts val="500"/>
               </a:spcAft>
             </a:pPr>
             <a:r>
-              <a:rPr sz="1300" b="0">
+              <a:rPr sz="1100" b="0">
                 <a:solidFill>
                   <a:srgbClr val="1A1C1E"/>
                 </a:solidFill>
                 <a:latin typeface="Calibri"/>
               </a:rPr>
-              <a:t>•  Our edge: model neutrality</a:t>
+              <a:t>•  Not a “smarter model” war</a:t>
             </a:r>
           </a:p>
           <a:p>
             <a:pPr algn="l">
               <a:spcAft>
-                <a:spcPts val="700"/>
+                <a:spcPts val="500"/>
               </a:spcAft>
             </a:pPr>
             <a:r>
-              <a:rPr sz="1300" b="0">
+              <a:rPr sz="1100" b="0">
                 <a:solidFill>
                   <a:srgbClr val="1A1C1E"/>
                 </a:solidFill>
                 <a:latin typeface="Calibri"/>
               </a:rPr>
-              <a:t>•  Our edge: SDLC integration</a:t>
+              <a:t>•  Our edge: model neutrality</a:t>
             </a:r>
           </a:p>
           <a:p>
             <a:pPr algn="l">
               <a:spcAft>
-                <a:spcPts val="700"/>
+                <a:spcPts val="500"/>
               </a:spcAft>
             </a:pPr>
             <a:r>
-              <a:rPr sz="1300" b="0">
+              <a:rPr sz="1100" b="0">
                 <a:solidFill>
                   <a:srgbClr val="1A1C1E"/>
                 </a:solidFill>
                 <a:latin typeface="Calibri"/>
               </a:rPr>
-              <a:t>•  Our edge: large / messy repos</a:t>
+              <a:t>•  Our edge: SDLC integration</a:t>
             </a:r>
           </a:p>
           <a:p>
             <a:pPr algn="l">
               <a:spcAft>
-                <a:spcPts val="700"/>
+                <a:spcPts val="500"/>
               </a:spcAft>
             </a:pPr>
             <a:r>
-              <a:rPr sz="1300" b="0">
+              <a:rPr sz="1100" b="0">
                 <a:solidFill>
                   <a:srgbClr val="1A1C1E"/>
                 </a:solidFill>
                 <a:latin typeface="Calibri"/>
               </a:rPr>
-              <a:t>•  Our edge: faster team time-to-value</a:t>
+              <a:t>•  Our edge: team time-to-value</a:t>
+            </a:r>
+          </a:p>
+        </p:txBody>
+      </p:sp>
+      <p:sp>
+        <p:nvSpPr>
+          <p:cNvPr id="19" name="Rectangle 18"/>
+          <p:cNvSpPr/>
+          <p:nvPr/>
+        </p:nvSpPr>
+        <p:spPr>
+          <a:xfrm>
+            <a:off x="9144000" y="2148840"/>
+            <a:ext cx="2743200" cy="3886200"/>
+          </a:xfrm>
+          <a:prstGeom prst="rect">
+            <a:avLst/>
+          </a:prstGeom>
+          <a:solidFill>
+            <a:srgbClr val="FFFFFF"/>
+          </a:solidFill>
+          <a:ln>
+            <a:noFill/>
+          </a:ln>
+        </p:spPr>
+        <p:style>
+          <a:lnRef idx="1">
+            <a:schemeClr val="accent1"/>
+          </a:lnRef>
+          <a:fillRef idx="3">
+            <a:schemeClr val="accent1"/>
+          </a:fillRef>
+          <a:effectRef idx="2">
+            <a:schemeClr val="accent1"/>
+          </a:effectRef>
+          <a:fontRef idx="minor">
+            <a:schemeClr val="lt1"/>
+          </a:fontRef>
+        </p:style>
+        <p:txBody>
+          <a:bodyPr rtlCol="0" anchor="ctr"/>
+          <a:lstStyle/>
+          <a:p>
+            <a:pPr algn="ctr"/>
+          </a:p>
+        </p:txBody>
+      </p:sp>
+      <p:sp>
+        <p:nvSpPr>
+          <p:cNvPr id="20" name="Rectangle 19"/>
+          <p:cNvSpPr/>
+          <p:nvPr/>
+        </p:nvSpPr>
+        <p:spPr>
+          <a:xfrm>
+            <a:off x="9144000" y="2148840"/>
+            <a:ext cx="2743200" cy="457200"/>
+          </a:xfrm>
+          <a:prstGeom prst="rect">
+            <a:avLst/>
+          </a:prstGeom>
+          <a:solidFill>
+            <a:srgbClr val="2A2F34"/>
+          </a:solidFill>
+          <a:ln>
+            <a:noFill/>
+          </a:ln>
+        </p:spPr>
+        <p:style>
+          <a:lnRef idx="1">
+            <a:schemeClr val="accent1"/>
+          </a:lnRef>
+          <a:fillRef idx="3">
+            <a:schemeClr val="accent1"/>
+          </a:fillRef>
+          <a:effectRef idx="2">
+            <a:schemeClr val="accent1"/>
+          </a:effectRef>
+          <a:fontRef idx="minor">
+            <a:schemeClr val="lt1"/>
+          </a:fontRef>
+        </p:style>
+        <p:txBody>
+          <a:bodyPr rtlCol="0" anchor="ctr"/>
+          <a:lstStyle/>
+          <a:p>
+            <a:pPr algn="ctr"/>
+          </a:p>
+        </p:txBody>
+      </p:sp>
+      <p:sp>
+        <p:nvSpPr>
+          <p:cNvPr id="21" name="TextBox 20"/>
+          <p:cNvSpPr txBox="1"/>
+          <p:nvPr/>
+        </p:nvSpPr>
+        <p:spPr>
+          <a:xfrm>
+            <a:off x="9253728" y="2212848"/>
+            <a:ext cx="2514600" cy="347472"/>
+          </a:xfrm>
+          <a:prstGeom prst="rect">
+            <a:avLst/>
+          </a:prstGeom>
+          <a:noFill/>
+        </p:spPr>
+        <p:txBody>
+          <a:bodyPr wrap="square" anchor="t">
+            <a:spAutoFit/>
+          </a:bodyPr>
+          <a:lstStyle/>
+          <a:p>
+            <a:pPr algn="l"/>
+            <a:r>
+              <a:rPr sz="1200" b="1">
+                <a:solidFill>
+                  <a:srgbClr val="FFFFFF"/>
+                </a:solidFill>
+                <a:latin typeface="Georgia"/>
+              </a:rPr>
+              <a:t>Also in market</a:t>
+            </a:r>
+          </a:p>
+        </p:txBody>
+      </p:sp>
+      <p:sp>
+        <p:nvSpPr>
+          <p:cNvPr id="22" name="TextBox 21"/>
+          <p:cNvSpPr txBox="1"/>
+          <p:nvPr/>
+        </p:nvSpPr>
+        <p:spPr>
+          <a:xfrm>
+            <a:off x="9253728" y="2788920"/>
+            <a:ext cx="2514600" cy="3017520"/>
+          </a:xfrm>
+          <a:prstGeom prst="rect">
+            <a:avLst/>
+          </a:prstGeom>
+          <a:noFill/>
+        </p:spPr>
+        <p:txBody>
+          <a:bodyPr wrap="square">
+            <a:spAutoFit/>
+          </a:bodyPr>
+          <a:lstStyle/>
+          <a:p>
+            <a:pPr algn="l">
+              <a:spcAft>
+                <a:spcPts val="500"/>
+              </a:spcAft>
+            </a:pPr>
+            <a:r>
+              <a:rPr sz="1100" b="0">
+                <a:solidFill>
+                  <a:srgbClr val="1A1C1E"/>
+                </a:solidFill>
+                <a:latin typeface="Calibri"/>
+              </a:rPr>
+              <a:t>•  Windsurf: Cascade agent UX</a:t>
+            </a:r>
+          </a:p>
+          <a:p>
+            <a:pPr algn="l">
+              <a:spcAft>
+                <a:spcPts val="500"/>
+              </a:spcAft>
+            </a:pPr>
+            <a:r>
+              <a:rPr sz="1100" b="0">
+                <a:solidFill>
+                  <a:srgbClr val="1A1C1E"/>
+                </a:solidFill>
+                <a:latin typeface="Calibri"/>
+              </a:rPr>
+              <a:t>•  Codex: OpenAI async agents</a:t>
+            </a:r>
+          </a:p>
+          <a:p>
+            <a:pPr algn="l">
+              <a:spcAft>
+                <a:spcPts val="500"/>
+              </a:spcAft>
+            </a:pPr>
+            <a:r>
+              <a:rPr sz="1100" b="0">
+                <a:solidFill>
+                  <a:srgbClr val="1A1C1E"/>
+                </a:solidFill>
+                <a:latin typeface="Calibri"/>
+              </a:rPr>
+              <a:t>•  Shadow AI: real enterprise rival</a:t>
+            </a:r>
+          </a:p>
+          <a:p>
+            <a:pPr algn="l">
+              <a:spcAft>
+                <a:spcPts val="500"/>
+              </a:spcAft>
+            </a:pPr>
+            <a:r>
+              <a:rPr sz="1100" b="0">
+                <a:solidFill>
+                  <a:srgbClr val="1A1C1E"/>
+                </a:solidFill>
+                <a:latin typeface="Calibri"/>
+              </a:rPr>
+              <a:t>•  Win = governed standardization</a:t>
+            </a:r>
+          </a:p>
+          <a:p>
+            <a:pPr algn="l">
+              <a:spcAft>
+                <a:spcPts val="500"/>
+              </a:spcAft>
+            </a:pPr>
+            <a:r>
+              <a:rPr sz="1100" b="0">
+                <a:solidFill>
+                  <a:srgbClr val="1A1C1E"/>
+                </a:solidFill>
+                <a:latin typeface="Calibri"/>
+              </a:rPr>
+              <a:t>•  Proof: Coinbase / Stripe / PayPal</a:t>
+            </a:r>
+          </a:p>
+          <a:p>
+            <a:pPr algn="l">
+              <a:spcAft>
+                <a:spcPts val="500"/>
+              </a:spcAft>
+            </a:pPr>
+            <a:r>
+              <a:rPr sz="1100" b="0">
+                <a:solidFill>
+                  <a:srgbClr val="1A1C1E"/>
+                </a:solidFill>
+                <a:latin typeface="Calibri"/>
+              </a:rPr>
+              <a:t>•  Outcomes &gt; autocomplete vanity</a:t>
             </a:r>
           </a:p>
         </p:txBody>
@@ -10345,7 +10566,7 @@
         <p:spPr>
           <a:xfrm>
             <a:off x="0" y="0"/>
-            <a:ext cx="12191695" cy="1143000"/>
+            <a:ext cx="12191695" cy="1097280"/>
           </a:xfrm>
           <a:prstGeom prst="rect">
             <a:avLst/>
@@ -10387,8 +10608,8 @@
         </p:nvSpPr>
         <p:spPr>
           <a:xfrm>
-            <a:off x="777240" y="320040"/>
-            <a:ext cx="10515600" cy="594360"/>
+            <a:off x="731520" y="292608"/>
+            <a:ext cx="10698480" cy="548640"/>
           </a:xfrm>
           <a:prstGeom prst="rect">
             <a:avLst/>
@@ -10403,13 +10624,13 @@
           <a:p>
             <a:pPr algn="l"/>
             <a:r>
-              <a:rPr sz="2600" b="1">
+              <a:rPr sz="2400" b="1">
                 <a:solidFill>
                   <a:srgbClr val="FFFFFF"/>
                 </a:solidFill>
                 <a:latin typeface="Georgia"/>
               </a:rPr>
-              <a:t>Thesis: make a high-performing machine materially better</a:t>
+              <a:t>Thesis: don’t rebuild a working machine — raise its ceiling</a:t>
             </a:r>
           </a:p>
         </p:txBody>
@@ -10422,8 +10643,8 @@
         </p:nvSpPr>
         <p:spPr>
           <a:xfrm>
-            <a:off x="822960" y="1554480"/>
-            <a:ext cx="10424160" cy="4297680"/>
+            <a:off x="777240" y="1417320"/>
+            <a:ext cx="10515600" cy="4572000"/>
           </a:xfrm>
           <a:prstGeom prst="rect">
             <a:avLst/>
@@ -10438,43 +10659,43 @@
           <a:p>
             <a:pPr algn="l">
               <a:spcAft>
-                <a:spcPts val="1300"/>
+                <a:spcPts val="1200"/>
               </a:spcAft>
             </a:pPr>
             <a:r>
-              <a:rPr sz="1900" b="0">
+              <a:rPr sz="1800" b="0">
                 <a:solidFill>
                   <a:srgbClr val="1A1C1E"/>
                 </a:solidFill>
                 <a:latin typeface="Calibri"/>
               </a:rPr>
-              <a:t>•  EMEA already works: AI-augmented workflows, clear ICP, eight-figure qualified pipeline / month</a:t>
+              <a:t>•  EMEA already high-performing: AI-augmented workflows, clear ICP, eight-figure monthly pipeline</a:t>
             </a:r>
           </a:p>
           <a:p>
             <a:pPr algn="l">
               <a:spcAft>
-                <a:spcPts val="1300"/>
+                <a:spcPts val="1200"/>
               </a:spcAft>
             </a:pPr>
             <a:r>
-              <a:rPr sz="1900" b="0">
+              <a:rPr sz="1800" b="0">
                 <a:solidFill>
                   <a:srgbClr val="1A1C1E"/>
                 </a:solidFill>
                 <a:latin typeface="Calibri"/>
               </a:rPr>
-              <a:t>•  Job = find real constraints, protect what’s working, run a few high-leverage experiments</a:t>
+              <a:t>•  Job = find real constraints, protect what works, run a few high-leverage experiments</a:t>
             </a:r>
           </a:p>
           <a:p>
             <a:pPr algn="l">
               <a:spcAft>
-                <a:spcPts val="1300"/>
+                <a:spcPts val="1200"/>
               </a:spcAft>
             </a:pPr>
             <a:r>
-              <a:rPr sz="1900" b="0">
+              <a:rPr sz="1800" b="0">
                 <a:solidFill>
                   <a:srgbClr val="1A1C1E"/>
                 </a:solidFill>
@@ -10486,11 +10707,11 @@
           <a:p>
             <a:pPr algn="l">
               <a:spcAft>
-                <a:spcPts val="1300"/>
+                <a:spcPts val="1200"/>
               </a:spcAft>
             </a:pPr>
             <a:r>
-              <a:rPr sz="1900" b="0">
+              <a:rPr sz="1800" b="0">
                 <a:solidFill>
                   <a:srgbClr val="1A1C1E"/>
                 </a:solidFill>
@@ -10502,52 +10723,17 @@
           <a:p>
             <a:pPr algn="l">
               <a:spcAft>
-                <a:spcPts val="1300"/>
+                <a:spcPts val="1200"/>
               </a:spcAft>
             </a:pPr>
             <a:r>
-              <a:rPr sz="1900" b="0">
+              <a:rPr sz="1800" b="0">
                 <a:solidFill>
                   <a:srgbClr val="1A1C1E"/>
                 </a:solidFill>
                 <a:latin typeface="Calibri"/>
               </a:rPr>
               <a:t>•  Success = better conversation quality + higher AE acceptance — not a reorg</a:t>
-            </a:r>
-          </a:p>
-        </p:txBody>
-      </p:sp>
-      <p:sp>
-        <p:nvSpPr>
-          <p:cNvPr id="6" name="TextBox 5"/>
-          <p:cNvSpPr txBox="1"/>
-          <p:nvPr/>
-        </p:nvSpPr>
-        <p:spPr>
-          <a:xfrm>
-            <a:off x="822960" y="6355080"/>
-            <a:ext cx="10058400" cy="274320"/>
-          </a:xfrm>
-          <a:prstGeom prst="rect">
-            <a:avLst/>
-          </a:prstGeom>
-          <a:noFill/>
-        </p:spPr>
-        <p:txBody>
-          <a:bodyPr wrap="square" anchor="t">
-            <a:spAutoFit/>
-          </a:bodyPr>
-          <a:lstStyle/>
-          <a:p>
-            <a:pPr algn="l"/>
-            <a:r>
-              <a:rPr sz="1100" b="0">
-                <a:solidFill>
-                  <a:srgbClr val="5E646B"/>
-                </a:solidFill>
-                <a:latin typeface="Calibri"/>
-              </a:rPr>
-              <a:t>Lindsey Dempsey  ·  EMEA SDR</a:t>
             </a:r>
           </a:p>
         </p:txBody>
@@ -10622,7 +10808,7 @@
         <p:spPr>
           <a:xfrm>
             <a:off x="0" y="0"/>
-            <a:ext cx="12191695" cy="1143000"/>
+            <a:ext cx="12191695" cy="1097280"/>
           </a:xfrm>
           <a:prstGeom prst="rect">
             <a:avLst/>
@@ -10664,8 +10850,8 @@
         </p:nvSpPr>
         <p:spPr>
           <a:xfrm>
-            <a:off x="777240" y="320040"/>
-            <a:ext cx="10515600" cy="594360"/>
+            <a:off x="731520" y="292608"/>
+            <a:ext cx="10698480" cy="548640"/>
           </a:xfrm>
           <a:prstGeom prst="rect">
             <a:avLst/>
@@ -10680,7 +10866,7 @@
           <a:p>
             <a:pPr algn="l"/>
             <a:r>
-              <a:rPr sz="2600" b="1">
+              <a:rPr sz="2400" b="1">
                 <a:solidFill>
                   <a:srgbClr val="FFFFFF"/>
                 </a:solidFill>
@@ -10699,8 +10885,8 @@
         </p:nvSpPr>
         <p:spPr>
           <a:xfrm>
-            <a:off x="640080" y="1417320"/>
-            <a:ext cx="5257800" cy="4572000"/>
+            <a:off x="594360" y="1325880"/>
+            <a:ext cx="5349240" cy="4754880"/>
           </a:xfrm>
           <a:prstGeom prst="rect">
             <a:avLst/>
@@ -10742,8 +10928,8 @@
         </p:nvSpPr>
         <p:spPr>
           <a:xfrm>
-            <a:off x="914400" y="1691640"/>
-            <a:ext cx="822960" cy="73152"/>
+            <a:off x="868680" y="1554480"/>
+            <a:ext cx="777240" cy="73152"/>
           </a:xfrm>
           <a:prstGeom prst="rect">
             <a:avLst/>
@@ -10785,8 +10971,8 @@
         </p:nvSpPr>
         <p:spPr>
           <a:xfrm>
-            <a:off x="914400" y="1920240"/>
-            <a:ext cx="4663440" cy="365760"/>
+            <a:off x="868680" y="1783080"/>
+            <a:ext cx="4754880" cy="365760"/>
           </a:xfrm>
           <a:prstGeom prst="rect">
             <a:avLst/>
@@ -10801,7 +10987,7 @@
           <a:p>
             <a:pPr algn="l"/>
             <a:r>
-              <a:rPr sz="1800" b="1">
+              <a:rPr sz="1700" b="1">
                 <a:solidFill>
                   <a:srgbClr val="141618"/>
                 </a:solidFill>
@@ -10820,8 +11006,8 @@
         </p:nvSpPr>
         <p:spPr>
           <a:xfrm>
-            <a:off x="914400" y="2423160"/>
-            <a:ext cx="4663440" cy="3200400"/>
+            <a:off x="868680" y="2286000"/>
+            <a:ext cx="4754880" cy="3474720"/>
           </a:xfrm>
           <a:prstGeom prst="rect">
             <a:avLst/>
@@ -10836,11 +11022,11 @@
           <a:p>
             <a:pPr algn="l">
               <a:spcAft>
-                <a:spcPts val="900"/>
+                <a:spcPts val="800"/>
               </a:spcAft>
             </a:pPr>
             <a:r>
-              <a:rPr sz="1600" b="0">
+              <a:rPr sz="1500" b="0">
                 <a:solidFill>
                   <a:srgbClr val="1A1C1E"/>
                 </a:solidFill>
@@ -10852,11 +11038,11 @@
           <a:p>
             <a:pPr algn="l">
               <a:spcAft>
-                <a:spcPts val="900"/>
+                <a:spcPts val="800"/>
               </a:spcAft>
             </a:pPr>
             <a:r>
-              <a:rPr sz="1600" b="0">
+              <a:rPr sz="1500" b="0">
                 <a:solidFill>
                   <a:srgbClr val="1A1C1E"/>
                 </a:solidFill>
@@ -10868,11 +11054,11 @@
           <a:p>
             <a:pPr algn="l">
               <a:spcAft>
-                <a:spcPts val="900"/>
+                <a:spcPts val="800"/>
               </a:spcAft>
             </a:pPr>
             <a:r>
-              <a:rPr sz="1600" b="0">
+              <a:rPr sz="1500" b="0">
                 <a:solidFill>
                   <a:srgbClr val="1A1C1E"/>
                 </a:solidFill>
@@ -10884,11 +11070,11 @@
           <a:p>
             <a:pPr algn="l">
               <a:spcAft>
-                <a:spcPts val="900"/>
+                <a:spcPts val="800"/>
               </a:spcAft>
             </a:pPr>
             <a:r>
-              <a:rPr sz="1600" b="0">
+              <a:rPr sz="1500" b="0">
                 <a:solidFill>
                   <a:srgbClr val="1A1C1E"/>
                 </a:solidFill>
@@ -10907,8 +11093,8 @@
         </p:nvSpPr>
         <p:spPr>
           <a:xfrm>
-            <a:off x="6263640" y="1417320"/>
-            <a:ext cx="5257800" cy="4572000"/>
+            <a:off x="6217920" y="1325880"/>
+            <a:ext cx="5349240" cy="4754880"/>
           </a:xfrm>
           <a:prstGeom prst="rect">
             <a:avLst/>
@@ -10950,8 +11136,8 @@
         </p:nvSpPr>
         <p:spPr>
           <a:xfrm>
-            <a:off x="6537960" y="1691640"/>
-            <a:ext cx="822960" cy="73152"/>
+            <a:off x="6492240" y="1554480"/>
+            <a:ext cx="777240" cy="73152"/>
           </a:xfrm>
           <a:prstGeom prst="rect">
             <a:avLst/>
@@ -10993,8 +11179,8 @@
         </p:nvSpPr>
         <p:spPr>
           <a:xfrm>
-            <a:off x="6537960" y="1920240"/>
-            <a:ext cx="4663440" cy="365760"/>
+            <a:off x="6492240" y="1783080"/>
+            <a:ext cx="4754880" cy="365760"/>
           </a:xfrm>
           <a:prstGeom prst="rect">
             <a:avLst/>
@@ -11009,7 +11195,7 @@
           <a:p>
             <a:pPr algn="l"/>
             <a:r>
-              <a:rPr sz="1800" b="1">
+              <a:rPr sz="1700" b="1">
                 <a:solidFill>
                   <a:srgbClr val="141618"/>
                 </a:solidFill>
@@ -11028,8 +11214,8 @@
         </p:nvSpPr>
         <p:spPr>
           <a:xfrm>
-            <a:off x="6537960" y="2423160"/>
-            <a:ext cx="4663440" cy="3200400"/>
+            <a:off x="6492240" y="2286000"/>
+            <a:ext cx="4754880" cy="3474720"/>
           </a:xfrm>
           <a:prstGeom prst="rect">
             <a:avLst/>
@@ -11044,11 +11230,11 @@
           <a:p>
             <a:pPr algn="l">
               <a:spcAft>
-                <a:spcPts val="900"/>
+                <a:spcPts val="800"/>
               </a:spcAft>
             </a:pPr>
             <a:r>
-              <a:rPr sz="1600" b="0">
+              <a:rPr sz="1500" b="0">
                 <a:solidFill>
                   <a:srgbClr val="1A1C1E"/>
                 </a:solidFill>
@@ -11060,11 +11246,11 @@
           <a:p>
             <a:pPr algn="l">
               <a:spcAft>
-                <a:spcPts val="900"/>
+                <a:spcPts val="800"/>
               </a:spcAft>
             </a:pPr>
             <a:r>
-              <a:rPr sz="1600" b="0">
+              <a:rPr sz="1500" b="0">
                 <a:solidFill>
                   <a:srgbClr val="1A1C1E"/>
                 </a:solidFill>
@@ -11076,27 +11262,27 @@
           <a:p>
             <a:pPr algn="l">
               <a:spcAft>
-                <a:spcPts val="900"/>
+                <a:spcPts val="800"/>
               </a:spcAft>
             </a:pPr>
             <a:r>
-              <a:rPr sz="1600" b="0">
+              <a:rPr sz="1500" b="0">
                 <a:solidFill>
                   <a:srgbClr val="1A1C1E"/>
                 </a:solidFill>
                 <a:latin typeface="Calibri"/>
               </a:rPr>
-              <a:t>•  Security requirements influence product design</a:t>
+              <a:t>•  SSO / SCIM / audit logs for regulated buyers</a:t>
             </a:r>
           </a:p>
           <a:p>
             <a:pPr algn="l">
               <a:spcAft>
-                <a:spcPts val="900"/>
+                <a:spcPts val="800"/>
               </a:spcAft>
             </a:pPr>
             <a:r>
-              <a:rPr sz="1600" b="0">
+              <a:rPr sz="1500" b="0">
                 <a:solidFill>
                   <a:srgbClr val="1A1C1E"/>
                 </a:solidFill>
@@ -11177,7 +11363,7 @@
         <p:spPr>
           <a:xfrm>
             <a:off x="0" y="0"/>
-            <a:ext cx="12191695" cy="1143000"/>
+            <a:ext cx="12191695" cy="1097280"/>
           </a:xfrm>
           <a:prstGeom prst="rect">
             <a:avLst/>
@@ -11219,8 +11405,8 @@
         </p:nvSpPr>
         <p:spPr>
           <a:xfrm>
-            <a:off x="777240" y="320040"/>
-            <a:ext cx="10515600" cy="594360"/>
+            <a:off x="731520" y="292608"/>
+            <a:ext cx="10698480" cy="548640"/>
           </a:xfrm>
           <a:prstGeom prst="rect">
             <a:avLst/>
@@ -11235,7 +11421,7 @@
           <a:p>
             <a:pPr algn="l"/>
             <a:r>
-              <a:rPr sz="2600" b="1">
+              <a:rPr sz="2400" b="1">
                 <a:solidFill>
                   <a:srgbClr val="FFFFFF"/>
                 </a:solidFill>
@@ -11254,8 +11440,8 @@
         </p:nvSpPr>
         <p:spPr>
           <a:xfrm>
-            <a:off x="822960" y="1554480"/>
-            <a:ext cx="10424160" cy="4297680"/>
+            <a:off x="777240" y="1417320"/>
+            <a:ext cx="10515600" cy="4572000"/>
           </a:xfrm>
           <a:prstGeom prst="rect">
             <a:avLst/>
@@ -11270,11 +11456,11 @@
           <a:p>
             <a:pPr algn="l">
               <a:spcAft>
-                <a:spcPts val="1300"/>
+                <a:spcPts val="1200"/>
               </a:spcAft>
             </a:pPr>
             <a:r>
-              <a:rPr sz="1900" b="0">
+              <a:rPr sz="1800" b="0">
                 <a:solidFill>
                   <a:srgbClr val="1A1C1E"/>
                 </a:solidFill>
@@ -11286,11 +11472,11 @@
           <a:p>
             <a:pPr algn="l">
               <a:spcAft>
-                <a:spcPts val="1300"/>
+                <a:spcPts val="1200"/>
               </a:spcAft>
             </a:pPr>
             <a:r>
-              <a:rPr sz="1900" b="0">
+              <a:rPr sz="1800" b="0">
                 <a:solidFill>
                   <a:srgbClr val="1A1C1E"/>
                 </a:solidFill>
@@ -11302,11 +11488,11 @@
           <a:p>
             <a:pPr algn="l">
               <a:spcAft>
-                <a:spcPts val="1300"/>
+                <a:spcPts val="1200"/>
               </a:spcAft>
             </a:pPr>
             <a:r>
-              <a:rPr sz="1900" b="0">
+              <a:rPr sz="1800" b="0">
                 <a:solidFill>
                   <a:srgbClr val="1A1C1E"/>
                 </a:solidFill>
@@ -11318,11 +11504,11 @@
           <a:p>
             <a:pPr algn="l">
               <a:spcAft>
-                <a:spcPts val="1300"/>
+                <a:spcPts val="1200"/>
               </a:spcAft>
             </a:pPr>
             <a:r>
-              <a:rPr sz="1900" b="0">
+              <a:rPr sz="1800" b="0">
                 <a:solidFill>
                   <a:srgbClr val="1A1C1E"/>
                 </a:solidFill>
@@ -11334,11 +11520,11 @@
           <a:p>
             <a:pPr algn="l">
               <a:spcAft>
-                <a:spcPts val="1300"/>
+                <a:spcPts val="1200"/>
               </a:spcAft>
             </a:pPr>
             <a:r>
-              <a:rPr sz="1900" b="0">
+              <a:rPr sz="1800" b="0">
                 <a:solidFill>
                   <a:srgbClr val="1A1C1E"/>
                 </a:solidFill>
@@ -11350,52 +11536,17 @@
           <a:p>
             <a:pPr algn="l">
               <a:spcAft>
-                <a:spcPts val="1300"/>
+                <a:spcPts val="1200"/>
               </a:spcAft>
             </a:pPr>
             <a:r>
-              <a:rPr sz="1900" b="0">
+              <a:rPr sz="1800" b="0">
                 <a:solidFill>
                   <a:srgbClr val="1A1C1E"/>
                 </a:solidFill>
                 <a:latin typeface="Calibri"/>
               </a:rPr>
               <a:t>•  Questions — and happy to pitch one of you live right now</a:t>
-            </a:r>
-          </a:p>
-        </p:txBody>
-      </p:sp>
-      <p:sp>
-        <p:nvSpPr>
-          <p:cNvPr id="6" name="TextBox 5"/>
-          <p:cNvSpPr txBox="1"/>
-          <p:nvPr/>
-        </p:nvSpPr>
-        <p:spPr>
-          <a:xfrm>
-            <a:off x="822960" y="6355080"/>
-            <a:ext cx="10058400" cy="274320"/>
-          </a:xfrm>
-          <a:prstGeom prst="rect">
-            <a:avLst/>
-          </a:prstGeom>
-          <a:noFill/>
-        </p:spPr>
-        <p:txBody>
-          <a:bodyPr wrap="square" anchor="t">
-            <a:spAutoFit/>
-          </a:bodyPr>
-          <a:lstStyle/>
-          <a:p>
-            <a:pPr algn="l"/>
-            <a:r>
-              <a:rPr sz="1100" b="0">
-                <a:solidFill>
-                  <a:srgbClr val="5E646B"/>
-                </a:solidFill>
-                <a:latin typeface="Calibri"/>
-              </a:rPr>
-              <a:t>Lindsey Dempsey  ·  EMEA SDR</a:t>
             </a:r>
           </a:p>
         </p:txBody>
@@ -11470,7 +11621,7 @@
         <p:spPr>
           <a:xfrm>
             <a:off x="0" y="0"/>
-            <a:ext cx="12191695" cy="1143000"/>
+            <a:ext cx="12191695" cy="1097280"/>
           </a:xfrm>
           <a:prstGeom prst="rect">
             <a:avLst/>
@@ -11512,8 +11663,8 @@
         </p:nvSpPr>
         <p:spPr>
           <a:xfrm>
-            <a:off x="777240" y="320040"/>
-            <a:ext cx="10515600" cy="594360"/>
+            <a:off x="731520" y="292608"/>
+            <a:ext cx="10698480" cy="548640"/>
           </a:xfrm>
           <a:prstGeom prst="rect">
             <a:avLst/>
@@ -11528,7 +11679,7 @@
           <a:p>
             <a:pPr algn="l"/>
             <a:r>
-              <a:rPr sz="2600" b="1">
+              <a:rPr sz="2400" b="1">
                 <a:solidFill>
                   <a:srgbClr val="FFFFFF"/>
                 </a:solidFill>
@@ -11547,8 +11698,8 @@
         </p:nvSpPr>
         <p:spPr>
           <a:xfrm>
-            <a:off x="822960" y="1554480"/>
-            <a:ext cx="10424160" cy="4297680"/>
+            <a:off x="777240" y="1417320"/>
+            <a:ext cx="10515600" cy="4572000"/>
           </a:xfrm>
           <a:prstGeom prst="rect">
             <a:avLst/>
@@ -11563,100 +11714,65 @@
           <a:p>
             <a:pPr algn="l">
               <a:spcAft>
-                <a:spcPts val="1300"/>
+                <a:spcPts val="1200"/>
               </a:spcAft>
             </a:pPr>
             <a:r>
-              <a:rPr sz="1900" b="0">
+              <a:rPr sz="1800" b="0">
                 <a:solidFill>
                   <a:srgbClr val="1A1C1E"/>
                 </a:solidFill>
                 <a:latin typeface="Calibri"/>
               </a:rPr>
-              <a:t>•  Part 1 — First 15 / 30 / 60 days: diagnose, protect, gains, two experiments</a:t>
+              <a:t>•  Part 1 (20 min) — First 15 / 30 / 60: diagnose, protect, gains, competitive context, two experiments</a:t>
             </a:r>
           </a:p>
           <a:p>
             <a:pPr algn="l">
               <a:spcAft>
-                <a:spcPts val="1300"/>
+                <a:spcPts val="1200"/>
               </a:spcAft>
             </a:pPr>
             <a:r>
-              <a:rPr sz="1900" b="0">
+              <a:rPr sz="1800" b="0">
                 <a:solidFill>
                   <a:srgbClr val="1A1C1E"/>
                 </a:solidFill>
                 <a:latin typeface="Calibri"/>
               </a:rPr>
-              <a:t>•  Part 2 — Fundamentals: hire, coach, and run the team as a player-coach</a:t>
+              <a:t>•  Part 2 (12 min) — Fundamentals: hire, coach, run the team as a player-coach</a:t>
             </a:r>
           </a:p>
           <a:p>
             <a:pPr algn="l">
               <a:spcAft>
-                <a:spcPts val="1300"/>
+                <a:spcPts val="1200"/>
               </a:spcAft>
             </a:pPr>
             <a:r>
-              <a:rPr sz="1900" b="0">
+              <a:rPr sz="1800" b="0">
                 <a:solidFill>
                   <a:srgbClr val="1A1C1E"/>
                 </a:solidFill>
                 <a:latin typeface="Calibri"/>
               </a:rPr>
-              <a:t>•  Part 3 — Craft: live pitch, persona outreach, why Cursor wins (Copilot + Claude Code)</a:t>
+              <a:t>•  Part 3 (10 min) — Craft: live pitch, persona outreach, why Cursor wins (Copilot + Claude Code)</a:t>
             </a:r>
           </a:p>
           <a:p>
             <a:pPr algn="l">
               <a:spcAft>
-                <a:spcPts val="1300"/>
+                <a:spcPts val="1200"/>
               </a:spcAft>
             </a:pPr>
             <a:r>
-              <a:rPr sz="1900" b="0">
+              <a:rPr sz="1800" b="0">
                 <a:solidFill>
                   <a:srgbClr val="1A1C1E"/>
                 </a:solidFill>
                 <a:latin typeface="Calibri"/>
               </a:rPr>
               <a:t>•  Clarity over polish — happy to go live earlier on the pitch</a:t>
-            </a:r>
-          </a:p>
-        </p:txBody>
-      </p:sp>
-      <p:sp>
-        <p:nvSpPr>
-          <p:cNvPr id="6" name="TextBox 5"/>
-          <p:cNvSpPr txBox="1"/>
-          <p:nvPr/>
-        </p:nvSpPr>
-        <p:spPr>
-          <a:xfrm>
-            <a:off x="822960" y="6355080"/>
-            <a:ext cx="10058400" cy="274320"/>
-          </a:xfrm>
-          <a:prstGeom prst="rect">
-            <a:avLst/>
-          </a:prstGeom>
-          <a:noFill/>
-        </p:spPr>
-        <p:txBody>
-          <a:bodyPr wrap="square" anchor="t">
-            <a:spAutoFit/>
-          </a:bodyPr>
-          <a:lstStyle/>
-          <a:p>
-            <a:pPr algn="l"/>
-            <a:r>
-              <a:rPr sz="1100" b="0">
-                <a:solidFill>
-                  <a:srgbClr val="5E646B"/>
-                </a:solidFill>
-                <a:latin typeface="Calibri"/>
-              </a:rPr>
-              <a:t>Lindsey Dempsey  ·  EMEA SDR</a:t>
             </a:r>
           </a:p>
         </p:txBody>
@@ -11730,7 +11846,7 @@
         </p:nvSpPr>
         <p:spPr>
           <a:xfrm>
-            <a:off x="822960" y="2331720"/>
+            <a:off x="777240" y="2286000"/>
             <a:ext cx="1280160" cy="73152"/>
           </a:xfrm>
           <a:prstGeom prst="rect">
@@ -11773,8 +11889,8 @@
         </p:nvSpPr>
         <p:spPr>
           <a:xfrm>
-            <a:off x="822960" y="2514600"/>
-            <a:ext cx="10058400" cy="411480"/>
+            <a:off x="777240" y="2468880"/>
+            <a:ext cx="10058400" cy="365760"/>
           </a:xfrm>
           <a:prstGeom prst="rect">
             <a:avLst/>
@@ -11808,7 +11924,7 @@
         </p:nvSpPr>
         <p:spPr>
           <a:xfrm>
-            <a:off x="822960" y="2971800"/>
+            <a:off x="777240" y="2926080"/>
             <a:ext cx="10515600" cy="1097280"/>
           </a:xfrm>
           <a:prstGeom prst="rect">
@@ -11824,7 +11940,7 @@
           <a:p>
             <a:pPr algn="l"/>
             <a:r>
-              <a:rPr sz="3400" b="1">
+              <a:rPr sz="3200" b="1">
                 <a:solidFill>
                   <a:srgbClr val="FFFFFF"/>
                 </a:solidFill>
@@ -11905,7 +12021,7 @@
         <p:spPr>
           <a:xfrm>
             <a:off x="0" y="0"/>
-            <a:ext cx="12191695" cy="1143000"/>
+            <a:ext cx="12191695" cy="1097280"/>
           </a:xfrm>
           <a:prstGeom prst="rect">
             <a:avLst/>
@@ -11947,8 +12063,8 @@
         </p:nvSpPr>
         <p:spPr>
           <a:xfrm>
-            <a:off x="777240" y="320040"/>
-            <a:ext cx="10515600" cy="594360"/>
+            <a:off x="731520" y="292608"/>
+            <a:ext cx="10698480" cy="548640"/>
           </a:xfrm>
           <a:prstGeom prst="rect">
             <a:avLst/>
@@ -11963,7 +12079,7 @@
           <a:p>
             <a:pPr algn="l"/>
             <a:r>
-              <a:rPr sz="2600" b="1">
+              <a:rPr sz="2400" b="1">
                 <a:solidFill>
                   <a:srgbClr val="FFFFFF"/>
                 </a:solidFill>
@@ -11982,8 +12098,8 @@
         </p:nvSpPr>
         <p:spPr>
           <a:xfrm>
-            <a:off x="640080" y="1417320"/>
-            <a:ext cx="5257800" cy="4572000"/>
+            <a:off x="594360" y="1325880"/>
+            <a:ext cx="5349240" cy="4754880"/>
           </a:xfrm>
           <a:prstGeom prst="rect">
             <a:avLst/>
@@ -12025,8 +12141,8 @@
         </p:nvSpPr>
         <p:spPr>
           <a:xfrm>
-            <a:off x="914400" y="1691640"/>
-            <a:ext cx="822960" cy="73152"/>
+            <a:off x="868680" y="1554480"/>
+            <a:ext cx="777240" cy="73152"/>
           </a:xfrm>
           <a:prstGeom prst="rect">
             <a:avLst/>
@@ -12068,8 +12184,8 @@
         </p:nvSpPr>
         <p:spPr>
           <a:xfrm>
-            <a:off x="914400" y="1920240"/>
-            <a:ext cx="4663440" cy="365760"/>
+            <a:off x="868680" y="1783080"/>
+            <a:ext cx="4754880" cy="365760"/>
           </a:xfrm>
           <a:prstGeom prst="rect">
             <a:avLst/>
@@ -12084,7 +12200,7 @@
           <a:p>
             <a:pPr algn="l"/>
             <a:r>
-              <a:rPr sz="1800" b="1">
+              <a:rPr sz="1700" b="1">
                 <a:solidFill>
                   <a:srgbClr val="141618"/>
                 </a:solidFill>
@@ -12103,8 +12219,8 @@
         </p:nvSpPr>
         <p:spPr>
           <a:xfrm>
-            <a:off x="914400" y="2423160"/>
-            <a:ext cx="4663440" cy="3200400"/>
+            <a:off x="868680" y="2286000"/>
+            <a:ext cx="4754880" cy="3474720"/>
           </a:xfrm>
           <a:prstGeom prst="rect">
             <a:avLst/>
@@ -12119,11 +12235,11 @@
           <a:p>
             <a:pPr algn="l">
               <a:spcAft>
-                <a:spcPts val="900"/>
+                <a:spcPts val="800"/>
               </a:spcAft>
             </a:pPr>
             <a:r>
-              <a:rPr sz="1600" b="0">
+              <a:rPr sz="1500" b="0">
                 <a:solidFill>
                   <a:srgbClr val="1A1C1E"/>
                 </a:solidFill>
@@ -12135,11 +12251,11 @@
           <a:p>
             <a:pPr algn="l">
               <a:spcAft>
-                <a:spcPts val="900"/>
+                <a:spcPts val="800"/>
               </a:spcAft>
             </a:pPr>
             <a:r>
-              <a:rPr sz="1600" b="0">
+              <a:rPr sz="1500" b="0">
                 <a:solidFill>
                   <a:srgbClr val="1A1C1E"/>
                 </a:solidFill>
@@ -12151,11 +12267,11 @@
           <a:p>
             <a:pPr algn="l">
               <a:spcAft>
-                <a:spcPts val="900"/>
+                <a:spcPts val="800"/>
               </a:spcAft>
             </a:pPr>
             <a:r>
-              <a:rPr sz="1600" b="0">
+              <a:rPr sz="1500" b="0">
                 <a:solidFill>
                   <a:srgbClr val="1A1C1E"/>
                 </a:solidFill>
@@ -12167,11 +12283,11 @@
           <a:p>
             <a:pPr algn="l">
               <a:spcAft>
-                <a:spcPts val="900"/>
+                <a:spcPts val="800"/>
               </a:spcAft>
             </a:pPr>
             <a:r>
-              <a:rPr sz="1600" b="0">
+              <a:rPr sz="1500" b="0">
                 <a:solidFill>
                   <a:srgbClr val="1A1C1E"/>
                 </a:solidFill>
@@ -12183,11 +12299,11 @@
           <a:p>
             <a:pPr algn="l">
               <a:spcAft>
-                <a:spcPts val="900"/>
+                <a:spcPts val="800"/>
               </a:spcAft>
             </a:pPr>
             <a:r>
-              <a:rPr sz="1600" b="0">
+              <a:rPr sz="1500" b="0">
                 <a:solidFill>
                   <a:srgbClr val="1A1C1E"/>
                 </a:solidFill>
@@ -12206,8 +12322,8 @@
         </p:nvSpPr>
         <p:spPr>
           <a:xfrm>
-            <a:off x="6263640" y="1417320"/>
-            <a:ext cx="5257800" cy="4572000"/>
+            <a:off x="6217920" y="1325880"/>
+            <a:ext cx="5349240" cy="4754880"/>
           </a:xfrm>
           <a:prstGeom prst="rect">
             <a:avLst/>
@@ -12249,8 +12365,8 @@
         </p:nvSpPr>
         <p:spPr>
           <a:xfrm>
-            <a:off x="6537960" y="1691640"/>
-            <a:ext cx="822960" cy="73152"/>
+            <a:off x="6492240" y="1554480"/>
+            <a:ext cx="777240" cy="73152"/>
           </a:xfrm>
           <a:prstGeom prst="rect">
             <a:avLst/>
@@ -12292,8 +12408,8 @@
         </p:nvSpPr>
         <p:spPr>
           <a:xfrm>
-            <a:off x="6537960" y="1920240"/>
-            <a:ext cx="4663440" cy="365760"/>
+            <a:off x="6492240" y="1783080"/>
+            <a:ext cx="4754880" cy="365760"/>
           </a:xfrm>
           <a:prstGeom prst="rect">
             <a:avLst/>
@@ -12308,7 +12424,7 @@
           <a:p>
             <a:pPr algn="l"/>
             <a:r>
-              <a:rPr sz="1800" b="1">
+              <a:rPr sz="1700" b="1">
                 <a:solidFill>
                   <a:srgbClr val="141618"/>
                 </a:solidFill>
@@ -12327,8 +12443,8 @@
         </p:nvSpPr>
         <p:spPr>
           <a:xfrm>
-            <a:off x="6537960" y="2423160"/>
-            <a:ext cx="4663440" cy="3200400"/>
+            <a:off x="6492240" y="2286000"/>
+            <a:ext cx="4754880" cy="3474720"/>
           </a:xfrm>
           <a:prstGeom prst="rect">
             <a:avLst/>
@@ -12343,11 +12459,11 @@
           <a:p>
             <a:pPr algn="l">
               <a:spcAft>
-                <a:spcPts val="900"/>
+                <a:spcPts val="800"/>
               </a:spcAft>
             </a:pPr>
             <a:r>
-              <a:rPr sz="1600" b="0">
+              <a:rPr sz="1500" b="0">
                 <a:solidFill>
                   <a:srgbClr val="1A1C1E"/>
                 </a:solidFill>
@@ -12359,11 +12475,11 @@
           <a:p>
             <a:pPr algn="l">
               <a:spcAft>
-                <a:spcPts val="900"/>
+                <a:spcPts val="800"/>
               </a:spcAft>
             </a:pPr>
             <a:r>
-              <a:rPr sz="1600" b="0">
+              <a:rPr sz="1500" b="0">
                 <a:solidFill>
                   <a:srgbClr val="1A1C1E"/>
                 </a:solidFill>
@@ -12375,11 +12491,11 @@
           <a:p>
             <a:pPr algn="l">
               <a:spcAft>
-                <a:spcPts val="900"/>
+                <a:spcPts val="800"/>
               </a:spcAft>
             </a:pPr>
             <a:r>
-              <a:rPr sz="1600" b="0">
+              <a:rPr sz="1500" b="0">
                 <a:solidFill>
                   <a:srgbClr val="1A1C1E"/>
                 </a:solidFill>
@@ -12391,11 +12507,11 @@
           <a:p>
             <a:pPr algn="l">
               <a:spcAft>
-                <a:spcPts val="900"/>
+                <a:spcPts val="800"/>
               </a:spcAft>
             </a:pPr>
             <a:r>
-              <a:rPr sz="1600" b="0">
+              <a:rPr sz="1500" b="0">
                 <a:solidFill>
                   <a:srgbClr val="1A1C1E"/>
                 </a:solidFill>
@@ -12407,11 +12523,11 @@
           <a:p>
             <a:pPr algn="l">
               <a:spcAft>
-                <a:spcPts val="900"/>
+                <a:spcPts val="800"/>
               </a:spcAft>
             </a:pPr>
             <a:r>
-              <a:rPr sz="1600" b="0">
+              <a:rPr sz="1500" b="0">
                 <a:solidFill>
                   <a:srgbClr val="1A1C1E"/>
                 </a:solidFill>
@@ -12492,7 +12608,7 @@
         <p:spPr>
           <a:xfrm>
             <a:off x="0" y="0"/>
-            <a:ext cx="12191695" cy="1143000"/>
+            <a:ext cx="12191695" cy="1097280"/>
           </a:xfrm>
           <a:prstGeom prst="rect">
             <a:avLst/>
@@ -12534,8 +12650,8 @@
         </p:nvSpPr>
         <p:spPr>
           <a:xfrm>
-            <a:off x="777240" y="320040"/>
-            <a:ext cx="10515600" cy="594360"/>
+            <a:off x="731520" y="292608"/>
+            <a:ext cx="10698480" cy="548640"/>
           </a:xfrm>
           <a:prstGeom prst="rect">
             <a:avLst/>
@@ -12550,7 +12666,7 @@
           <a:p>
             <a:pPr algn="l"/>
             <a:r>
-              <a:rPr sz="2600" b="1">
+              <a:rPr sz="2400" b="1">
                 <a:solidFill>
                   <a:srgbClr val="FFFFFF"/>
                 </a:solidFill>
@@ -12569,8 +12685,8 @@
         </p:nvSpPr>
         <p:spPr>
           <a:xfrm>
-            <a:off x="822960" y="1554480"/>
-            <a:ext cx="10424160" cy="4297680"/>
+            <a:off x="777240" y="1417320"/>
+            <a:ext cx="10515600" cy="4572000"/>
           </a:xfrm>
           <a:prstGeom prst="rect">
             <a:avLst/>
@@ -12585,11 +12701,11 @@
           <a:p>
             <a:pPr algn="l">
               <a:spcAft>
-                <a:spcPts val="1300"/>
+                <a:spcPts val="1200"/>
               </a:spcAft>
             </a:pPr>
             <a:r>
-              <a:rPr sz="1900" b="0">
+              <a:rPr sz="1800" b="0">
                 <a:solidFill>
                   <a:srgbClr val="1A1C1E"/>
                 </a:solidFill>
@@ -12601,11 +12717,11 @@
           <a:p>
             <a:pPr algn="l">
               <a:spcAft>
-                <a:spcPts val="1300"/>
+                <a:spcPts val="1200"/>
               </a:spcAft>
             </a:pPr>
             <a:r>
-              <a:rPr sz="1900" b="0">
+              <a:rPr sz="1800" b="0">
                 <a:solidFill>
                   <a:srgbClr val="1A1C1E"/>
                 </a:solidFill>
@@ -12617,11 +12733,11 @@
           <a:p>
             <a:pPr algn="l">
               <a:spcAft>
-                <a:spcPts val="1300"/>
+                <a:spcPts val="1200"/>
               </a:spcAft>
             </a:pPr>
             <a:r>
-              <a:rPr sz="1900" b="0">
+              <a:rPr sz="1800" b="0">
                 <a:solidFill>
                   <a:srgbClr val="1A1C1E"/>
                 </a:solidFill>
@@ -12633,11 +12749,11 @@
           <a:p>
             <a:pPr algn="l">
               <a:spcAft>
-                <a:spcPts val="1300"/>
+                <a:spcPts val="1200"/>
               </a:spcAft>
             </a:pPr>
             <a:r>
-              <a:rPr sz="1900" b="0">
+              <a:rPr sz="1800" b="0">
                 <a:solidFill>
                   <a:srgbClr val="1A1C1E"/>
                 </a:solidFill>
@@ -12649,11 +12765,11 @@
           <a:p>
             <a:pPr algn="l">
               <a:spcAft>
-                <a:spcPts val="1300"/>
+                <a:spcPts val="1200"/>
               </a:spcAft>
             </a:pPr>
             <a:r>
-              <a:rPr sz="1900" b="0">
+              <a:rPr sz="1800" b="0">
                 <a:solidFill>
                   <a:srgbClr val="1A1C1E"/>
                 </a:solidFill>
@@ -12665,52 +12781,17 @@
           <a:p>
             <a:pPr algn="l">
               <a:spcAft>
-                <a:spcPts val="1300"/>
+                <a:spcPts val="1200"/>
               </a:spcAft>
             </a:pPr>
             <a:r>
-              <a:rPr sz="1900" b="0">
+              <a:rPr sz="1800" b="0">
                 <a:solidFill>
                   <a:srgbClr val="1A1C1E"/>
                 </a:solidFill>
                 <a:latin typeface="Calibri"/>
               </a:rPr>
               <a:t>•  Explicit: no reorg, rename stages, or full playbook rewrite in month one</a:t>
-            </a:r>
-          </a:p>
-        </p:txBody>
-      </p:sp>
-      <p:sp>
-        <p:nvSpPr>
-          <p:cNvPr id="6" name="TextBox 5"/>
-          <p:cNvSpPr txBox="1"/>
-          <p:nvPr/>
-        </p:nvSpPr>
-        <p:spPr>
-          <a:xfrm>
-            <a:off x="822960" y="6355080"/>
-            <a:ext cx="10058400" cy="274320"/>
-          </a:xfrm>
-          <a:prstGeom prst="rect">
-            <a:avLst/>
-          </a:prstGeom>
-          <a:noFill/>
-        </p:spPr>
-        <p:txBody>
-          <a:bodyPr wrap="square" anchor="t">
-            <a:spAutoFit/>
-          </a:bodyPr>
-          <a:lstStyle/>
-          <a:p>
-            <a:pPr algn="l"/>
-            <a:r>
-              <a:rPr sz="1100" b="0">
-                <a:solidFill>
-                  <a:srgbClr val="5E646B"/>
-                </a:solidFill>
-                <a:latin typeface="Calibri"/>
-              </a:rPr>
-              <a:t>Lindsey Dempsey  ·  EMEA SDR</a:t>
             </a:r>
           </a:p>
         </p:txBody>
@@ -12785,7 +12866,7 @@
         <p:spPr>
           <a:xfrm>
             <a:off x="0" y="0"/>
-            <a:ext cx="12191695" cy="1143000"/>
+            <a:ext cx="12191695" cy="1097280"/>
           </a:xfrm>
           <a:prstGeom prst="rect">
             <a:avLst/>
@@ -12827,8 +12908,8 @@
         </p:nvSpPr>
         <p:spPr>
           <a:xfrm>
-            <a:off x="777240" y="320040"/>
-            <a:ext cx="10515600" cy="594360"/>
+            <a:off x="731520" y="292608"/>
+            <a:ext cx="10698480" cy="548640"/>
           </a:xfrm>
           <a:prstGeom prst="rect">
             <a:avLst/>
@@ -12843,7 +12924,7 @@
           <a:p>
             <a:pPr algn="l"/>
             <a:r>
-              <a:rPr sz="2600" b="1">
+              <a:rPr sz="2400" b="1">
                 <a:solidFill>
                   <a:srgbClr val="FFFFFF"/>
                 </a:solidFill>
@@ -12862,8 +12943,8 @@
         </p:nvSpPr>
         <p:spPr>
           <a:xfrm>
-            <a:off x="822960" y="1554480"/>
-            <a:ext cx="10424160" cy="4297680"/>
+            <a:off x="777240" y="1417320"/>
+            <a:ext cx="10515600" cy="4572000"/>
           </a:xfrm>
           <a:prstGeom prst="rect">
             <a:avLst/>
@@ -12878,11 +12959,11 @@
           <a:p>
             <a:pPr algn="l">
               <a:spcAft>
-                <a:spcPts val="1300"/>
+                <a:spcPts val="1200"/>
               </a:spcAft>
             </a:pPr>
             <a:r>
-              <a:rPr sz="1900" b="0">
+              <a:rPr sz="1800" b="0">
                 <a:solidFill>
                   <a:srgbClr val="1A1C1E"/>
                 </a:solidFill>
@@ -12894,11 +12975,11 @@
           <a:p>
             <a:pPr algn="l">
               <a:spcAft>
-                <a:spcPts val="1300"/>
+                <a:spcPts val="1200"/>
               </a:spcAft>
             </a:pPr>
             <a:r>
-              <a:rPr sz="1900" b="0">
+              <a:rPr sz="1800" b="0">
                 <a:solidFill>
                   <a:srgbClr val="1A1C1E"/>
                 </a:solidFill>
@@ -12910,27 +12991,27 @@
           <a:p>
             <a:pPr algn="l">
               <a:spcAft>
-                <a:spcPts val="1300"/>
+                <a:spcPts val="1200"/>
               </a:spcAft>
             </a:pPr>
             <a:r>
-              <a:rPr sz="1900" b="0">
+              <a:rPr sz="1800" b="0">
                 <a:solidFill>
                   <a:srgbClr val="1A1C1E"/>
                 </a:solidFill>
                 <a:latin typeface="Calibri"/>
               </a:rPr>
-              <a:t>•  Competitive fluency — clean Copilot / Claude Code frames (no trash talk or feature dumps)</a:t>
+              <a:t>•  Competitive fluency — clean Copilot / Claude Code / Windsurf frames (no trash talk)</a:t>
             </a:r>
           </a:p>
           <a:p>
             <a:pPr algn="l">
               <a:spcAft>
-                <a:spcPts val="1300"/>
+                <a:spcPts val="1200"/>
               </a:spcAft>
             </a:pPr>
             <a:r>
-              <a:rPr sz="1900" b="0">
+              <a:rPr sz="1800" b="0">
                 <a:solidFill>
                   <a:srgbClr val="1A1C1E"/>
                 </a:solidFill>
@@ -12942,52 +13023,17 @@
           <a:p>
             <a:pPr algn="l">
               <a:spcAft>
-                <a:spcPts val="1300"/>
+                <a:spcPts val="1200"/>
               </a:spcAft>
             </a:pPr>
             <a:r>
-              <a:rPr sz="1900" b="0">
+              <a:rPr sz="1800" b="0">
                 <a:solidFill>
                   <a:srgbClr val="1A1C1E"/>
                 </a:solidFill>
                 <a:latin typeface="Calibri"/>
               </a:rPr>
               <a:t>•  Validate with diagnosis data before scaling changes</a:t>
-            </a:r>
-          </a:p>
-        </p:txBody>
-      </p:sp>
-      <p:sp>
-        <p:nvSpPr>
-          <p:cNvPr id="6" name="TextBox 5"/>
-          <p:cNvSpPr txBox="1"/>
-          <p:nvPr/>
-        </p:nvSpPr>
-        <p:spPr>
-          <a:xfrm>
-            <a:off x="822960" y="6355080"/>
-            <a:ext cx="10058400" cy="274320"/>
-          </a:xfrm>
-          <a:prstGeom prst="rect">
-            <a:avLst/>
-          </a:prstGeom>
-          <a:noFill/>
-        </p:spPr>
-        <p:txBody>
-          <a:bodyPr wrap="square" anchor="t">
-            <a:spAutoFit/>
-          </a:bodyPr>
-          <a:lstStyle/>
-          <a:p>
-            <a:pPr algn="l"/>
-            <a:r>
-              <a:rPr sz="1100" b="0">
-                <a:solidFill>
-                  <a:srgbClr val="5E646B"/>
-                </a:solidFill>
-                <a:latin typeface="Calibri"/>
-              </a:rPr>
-              <a:t>Lindsey Dempsey  ·  EMEA SDR</a:t>
             </a:r>
           </a:p>
         </p:txBody>
@@ -13062,7 +13108,7 @@
         <p:spPr>
           <a:xfrm>
             <a:off x="0" y="0"/>
-            <a:ext cx="12191695" cy="1143000"/>
+            <a:ext cx="12191695" cy="1097280"/>
           </a:xfrm>
           <a:prstGeom prst="rect">
             <a:avLst/>
@@ -13104,8 +13150,8 @@
         </p:nvSpPr>
         <p:spPr>
           <a:xfrm>
-            <a:off x="777240" y="320040"/>
-            <a:ext cx="10515600" cy="594360"/>
+            <a:off x="731520" y="292608"/>
+            <a:ext cx="10698480" cy="548640"/>
           </a:xfrm>
           <a:prstGeom prst="rect">
             <a:avLst/>
@@ -13120,7 +13166,7 @@
           <a:p>
             <a:pPr algn="l"/>
             <a:r>
-              <a:rPr sz="2600" b="1">
+              <a:rPr sz="2400" b="1">
                 <a:solidFill>
                   <a:srgbClr val="FFFFFF"/>
                 </a:solidFill>
@@ -13139,8 +13185,8 @@
         </p:nvSpPr>
         <p:spPr>
           <a:xfrm>
-            <a:off x="640080" y="1417320"/>
-            <a:ext cx="5257800" cy="3246120"/>
+            <a:off x="594360" y="1325880"/>
+            <a:ext cx="5349240" cy="3063240"/>
           </a:xfrm>
           <a:prstGeom prst="rect">
             <a:avLst/>
@@ -13182,8 +13228,8 @@
         </p:nvSpPr>
         <p:spPr>
           <a:xfrm>
-            <a:off x="640080" y="1417320"/>
-            <a:ext cx="5257800" cy="502920"/>
+            <a:off x="594360" y="1325880"/>
+            <a:ext cx="5349240" cy="457200"/>
           </a:xfrm>
           <a:prstGeom prst="rect">
             <a:avLst/>
@@ -13225,8 +13271,8 @@
         </p:nvSpPr>
         <p:spPr>
           <a:xfrm>
-            <a:off x="868680" y="1508760"/>
-            <a:ext cx="4754880" cy="365760"/>
+            <a:off x="822960" y="1389888"/>
+            <a:ext cx="4846320" cy="365760"/>
           </a:xfrm>
           <a:prstGeom prst="rect">
             <a:avLst/>
@@ -13241,7 +13287,7 @@
           <a:p>
             <a:pPr algn="l"/>
             <a:r>
-              <a:rPr sz="1600" b="1">
+              <a:rPr sz="1500" b="1">
                 <a:solidFill>
                   <a:srgbClr val="D6F26A"/>
                 </a:solidFill>
@@ -13260,8 +13306,8 @@
         </p:nvSpPr>
         <p:spPr>
           <a:xfrm>
-            <a:off x="868680" y="2148840"/>
-            <a:ext cx="4754880" cy="2286000"/>
+            <a:off x="822960" y="1965960"/>
+            <a:ext cx="4846320" cy="2194560"/>
           </a:xfrm>
           <a:prstGeom prst="rect">
             <a:avLst/>
@@ -13276,11 +13322,11 @@
           <a:p>
             <a:pPr algn="l">
               <a:spcAft>
-                <a:spcPts val="900"/>
+                <a:spcPts val="700"/>
               </a:spcAft>
             </a:pPr>
             <a:r>
-              <a:rPr sz="1500" b="0">
+              <a:rPr sz="1400" b="0">
                 <a:solidFill>
                   <a:srgbClr val="1A1C1E"/>
                 </a:solidFill>
@@ -13292,11 +13338,11 @@
           <a:p>
             <a:pPr algn="l">
               <a:spcAft>
-                <a:spcPts val="900"/>
+                <a:spcPts val="700"/>
               </a:spcAft>
             </a:pPr>
             <a:r>
-              <a:rPr sz="1500" b="0">
+              <a:rPr sz="1400" b="0">
                 <a:solidFill>
                   <a:srgbClr val="1A1C1E"/>
                 </a:solidFill>
@@ -13308,27 +13354,27 @@
           <a:p>
             <a:pPr algn="l">
               <a:spcAft>
-                <a:spcPts val="900"/>
+                <a:spcPts val="700"/>
               </a:spcAft>
             </a:pPr>
             <a:r>
-              <a:rPr sz="1500" b="0">
+              <a:rPr sz="1400" b="0">
                 <a:solidFill>
                   <a:srgbClr val="1A1C1E"/>
                 </a:solidFill>
                 <a:latin typeface="Calibri"/>
               </a:rPr>
-              <a:t>•  Where Cursor already has commercial strength</a:t>
+              <a:t>•  Cursor’s established commercial strength</a:t>
             </a:r>
           </a:p>
           <a:p>
             <a:pPr algn="l">
               <a:spcAft>
-                <a:spcPts val="900"/>
+                <a:spcPts val="700"/>
               </a:spcAft>
             </a:pPr>
             <a:r>
-              <a:rPr sz="1500" b="0">
+              <a:rPr sz="1400" b="0">
                 <a:solidFill>
                   <a:srgbClr val="1A1C1E"/>
                 </a:solidFill>
@@ -13347,8 +13393,8 @@
         </p:nvSpPr>
         <p:spPr>
           <a:xfrm>
-            <a:off x="6263640" y="1417320"/>
-            <a:ext cx="5257800" cy="3246120"/>
+            <a:off x="6217920" y="1325880"/>
+            <a:ext cx="5349240" cy="3063240"/>
           </a:xfrm>
           <a:prstGeom prst="rect">
             <a:avLst/>
@@ -13390,8 +13436,8 @@
         </p:nvSpPr>
         <p:spPr>
           <a:xfrm>
-            <a:off x="6263640" y="1417320"/>
-            <a:ext cx="5257800" cy="502920"/>
+            <a:off x="6217920" y="1325880"/>
+            <a:ext cx="5349240" cy="457200"/>
           </a:xfrm>
           <a:prstGeom prst="rect">
             <a:avLst/>
@@ -13433,8 +13479,8 @@
         </p:nvSpPr>
         <p:spPr>
           <a:xfrm>
-            <a:off x="6492240" y="1508760"/>
-            <a:ext cx="4754880" cy="365760"/>
+            <a:off x="6446520" y="1389888"/>
+            <a:ext cx="4846320" cy="365760"/>
           </a:xfrm>
           <a:prstGeom prst="rect">
             <a:avLst/>
@@ -13449,7 +13495,7 @@
           <a:p>
             <a:pPr algn="l"/>
             <a:r>
-              <a:rPr sz="1600" b="1">
+              <a:rPr sz="1500" b="1">
                 <a:solidFill>
                   <a:srgbClr val="FFFFFF"/>
                 </a:solidFill>
@@ -13468,8 +13514,8 @@
         </p:nvSpPr>
         <p:spPr>
           <a:xfrm>
-            <a:off x="6492240" y="2148840"/>
-            <a:ext cx="4754880" cy="2286000"/>
+            <a:off x="6446520" y="1965960"/>
+            <a:ext cx="4846320" cy="2194560"/>
           </a:xfrm>
           <a:prstGeom prst="rect">
             <a:avLst/>
@@ -13484,27 +13530,27 @@
           <a:p>
             <a:pPr algn="l">
               <a:spcAft>
-                <a:spcPts val="900"/>
+                <a:spcPts val="700"/>
               </a:spcAft>
             </a:pPr>
             <a:r>
-              <a:rPr sz="1500" b="0">
+              <a:rPr sz="1400" b="0">
                 <a:solidFill>
                   <a:srgbClr val="1A1C1E"/>
                 </a:solidFill>
                 <a:latin typeface="Calibri"/>
               </a:rPr>
-              <a:t>•  Reasoning quality + long-horizon coding</a:t>
+              <a:t>•  Reasoning + long-horizon coding quality</a:t>
             </a:r>
           </a:p>
           <a:p>
             <a:pPr algn="l">
               <a:spcAft>
-                <a:spcPts val="900"/>
+                <a:spcPts val="700"/>
               </a:spcAft>
             </a:pPr>
             <a:r>
-              <a:rPr sz="1500" b="0">
+              <a:rPr sz="1400" b="0">
                 <a:solidFill>
                   <a:srgbClr val="1A1C1E"/>
                 </a:solidFill>
@@ -13516,11 +13562,11 @@
           <a:p>
             <a:pPr algn="l">
               <a:spcAft>
-                <a:spcPts val="900"/>
+                <a:spcPts val="700"/>
               </a:spcAft>
             </a:pPr>
             <a:r>
-              <a:rPr sz="1500" b="0">
+              <a:rPr sz="1400" b="0">
                 <a:solidFill>
                   <a:srgbClr val="1A1C1E"/>
                 </a:solidFill>
@@ -13532,11 +13578,11 @@
           <a:p>
             <a:pPr algn="l">
               <a:spcAft>
-                <a:spcPts val="900"/>
+                <a:spcPts val="700"/>
               </a:spcAft>
             </a:pPr>
             <a:r>
-              <a:rPr sz="1500" b="0">
+              <a:rPr sz="1400" b="0">
                 <a:solidFill>
                   <a:srgbClr val="1A1C1E"/>
                 </a:solidFill>
@@ -13555,8 +13601,8 @@
         </p:nvSpPr>
         <p:spPr>
           <a:xfrm>
-            <a:off x="640080" y="4846320"/>
-            <a:ext cx="10881360" cy="1143000"/>
+            <a:off x="594360" y="4572000"/>
+            <a:ext cx="10927080" cy="1417320"/>
           </a:xfrm>
           <a:prstGeom prst="rect">
             <a:avLst/>
@@ -13598,8 +13644,8 @@
         </p:nvSpPr>
         <p:spPr>
           <a:xfrm>
-            <a:off x="868680" y="4983480"/>
-            <a:ext cx="10424160" cy="868680"/>
+            <a:off x="822960" y="4709160"/>
+            <a:ext cx="10424160" cy="320040"/>
           </a:xfrm>
           <a:prstGeom prst="rect">
             <a:avLst/>
@@ -13614,13 +13660,48 @@
           <a:p>
             <a:pPr algn="l"/>
             <a:r>
-              <a:rPr sz="1500" b="0">
+              <a:rPr sz="1300" b="1">
+                <a:solidFill>
+                  <a:srgbClr val="D6F26A"/>
+                </a:solidFill>
+                <a:latin typeface="Calibri"/>
+              </a:rPr>
+              <a:t>Competitive shapes (from differentiation history)</a:t>
+            </a:r>
+          </a:p>
+        </p:txBody>
+      </p:sp>
+      <p:sp>
+        <p:nvSpPr>
+          <p:cNvPr id="15" name="TextBox 14"/>
+          <p:cNvSpPr txBox="1"/>
+          <p:nvPr/>
+        </p:nvSpPr>
+        <p:spPr>
+          <a:xfrm>
+            <a:off x="822960" y="5074920"/>
+            <a:ext cx="10424160" cy="731520"/>
+          </a:xfrm>
+          <a:prstGeom prst="rect">
+            <a:avLst/>
+          </a:prstGeom>
+          <a:noFill/>
+        </p:spPr>
+        <p:txBody>
+          <a:bodyPr wrap="square" anchor="t">
+            <a:spAutoFit/>
+          </a:bodyPr>
+          <a:lstStyle/>
+          <a:p>
+            <a:pPr algn="l"/>
+            <a:r>
+              <a:rPr sz="1300" b="0">
                 <a:solidFill>
                   <a:srgbClr val="E8EAE4"/>
                 </a:solidFill>
                 <a:latin typeface="Calibri"/>
               </a:rPr>
-              <a:t>EMEA SDR implication: lead with workflow · context · execution. Stay fluent on the model layer. Never turn a customer call into an infrastructure or acquisition debate. Model neutrality is the durable frame.</a:t>
+              <a:t>Cursor = AI-native IDE + enterprise platform   ·   Copilot = plugin / GitHub ecosystem   ·   Claude Code = terminal-first agent   ·   Windsurf = AI-IDE challenger (Cascade)   ·   Often the real competitor = ungoverned shadow AI</a:t>
             </a:r>
           </a:p>
         </p:txBody>
@@ -13695,7 +13776,7 @@
         <p:spPr>
           <a:xfrm>
             <a:off x="0" y="0"/>
-            <a:ext cx="12191695" cy="1143000"/>
+            <a:ext cx="12191695" cy="1097280"/>
           </a:xfrm>
           <a:prstGeom prst="rect">
             <a:avLst/>
@@ -13737,8 +13818,8 @@
         </p:nvSpPr>
         <p:spPr>
           <a:xfrm>
-            <a:off x="777240" y="320040"/>
-            <a:ext cx="10515600" cy="594360"/>
+            <a:off x="731520" y="292608"/>
+            <a:ext cx="10698480" cy="548640"/>
           </a:xfrm>
           <a:prstGeom prst="rect">
             <a:avLst/>
@@ -13753,13 +13834,13 @@
           <a:p>
             <a:pPr algn="l"/>
             <a:r>
-              <a:rPr sz="2600" b="1">
+              <a:rPr sz="2400" b="1">
                 <a:solidFill>
                   <a:srgbClr val="FFFFFF"/>
                 </a:solidFill>
                 <a:latin typeface="Georgia"/>
               </a:rPr>
-              <a:t>Cursor positioning — the spine every rep trains on</a:t>
+              <a:t>Cursor positioning — workflow · context · execution</a:t>
             </a:r>
           </a:p>
         </p:txBody>
@@ -13772,8 +13853,8 @@
         </p:nvSpPr>
         <p:spPr>
           <a:xfrm>
-            <a:off x="640080" y="1371600"/>
-            <a:ext cx="10881360" cy="1005840"/>
+            <a:off x="594360" y="1280160"/>
+            <a:ext cx="10927080" cy="914400"/>
           </a:xfrm>
           <a:prstGeom prst="rect">
             <a:avLst/>
@@ -13815,8 +13896,8 @@
         </p:nvSpPr>
         <p:spPr>
           <a:xfrm>
-            <a:off x="868680" y="1508760"/>
-            <a:ext cx="10424160" cy="731520"/>
+            <a:off x="822960" y="1417320"/>
+            <a:ext cx="10424160" cy="640080"/>
           </a:xfrm>
           <a:prstGeom prst="rect">
             <a:avLst/>
@@ -13831,13 +13912,13 @@
           <a:p>
             <a:pPr algn="l"/>
             <a:r>
-              <a:rPr sz="1600" b="0">
+              <a:rPr sz="1500" b="0">
                 <a:solidFill>
                   <a:srgbClr val="E8EAE4"/>
                 </a:solidFill>
                 <a:latin typeface="Calibri"/>
               </a:rPr>
-              <a:t>Leading agentic coding platform — a shared AI layer on the codebase that connects developers, tools, and agents so teams get more from frontier models.</a:t>
+              <a:t>Leading agentic coding platform — shared AI layer on the codebase that connects developers, tools, and agents so teams get more from frontier models.</a:t>
             </a:r>
           </a:p>
         </p:txBody>
@@ -13850,8 +13931,8 @@
         </p:nvSpPr>
         <p:spPr>
           <a:xfrm>
-            <a:off x="640080" y="2651760"/>
-            <a:ext cx="2606040" cy="1234440"/>
+            <a:off x="594360" y="2423160"/>
+            <a:ext cx="2606040" cy="1143000"/>
           </a:xfrm>
           <a:prstGeom prst="rect">
             <a:avLst/>
@@ -13893,8 +13974,8 @@
         </p:nvSpPr>
         <p:spPr>
           <a:xfrm>
-            <a:off x="868680" y="2834640"/>
-            <a:ext cx="640080" cy="73152"/>
+            <a:off x="777240" y="2606040"/>
+            <a:ext cx="594360" cy="73152"/>
           </a:xfrm>
           <a:prstGeom prst="rect">
             <a:avLst/>
@@ -13936,8 +14017,8 @@
         </p:nvSpPr>
         <p:spPr>
           <a:xfrm>
-            <a:off x="868680" y="3017520"/>
-            <a:ext cx="2194560" cy="320040"/>
+            <a:off x="777240" y="2788920"/>
+            <a:ext cx="2240280" cy="274320"/>
           </a:xfrm>
           <a:prstGeom prst="rect">
             <a:avLst/>
@@ -13952,7 +14033,7 @@
           <a:p>
             <a:pPr algn="l"/>
             <a:r>
-              <a:rPr sz="1600" b="1">
+              <a:rPr sz="1500" b="1">
                 <a:solidFill>
                   <a:srgbClr val="141618"/>
                 </a:solidFill>
@@ -13971,8 +14052,8 @@
         </p:nvSpPr>
         <p:spPr>
           <a:xfrm>
-            <a:off x="868680" y="3383280"/>
-            <a:ext cx="2194560" cy="320040"/>
+            <a:off x="777240" y="3108960"/>
+            <a:ext cx="2240280" cy="274320"/>
           </a:xfrm>
           <a:prstGeom prst="rect">
             <a:avLst/>
@@ -13987,7 +14068,7 @@
           <a:p>
             <a:pPr algn="l"/>
             <a:r>
-              <a:rPr sz="1300" b="0">
+              <a:rPr sz="1200" b="0">
                 <a:solidFill>
                   <a:srgbClr val="5E646B"/>
                 </a:solidFill>
@@ -14006,8 +14087,8 @@
         </p:nvSpPr>
         <p:spPr>
           <a:xfrm>
-            <a:off x="3474720" y="2651760"/>
-            <a:ext cx="2606040" cy="1234440"/>
+            <a:off x="3383280" y="2423160"/>
+            <a:ext cx="2606040" cy="1143000"/>
           </a:xfrm>
           <a:prstGeom prst="rect">
             <a:avLst/>
@@ -14049,8 +14130,8 @@
         </p:nvSpPr>
         <p:spPr>
           <a:xfrm>
-            <a:off x="3703320" y="2834640"/>
-            <a:ext cx="640080" cy="73152"/>
+            <a:off x="3566160" y="2606040"/>
+            <a:ext cx="594360" cy="73152"/>
           </a:xfrm>
           <a:prstGeom prst="rect">
             <a:avLst/>
@@ -14092,8 +14173,8 @@
         </p:nvSpPr>
         <p:spPr>
           <a:xfrm>
-            <a:off x="3703320" y="3017520"/>
-            <a:ext cx="2194560" cy="320040"/>
+            <a:off x="3566160" y="2788920"/>
+            <a:ext cx="2240280" cy="274320"/>
           </a:xfrm>
           <a:prstGeom prst="rect">
             <a:avLst/>
@@ -14108,7 +14189,7 @@
           <a:p>
             <a:pPr algn="l"/>
             <a:r>
-              <a:rPr sz="1600" b="1">
+              <a:rPr sz="1500" b="1">
                 <a:solidFill>
                   <a:srgbClr val="141618"/>
                 </a:solidFill>
@@ -14127,8 +14208,8 @@
         </p:nvSpPr>
         <p:spPr>
           <a:xfrm>
-            <a:off x="3703320" y="3383280"/>
-            <a:ext cx="2194560" cy="320040"/>
+            <a:off x="3566160" y="3108960"/>
+            <a:ext cx="2240280" cy="274320"/>
           </a:xfrm>
           <a:prstGeom prst="rect">
             <a:avLst/>
@@ -14143,13 +14224,13 @@
           <a:p>
             <a:pPr algn="l"/>
             <a:r>
-              <a:rPr sz="1300" b="0">
+              <a:rPr sz="1200" b="0">
                 <a:solidFill>
                   <a:srgbClr val="5E646B"/>
                 </a:solidFill>
                 <a:latin typeface="Calibri"/>
               </a:rPr>
-              <a:t>Any terminal / script</a:t>
+              <a:t>Terminal / any workflow</a:t>
             </a:r>
           </a:p>
         </p:txBody>
@@ -14162,8 +14243,8 @@
         </p:nvSpPr>
         <p:spPr>
           <a:xfrm>
-            <a:off x="6309360" y="2651760"/>
-            <a:ext cx="2606040" cy="1234440"/>
+            <a:off x="6172200" y="2423160"/>
+            <a:ext cx="2606040" cy="1143000"/>
           </a:xfrm>
           <a:prstGeom prst="rect">
             <a:avLst/>
@@ -14205,8 +14286,8 @@
         </p:nvSpPr>
         <p:spPr>
           <a:xfrm>
-            <a:off x="6537960" y="2834640"/>
-            <a:ext cx="640080" cy="73152"/>
+            <a:off x="6355080" y="2606040"/>
+            <a:ext cx="594360" cy="73152"/>
           </a:xfrm>
           <a:prstGeom prst="rect">
             <a:avLst/>
@@ -14248,8 +14329,8 @@
         </p:nvSpPr>
         <p:spPr>
           <a:xfrm>
-            <a:off x="6537960" y="3017520"/>
-            <a:ext cx="2194560" cy="320040"/>
+            <a:off x="6355080" y="2788920"/>
+            <a:ext cx="2240280" cy="274320"/>
           </a:xfrm>
           <a:prstGeom prst="rect">
             <a:avLst/>
@@ -14264,7 +14345,7 @@
           <a:p>
             <a:pPr algn="l"/>
             <a:r>
-              <a:rPr sz="1600" b="1">
+              <a:rPr sz="1500" b="1">
                 <a:solidFill>
                   <a:srgbClr val="141618"/>
                 </a:solidFill>
@@ -14283,8 +14364,8 @@
         </p:nvSpPr>
         <p:spPr>
           <a:xfrm>
-            <a:off x="6537960" y="3383280"/>
-            <a:ext cx="2194560" cy="320040"/>
+            <a:off x="6355080" y="3108960"/>
+            <a:ext cx="2240280" cy="274320"/>
           </a:xfrm>
           <a:prstGeom prst="rect">
             <a:avLst/>
@@ -14299,13 +14380,13 @@
           <a:p>
             <a:pPr algn="l"/>
             <a:r>
-              <a:rPr sz="1300" b="0">
+              <a:rPr sz="1200" b="0">
                 <a:solidFill>
                   <a:srgbClr val="5E646B"/>
                 </a:solidFill>
                 <a:latin typeface="Calibri"/>
               </a:rPr>
-              <a:t>Repeatable agent workflows</a:t>
+              <a:t>Event-driven agents</a:t>
             </a:r>
           </a:p>
         </p:txBody>
@@ -14318,8 +14399,8 @@
         </p:nvSpPr>
         <p:spPr>
           <a:xfrm>
-            <a:off x="9144000" y="2651760"/>
-            <a:ext cx="2606040" cy="1234440"/>
+            <a:off x="8961120" y="2423160"/>
+            <a:ext cx="2606040" cy="1143000"/>
           </a:xfrm>
           <a:prstGeom prst="rect">
             <a:avLst/>
@@ -14361,8 +14442,8 @@
         </p:nvSpPr>
         <p:spPr>
           <a:xfrm>
-            <a:off x="9372600" y="2834640"/>
-            <a:ext cx="640080" cy="73152"/>
+            <a:off x="9144000" y="2606040"/>
+            <a:ext cx="594360" cy="73152"/>
           </a:xfrm>
           <a:prstGeom prst="rect">
             <a:avLst/>
@@ -14404,8 +14485,8 @@
         </p:nvSpPr>
         <p:spPr>
           <a:xfrm>
-            <a:off x="9372600" y="3017520"/>
-            <a:ext cx="2194560" cy="320040"/>
+            <a:off x="9144000" y="2788920"/>
+            <a:ext cx="2240280" cy="274320"/>
           </a:xfrm>
           <a:prstGeom prst="rect">
             <a:avLst/>
@@ -14420,7 +14501,7 @@
           <a:p>
             <a:pPr algn="l"/>
             <a:r>
-              <a:rPr sz="1600" b="1">
+              <a:rPr sz="1500" b="1">
                 <a:solidFill>
                   <a:srgbClr val="141618"/>
                 </a:solidFill>
@@ -14439,8 +14520,8 @@
         </p:nvSpPr>
         <p:spPr>
           <a:xfrm>
-            <a:off x="9372600" y="3383280"/>
-            <a:ext cx="2194560" cy="320040"/>
+            <a:off x="9144000" y="3108960"/>
+            <a:ext cx="2240280" cy="274320"/>
           </a:xfrm>
           <a:prstGeom prst="rect">
             <a:avLst/>
@@ -14455,62 +14536,27 @@
           <a:p>
             <a:pPr algn="l"/>
             <a:r>
-              <a:rPr sz="1300" b="0">
+              <a:rPr sz="1200" b="0">
                 <a:solidFill>
                   <a:srgbClr val="5E646B"/>
                 </a:solidFill>
                 <a:latin typeface="Calibri"/>
               </a:rPr>
-              <a:t>Browser / mobile / async</a:t>
-            </a:r>
-          </a:p>
-        </p:txBody>
-      </p:sp>
-      <p:sp>
-        <p:nvSpPr>
-          <p:cNvPr id="23" name="TextBox 22"/>
-          <p:cNvSpPr txBox="1"/>
-          <p:nvPr/>
-        </p:nvSpPr>
-        <p:spPr>
-          <a:xfrm>
-            <a:off x="822960" y="4160520"/>
-            <a:ext cx="10515600" cy="365760"/>
-          </a:xfrm>
-          <a:prstGeom prst="rect">
-            <a:avLst/>
-          </a:prstGeom>
-          <a:noFill/>
-        </p:spPr>
-        <p:txBody>
-          <a:bodyPr wrap="square" anchor="t">
-            <a:spAutoFit/>
-          </a:bodyPr>
-          <a:lstStyle/>
-          <a:p>
-            <a:pPr algn="l"/>
-            <a:r>
-              <a:rPr sz="1400" b="1">
-                <a:solidFill>
-                  <a:srgbClr val="141618"/>
-                </a:solidFill>
-                <a:latin typeface="Georgia"/>
-              </a:rPr>
-              <a:t>Teach these three words</a:t>
-            </a:r>
-          </a:p>
-        </p:txBody>
-      </p:sp>
-      <p:sp>
-        <p:nvSpPr>
-          <p:cNvPr id="24" name="Rectangle 23"/>
+              <a:t>Async / browser / mobile</a:t>
+            </a:r>
+          </a:p>
+        </p:txBody>
+      </p:sp>
+      <p:sp>
+        <p:nvSpPr>
+          <p:cNvPr id="23" name="Rectangle 22"/>
           <p:cNvSpPr/>
           <p:nvPr/>
         </p:nvSpPr>
         <p:spPr>
           <a:xfrm>
-            <a:off x="640080" y="4617720"/>
-            <a:ext cx="3520440" cy="1325880"/>
+            <a:off x="594360" y="3840480"/>
+            <a:ext cx="3566160" cy="1234440"/>
           </a:xfrm>
           <a:prstGeom prst="rect">
             <a:avLst/>
@@ -14546,14 +14592,14 @@
       </p:sp>
       <p:sp>
         <p:nvSpPr>
-          <p:cNvPr id="25" name="TextBox 24"/>
+          <p:cNvPr id="24" name="TextBox 23"/>
           <p:cNvSpPr txBox="1"/>
           <p:nvPr/>
         </p:nvSpPr>
         <p:spPr>
           <a:xfrm>
-            <a:off x="868680" y="4754880"/>
-            <a:ext cx="3063240" cy="320040"/>
+            <a:off x="822960" y="4023360"/>
+            <a:ext cx="3108960" cy="320040"/>
           </a:xfrm>
           <a:prstGeom prst="rect">
             <a:avLst/>
@@ -14581,14 +14627,14 @@
       </p:sp>
       <p:sp>
         <p:nvSpPr>
-          <p:cNvPr id="26" name="TextBox 25"/>
+          <p:cNvPr id="25" name="TextBox 24"/>
           <p:cNvSpPr txBox="1"/>
           <p:nvPr/>
         </p:nvSpPr>
         <p:spPr>
           <a:xfrm>
-            <a:off x="868680" y="5120640"/>
-            <a:ext cx="3063240" cy="594360"/>
+            <a:off x="822960" y="4434840"/>
+            <a:ext cx="3108960" cy="457200"/>
           </a:xfrm>
           <a:prstGeom prst="rect">
             <a:avLst/>
@@ -14609,21 +14655,21 @@
                 </a:solidFill>
                 <a:latin typeface="Calibri"/>
               </a:rPr>
-              <a:t>How work actually gets done</a:t>
-            </a:r>
-          </a:p>
-        </p:txBody>
-      </p:sp>
-      <p:sp>
-        <p:nvSpPr>
-          <p:cNvPr id="27" name="Rectangle 26"/>
+              <a:t>How work actually gets done across the SDLC</a:t>
+            </a:r>
+          </a:p>
+        </p:txBody>
+      </p:sp>
+      <p:sp>
+        <p:nvSpPr>
+          <p:cNvPr id="26" name="Rectangle 25"/>
           <p:cNvSpPr/>
           <p:nvPr/>
         </p:nvSpPr>
         <p:spPr>
           <a:xfrm>
-            <a:off x="4343400" y="4617720"/>
-            <a:ext cx="3520440" cy="1325880"/>
+            <a:off x="4343399" y="3840480"/>
+            <a:ext cx="3566160" cy="1234440"/>
           </a:xfrm>
           <a:prstGeom prst="rect">
             <a:avLst/>
@@ -14659,14 +14705,14 @@
       </p:sp>
       <p:sp>
         <p:nvSpPr>
-          <p:cNvPr id="28" name="TextBox 27"/>
+          <p:cNvPr id="27" name="TextBox 26"/>
           <p:cNvSpPr txBox="1"/>
           <p:nvPr/>
         </p:nvSpPr>
         <p:spPr>
           <a:xfrm>
-            <a:off x="4572000" y="4754880"/>
-            <a:ext cx="3063240" cy="320040"/>
+            <a:off x="4571999" y="4023360"/>
+            <a:ext cx="3108960" cy="320040"/>
           </a:xfrm>
           <a:prstGeom prst="rect">
             <a:avLst/>
@@ -14694,14 +14740,14 @@
       </p:sp>
       <p:sp>
         <p:nvSpPr>
-          <p:cNvPr id="29" name="TextBox 28"/>
+          <p:cNvPr id="28" name="TextBox 27"/>
           <p:cNvSpPr txBox="1"/>
           <p:nvPr/>
         </p:nvSpPr>
         <p:spPr>
           <a:xfrm>
-            <a:off x="4572000" y="5120640"/>
-            <a:ext cx="3063240" cy="594360"/>
+            <a:off x="4571999" y="4434840"/>
+            <a:ext cx="3108960" cy="457200"/>
           </a:xfrm>
           <a:prstGeom prst="rect">
             <a:avLst/>
@@ -14722,21 +14768,21 @@
                 </a:solidFill>
                 <a:latin typeface="Calibri"/>
               </a:rPr>
-              <a:t>Codebase + dependencies + team systems</a:t>
-            </a:r>
-          </a:p>
-        </p:txBody>
-      </p:sp>
-      <p:sp>
-        <p:nvSpPr>
-          <p:cNvPr id="30" name="Rectangle 29"/>
+              <a:t>Codebase, dependencies, team systems</a:t>
+            </a:r>
+          </a:p>
+        </p:txBody>
+      </p:sp>
+      <p:sp>
+        <p:nvSpPr>
+          <p:cNvPr id="29" name="Rectangle 28"/>
           <p:cNvSpPr/>
           <p:nvPr/>
         </p:nvSpPr>
         <p:spPr>
           <a:xfrm>
-            <a:off x="8046720" y="4617720"/>
-            <a:ext cx="3520440" cy="1325880"/>
+            <a:off x="8092438" y="3840480"/>
+            <a:ext cx="3566160" cy="1234440"/>
           </a:xfrm>
           <a:prstGeom prst="rect">
             <a:avLst/>
@@ -14772,14 +14818,14 @@
       </p:sp>
       <p:sp>
         <p:nvSpPr>
-          <p:cNvPr id="31" name="TextBox 30"/>
+          <p:cNvPr id="30" name="TextBox 29"/>
           <p:cNvSpPr txBox="1"/>
           <p:nvPr/>
         </p:nvSpPr>
         <p:spPr>
           <a:xfrm>
-            <a:off x="8275320" y="4754880"/>
-            <a:ext cx="3063240" cy="320040"/>
+            <a:off x="8321038" y="4023360"/>
+            <a:ext cx="3108960" cy="320040"/>
           </a:xfrm>
           <a:prstGeom prst="rect">
             <a:avLst/>
@@ -14807,14 +14853,14 @@
       </p:sp>
       <p:sp>
         <p:nvSpPr>
-          <p:cNvPr id="32" name="TextBox 31"/>
+          <p:cNvPr id="31" name="TextBox 30"/>
           <p:cNvSpPr txBox="1"/>
           <p:nvPr/>
         </p:nvSpPr>
         <p:spPr>
           <a:xfrm>
-            <a:off x="8275320" y="5120640"/>
-            <a:ext cx="3063240" cy="594360"/>
+            <a:off x="8321038" y="4434840"/>
+            <a:ext cx="3108960" cy="457200"/>
           </a:xfrm>
           <a:prstGeom prst="rect">
             <a:avLst/>
@@ -14836,6 +14882,42 @@
                 <a:latin typeface="Calibri"/>
               </a:rPr>
               <a:t>Plan → build → review → ship with less friction</a:t>
+            </a:r>
+          </a:p>
+        </p:txBody>
+      </p:sp>
+      <p:sp>
+        <p:nvSpPr>
+          <p:cNvPr id="32" name="TextBox 31"/>
+          <p:cNvSpPr txBox="1"/>
+          <p:nvPr/>
+        </p:nvSpPr>
+        <p:spPr>
+          <a:xfrm>
+            <a:off x="777240" y="5303520"/>
+            <a:ext cx="10515600" cy="777240"/>
+          </a:xfrm>
+          <a:prstGeom prst="rect">
+            <a:avLst/>
+          </a:prstGeom>
+          <a:noFill/>
+        </p:spPr>
+        <p:txBody>
+          <a:bodyPr wrap="square" anchor="t">
+            <a:spAutoFit/>
+          </a:bodyPr>
+          <a:lstStyle/>
+          <a:p>
+            <a:pPr algn="l"/>
+            <a:r>
+              <a:rPr sz="1300" b="0">
+                <a:solidFill>
+                  <a:srgbClr val="5E646B"/>
+                </a:solidFill>
+                <a:latin typeface="Calibri"/>
+              </a:rPr>
+              <a:t>Enterprise 3 buckets:  Productivity (agents + multi-file)  ·  Governance (SSO / SCIM / audit / admin)  ·  Privacy &amp; security (Privacy Mode, SOC 2 Type II)
+Proof points: Coinbase · Stripe · PayPal — speed + governed adoption, not autocomplete vanity.</a:t>
             </a:r>
           </a:p>
         </p:txBody>

</xml_diff>

<commit_message>
Recreate challenge deck from full competitor-diff history
Full rebuild incorporating AI-native vs plugin map, two-layer race,
Copilot/Claude Code/Windsurf/Codex/shadow-AI battlecard, enterprise
buckets, software-factory bottleneck, harness definition, and
Coinbase/Stripe/PayPal proof — with verbatim speaker notes retained.

Co-authored-by: dempseli01-stack <dempseli01-stack@users.noreply.github.com>
</commit_message>
<xml_diff>
--- a/Lindsey_Presentation.pptx
+++ b/Lindsey_Presentation.pptx
@@ -5388,8 +5388,8 @@
         </p:nvSpPr>
         <p:spPr>
           <a:xfrm>
-            <a:off x="0" y="5212080"/>
-            <a:ext cx="12191695" cy="1645920"/>
+            <a:off x="0" y="5074920"/>
+            <a:ext cx="12191695" cy="1783080"/>
           </a:xfrm>
           <a:prstGeom prst="rect">
             <a:avLst/>
@@ -5431,8 +5431,8 @@
         </p:nvSpPr>
         <p:spPr>
           <a:xfrm>
-            <a:off x="777240" y="1691640"/>
-            <a:ext cx="1371600" cy="73152"/>
+            <a:off x="731520" y="1554480"/>
+            <a:ext cx="1371600" cy="64008"/>
           </a:xfrm>
           <a:prstGeom prst="rect">
             <a:avLst/>
@@ -5474,8 +5474,8 @@
         </p:nvSpPr>
         <p:spPr>
           <a:xfrm>
-            <a:off x="777240" y="1920240"/>
-            <a:ext cx="10515600" cy="914400"/>
+            <a:off x="731520" y="1783080"/>
+            <a:ext cx="10607040" cy="822960"/>
           </a:xfrm>
           <a:prstGeom prst="rect">
             <a:avLst/>
@@ -5490,7 +5490,7 @@
           <a:p>
             <a:pPr algn="l"/>
             <a:r>
-              <a:rPr sz="4200" b="1">
+              <a:rPr sz="4000" b="1">
                 <a:solidFill>
                   <a:srgbClr val="FFFFFF"/>
                 </a:solidFill>
@@ -5509,8 +5509,8 @@
         </p:nvSpPr>
         <p:spPr>
           <a:xfrm>
-            <a:off x="777240" y="2926080"/>
-            <a:ext cx="10515600" cy="457200"/>
+            <a:off x="731520" y="2697480"/>
+            <a:ext cx="10607040" cy="411480"/>
           </a:xfrm>
           <a:prstGeom prst="rect">
             <a:avLst/>
@@ -5544,8 +5544,8 @@
         </p:nvSpPr>
         <p:spPr>
           <a:xfrm>
-            <a:off x="777240" y="3520440"/>
-            <a:ext cx="10515600" cy="457200"/>
+            <a:off x="731520" y="3246120"/>
+            <a:ext cx="10607040" cy="411480"/>
           </a:xfrm>
           <a:prstGeom prst="rect">
             <a:avLst/>
@@ -5560,7 +5560,7 @@
           <a:p>
             <a:pPr algn="l"/>
             <a:r>
-              <a:rPr sz="1800" b="0">
+              <a:rPr sz="1700" b="0">
                 <a:solidFill>
                   <a:srgbClr val="E8EAE4"/>
                 </a:solidFill>
@@ -5579,8 +5579,8 @@
         </p:nvSpPr>
         <p:spPr>
           <a:xfrm>
-            <a:off x="777240" y="5577840"/>
-            <a:ext cx="10515600" cy="365760"/>
+            <a:off x="731520" y="3840480"/>
+            <a:ext cx="10607040" cy="365760"/>
           </a:xfrm>
           <a:prstGeom prst="rect">
             <a:avLst/>
@@ -5595,13 +5595,13 @@
           <a:p>
             <a:pPr algn="l"/>
             <a:r>
-              <a:rPr sz="1800" b="1">
-                <a:solidFill>
-                  <a:srgbClr val="FFFFFF"/>
-                </a:solidFill>
-                <a:latin typeface="Georgia"/>
-              </a:rPr>
-              <a:t>Lindsey Dempsey  ·  EMEA SDR Leader Candidate</a:t>
+              <a:rPr sz="1300" b="0">
+                <a:solidFill>
+                  <a:srgbClr val="5E646B"/>
+                </a:solidFill>
+                <a:latin typeface="Calibri"/>
+              </a:rPr>
+              <a:t>Built from Cursor competitor differentiation + enterprise prep history</a:t>
             </a:r>
           </a:p>
         </p:txBody>
@@ -5614,8 +5614,43 @@
         </p:nvSpPr>
         <p:spPr>
           <a:xfrm>
-            <a:off x="777240" y="5989320"/>
-            <a:ext cx="10515600" cy="320040"/>
+            <a:off x="731520" y="5394960"/>
+            <a:ext cx="10607040" cy="365760"/>
+          </a:xfrm>
+          <a:prstGeom prst="rect">
+            <a:avLst/>
+          </a:prstGeom>
+          <a:noFill/>
+        </p:spPr>
+        <p:txBody>
+          <a:bodyPr wrap="square" anchor="t">
+            <a:spAutoFit/>
+          </a:bodyPr>
+          <a:lstStyle/>
+          <a:p>
+            <a:pPr algn="l"/>
+            <a:r>
+              <a:rPr sz="1800" b="1">
+                <a:solidFill>
+                  <a:srgbClr val="FFFFFF"/>
+                </a:solidFill>
+                <a:latin typeface="Georgia"/>
+              </a:rPr>
+              <a:t>Lindsey Dempsey  ·  EMEA SDR Leader Candidate</a:t>
+            </a:r>
+          </a:p>
+        </p:txBody>
+      </p:sp>
+      <p:sp>
+        <p:nvSpPr>
+          <p:cNvPr id="10" name="TextBox 9"/>
+          <p:cNvSpPr txBox="1"/>
+          <p:nvPr/>
+        </p:nvSpPr>
+        <p:spPr>
+          <a:xfrm>
+            <a:off x="731520" y="5852160"/>
+            <a:ext cx="10607040" cy="320040"/>
           </a:xfrm>
           <a:prstGeom prst="rect">
             <a:avLst/>
@@ -5711,7 +5746,7 @@
         <p:spPr>
           <a:xfrm>
             <a:off x="0" y="0"/>
-            <a:ext cx="12191695" cy="1097280"/>
+            <a:ext cx="12191695" cy="1051560"/>
           </a:xfrm>
           <a:prstGeom prst="rect">
             <a:avLst/>
@@ -5753,8 +5788,8 @@
         </p:nvSpPr>
         <p:spPr>
           <a:xfrm>
-            <a:off x="731520" y="292608"/>
-            <a:ext cx="10698480" cy="548640"/>
+            <a:off x="685800" y="274320"/>
+            <a:ext cx="10789920" cy="502920"/>
           </a:xfrm>
           <a:prstGeom prst="rect">
             <a:avLst/>
@@ -5769,13 +5804,13 @@
           <a:p>
             <a:pPr algn="l"/>
             <a:r>
-              <a:rPr sz="2400" b="1">
+              <a:rPr sz="2300" b="1">
                 <a:solidFill>
                   <a:srgbClr val="FFFFFF"/>
                 </a:solidFill>
                 <a:latin typeface="Georgia"/>
               </a:rPr>
-              <a:t>Four differentiators — diagnose first, lead with one wedge</a:t>
+              <a:t>Four differentiators — lead with one based on buyer pain</a:t>
             </a:r>
           </a:p>
         </p:txBody>
@@ -5788,8 +5823,8 @@
         </p:nvSpPr>
         <p:spPr>
           <a:xfrm>
-            <a:off x="594360" y="1325880"/>
-            <a:ext cx="5349240" cy="2148840"/>
+            <a:off x="548640" y="1280160"/>
+            <a:ext cx="5394960" cy="2148840"/>
           </a:xfrm>
           <a:prstGeom prst="rect">
             <a:avLst/>
@@ -5831,8 +5866,8 @@
         </p:nvSpPr>
         <p:spPr>
           <a:xfrm>
-            <a:off x="822960" y="1554480"/>
-            <a:ext cx="685800" cy="73152"/>
+            <a:off x="777240" y="1508760"/>
+            <a:ext cx="640080" cy="64008"/>
           </a:xfrm>
           <a:prstGeom prst="rect">
             <a:avLst/>
@@ -5874,8 +5909,8 @@
         </p:nvSpPr>
         <p:spPr>
           <a:xfrm>
-            <a:off x="822960" y="1737360"/>
-            <a:ext cx="822960" cy="320040"/>
+            <a:off x="777240" y="1691640"/>
+            <a:ext cx="777240" cy="274320"/>
           </a:xfrm>
           <a:prstGeom prst="rect">
             <a:avLst/>
@@ -5890,7 +5925,7 @@
           <a:p>
             <a:pPr algn="l"/>
             <a:r>
-              <a:rPr sz="1600" b="1">
+              <a:rPr sz="1500" b="1">
                 <a:solidFill>
                   <a:srgbClr val="141618"/>
                 </a:solidFill>
@@ -5909,8 +5944,8 @@
         </p:nvSpPr>
         <p:spPr>
           <a:xfrm>
-            <a:off x="1645920" y="1737360"/>
-            <a:ext cx="3931920" cy="320040"/>
+            <a:off x="1554480" y="1691640"/>
+            <a:ext cx="4023360" cy="274320"/>
           </a:xfrm>
           <a:prstGeom prst="rect">
             <a:avLst/>
@@ -5925,7 +5960,7 @@
           <a:p>
             <a:pPr algn="l"/>
             <a:r>
-              <a:rPr sz="1600" b="1">
+              <a:rPr sz="1500" b="1">
                 <a:solidFill>
                   <a:srgbClr val="141618"/>
                 </a:solidFill>
@@ -5944,8 +5979,8 @@
         </p:nvSpPr>
         <p:spPr>
           <a:xfrm>
-            <a:off x="822960" y="2286000"/>
-            <a:ext cx="4846320" cy="914400"/>
+            <a:off x="777240" y="2194560"/>
+            <a:ext cx="4892040" cy="960120"/>
           </a:xfrm>
           <a:prstGeom prst="rect">
             <a:avLst/>
@@ -5960,13 +5995,13 @@
           <a:p>
             <a:pPr algn="l"/>
             <a:r>
-              <a:rPr sz="1400" b="0">
+              <a:rPr sz="1300" b="0">
                 <a:solidFill>
                   <a:srgbClr val="5E646B"/>
                 </a:solidFill>
                 <a:latin typeface="Calibri"/>
               </a:rPr>
-              <a:t>Best model changes. Flexibility over single-vendor lock-in. Labs can be suppliers and competitors.</a:t>
+              <a:t>Best model changes. No single-vendor lock-in. Labs are suppliers and competitors — optionality is strategic.</a:t>
             </a:r>
           </a:p>
         </p:txBody>
@@ -5979,8 +6014,8 @@
         </p:nvSpPr>
         <p:spPr>
           <a:xfrm>
-            <a:off x="6217920" y="1325880"/>
-            <a:ext cx="5349240" cy="2148840"/>
+            <a:off x="6172200" y="1280160"/>
+            <a:ext cx="5394960" cy="2148840"/>
           </a:xfrm>
           <a:prstGeom prst="rect">
             <a:avLst/>
@@ -6022,8 +6057,8 @@
         </p:nvSpPr>
         <p:spPr>
           <a:xfrm>
-            <a:off x="6446520" y="1554480"/>
-            <a:ext cx="685800" cy="73152"/>
+            <a:off x="6400800" y="1508760"/>
+            <a:ext cx="640080" cy="64008"/>
           </a:xfrm>
           <a:prstGeom prst="rect">
             <a:avLst/>
@@ -6065,8 +6100,8 @@
         </p:nvSpPr>
         <p:spPr>
           <a:xfrm>
-            <a:off x="6446520" y="1737360"/>
-            <a:ext cx="822960" cy="320040"/>
+            <a:off x="6400800" y="1691640"/>
+            <a:ext cx="777240" cy="274320"/>
           </a:xfrm>
           <a:prstGeom prst="rect">
             <a:avLst/>
@@ -6081,7 +6116,7 @@
           <a:p>
             <a:pPr algn="l"/>
             <a:r>
-              <a:rPr sz="1600" b="1">
+              <a:rPr sz="1500" b="1">
                 <a:solidFill>
                   <a:srgbClr val="141618"/>
                 </a:solidFill>
@@ -6100,8 +6135,8 @@
         </p:nvSpPr>
         <p:spPr>
           <a:xfrm>
-            <a:off x="7269480" y="1737360"/>
-            <a:ext cx="3931920" cy="320040"/>
+            <a:off x="7178040" y="1691640"/>
+            <a:ext cx="4023360" cy="274320"/>
           </a:xfrm>
           <a:prstGeom prst="rect">
             <a:avLst/>
@@ -6116,7 +6151,7 @@
           <a:p>
             <a:pPr algn="l"/>
             <a:r>
-              <a:rPr sz="1600" b="1">
+              <a:rPr sz="1500" b="1">
                 <a:solidFill>
                   <a:srgbClr val="141618"/>
                 </a:solidFill>
@@ -6135,8 +6170,8 @@
         </p:nvSpPr>
         <p:spPr>
           <a:xfrm>
-            <a:off x="6446520" y="2286000"/>
-            <a:ext cx="4846320" cy="914400"/>
+            <a:off x="6400800" y="2194560"/>
+            <a:ext cx="4892040" cy="960120"/>
           </a:xfrm>
           <a:prstGeom prst="rect">
             <a:avLst/>
@@ -6151,13 +6186,13 @@
           <a:p>
             <a:pPr algn="l"/>
             <a:r>
-              <a:rPr sz="1400" b="0">
+              <a:rPr sz="1300" b="0">
                 <a:solidFill>
                   <a:srgbClr val="5E646B"/>
                 </a:solidFill>
                 <a:latin typeface="Calibri"/>
               </a:rPr>
-              <a:t>Not just wrapping a model — better finding + using context in messy enterprise repos.</a:t>
+              <a:t>Not just wrapping a model. Better finding + using context in messy enterprise repos. Buyers feel this day one.</a:t>
             </a:r>
           </a:p>
         </p:txBody>
@@ -6170,8 +6205,8 @@
         </p:nvSpPr>
         <p:spPr>
           <a:xfrm>
-            <a:off x="594360" y="3703320"/>
-            <a:ext cx="5349240" cy="2148840"/>
+            <a:off x="548640" y="3657600"/>
+            <a:ext cx="5394960" cy="2148840"/>
           </a:xfrm>
           <a:prstGeom prst="rect">
             <a:avLst/>
@@ -6213,8 +6248,8 @@
         </p:nvSpPr>
         <p:spPr>
           <a:xfrm>
-            <a:off x="822960" y="3931920"/>
-            <a:ext cx="685800" cy="73152"/>
+            <a:off x="777240" y="3886200"/>
+            <a:ext cx="640080" cy="64008"/>
           </a:xfrm>
           <a:prstGeom prst="rect">
             <a:avLst/>
@@ -6256,8 +6291,8 @@
         </p:nvSpPr>
         <p:spPr>
           <a:xfrm>
-            <a:off x="822960" y="4114800"/>
-            <a:ext cx="822960" cy="320040"/>
+            <a:off x="777240" y="4069080"/>
+            <a:ext cx="777240" cy="274320"/>
           </a:xfrm>
           <a:prstGeom prst="rect">
             <a:avLst/>
@@ -6272,7 +6307,7 @@
           <a:p>
             <a:pPr algn="l"/>
             <a:r>
-              <a:rPr sz="1600" b="1">
+              <a:rPr sz="1500" b="1">
                 <a:solidFill>
                   <a:srgbClr val="141618"/>
                 </a:solidFill>
@@ -6291,8 +6326,8 @@
         </p:nvSpPr>
         <p:spPr>
           <a:xfrm>
-            <a:off x="1645920" y="4114800"/>
-            <a:ext cx="3931920" cy="320040"/>
+            <a:off x="1554480" y="4069080"/>
+            <a:ext cx="4023360" cy="274320"/>
           </a:xfrm>
           <a:prstGeom prst="rect">
             <a:avLst/>
@@ -6307,7 +6342,7 @@
           <a:p>
             <a:pPr algn="l"/>
             <a:r>
-              <a:rPr sz="1600" b="1">
+              <a:rPr sz="1500" b="1">
                 <a:solidFill>
                   <a:srgbClr val="141618"/>
                 </a:solidFill>
@@ -6326,8 +6361,8 @@
         </p:nvSpPr>
         <p:spPr>
           <a:xfrm>
-            <a:off x="822960" y="4663440"/>
-            <a:ext cx="4846320" cy="914400"/>
+            <a:off x="777240" y="4572000"/>
+            <a:ext cx="4892040" cy="960120"/>
           </a:xfrm>
           <a:prstGeom prst="rect">
             <a:avLst/>
@@ -6342,13 +6377,13 @@
           <a:p>
             <a:pPr algn="l"/>
             <a:r>
-              <a:rPr sz="1400" b="0">
+              <a:rPr sz="1300" b="0">
                 <a:solidFill>
                   <a:srgbClr val="5E646B"/>
                 </a:solidFill>
                 <a:latin typeface="Calibri"/>
               </a:rPr>
-              <a:t>Useful quickly without every developer inventing a custom setup. Adoption + consistency.</a:t>
+              <a:t>Strong out of the box. Standardize without every developer inventing a custom setup. Adoption + consistency.</a:t>
             </a:r>
           </a:p>
         </p:txBody>
@@ -6361,8 +6396,8 @@
         </p:nvSpPr>
         <p:spPr>
           <a:xfrm>
-            <a:off x="6217920" y="3703320"/>
-            <a:ext cx="5349240" cy="2148840"/>
+            <a:off x="6172200" y="3657600"/>
+            <a:ext cx="5394960" cy="2148840"/>
           </a:xfrm>
           <a:prstGeom prst="rect">
             <a:avLst/>
@@ -6404,8 +6439,8 @@
         </p:nvSpPr>
         <p:spPr>
           <a:xfrm>
-            <a:off x="6446520" y="3931920"/>
-            <a:ext cx="685800" cy="73152"/>
+            <a:off x="6400800" y="3886200"/>
+            <a:ext cx="640080" cy="64008"/>
           </a:xfrm>
           <a:prstGeom prst="rect">
             <a:avLst/>
@@ -6447,8 +6482,8 @@
         </p:nvSpPr>
         <p:spPr>
           <a:xfrm>
-            <a:off x="6446520" y="4114800"/>
-            <a:ext cx="822960" cy="320040"/>
+            <a:off x="6400800" y="4069080"/>
+            <a:ext cx="777240" cy="274320"/>
           </a:xfrm>
           <a:prstGeom prst="rect">
             <a:avLst/>
@@ -6463,7 +6498,7 @@
           <a:p>
             <a:pPr algn="l"/>
             <a:r>
-              <a:rPr sz="1600" b="1">
+              <a:rPr sz="1500" b="1">
                 <a:solidFill>
                   <a:srgbClr val="141618"/>
                 </a:solidFill>
@@ -6482,8 +6517,8 @@
         </p:nvSpPr>
         <p:spPr>
           <a:xfrm>
-            <a:off x="7269480" y="4114800"/>
-            <a:ext cx="3931920" cy="320040"/>
+            <a:off x="7178040" y="4069080"/>
+            <a:ext cx="4023360" cy="274320"/>
           </a:xfrm>
           <a:prstGeom prst="rect">
             <a:avLst/>
@@ -6498,7 +6533,7 @@
           <a:p>
             <a:pPr algn="l"/>
             <a:r>
-              <a:rPr sz="1600" b="1">
+              <a:rPr sz="1500" b="1">
                 <a:solidFill>
                   <a:srgbClr val="141618"/>
                 </a:solidFill>
@@ -6517,8 +6552,8 @@
         </p:nvSpPr>
         <p:spPr>
           <a:xfrm>
-            <a:off x="6446520" y="4663440"/>
-            <a:ext cx="4846320" cy="914400"/>
+            <a:off x="6400800" y="4572000"/>
+            <a:ext cx="4892040" cy="960120"/>
           </a:xfrm>
           <a:prstGeom prst="rect">
             <a:avLst/>
@@ -6533,13 +6568,13 @@
           <a:p>
             <a:pPr algn="l"/>
             <a:r>
-              <a:rPr sz="1400" b="0">
+              <a:rPr sz="1300" b="0">
                 <a:solidFill>
                   <a:srgbClr val="5E646B"/>
                 </a:solidFill>
                 <a:latin typeface="Calibri"/>
               </a:rPr>
-              <a:t>Plan, write, review, debug, iterate — Bugbot, Agent Review, Automations. Better execution.</a:t>
+              <a:t>Bugbot, Agent Review, Automations. Clear the review bottleneck AI creates. Better execution, not just answers.</a:t>
             </a:r>
           </a:p>
         </p:txBody>
@@ -6614,7 +6649,7 @@
         <p:spPr>
           <a:xfrm>
             <a:off x="0" y="0"/>
-            <a:ext cx="12191695" cy="1097280"/>
+            <a:ext cx="12191695" cy="1051560"/>
           </a:xfrm>
           <a:prstGeom prst="rect">
             <a:avLst/>
@@ -6656,8 +6691,8 @@
         </p:nvSpPr>
         <p:spPr>
           <a:xfrm>
-            <a:off x="731520" y="292608"/>
-            <a:ext cx="10698480" cy="548640"/>
+            <a:off x="685800" y="274320"/>
+            <a:ext cx="10789920" cy="502920"/>
           </a:xfrm>
           <a:prstGeom prst="rect">
             <a:avLst/>
@@ -6672,7 +6707,7 @@
           <a:p>
             <a:pPr algn="l"/>
             <a:r>
-              <a:rPr sz="2400" b="1">
+              <a:rPr sz="2300" b="1">
                 <a:solidFill>
                   <a:srgbClr val="FFFFFF"/>
                 </a:solidFill>
@@ -6691,8 +6726,8 @@
         </p:nvSpPr>
         <p:spPr>
           <a:xfrm>
-            <a:off x="594360" y="1325880"/>
-            <a:ext cx="5349240" cy="4754880"/>
+            <a:off x="548640" y="1280160"/>
+            <a:ext cx="5394960" cy="4800600"/>
           </a:xfrm>
           <a:prstGeom prst="rect">
             <a:avLst/>
@@ -6734,8 +6769,8 @@
         </p:nvSpPr>
         <p:spPr>
           <a:xfrm>
-            <a:off x="868680" y="1554480"/>
-            <a:ext cx="777240" cy="73152"/>
+            <a:off x="822960" y="1508760"/>
+            <a:ext cx="731520" cy="64008"/>
           </a:xfrm>
           <a:prstGeom prst="rect">
             <a:avLst/>
@@ -6777,8 +6812,8 @@
         </p:nvSpPr>
         <p:spPr>
           <a:xfrm>
-            <a:off x="868680" y="1783080"/>
-            <a:ext cx="4754880" cy="365760"/>
+            <a:off x="822960" y="1737360"/>
+            <a:ext cx="4846320" cy="320040"/>
           </a:xfrm>
           <a:prstGeom prst="rect">
             <a:avLst/>
@@ -6793,7 +6828,7 @@
           <a:p>
             <a:pPr algn="l"/>
             <a:r>
-              <a:rPr sz="1700" b="1">
+              <a:rPr sz="1600" b="1">
                 <a:solidFill>
                   <a:srgbClr val="141618"/>
                 </a:solidFill>
@@ -6812,8 +6847,8 @@
         </p:nvSpPr>
         <p:spPr>
           <a:xfrm>
-            <a:off x="868680" y="2286000"/>
-            <a:ext cx="4754880" cy="3474720"/>
+            <a:off x="822960" y="2194560"/>
+            <a:ext cx="4846320" cy="3566160"/>
           </a:xfrm>
           <a:prstGeom prst="rect">
             <a:avLst/>
@@ -6828,11 +6863,11 @@
           <a:p>
             <a:pPr algn="l">
               <a:spcAft>
-                <a:spcPts val="800"/>
+                <a:spcPts val="700"/>
               </a:spcAft>
             </a:pPr>
             <a:r>
-              <a:rPr sz="1500" b="0">
+              <a:rPr sz="1400" b="0">
                 <a:solidFill>
                   <a:srgbClr val="1A1C1E"/>
                 </a:solidFill>
@@ -6844,11 +6879,11 @@
           <a:p>
             <a:pPr algn="l">
               <a:spcAft>
-                <a:spcPts val="800"/>
+                <a:spcPts val="700"/>
               </a:spcAft>
             </a:pPr>
             <a:r>
-              <a:rPr sz="1500" b="0">
+              <a:rPr sz="1400" b="0">
                 <a:solidFill>
                   <a:srgbClr val="1A1C1E"/>
                 </a:solidFill>
@@ -6860,11 +6895,11 @@
           <a:p>
             <a:pPr algn="l">
               <a:spcAft>
-                <a:spcPts val="800"/>
+                <a:spcPts val="700"/>
               </a:spcAft>
             </a:pPr>
             <a:r>
-              <a:rPr sz="1500" b="0">
+              <a:rPr sz="1400" b="0">
                 <a:solidFill>
                   <a:srgbClr val="1A1C1E"/>
                 </a:solidFill>
@@ -6883,8 +6918,8 @@
         </p:nvSpPr>
         <p:spPr>
           <a:xfrm>
-            <a:off x="6217920" y="1325880"/>
-            <a:ext cx="5349240" cy="4754880"/>
+            <a:off x="6172200" y="1280160"/>
+            <a:ext cx="5394960" cy="4800600"/>
           </a:xfrm>
           <a:prstGeom prst="rect">
             <a:avLst/>
@@ -6926,8 +6961,8 @@
         </p:nvSpPr>
         <p:spPr>
           <a:xfrm>
-            <a:off x="6492240" y="1554480"/>
-            <a:ext cx="777240" cy="73152"/>
+            <a:off x="6446520" y="1508760"/>
+            <a:ext cx="731520" cy="64008"/>
           </a:xfrm>
           <a:prstGeom prst="rect">
             <a:avLst/>
@@ -6969,8 +7004,8 @@
         </p:nvSpPr>
         <p:spPr>
           <a:xfrm>
-            <a:off x="6492240" y="1783080"/>
-            <a:ext cx="4754880" cy="365760"/>
+            <a:off x="6446520" y="1737360"/>
+            <a:ext cx="4846320" cy="320040"/>
           </a:xfrm>
           <a:prstGeom prst="rect">
             <a:avLst/>
@@ -6985,7 +7020,7 @@
           <a:p>
             <a:pPr algn="l"/>
             <a:r>
-              <a:rPr sz="1700" b="1">
+              <a:rPr sz="1600" b="1">
                 <a:solidFill>
                   <a:srgbClr val="141618"/>
                 </a:solidFill>
@@ -7004,8 +7039,8 @@
         </p:nvSpPr>
         <p:spPr>
           <a:xfrm>
-            <a:off x="6492240" y="2286000"/>
-            <a:ext cx="4754880" cy="3474720"/>
+            <a:off x="6446520" y="2194560"/>
+            <a:ext cx="4846320" cy="3566160"/>
           </a:xfrm>
           <a:prstGeom prst="rect">
             <a:avLst/>
@@ -7020,11 +7055,11 @@
           <a:p>
             <a:pPr algn="l">
               <a:spcAft>
-                <a:spcPts val="800"/>
+                <a:spcPts val="700"/>
               </a:spcAft>
             </a:pPr>
             <a:r>
-              <a:rPr sz="1500" b="0">
+              <a:rPr sz="1400" b="0">
                 <a:solidFill>
                   <a:srgbClr val="1A1C1E"/>
                 </a:solidFill>
@@ -7036,11 +7071,11 @@
           <a:p>
             <a:pPr algn="l">
               <a:spcAft>
-                <a:spcPts val="800"/>
+                <a:spcPts val="700"/>
               </a:spcAft>
             </a:pPr>
             <a:r>
-              <a:rPr sz="1500" b="0">
+              <a:rPr sz="1400" b="0">
                 <a:solidFill>
                   <a:srgbClr val="1A1C1E"/>
                 </a:solidFill>
@@ -7052,11 +7087,11 @@
           <a:p>
             <a:pPr algn="l">
               <a:spcAft>
-                <a:spcPts val="800"/>
+                <a:spcPts val="700"/>
               </a:spcAft>
             </a:pPr>
             <a:r>
-              <a:rPr sz="1500" b="0">
+              <a:rPr sz="1400" b="0">
                 <a:solidFill>
                   <a:srgbClr val="1A1C1E"/>
                 </a:solidFill>
@@ -7137,7 +7172,7 @@
         <p:spPr>
           <a:xfrm>
             <a:off x="0" y="0"/>
-            <a:ext cx="12191695" cy="1097280"/>
+            <a:ext cx="12191695" cy="1051560"/>
           </a:xfrm>
           <a:prstGeom prst="rect">
             <a:avLst/>
@@ -7179,8 +7214,8 @@
         </p:nvSpPr>
         <p:spPr>
           <a:xfrm>
-            <a:off x="731520" y="292608"/>
-            <a:ext cx="10698480" cy="548640"/>
+            <a:off x="685800" y="274320"/>
+            <a:ext cx="10789920" cy="502920"/>
           </a:xfrm>
           <a:prstGeom prst="rect">
             <a:avLst/>
@@ -7195,7 +7230,7 @@
           <a:p>
             <a:pPr algn="l"/>
             <a:r>
-              <a:rPr sz="2400" b="1">
+              <a:rPr sz="2300" b="1">
                 <a:solidFill>
                   <a:srgbClr val="FFFFFF"/>
                 </a:solidFill>
@@ -7214,8 +7249,8 @@
         </p:nvSpPr>
         <p:spPr>
           <a:xfrm>
-            <a:off x="777240" y="1417320"/>
-            <a:ext cx="10515600" cy="4572000"/>
+            <a:off x="731520" y="1371600"/>
+            <a:ext cx="10607040" cy="4663440"/>
           </a:xfrm>
           <a:prstGeom prst="rect">
             <a:avLst/>
@@ -7230,11 +7265,11 @@
           <a:p>
             <a:pPr algn="l">
               <a:spcAft>
-                <a:spcPts val="1200"/>
+                <a:spcPts val="1100"/>
               </a:spcAft>
             </a:pPr>
             <a:r>
-              <a:rPr sz="1800" b="0">
+              <a:rPr sz="1700" b="0">
                 <a:solidFill>
                   <a:srgbClr val="1A1C1E"/>
                 </a:solidFill>
@@ -7246,11 +7281,11 @@
           <a:p>
             <a:pPr algn="l">
               <a:spcAft>
-                <a:spcPts val="1200"/>
+                <a:spcPts val="1100"/>
               </a:spcAft>
             </a:pPr>
             <a:r>
-              <a:rPr sz="1800" b="0">
+              <a:rPr sz="1700" b="0">
                 <a:solidFill>
                   <a:srgbClr val="1A1C1E"/>
                 </a:solidFill>
@@ -7262,11 +7297,11 @@
           <a:p>
             <a:pPr algn="l">
               <a:spcAft>
-                <a:spcPts val="1200"/>
+                <a:spcPts val="1100"/>
               </a:spcAft>
             </a:pPr>
             <a:r>
-              <a:rPr sz="1800" b="0">
+              <a:rPr sz="1700" b="0">
                 <a:solidFill>
                   <a:srgbClr val="1A1C1E"/>
                 </a:solidFill>
@@ -7278,11 +7313,11 @@
           <a:p>
             <a:pPr algn="l">
               <a:spcAft>
-                <a:spcPts val="1200"/>
+                <a:spcPts val="1100"/>
               </a:spcAft>
             </a:pPr>
             <a:r>
-              <a:rPr sz="1800" b="0">
+              <a:rPr sz="1700" b="0">
                 <a:solidFill>
                   <a:srgbClr val="1A1C1E"/>
                 </a:solidFill>
@@ -7294,11 +7329,11 @@
           <a:p>
             <a:pPr algn="l">
               <a:spcAft>
-                <a:spcPts val="1200"/>
+                <a:spcPts val="1100"/>
               </a:spcAft>
             </a:pPr>
             <a:r>
-              <a:rPr sz="1800" b="0">
+              <a:rPr sz="1700" b="0">
                 <a:solidFill>
                   <a:srgbClr val="1A1C1E"/>
                 </a:solidFill>
@@ -7310,11 +7345,11 @@
           <a:p>
             <a:pPr algn="l">
               <a:spcAft>
-                <a:spcPts val="1200"/>
+                <a:spcPts val="1100"/>
               </a:spcAft>
             </a:pPr>
             <a:r>
-              <a:rPr sz="1800" b="0">
+              <a:rPr sz="1700" b="0">
                 <a:solidFill>
                   <a:srgbClr val="1A1C1E"/>
                 </a:solidFill>
@@ -7394,8 +7429,8 @@
         </p:nvSpPr>
         <p:spPr>
           <a:xfrm>
-            <a:off x="777240" y="2286000"/>
-            <a:ext cx="1280160" cy="73152"/>
+            <a:off x="731520" y="2240280"/>
+            <a:ext cx="1234440" cy="64008"/>
           </a:xfrm>
           <a:prstGeom prst="rect">
             <a:avLst/>
@@ -7437,8 +7472,8 @@
         </p:nvSpPr>
         <p:spPr>
           <a:xfrm>
-            <a:off x="777240" y="2468880"/>
-            <a:ext cx="10058400" cy="365760"/>
+            <a:off x="731520" y="2423160"/>
+            <a:ext cx="10058400" cy="320040"/>
           </a:xfrm>
           <a:prstGeom prst="rect">
             <a:avLst/>
@@ -7453,7 +7488,7 @@
           <a:p>
             <a:pPr algn="l"/>
             <a:r>
-              <a:rPr sz="1400" b="1">
+              <a:rPr sz="1300" b="1">
                 <a:solidFill>
                   <a:srgbClr val="D6F26A"/>
                 </a:solidFill>
@@ -7472,8 +7507,8 @@
         </p:nvSpPr>
         <p:spPr>
           <a:xfrm>
-            <a:off x="777240" y="2926080"/>
-            <a:ext cx="10515600" cy="1097280"/>
+            <a:off x="731520" y="2880360"/>
+            <a:ext cx="10607040" cy="1097280"/>
           </a:xfrm>
           <a:prstGeom prst="rect">
             <a:avLst/>
@@ -7488,7 +7523,7 @@
           <a:p>
             <a:pPr algn="l"/>
             <a:r>
-              <a:rPr sz="3200" b="1">
+              <a:rPr sz="3000" b="1">
                 <a:solidFill>
                   <a:srgbClr val="FFFFFF"/>
                 </a:solidFill>
@@ -7569,7 +7604,7 @@
         <p:spPr>
           <a:xfrm>
             <a:off x="0" y="0"/>
-            <a:ext cx="12191695" cy="1097280"/>
+            <a:ext cx="12191695" cy="1051560"/>
           </a:xfrm>
           <a:prstGeom prst="rect">
             <a:avLst/>
@@ -7611,8 +7646,8 @@
         </p:nvSpPr>
         <p:spPr>
           <a:xfrm>
-            <a:off x="731520" y="292608"/>
-            <a:ext cx="10698480" cy="548640"/>
+            <a:off x="685800" y="274320"/>
+            <a:ext cx="10789920" cy="502920"/>
           </a:xfrm>
           <a:prstGeom prst="rect">
             <a:avLst/>
@@ -7627,7 +7662,7 @@
           <a:p>
             <a:pPr algn="l"/>
             <a:r>
-              <a:rPr sz="2400" b="1">
+              <a:rPr sz="2300" b="1">
                 <a:solidFill>
                   <a:srgbClr val="FFFFFF"/>
                 </a:solidFill>
@@ -7646,8 +7681,8 @@
         </p:nvSpPr>
         <p:spPr>
           <a:xfrm>
-            <a:off x="777240" y="1417320"/>
-            <a:ext cx="10515600" cy="4572000"/>
+            <a:off x="731520" y="1371600"/>
+            <a:ext cx="10607040" cy="4663440"/>
           </a:xfrm>
           <a:prstGeom prst="rect">
             <a:avLst/>
@@ -7662,11 +7697,11 @@
           <a:p>
             <a:pPr algn="l">
               <a:spcAft>
-                <a:spcPts val="1200"/>
+                <a:spcPts val="1100"/>
               </a:spcAft>
             </a:pPr>
             <a:r>
-              <a:rPr sz="1800" b="0">
+              <a:rPr sz="1700" b="0">
                 <a:solidFill>
                   <a:srgbClr val="1A1C1E"/>
                 </a:solidFill>
@@ -7678,11 +7713,11 @@
           <a:p>
             <a:pPr algn="l">
               <a:spcAft>
-                <a:spcPts val="1200"/>
+                <a:spcPts val="1100"/>
               </a:spcAft>
             </a:pPr>
             <a:r>
-              <a:rPr sz="1800" b="0">
+              <a:rPr sz="1700" b="0">
                 <a:solidFill>
                   <a:srgbClr val="1A1C1E"/>
                 </a:solidFill>
@@ -7694,11 +7729,11 @@
           <a:p>
             <a:pPr algn="l">
               <a:spcAft>
-                <a:spcPts val="1200"/>
+                <a:spcPts val="1100"/>
               </a:spcAft>
             </a:pPr>
             <a:r>
-              <a:rPr sz="1800" b="0">
+              <a:rPr sz="1700" b="0">
                 <a:solidFill>
                   <a:srgbClr val="1A1C1E"/>
                 </a:solidFill>
@@ -7710,11 +7745,11 @@
           <a:p>
             <a:pPr algn="l">
               <a:spcAft>
-                <a:spcPts val="1200"/>
+                <a:spcPts val="1100"/>
               </a:spcAft>
             </a:pPr>
             <a:r>
-              <a:rPr sz="1800" b="0">
+              <a:rPr sz="1700" b="0">
                 <a:solidFill>
                   <a:srgbClr val="1A1C1E"/>
                 </a:solidFill>
@@ -7726,11 +7761,11 @@
           <a:p>
             <a:pPr algn="l">
               <a:spcAft>
-                <a:spcPts val="1200"/>
+                <a:spcPts val="1100"/>
               </a:spcAft>
             </a:pPr>
             <a:r>
-              <a:rPr sz="1800" b="0">
+              <a:rPr sz="1700" b="0">
                 <a:solidFill>
                   <a:srgbClr val="1A1C1E"/>
                 </a:solidFill>
@@ -7742,11 +7777,11 @@
           <a:p>
             <a:pPr algn="l">
               <a:spcAft>
-                <a:spcPts val="1200"/>
+                <a:spcPts val="1100"/>
               </a:spcAft>
             </a:pPr>
             <a:r>
-              <a:rPr sz="1800" b="0">
+              <a:rPr sz="1700" b="0">
                 <a:solidFill>
                   <a:srgbClr val="1A1C1E"/>
                 </a:solidFill>
@@ -7758,11 +7793,11 @@
           <a:p>
             <a:pPr algn="l">
               <a:spcAft>
-                <a:spcPts val="1200"/>
+                <a:spcPts val="1100"/>
               </a:spcAft>
             </a:pPr>
             <a:r>
-              <a:rPr sz="1800" b="0">
+              <a:rPr sz="1700" b="0">
                 <a:solidFill>
                   <a:srgbClr val="1A1C1E"/>
                 </a:solidFill>
@@ -7843,7 +7878,7 @@
         <p:spPr>
           <a:xfrm>
             <a:off x="0" y="0"/>
-            <a:ext cx="12191695" cy="1097280"/>
+            <a:ext cx="12191695" cy="1051560"/>
           </a:xfrm>
           <a:prstGeom prst="rect">
             <a:avLst/>
@@ -7885,8 +7920,8 @@
         </p:nvSpPr>
         <p:spPr>
           <a:xfrm>
-            <a:off x="731520" y="292608"/>
-            <a:ext cx="10698480" cy="548640"/>
+            <a:off x="685800" y="274320"/>
+            <a:ext cx="10789920" cy="502920"/>
           </a:xfrm>
           <a:prstGeom prst="rect">
             <a:avLst/>
@@ -7901,7 +7936,7 @@
           <a:p>
             <a:pPr algn="l"/>
             <a:r>
-              <a:rPr sz="2400" b="1">
+              <a:rPr sz="2300" b="1">
                 <a:solidFill>
                   <a:srgbClr val="FFFFFF"/>
                 </a:solidFill>
@@ -7920,8 +7955,8 @@
         </p:nvSpPr>
         <p:spPr>
           <a:xfrm>
-            <a:off x="594360" y="1325880"/>
-            <a:ext cx="5349240" cy="4754880"/>
+            <a:off x="548640" y="1280160"/>
+            <a:ext cx="5394960" cy="4800600"/>
           </a:xfrm>
           <a:prstGeom prst="rect">
             <a:avLst/>
@@ -7963,8 +7998,8 @@
         </p:nvSpPr>
         <p:spPr>
           <a:xfrm>
-            <a:off x="868680" y="1554480"/>
-            <a:ext cx="777240" cy="73152"/>
+            <a:off x="822960" y="1508760"/>
+            <a:ext cx="731520" cy="64008"/>
           </a:xfrm>
           <a:prstGeom prst="rect">
             <a:avLst/>
@@ -8006,8 +8041,8 @@
         </p:nvSpPr>
         <p:spPr>
           <a:xfrm>
-            <a:off x="868680" y="1783080"/>
-            <a:ext cx="4754880" cy="365760"/>
+            <a:off x="822960" y="1737360"/>
+            <a:ext cx="4846320" cy="320040"/>
           </a:xfrm>
           <a:prstGeom prst="rect">
             <a:avLst/>
@@ -8022,7 +8057,7 @@
           <a:p>
             <a:pPr algn="l"/>
             <a:r>
-              <a:rPr sz="1700" b="1">
+              <a:rPr sz="1600" b="1">
                 <a:solidFill>
                   <a:srgbClr val="141618"/>
                 </a:solidFill>
@@ -8041,8 +8076,8 @@
         </p:nvSpPr>
         <p:spPr>
           <a:xfrm>
-            <a:off x="868680" y="2286000"/>
-            <a:ext cx="4754880" cy="3474720"/>
+            <a:off x="822960" y="2194560"/>
+            <a:ext cx="4846320" cy="3566160"/>
           </a:xfrm>
           <a:prstGeom prst="rect">
             <a:avLst/>
@@ -8057,11 +8092,11 @@
           <a:p>
             <a:pPr algn="l">
               <a:spcAft>
-                <a:spcPts val="800"/>
+                <a:spcPts val="700"/>
               </a:spcAft>
             </a:pPr>
             <a:r>
-              <a:rPr sz="1500" b="0">
+              <a:rPr sz="1400" b="0">
                 <a:solidFill>
                   <a:srgbClr val="1A1C1E"/>
                 </a:solidFill>
@@ -8073,11 +8108,11 @@
           <a:p>
             <a:pPr algn="l">
               <a:spcAft>
-                <a:spcPts val="800"/>
+                <a:spcPts val="700"/>
               </a:spcAft>
             </a:pPr>
             <a:r>
-              <a:rPr sz="1500" b="0">
+              <a:rPr sz="1400" b="0">
                 <a:solidFill>
                   <a:srgbClr val="1A1C1E"/>
                 </a:solidFill>
@@ -8089,11 +8124,11 @@
           <a:p>
             <a:pPr algn="l">
               <a:spcAft>
-                <a:spcPts val="800"/>
+                <a:spcPts val="700"/>
               </a:spcAft>
             </a:pPr>
             <a:r>
-              <a:rPr sz="1500" b="0">
+              <a:rPr sz="1400" b="0">
                 <a:solidFill>
                   <a:srgbClr val="1A1C1E"/>
                 </a:solidFill>
@@ -8112,8 +8147,8 @@
         </p:nvSpPr>
         <p:spPr>
           <a:xfrm>
-            <a:off x="6217920" y="1325880"/>
-            <a:ext cx="5349240" cy="4754880"/>
+            <a:off x="6172200" y="1280160"/>
+            <a:ext cx="5394960" cy="4800600"/>
           </a:xfrm>
           <a:prstGeom prst="rect">
             <a:avLst/>
@@ -8155,8 +8190,8 @@
         </p:nvSpPr>
         <p:spPr>
           <a:xfrm>
-            <a:off x="6492240" y="1554480"/>
-            <a:ext cx="777240" cy="73152"/>
+            <a:off x="6446520" y="1508760"/>
+            <a:ext cx="731520" cy="64008"/>
           </a:xfrm>
           <a:prstGeom prst="rect">
             <a:avLst/>
@@ -8198,8 +8233,8 @@
         </p:nvSpPr>
         <p:spPr>
           <a:xfrm>
-            <a:off x="6492240" y="1783080"/>
-            <a:ext cx="4754880" cy="365760"/>
+            <a:off x="6446520" y="1737360"/>
+            <a:ext cx="4846320" cy="320040"/>
           </a:xfrm>
           <a:prstGeom prst="rect">
             <a:avLst/>
@@ -8214,7 +8249,7 @@
           <a:p>
             <a:pPr algn="l"/>
             <a:r>
-              <a:rPr sz="1700" b="1">
+              <a:rPr sz="1600" b="1">
                 <a:solidFill>
                   <a:srgbClr val="141618"/>
                 </a:solidFill>
@@ -8233,8 +8268,8 @@
         </p:nvSpPr>
         <p:spPr>
           <a:xfrm>
-            <a:off x="6492240" y="2286000"/>
-            <a:ext cx="4754880" cy="3474720"/>
+            <a:off x="6446520" y="2194560"/>
+            <a:ext cx="4846320" cy="3566160"/>
           </a:xfrm>
           <a:prstGeom prst="rect">
             <a:avLst/>
@@ -8249,11 +8284,11 @@
           <a:p>
             <a:pPr algn="l">
               <a:spcAft>
-                <a:spcPts val="800"/>
+                <a:spcPts val="700"/>
               </a:spcAft>
             </a:pPr>
             <a:r>
-              <a:rPr sz="1500" b="0">
+              <a:rPr sz="1400" b="0">
                 <a:solidFill>
                   <a:srgbClr val="1A1C1E"/>
                 </a:solidFill>
@@ -8265,11 +8300,11 @@
           <a:p>
             <a:pPr algn="l">
               <a:spcAft>
-                <a:spcPts val="800"/>
+                <a:spcPts val="700"/>
               </a:spcAft>
             </a:pPr>
             <a:r>
-              <a:rPr sz="1500" b="0">
+              <a:rPr sz="1400" b="0">
                 <a:solidFill>
                   <a:srgbClr val="1A1C1E"/>
                 </a:solidFill>
@@ -8281,11 +8316,11 @@
           <a:p>
             <a:pPr algn="l">
               <a:spcAft>
-                <a:spcPts val="800"/>
+                <a:spcPts val="700"/>
               </a:spcAft>
             </a:pPr>
             <a:r>
-              <a:rPr sz="1500" b="0">
+              <a:rPr sz="1400" b="0">
                 <a:solidFill>
                   <a:srgbClr val="1A1C1E"/>
                 </a:solidFill>
@@ -8297,11 +8332,11 @@
           <a:p>
             <a:pPr algn="l">
               <a:spcAft>
-                <a:spcPts val="800"/>
+                <a:spcPts val="700"/>
               </a:spcAft>
             </a:pPr>
             <a:r>
-              <a:rPr sz="1500" b="0">
+              <a:rPr sz="1400" b="0">
                 <a:solidFill>
                   <a:srgbClr val="1A1C1E"/>
                 </a:solidFill>
@@ -8313,11 +8348,11 @@
           <a:p>
             <a:pPr algn="l">
               <a:spcAft>
-                <a:spcPts val="800"/>
+                <a:spcPts val="700"/>
               </a:spcAft>
             </a:pPr>
             <a:r>
-              <a:rPr sz="1500" b="0">
+              <a:rPr sz="1400" b="0">
                 <a:solidFill>
                   <a:srgbClr val="1A1C1E"/>
                 </a:solidFill>
@@ -8397,8 +8432,8 @@
         </p:nvSpPr>
         <p:spPr>
           <a:xfrm>
-            <a:off x="777240" y="2286000"/>
-            <a:ext cx="1280160" cy="73152"/>
+            <a:off x="731520" y="2240280"/>
+            <a:ext cx="1234440" cy="64008"/>
           </a:xfrm>
           <a:prstGeom prst="rect">
             <a:avLst/>
@@ -8440,8 +8475,8 @@
         </p:nvSpPr>
         <p:spPr>
           <a:xfrm>
-            <a:off x="777240" y="2468880"/>
-            <a:ext cx="10058400" cy="365760"/>
+            <a:off x="731520" y="2423160"/>
+            <a:ext cx="10058400" cy="320040"/>
           </a:xfrm>
           <a:prstGeom prst="rect">
             <a:avLst/>
@@ -8456,7 +8491,7 @@
           <a:p>
             <a:pPr algn="l"/>
             <a:r>
-              <a:rPr sz="1400" b="1">
+              <a:rPr sz="1300" b="1">
                 <a:solidFill>
                   <a:srgbClr val="D6F26A"/>
                 </a:solidFill>
@@ -8475,8 +8510,8 @@
         </p:nvSpPr>
         <p:spPr>
           <a:xfrm>
-            <a:off x="777240" y="2926080"/>
-            <a:ext cx="10515600" cy="1097280"/>
+            <a:off x="731520" y="2880360"/>
+            <a:ext cx="10607040" cy="1097280"/>
           </a:xfrm>
           <a:prstGeom prst="rect">
             <a:avLst/>
@@ -8491,7 +8526,7 @@
           <a:p>
             <a:pPr algn="l"/>
             <a:r>
-              <a:rPr sz="3200" b="1">
+              <a:rPr sz="3000" b="1">
                 <a:solidFill>
                   <a:srgbClr val="FFFFFF"/>
                 </a:solidFill>
@@ -8572,7 +8607,7 @@
         <p:spPr>
           <a:xfrm>
             <a:off x="0" y="0"/>
-            <a:ext cx="12191695" cy="1097280"/>
+            <a:ext cx="12191695" cy="1051560"/>
           </a:xfrm>
           <a:prstGeom prst="rect">
             <a:avLst/>
@@ -8614,8 +8649,8 @@
         </p:nvSpPr>
         <p:spPr>
           <a:xfrm>
-            <a:off x="731520" y="292608"/>
-            <a:ext cx="10698480" cy="548640"/>
+            <a:off x="685800" y="274320"/>
+            <a:ext cx="10789920" cy="502920"/>
           </a:xfrm>
           <a:prstGeom prst="rect">
             <a:avLst/>
@@ -8630,7 +8665,7 @@
           <a:p>
             <a:pPr algn="l"/>
             <a:r>
-              <a:rPr sz="2400" b="1">
+              <a:rPr sz="2300" b="1">
                 <a:solidFill>
                   <a:srgbClr val="FFFFFF"/>
                 </a:solidFill>
@@ -8649,8 +8684,8 @@
         </p:nvSpPr>
         <p:spPr>
           <a:xfrm>
-            <a:off x="777240" y="1325880"/>
-            <a:ext cx="640080" cy="320040"/>
+            <a:off x="731520" y="1280160"/>
+            <a:ext cx="594360" cy="292608"/>
           </a:xfrm>
           <a:prstGeom prst="rect">
             <a:avLst/>
@@ -8665,7 +8700,7 @@
           <a:p>
             <a:pPr algn="l"/>
             <a:r>
-              <a:rPr sz="1700" b="1">
+              <a:rPr sz="1600" b="1">
                 <a:solidFill>
                   <a:srgbClr val="141618"/>
                 </a:solidFill>
@@ -8684,8 +8719,8 @@
         </p:nvSpPr>
         <p:spPr>
           <a:xfrm>
-            <a:off x="1417320" y="1325880"/>
-            <a:ext cx="9875520" cy="292608"/>
+            <a:off x="1371600" y="1280160"/>
+            <a:ext cx="9966960" cy="274320"/>
           </a:xfrm>
           <a:prstGeom prst="rect">
             <a:avLst/>
@@ -8700,7 +8735,7 @@
           <a:p>
             <a:pPr algn="l"/>
             <a:r>
-              <a:rPr sz="1600" b="1">
+              <a:rPr sz="1500" b="1">
                 <a:solidFill>
                   <a:srgbClr val="141618"/>
                 </a:solidFill>
@@ -8719,8 +8754,8 @@
         </p:nvSpPr>
         <p:spPr>
           <a:xfrm>
-            <a:off x="1417320" y="1618488"/>
-            <a:ext cx="9875520" cy="457200"/>
+            <a:off x="1371600" y="1572768"/>
+            <a:ext cx="9966960" cy="457200"/>
           </a:xfrm>
           <a:prstGeom prst="rect">
             <a:avLst/>
@@ -8735,7 +8770,7 @@
           <a:p>
             <a:pPr algn="l"/>
             <a:r>
-              <a:rPr sz="1400" b="0">
+              <a:rPr sz="1300" b="0">
                 <a:solidFill>
                   <a:srgbClr val="5E646B"/>
                 </a:solidFill>
@@ -8754,8 +8789,8 @@
         </p:nvSpPr>
         <p:spPr>
           <a:xfrm>
-            <a:off x="777240" y="2377440"/>
-            <a:ext cx="640080" cy="320040"/>
+            <a:off x="731520" y="2331720"/>
+            <a:ext cx="594360" cy="292608"/>
           </a:xfrm>
           <a:prstGeom prst="rect">
             <a:avLst/>
@@ -8770,7 +8805,7 @@
           <a:p>
             <a:pPr algn="l"/>
             <a:r>
-              <a:rPr sz="1700" b="1">
+              <a:rPr sz="1600" b="1">
                 <a:solidFill>
                   <a:srgbClr val="141618"/>
                 </a:solidFill>
@@ -8789,8 +8824,8 @@
         </p:nvSpPr>
         <p:spPr>
           <a:xfrm>
-            <a:off x="1417320" y="2377440"/>
-            <a:ext cx="9875520" cy="292608"/>
+            <a:off x="1371600" y="2331720"/>
+            <a:ext cx="9966960" cy="274320"/>
           </a:xfrm>
           <a:prstGeom prst="rect">
             <a:avLst/>
@@ -8805,7 +8840,7 @@
           <a:p>
             <a:pPr algn="l"/>
             <a:r>
-              <a:rPr sz="1600" b="1">
+              <a:rPr sz="1500" b="1">
                 <a:solidFill>
                   <a:srgbClr val="141618"/>
                 </a:solidFill>
@@ -8824,8 +8859,8 @@
         </p:nvSpPr>
         <p:spPr>
           <a:xfrm>
-            <a:off x="1417320" y="2670048"/>
-            <a:ext cx="9875520" cy="457200"/>
+            <a:off x="1371600" y="2624328"/>
+            <a:ext cx="9966960" cy="457200"/>
           </a:xfrm>
           <a:prstGeom prst="rect">
             <a:avLst/>
@@ -8840,7 +8875,7 @@
           <a:p>
             <a:pPr algn="l"/>
             <a:r>
-              <a:rPr sz="1400" b="0">
+              <a:rPr sz="1300" b="0">
                 <a:solidFill>
                   <a:srgbClr val="5E646B"/>
                 </a:solidFill>
@@ -8859,8 +8894,8 @@
         </p:nvSpPr>
         <p:spPr>
           <a:xfrm>
-            <a:off x="777240" y="3429000"/>
-            <a:ext cx="640080" cy="320040"/>
+            <a:off x="731520" y="3383280"/>
+            <a:ext cx="594360" cy="292608"/>
           </a:xfrm>
           <a:prstGeom prst="rect">
             <a:avLst/>
@@ -8875,7 +8910,7 @@
           <a:p>
             <a:pPr algn="l"/>
             <a:r>
-              <a:rPr sz="1700" b="1">
+              <a:rPr sz="1600" b="1">
                 <a:solidFill>
                   <a:srgbClr val="141618"/>
                 </a:solidFill>
@@ -8894,8 +8929,8 @@
         </p:nvSpPr>
         <p:spPr>
           <a:xfrm>
-            <a:off x="1417320" y="3429000"/>
-            <a:ext cx="9875520" cy="292608"/>
+            <a:off x="1371600" y="3383280"/>
+            <a:ext cx="9966960" cy="274320"/>
           </a:xfrm>
           <a:prstGeom prst="rect">
             <a:avLst/>
@@ -8910,7 +8945,7 @@
           <a:p>
             <a:pPr algn="l"/>
             <a:r>
-              <a:rPr sz="1600" b="1">
+              <a:rPr sz="1500" b="1">
                 <a:solidFill>
                   <a:srgbClr val="141618"/>
                 </a:solidFill>
@@ -8929,8 +8964,8 @@
         </p:nvSpPr>
         <p:spPr>
           <a:xfrm>
-            <a:off x="1417320" y="3721608"/>
-            <a:ext cx="9875520" cy="457200"/>
+            <a:off x="1371600" y="3675888"/>
+            <a:ext cx="9966960" cy="457200"/>
           </a:xfrm>
           <a:prstGeom prst="rect">
             <a:avLst/>
@@ -8945,7 +8980,7 @@
           <a:p>
             <a:pPr algn="l"/>
             <a:r>
-              <a:rPr sz="1400" b="0">
+              <a:rPr sz="1300" b="0">
                 <a:solidFill>
                   <a:srgbClr val="5E646B"/>
                 </a:solidFill>
@@ -8964,8 +8999,8 @@
         </p:nvSpPr>
         <p:spPr>
           <a:xfrm>
-            <a:off x="777240" y="4480560"/>
-            <a:ext cx="640080" cy="320040"/>
+            <a:off x="731520" y="4434840"/>
+            <a:ext cx="594360" cy="292608"/>
           </a:xfrm>
           <a:prstGeom prst="rect">
             <a:avLst/>
@@ -8980,7 +9015,7 @@
           <a:p>
             <a:pPr algn="l"/>
             <a:r>
-              <a:rPr sz="1700" b="1">
+              <a:rPr sz="1600" b="1">
                 <a:solidFill>
                   <a:srgbClr val="141618"/>
                 </a:solidFill>
@@ -8999,8 +9034,8 @@
         </p:nvSpPr>
         <p:spPr>
           <a:xfrm>
-            <a:off x="1417320" y="4480560"/>
-            <a:ext cx="9875520" cy="292608"/>
+            <a:off x="1371600" y="4434840"/>
+            <a:ext cx="9966960" cy="274320"/>
           </a:xfrm>
           <a:prstGeom prst="rect">
             <a:avLst/>
@@ -9015,7 +9050,7 @@
           <a:p>
             <a:pPr algn="l"/>
             <a:r>
-              <a:rPr sz="1600" b="1">
+              <a:rPr sz="1500" b="1">
                 <a:solidFill>
                   <a:srgbClr val="141618"/>
                 </a:solidFill>
@@ -9034,8 +9069,8 @@
         </p:nvSpPr>
         <p:spPr>
           <a:xfrm>
-            <a:off x="1417320" y="4773168"/>
-            <a:ext cx="9875520" cy="457200"/>
+            <a:off x="1371600" y="4727448"/>
+            <a:ext cx="9966960" cy="457200"/>
           </a:xfrm>
           <a:prstGeom prst="rect">
             <a:avLst/>
@@ -9050,7 +9085,7 @@
           <a:p>
             <a:pPr algn="l"/>
             <a:r>
-              <a:rPr sz="1400" b="0">
+              <a:rPr sz="1300" b="0">
                 <a:solidFill>
                   <a:srgbClr val="5E646B"/>
                 </a:solidFill>
@@ -9131,7 +9166,7 @@
         <p:spPr>
           <a:xfrm>
             <a:off x="0" y="0"/>
-            <a:ext cx="12191695" cy="1097280"/>
+            <a:ext cx="12191695" cy="1051560"/>
           </a:xfrm>
           <a:prstGeom prst="rect">
             <a:avLst/>
@@ -9173,8 +9208,8 @@
         </p:nvSpPr>
         <p:spPr>
           <a:xfrm>
-            <a:off x="731520" y="292608"/>
-            <a:ext cx="10698480" cy="548640"/>
+            <a:off x="685800" y="274320"/>
+            <a:ext cx="10789920" cy="502920"/>
           </a:xfrm>
           <a:prstGeom prst="rect">
             <a:avLst/>
@@ -9189,7 +9224,7 @@
           <a:p>
             <a:pPr algn="l"/>
             <a:r>
-              <a:rPr sz="2400" b="1">
+              <a:rPr sz="2300" b="1">
                 <a:solidFill>
                   <a:srgbClr val="FFFFFF"/>
                 </a:solidFill>
@@ -9208,8 +9243,8 @@
         </p:nvSpPr>
         <p:spPr>
           <a:xfrm>
-            <a:off x="777240" y="1417320"/>
-            <a:ext cx="10515600" cy="4572000"/>
+            <a:off x="731520" y="1371600"/>
+            <a:ext cx="10607040" cy="4663440"/>
           </a:xfrm>
           <a:prstGeom prst="rect">
             <a:avLst/>
@@ -9224,11 +9259,11 @@
           <a:p>
             <a:pPr algn="l">
               <a:spcAft>
-                <a:spcPts val="1200"/>
+                <a:spcPts val="1100"/>
               </a:spcAft>
             </a:pPr>
             <a:r>
-              <a:rPr sz="1600" b="0">
+              <a:rPr sz="1500" b="0">
                 <a:solidFill>
                   <a:srgbClr val="1A1C1E"/>
                 </a:solidFill>
@@ -9240,11 +9275,11 @@
           <a:p>
             <a:pPr algn="l">
               <a:spcAft>
-                <a:spcPts val="1200"/>
+                <a:spcPts val="1100"/>
               </a:spcAft>
             </a:pPr>
             <a:r>
-              <a:rPr sz="1600" b="0">
+              <a:rPr sz="1500" b="0">
                 <a:solidFill>
                   <a:srgbClr val="1A1C1E"/>
                 </a:solidFill>
@@ -9256,11 +9291,11 @@
           <a:p>
             <a:pPr algn="l">
               <a:spcAft>
-                <a:spcPts val="1200"/>
+                <a:spcPts val="1100"/>
               </a:spcAft>
             </a:pPr>
             <a:r>
-              <a:rPr sz="1600" b="0">
+              <a:rPr sz="1500" b="0">
                 <a:solidFill>
                   <a:srgbClr val="1A1C1E"/>
                 </a:solidFill>
@@ -9272,49 +9307,49 @@
           <a:p>
             <a:pPr algn="l">
               <a:spcAft>
-                <a:spcPts val="1200"/>
+                <a:spcPts val="1100"/>
               </a:spcAft>
             </a:pPr>
             <a:r>
-              <a:rPr sz="1600" b="0">
+              <a:rPr sz="1500" b="0">
                 <a:solidFill>
                   <a:srgbClr val="1A1C1E"/>
                 </a:solidFill>
                 <a:latin typeface="Calibri"/>
               </a:rPr>
-              <a:t>•  What works: trigger-based relevance (Copilot sprawl, AI policy, migrations, DevEx) + one sharp question</a:t>
+              <a:t>•  Triggers that work: Copilot sprawl, AI policy, migrations, DevEx ownership + one sharp question</a:t>
             </a:r>
           </a:p>
           <a:p>
             <a:pPr algn="l">
               <a:spcAft>
-                <a:spcPts val="1200"/>
+                <a:spcPts val="1100"/>
               </a:spcAft>
             </a:pPr>
             <a:r>
-              <a:rPr sz="1600" b="0">
+              <a:rPr sz="1500" b="0">
                 <a:solidFill>
                   <a:srgbClr val="1A1C1E"/>
                 </a:solidFill>
                 <a:latin typeface="Calibri"/>
               </a:rPr>
-              <a:t>•  What fails: generic “quick chat” spam and fake personalization</a:t>
+              <a:t>•  Arm reps with proof: Coinbase (agent-first) · Stripe (rollout) · PayPal (enterprise velocity)</a:t>
             </a:r>
           </a:p>
           <a:p>
             <a:pPr algn="l">
               <a:spcAft>
-                <a:spcPts val="1200"/>
+                <a:spcPts val="1100"/>
               </a:spcAft>
             </a:pPr>
             <a:r>
-              <a:rPr sz="1600" b="0">
+              <a:rPr sz="1500" b="0">
                 <a:solidFill>
                   <a:srgbClr val="1A1C1E"/>
                 </a:solidFill>
                 <a:latin typeface="Calibri"/>
               </a:rPr>
-              <a:t>•  Proof to arm reps: Coinbase (agent-first), Stripe (rollout), PayPal (enterprise velocity)</a:t>
+              <a:t>•  What fails: generic “quick chat” spam and fake personalization</a:t>
             </a:r>
           </a:p>
         </p:txBody>
@@ -9389,7 +9424,7 @@
         <p:spPr>
           <a:xfrm>
             <a:off x="0" y="0"/>
-            <a:ext cx="12191695" cy="1097280"/>
+            <a:ext cx="12191695" cy="1051560"/>
           </a:xfrm>
           <a:prstGeom prst="rect">
             <a:avLst/>
@@ -9431,8 +9466,8 @@
         </p:nvSpPr>
         <p:spPr>
           <a:xfrm>
-            <a:off x="731520" y="292608"/>
-            <a:ext cx="10698480" cy="548640"/>
+            <a:off x="685800" y="274320"/>
+            <a:ext cx="10789920" cy="502920"/>
           </a:xfrm>
           <a:prstGeom prst="rect">
             <a:avLst/>
@@ -9447,13 +9482,13 @@
           <a:p>
             <a:pPr algn="l"/>
             <a:r>
-              <a:rPr sz="2400" b="1">
+              <a:rPr sz="2300" b="1">
                 <a:solidFill>
                   <a:srgbClr val="FFFFFF"/>
                 </a:solidFill>
                 <a:latin typeface="Georgia"/>
               </a:rPr>
-              <a:t>Why we win — competition differentiation</a:t>
+              <a:t>Why we win — competition differentiation battlecard</a:t>
             </a:r>
           </a:p>
         </p:txBody>
@@ -9466,8 +9501,8 @@
         </p:nvSpPr>
         <p:spPr>
           <a:xfrm>
-            <a:off x="502920" y="1234440"/>
-            <a:ext cx="11109960" cy="731520"/>
+            <a:off x="457200" y="1188720"/>
+            <a:ext cx="11201400" cy="640080"/>
           </a:xfrm>
           <a:prstGeom prst="rect">
             <a:avLst/>
@@ -9509,8 +9544,8 @@
         </p:nvSpPr>
         <p:spPr>
           <a:xfrm>
-            <a:off x="685800" y="1325880"/>
-            <a:ext cx="10698480" cy="548640"/>
+            <a:off x="640080" y="1280160"/>
+            <a:ext cx="10789920" cy="457200"/>
           </a:xfrm>
           <a:prstGeom prst="rect">
             <a:avLst/>
@@ -9525,13 +9560,13 @@
           <a:p>
             <a:pPr algn="l"/>
             <a:r>
-              <a:rPr sz="1300" b="0">
+              <a:rPr sz="1200" b="0">
                 <a:solidFill>
                   <a:srgbClr val="E8EAE4"/>
                 </a:solidFill>
                 <a:latin typeface="Calibri"/>
               </a:rPr>
-              <a:t>We don’t win by claiming exclusive smarter intelligence forever. We win by applying intelligence better — workflow, codebase context, integrated SDLC — with model neutrality.</a:t>
+              <a:t>Not exclusive smarter intelligence forever — apply intelligence better: workflow + codebase context + SDLC integration + model neutrality.</a:t>
             </a:r>
           </a:p>
         </p:txBody>
@@ -9544,8 +9579,8 @@
         </p:nvSpPr>
         <p:spPr>
           <a:xfrm>
-            <a:off x="502920" y="2148840"/>
-            <a:ext cx="2743200" cy="3886200"/>
+            <a:off x="457200" y="2011680"/>
+            <a:ext cx="2743200" cy="4023360"/>
           </a:xfrm>
           <a:prstGeom prst="rect">
             <a:avLst/>
@@ -9587,8 +9622,8 @@
         </p:nvSpPr>
         <p:spPr>
           <a:xfrm>
-            <a:off x="502920" y="2148840"/>
-            <a:ext cx="2743200" cy="457200"/>
+            <a:off x="457200" y="2011680"/>
+            <a:ext cx="2743200" cy="438912"/>
           </a:xfrm>
           <a:prstGeom prst="rect">
             <a:avLst/>
@@ -9630,8 +9665,8 @@
         </p:nvSpPr>
         <p:spPr>
           <a:xfrm>
-            <a:off x="612648" y="2212848"/>
-            <a:ext cx="2514600" cy="347472"/>
+            <a:off x="566928" y="2084831"/>
+            <a:ext cx="2514600" cy="320040"/>
           </a:xfrm>
           <a:prstGeom prst="rect">
             <a:avLst/>
@@ -9665,8 +9700,8 @@
         </p:nvSpPr>
         <p:spPr>
           <a:xfrm>
-            <a:off x="612648" y="2788920"/>
-            <a:ext cx="2514600" cy="3017520"/>
+            <a:off x="566928" y="2651760"/>
+            <a:ext cx="2514600" cy="3108960"/>
           </a:xfrm>
           <a:prstGeom prst="rect">
             <a:avLst/>
@@ -9707,7 +9742,7 @@
                 </a:solidFill>
                 <a:latin typeface="Calibri"/>
               </a:rPr>
-              <a:t>•  Snippet help → task completion</a:t>
+              <a:t>•  Full-repo context + agent-first</a:t>
             </a:r>
           </a:p>
           <a:p>
@@ -9723,7 +9758,7 @@
                 </a:solidFill>
                 <a:latin typeface="Calibri"/>
               </a:rPr>
-              <a:t>•  Shared AI layer on the codebase</a:t>
+              <a:t>•  IDE · CLI · Automations · Cloud Agents</a:t>
             </a:r>
           </a:p>
           <a:p>
@@ -9739,7 +9774,7 @@
                 </a:solidFill>
                 <a:latin typeface="Calibri"/>
               </a:rPr>
-              <a:t>•  IDE · CLI · Automations · Cloud Agents</a:t>
+              <a:t>•  Multi-model + Composer path</a:t>
             </a:r>
           </a:p>
           <a:p>
@@ -9755,7 +9790,7 @@
                 </a:solidFill>
                 <a:latin typeface="Calibri"/>
               </a:rPr>
-              <a:t>•  Multi-model + Composer path</a:t>
+              <a:t>•  Bugbot clears PR bottleneck</a:t>
             </a:r>
           </a:p>
           <a:p>
@@ -9771,7 +9806,7 @@
                 </a:solidFill>
                 <a:latin typeface="Calibri"/>
               </a:rPr>
-              <a:t>•  Bugbot / review clears PR bottleneck</a:t>
+              <a:t>•  Governance: SSO / SCIM / audit</a:t>
             </a:r>
           </a:p>
         </p:txBody>
@@ -9784,8 +9819,8 @@
         </p:nvSpPr>
         <p:spPr>
           <a:xfrm>
-            <a:off x="3383280" y="2148840"/>
-            <a:ext cx="2743200" cy="3886200"/>
+            <a:off x="3337560" y="2011680"/>
+            <a:ext cx="2743200" cy="4023360"/>
           </a:xfrm>
           <a:prstGeom prst="rect">
             <a:avLst/>
@@ -9827,8 +9862,8 @@
         </p:nvSpPr>
         <p:spPr>
           <a:xfrm>
-            <a:off x="3383280" y="2148840"/>
-            <a:ext cx="2743200" cy="457200"/>
+            <a:off x="3337560" y="2011680"/>
+            <a:ext cx="2743200" cy="438912"/>
           </a:xfrm>
           <a:prstGeom prst="rect">
             <a:avLst/>
@@ -9870,8 +9905,8 @@
         </p:nvSpPr>
         <p:spPr>
           <a:xfrm>
-            <a:off x="3493008" y="2212848"/>
-            <a:ext cx="2514600" cy="347472"/>
+            <a:off x="3447288" y="2084831"/>
+            <a:ext cx="2514600" cy="320040"/>
           </a:xfrm>
           <a:prstGeom prst="rect">
             <a:avLst/>
@@ -9892,7 +9927,7 @@
                 </a:solidFill>
                 <a:latin typeface="Georgia"/>
               </a:rPr>
-              <a:t>vs GitHub Copilot</a:t>
+              <a:t>vs Copilot</a:t>
             </a:r>
           </a:p>
         </p:txBody>
@@ -9905,8 +9940,8 @@
         </p:nvSpPr>
         <p:spPr>
           <a:xfrm>
-            <a:off x="3493008" y="2788920"/>
-            <a:ext cx="2514600" cy="3017520"/>
+            <a:off x="3447288" y="2651760"/>
+            <a:ext cx="2514600" cy="3108960"/>
           </a:xfrm>
           <a:prstGeom prst="rect">
             <a:avLst/>
@@ -9931,7 +9966,7 @@
                 </a:solidFill>
                 <a:latin typeface="Calibri"/>
               </a:rPr>
-              <a:t>•  Helps developers write faster</a:t>
+              <a:t>•  Biggest by market share</a:t>
             </a:r>
           </a:p>
           <a:p>
@@ -9947,7 +9982,7 @@
                 </a:solidFill>
                 <a:latin typeface="Calibri"/>
               </a:rPr>
-              <a:t>•  Often felt as local / snippet help</a:t>
+              <a:t>•  Plugin in existing IDEs</a:t>
             </a:r>
           </a:p>
           <a:p>
@@ -9979,7 +10014,7 @@
                 </a:solidFill>
                 <a:latin typeface="Calibri"/>
               </a:rPr>
-              <a:t>•  Our move: task completion</a:t>
+              <a:t>•  Often local / snippet help</a:t>
             </a:r>
           </a:p>
           <a:p>
@@ -9995,7 +10030,7 @@
                 </a:solidFill>
                 <a:latin typeface="Calibri"/>
               </a:rPr>
-              <a:t>•  Our move: broader codebase context</a:t>
+              <a:t>•  Our move: task completion</a:t>
             </a:r>
           </a:p>
           <a:p>
@@ -10011,7 +10046,7 @@
                 </a:solidFill>
                 <a:latin typeface="Calibri"/>
               </a:rPr>
-              <a:t>•  Our move: integrated experience</a:t>
+              <a:t>•  Our move: codebase workflow</a:t>
             </a:r>
           </a:p>
         </p:txBody>
@@ -10024,8 +10059,8 @@
         </p:nvSpPr>
         <p:spPr>
           <a:xfrm>
-            <a:off x="6263640" y="2148840"/>
-            <a:ext cx="2743200" cy="3886200"/>
+            <a:off x="6217920" y="2011680"/>
+            <a:ext cx="2743200" cy="4023360"/>
           </a:xfrm>
           <a:prstGeom prst="rect">
             <a:avLst/>
@@ -10067,8 +10102,8 @@
         </p:nvSpPr>
         <p:spPr>
           <a:xfrm>
-            <a:off x="6263640" y="2148840"/>
-            <a:ext cx="2743200" cy="457200"/>
+            <a:off x="6217920" y="2011680"/>
+            <a:ext cx="2743200" cy="438912"/>
           </a:xfrm>
           <a:prstGeom prst="rect">
             <a:avLst/>
@@ -10110,8 +10145,8 @@
         </p:nvSpPr>
         <p:spPr>
           <a:xfrm>
-            <a:off x="6373368" y="2212848"/>
-            <a:ext cx="2514600" cy="347472"/>
+            <a:off x="6327648" y="2084831"/>
+            <a:ext cx="2514600" cy="320040"/>
           </a:xfrm>
           <a:prstGeom prst="rect">
             <a:avLst/>
@@ -10145,8 +10180,8 @@
         </p:nvSpPr>
         <p:spPr>
           <a:xfrm>
-            <a:off x="6373368" y="2788920"/>
-            <a:ext cx="2514600" cy="3017520"/>
+            <a:off x="6327648" y="2651760"/>
+            <a:ext cx="2514600" cy="3108960"/>
           </a:xfrm>
           <a:prstGeom prst="rect">
             <a:avLst/>
@@ -10171,7 +10206,7 @@
                 </a:solidFill>
                 <a:latin typeface="Calibri"/>
               </a:rPr>
-              <a:t>•  Strong — don’t trash-talk it</a:t>
+              <a:t>•  Strong — don’t trash-talk</a:t>
             </a:r>
           </a:p>
           <a:p>
@@ -10203,7 +10238,7 @@
                 </a:solidFill>
                 <a:latin typeface="Calibri"/>
               </a:rPr>
-              <a:t>•  Not a “smarter model” war</a:t>
+              <a:t>•  Not a model-war pitch</a:t>
             </a:r>
           </a:p>
           <a:p>
@@ -10219,7 +10254,7 @@
                 </a:solidFill>
                 <a:latin typeface="Calibri"/>
               </a:rPr>
-              <a:t>•  Our edge: model neutrality</a:t>
+              <a:t>•  Our edge: neutrality</a:t>
             </a:r>
           </a:p>
           <a:p>
@@ -10264,8 +10299,8 @@
         </p:nvSpPr>
         <p:spPr>
           <a:xfrm>
-            <a:off x="9144000" y="2148840"/>
-            <a:ext cx="2743200" cy="3886200"/>
+            <a:off x="9098280" y="2011680"/>
+            <a:ext cx="2743200" cy="4023360"/>
           </a:xfrm>
           <a:prstGeom prst="rect">
             <a:avLst/>
@@ -10307,8 +10342,8 @@
         </p:nvSpPr>
         <p:spPr>
           <a:xfrm>
-            <a:off x="9144000" y="2148840"/>
-            <a:ext cx="2743200" cy="457200"/>
+            <a:off x="9098280" y="2011680"/>
+            <a:ext cx="2743200" cy="438912"/>
           </a:xfrm>
           <a:prstGeom prst="rect">
             <a:avLst/>
@@ -10350,8 +10385,8 @@
         </p:nvSpPr>
         <p:spPr>
           <a:xfrm>
-            <a:off x="9253728" y="2212848"/>
-            <a:ext cx="2514600" cy="347472"/>
+            <a:off x="9208008" y="2084831"/>
+            <a:ext cx="2514600" cy="320040"/>
           </a:xfrm>
           <a:prstGeom prst="rect">
             <a:avLst/>
@@ -10372,7 +10407,7 @@
                 </a:solidFill>
                 <a:latin typeface="Georgia"/>
               </a:rPr>
-              <a:t>Also in market</a:t>
+              <a:t>Also / real rival</a:t>
             </a:r>
           </a:p>
         </p:txBody>
@@ -10385,8 +10420,8 @@
         </p:nvSpPr>
         <p:spPr>
           <a:xfrm>
-            <a:off x="9253728" y="2788920"/>
-            <a:ext cx="2514600" cy="3017520"/>
+            <a:off x="9208008" y="2651760"/>
+            <a:ext cx="2514600" cy="3108960"/>
           </a:xfrm>
           <a:prstGeom prst="rect">
             <a:avLst/>
@@ -10411,7 +10446,7 @@
                 </a:solidFill>
                 <a:latin typeface="Calibri"/>
               </a:rPr>
-              <a:t>•  Windsurf: Cascade agent UX</a:t>
+              <a:t>•  Windsurf: Cascade UX challenger</a:t>
             </a:r>
           </a:p>
           <a:p>
@@ -10443,7 +10478,7 @@
                 </a:solidFill>
                 <a:latin typeface="Calibri"/>
               </a:rPr>
-              <a:t>•  Shadow AI: real enterprise rival</a:t>
+              <a:t>•  Shadow AI = real enterprise rival</a:t>
             </a:r>
           </a:p>
           <a:p>
@@ -10475,7 +10510,7 @@
                 </a:solidFill>
                 <a:latin typeface="Calibri"/>
               </a:rPr>
-              <a:t>•  Proof: Coinbase / Stripe / PayPal</a:t>
+              <a:t>•  Proof: Coinbase · Stripe · PayPal</a:t>
             </a:r>
           </a:p>
           <a:p>
@@ -10491,7 +10526,7 @@
                 </a:solidFill>
                 <a:latin typeface="Calibri"/>
               </a:rPr>
-              <a:t>•  Outcomes &gt; autocomplete vanity</a:t>
+              <a:t>•  Outcomes per $ &gt; autocomplete</a:t>
             </a:r>
           </a:p>
         </p:txBody>
@@ -10566,7 +10601,7 @@
         <p:spPr>
           <a:xfrm>
             <a:off x="0" y="0"/>
-            <a:ext cx="12191695" cy="1097280"/>
+            <a:ext cx="12191695" cy="1051560"/>
           </a:xfrm>
           <a:prstGeom prst="rect">
             <a:avLst/>
@@ -10608,8 +10643,8 @@
         </p:nvSpPr>
         <p:spPr>
           <a:xfrm>
-            <a:off x="731520" y="292608"/>
-            <a:ext cx="10698480" cy="548640"/>
+            <a:off x="685800" y="274320"/>
+            <a:ext cx="10789920" cy="502920"/>
           </a:xfrm>
           <a:prstGeom prst="rect">
             <a:avLst/>
@@ -10624,7 +10659,7 @@
           <a:p>
             <a:pPr algn="l"/>
             <a:r>
-              <a:rPr sz="2400" b="1">
+              <a:rPr sz="2300" b="1">
                 <a:solidFill>
                   <a:srgbClr val="FFFFFF"/>
                 </a:solidFill>
@@ -10643,8 +10678,8 @@
         </p:nvSpPr>
         <p:spPr>
           <a:xfrm>
-            <a:off x="777240" y="1417320"/>
-            <a:ext cx="10515600" cy="4572000"/>
+            <a:off x="731520" y="1371600"/>
+            <a:ext cx="10607040" cy="4663440"/>
           </a:xfrm>
           <a:prstGeom prst="rect">
             <a:avLst/>
@@ -10659,11 +10694,11 @@
           <a:p>
             <a:pPr algn="l">
               <a:spcAft>
-                <a:spcPts val="1200"/>
+                <a:spcPts val="1100"/>
               </a:spcAft>
             </a:pPr>
             <a:r>
-              <a:rPr sz="1800" b="0">
+              <a:rPr sz="1700" b="0">
                 <a:solidFill>
                   <a:srgbClr val="1A1C1E"/>
                 </a:solidFill>
@@ -10675,11 +10710,11 @@
           <a:p>
             <a:pPr algn="l">
               <a:spcAft>
-                <a:spcPts val="1200"/>
+                <a:spcPts val="1100"/>
               </a:spcAft>
             </a:pPr>
             <a:r>
-              <a:rPr sz="1800" b="0">
+              <a:rPr sz="1700" b="0">
                 <a:solidFill>
                   <a:srgbClr val="1A1C1E"/>
                 </a:solidFill>
@@ -10691,11 +10726,11 @@
           <a:p>
             <a:pPr algn="l">
               <a:spcAft>
-                <a:spcPts val="1200"/>
+                <a:spcPts val="1100"/>
               </a:spcAft>
             </a:pPr>
             <a:r>
-              <a:rPr sz="1800" b="0">
+              <a:rPr sz="1700" b="0">
                 <a:solidFill>
                   <a:srgbClr val="1A1C1E"/>
                 </a:solidFill>
@@ -10707,11 +10742,11 @@
           <a:p>
             <a:pPr algn="l">
               <a:spcAft>
-                <a:spcPts val="1200"/>
+                <a:spcPts val="1100"/>
               </a:spcAft>
             </a:pPr>
             <a:r>
-              <a:rPr sz="1800" b="0">
+              <a:rPr sz="1700" b="0">
                 <a:solidFill>
                   <a:srgbClr val="1A1C1E"/>
                 </a:solidFill>
@@ -10723,11 +10758,11 @@
           <a:p>
             <a:pPr algn="l">
               <a:spcAft>
-                <a:spcPts val="1200"/>
+                <a:spcPts val="1100"/>
               </a:spcAft>
             </a:pPr>
             <a:r>
-              <a:rPr sz="1800" b="0">
+              <a:rPr sz="1700" b="0">
                 <a:solidFill>
                   <a:srgbClr val="1A1C1E"/>
                 </a:solidFill>
@@ -10808,7 +10843,7 @@
         <p:spPr>
           <a:xfrm>
             <a:off x="0" y="0"/>
-            <a:ext cx="12191695" cy="1097280"/>
+            <a:ext cx="12191695" cy="1051560"/>
           </a:xfrm>
           <a:prstGeom prst="rect">
             <a:avLst/>
@@ -10850,8 +10885,8 @@
         </p:nvSpPr>
         <p:spPr>
           <a:xfrm>
-            <a:off x="731520" y="292608"/>
-            <a:ext cx="10698480" cy="548640"/>
+            <a:off x="685800" y="274320"/>
+            <a:ext cx="10789920" cy="502920"/>
           </a:xfrm>
           <a:prstGeom prst="rect">
             <a:avLst/>
@@ -10866,7 +10901,7 @@
           <a:p>
             <a:pPr algn="l"/>
             <a:r>
-              <a:rPr sz="2400" b="1">
+              <a:rPr sz="2300" b="1">
                 <a:solidFill>
                   <a:srgbClr val="FFFFFF"/>
                 </a:solidFill>
@@ -10885,8 +10920,8 @@
         </p:nvSpPr>
         <p:spPr>
           <a:xfrm>
-            <a:off x="594360" y="1325880"/>
-            <a:ext cx="5349240" cy="4754880"/>
+            <a:off x="548640" y="1280160"/>
+            <a:ext cx="5394960" cy="4800600"/>
           </a:xfrm>
           <a:prstGeom prst="rect">
             <a:avLst/>
@@ -10928,8 +10963,8 @@
         </p:nvSpPr>
         <p:spPr>
           <a:xfrm>
-            <a:off x="868680" y="1554480"/>
-            <a:ext cx="777240" cy="73152"/>
+            <a:off x="822960" y="1508760"/>
+            <a:ext cx="731520" cy="64008"/>
           </a:xfrm>
           <a:prstGeom prst="rect">
             <a:avLst/>
@@ -10971,8 +11006,8 @@
         </p:nvSpPr>
         <p:spPr>
           <a:xfrm>
-            <a:off x="868680" y="1783080"/>
-            <a:ext cx="4754880" cy="365760"/>
+            <a:off x="822960" y="1737360"/>
+            <a:ext cx="4846320" cy="320040"/>
           </a:xfrm>
           <a:prstGeom prst="rect">
             <a:avLst/>
@@ -10987,7 +11022,7 @@
           <a:p>
             <a:pPr algn="l"/>
             <a:r>
-              <a:rPr sz="1700" b="1">
+              <a:rPr sz="1600" b="1">
                 <a:solidFill>
                   <a:srgbClr val="141618"/>
                 </a:solidFill>
@@ -11006,8 +11041,8 @@
         </p:nvSpPr>
         <p:spPr>
           <a:xfrm>
-            <a:off x="868680" y="2286000"/>
-            <a:ext cx="4754880" cy="3474720"/>
+            <a:off x="822960" y="2194560"/>
+            <a:ext cx="4846320" cy="3566160"/>
           </a:xfrm>
           <a:prstGeom prst="rect">
             <a:avLst/>
@@ -11022,11 +11057,11 @@
           <a:p>
             <a:pPr algn="l">
               <a:spcAft>
-                <a:spcPts val="800"/>
+                <a:spcPts val="700"/>
               </a:spcAft>
             </a:pPr>
             <a:r>
-              <a:rPr sz="1500" b="0">
+              <a:rPr sz="1400" b="0">
                 <a:solidFill>
                   <a:srgbClr val="1A1C1E"/>
                 </a:solidFill>
@@ -11038,11 +11073,11 @@
           <a:p>
             <a:pPr algn="l">
               <a:spcAft>
-                <a:spcPts val="800"/>
+                <a:spcPts val="700"/>
               </a:spcAft>
             </a:pPr>
             <a:r>
-              <a:rPr sz="1500" b="0">
+              <a:rPr sz="1400" b="0">
                 <a:solidFill>
                   <a:srgbClr val="1A1C1E"/>
                 </a:solidFill>
@@ -11054,11 +11089,11 @@
           <a:p>
             <a:pPr algn="l">
               <a:spcAft>
-                <a:spcPts val="800"/>
+                <a:spcPts val="700"/>
               </a:spcAft>
             </a:pPr>
             <a:r>
-              <a:rPr sz="1500" b="0">
+              <a:rPr sz="1400" b="0">
                 <a:solidFill>
                   <a:srgbClr val="1A1C1E"/>
                 </a:solidFill>
@@ -11070,17 +11105,17 @@
           <a:p>
             <a:pPr algn="l">
               <a:spcAft>
-                <a:spcPts val="800"/>
+                <a:spcPts val="700"/>
               </a:spcAft>
             </a:pPr>
             <a:r>
-              <a:rPr sz="1500" b="0">
+              <a:rPr sz="1400" b="0">
                 <a:solidFill>
                   <a:srgbClr val="1A1C1E"/>
                 </a:solidFill>
                 <a:latin typeface="Calibri"/>
               </a:rPr>
-              <a:t>•  Enterprise: enforce org-wide so shadow AI doesn’t win</a:t>
+              <a:t>•  Enforce org-wide so shadow AI doesn’t win</a:t>
             </a:r>
           </a:p>
         </p:txBody>
@@ -11093,8 +11128,8 @@
         </p:nvSpPr>
         <p:spPr>
           <a:xfrm>
-            <a:off x="6217920" y="1325880"/>
-            <a:ext cx="5349240" cy="4754880"/>
+            <a:off x="6172200" y="1280160"/>
+            <a:ext cx="5394960" cy="4800600"/>
           </a:xfrm>
           <a:prstGeom prst="rect">
             <a:avLst/>
@@ -11136,8 +11171,8 @@
         </p:nvSpPr>
         <p:spPr>
           <a:xfrm>
-            <a:off x="6492240" y="1554480"/>
-            <a:ext cx="777240" cy="73152"/>
+            <a:off x="6446520" y="1508760"/>
+            <a:ext cx="731520" cy="64008"/>
           </a:xfrm>
           <a:prstGeom prst="rect">
             <a:avLst/>
@@ -11179,8 +11214,8 @@
         </p:nvSpPr>
         <p:spPr>
           <a:xfrm>
-            <a:off x="6492240" y="1783080"/>
-            <a:ext cx="4754880" cy="365760"/>
+            <a:off x="6446520" y="1737360"/>
+            <a:ext cx="4846320" cy="320040"/>
           </a:xfrm>
           <a:prstGeom prst="rect">
             <a:avLst/>
@@ -11195,7 +11230,7 @@
           <a:p>
             <a:pPr algn="l"/>
             <a:r>
-              <a:rPr sz="1700" b="1">
+              <a:rPr sz="1600" b="1">
                 <a:solidFill>
                   <a:srgbClr val="141618"/>
                 </a:solidFill>
@@ -11214,8 +11249,8 @@
         </p:nvSpPr>
         <p:spPr>
           <a:xfrm>
-            <a:off x="6492240" y="2286000"/>
-            <a:ext cx="4754880" cy="3474720"/>
+            <a:off x="6446520" y="2194560"/>
+            <a:ext cx="4846320" cy="3566160"/>
           </a:xfrm>
           <a:prstGeom prst="rect">
             <a:avLst/>
@@ -11230,11 +11265,11 @@
           <a:p>
             <a:pPr algn="l">
               <a:spcAft>
-                <a:spcPts val="800"/>
+                <a:spcPts val="700"/>
               </a:spcAft>
             </a:pPr>
             <a:r>
-              <a:rPr sz="1500" b="0">
+              <a:rPr sz="1400" b="0">
                 <a:solidFill>
                   <a:srgbClr val="1A1C1E"/>
                 </a:solidFill>
@@ -11246,49 +11281,49 @@
           <a:p>
             <a:pPr algn="l">
               <a:spcAft>
-                <a:spcPts val="800"/>
+                <a:spcPts val="700"/>
               </a:spcAft>
             </a:pPr>
             <a:r>
-              <a:rPr sz="1500" b="0">
+              <a:rPr sz="1400" b="0">
                 <a:solidFill>
                   <a:srgbClr val="1A1C1E"/>
                 </a:solidFill>
                 <a:latin typeface="Calibri"/>
               </a:rPr>
-              <a:t>•  Admin controls, visibility, model / MCP governance</a:t>
+              <a:t>•  SSO / SCIM / audit logs / admin visibility</a:t>
             </a:r>
           </a:p>
           <a:p>
             <a:pPr algn="l">
               <a:spcAft>
-                <a:spcPts val="800"/>
+                <a:spcPts val="700"/>
               </a:spcAft>
             </a:pPr>
             <a:r>
-              <a:rPr sz="1500" b="0">
+              <a:rPr sz="1400" b="0">
                 <a:solidFill>
                   <a:srgbClr val="1A1C1E"/>
                 </a:solidFill>
                 <a:latin typeface="Calibri"/>
               </a:rPr>
-              <a:t>•  SSO / SCIM / audit logs for regulated buyers</a:t>
+              <a:t>•  Model, repo, and MCP governance controls</a:t>
             </a:r>
           </a:p>
           <a:p>
             <a:pPr algn="l">
               <a:spcAft>
-                <a:spcPts val="800"/>
+                <a:spcPts val="700"/>
               </a:spcAft>
             </a:pPr>
             <a:r>
-              <a:rPr sz="1500" b="0">
+              <a:rPr sz="1400" b="0">
                 <a:solidFill>
                   <a:srgbClr val="1A1C1E"/>
                 </a:solidFill>
                 <a:latin typeface="Calibri"/>
               </a:rPr>
-              <a:t>•  First-call frame: adoption confidence — bring the right partner when deep</a:t>
+              <a:t>•  First-call frame: adoption confidence — bring partner when deep</a:t>
             </a:r>
           </a:p>
         </p:txBody>
@@ -11363,7 +11398,7 @@
         <p:spPr>
           <a:xfrm>
             <a:off x="0" y="0"/>
-            <a:ext cx="12191695" cy="1097280"/>
+            <a:ext cx="12191695" cy="1051560"/>
           </a:xfrm>
           <a:prstGeom prst="rect">
             <a:avLst/>
@@ -11405,8 +11440,8 @@
         </p:nvSpPr>
         <p:spPr>
           <a:xfrm>
-            <a:off x="731520" y="292608"/>
-            <a:ext cx="10698480" cy="548640"/>
+            <a:off x="685800" y="274320"/>
+            <a:ext cx="10789920" cy="502920"/>
           </a:xfrm>
           <a:prstGeom prst="rect">
             <a:avLst/>
@@ -11421,7 +11456,7 @@
           <a:p>
             <a:pPr algn="l"/>
             <a:r>
-              <a:rPr sz="2400" b="1">
+              <a:rPr sz="2300" b="1">
                 <a:solidFill>
                   <a:srgbClr val="FFFFFF"/>
                 </a:solidFill>
@@ -11440,8 +11475,8 @@
         </p:nvSpPr>
         <p:spPr>
           <a:xfrm>
-            <a:off x="777240" y="1417320"/>
-            <a:ext cx="10515600" cy="4572000"/>
+            <a:off x="731520" y="1371600"/>
+            <a:ext cx="10607040" cy="4663440"/>
           </a:xfrm>
           <a:prstGeom prst="rect">
             <a:avLst/>
@@ -11456,11 +11491,11 @@
           <a:p>
             <a:pPr algn="l">
               <a:spcAft>
-                <a:spcPts val="1200"/>
+                <a:spcPts val="1100"/>
               </a:spcAft>
             </a:pPr>
             <a:r>
-              <a:rPr sz="1800" b="0">
+              <a:rPr sz="1700" b="0">
                 <a:solidFill>
                   <a:srgbClr val="1A1C1E"/>
                 </a:solidFill>
@@ -11472,11 +11507,11 @@
           <a:p>
             <a:pPr algn="l">
               <a:spcAft>
-                <a:spcPts val="1200"/>
+                <a:spcPts val="1100"/>
               </a:spcAft>
             </a:pPr>
             <a:r>
-              <a:rPr sz="1800" b="0">
+              <a:rPr sz="1700" b="0">
                 <a:solidFill>
                   <a:srgbClr val="1A1C1E"/>
                 </a:solidFill>
@@ -11488,11 +11523,11 @@
           <a:p>
             <a:pPr algn="l">
               <a:spcAft>
-                <a:spcPts val="1200"/>
+                <a:spcPts val="1100"/>
               </a:spcAft>
             </a:pPr>
             <a:r>
-              <a:rPr sz="1800" b="0">
+              <a:rPr sz="1700" b="0">
                 <a:solidFill>
                   <a:srgbClr val="1A1C1E"/>
                 </a:solidFill>
@@ -11504,11 +11539,11 @@
           <a:p>
             <a:pPr algn="l">
               <a:spcAft>
-                <a:spcPts val="1200"/>
+                <a:spcPts val="1100"/>
               </a:spcAft>
             </a:pPr>
             <a:r>
-              <a:rPr sz="1800" b="0">
+              <a:rPr sz="1700" b="0">
                 <a:solidFill>
                   <a:srgbClr val="1A1C1E"/>
                 </a:solidFill>
@@ -11520,11 +11555,11 @@
           <a:p>
             <a:pPr algn="l">
               <a:spcAft>
-                <a:spcPts val="1200"/>
+                <a:spcPts val="1100"/>
               </a:spcAft>
             </a:pPr>
             <a:r>
-              <a:rPr sz="1800" b="0">
+              <a:rPr sz="1700" b="0">
                 <a:solidFill>
                   <a:srgbClr val="1A1C1E"/>
                 </a:solidFill>
@@ -11536,11 +11571,11 @@
           <a:p>
             <a:pPr algn="l">
               <a:spcAft>
-                <a:spcPts val="1200"/>
+                <a:spcPts val="1100"/>
               </a:spcAft>
             </a:pPr>
             <a:r>
-              <a:rPr sz="1800" b="0">
+              <a:rPr sz="1700" b="0">
                 <a:solidFill>
                   <a:srgbClr val="1A1C1E"/>
                 </a:solidFill>
@@ -11621,7 +11656,7 @@
         <p:spPr>
           <a:xfrm>
             <a:off x="0" y="0"/>
-            <a:ext cx="12191695" cy="1097280"/>
+            <a:ext cx="12191695" cy="1051560"/>
           </a:xfrm>
           <a:prstGeom prst="rect">
             <a:avLst/>
@@ -11663,8 +11698,8 @@
         </p:nvSpPr>
         <p:spPr>
           <a:xfrm>
-            <a:off x="731520" y="292608"/>
-            <a:ext cx="10698480" cy="548640"/>
+            <a:off x="685800" y="274320"/>
+            <a:ext cx="10789920" cy="502920"/>
           </a:xfrm>
           <a:prstGeom prst="rect">
             <a:avLst/>
@@ -11679,7 +11714,7 @@
           <a:p>
             <a:pPr algn="l"/>
             <a:r>
-              <a:rPr sz="2400" b="1">
+              <a:rPr sz="2300" b="1">
                 <a:solidFill>
                   <a:srgbClr val="FFFFFF"/>
                 </a:solidFill>
@@ -11698,8 +11733,8 @@
         </p:nvSpPr>
         <p:spPr>
           <a:xfrm>
-            <a:off x="777240" y="1417320"/>
-            <a:ext cx="10515600" cy="4572000"/>
+            <a:off x="731520" y="1371600"/>
+            <a:ext cx="10607040" cy="4663440"/>
           </a:xfrm>
           <a:prstGeom prst="rect">
             <a:avLst/>
@@ -11714,59 +11749,59 @@
           <a:p>
             <a:pPr algn="l">
               <a:spcAft>
-                <a:spcPts val="1200"/>
+                <a:spcPts val="1100"/>
               </a:spcAft>
             </a:pPr>
             <a:r>
-              <a:rPr sz="1800" b="0">
+              <a:rPr sz="1700" b="0">
                 <a:solidFill>
                   <a:srgbClr val="1A1C1E"/>
                 </a:solidFill>
                 <a:latin typeface="Calibri"/>
               </a:rPr>
-              <a:t>•  Part 1 (20 min) — First 15 / 30 / 60: diagnose, protect, gains, competitive context, two experiments</a:t>
+              <a:t>•  Part 1 (20 min) — 15/30/60: diagnose, protect, gains, competitor map, experiments</a:t>
             </a:r>
           </a:p>
           <a:p>
             <a:pPr algn="l">
               <a:spcAft>
-                <a:spcPts val="1200"/>
+                <a:spcPts val="1100"/>
               </a:spcAft>
             </a:pPr>
             <a:r>
-              <a:rPr sz="1800" b="0">
+              <a:rPr sz="1700" b="0">
                 <a:solidFill>
                   <a:srgbClr val="1A1C1E"/>
                 </a:solidFill>
                 <a:latin typeface="Calibri"/>
               </a:rPr>
-              <a:t>•  Part 2 (12 min) — Fundamentals: hire, coach, run the team as a player-coach</a:t>
+              <a:t>•  Part 2 (12 min) — Fundamentals: hire, coach, run as a player-coach</a:t>
             </a:r>
           </a:p>
           <a:p>
             <a:pPr algn="l">
               <a:spcAft>
-                <a:spcPts val="1200"/>
+                <a:spcPts val="1100"/>
               </a:spcAft>
             </a:pPr>
             <a:r>
-              <a:rPr sz="1800" b="0">
+              <a:rPr sz="1700" b="0">
                 <a:solidFill>
                   <a:srgbClr val="1A1C1E"/>
                 </a:solidFill>
                 <a:latin typeface="Calibri"/>
               </a:rPr>
-              <a:t>•  Part 3 (10 min) — Craft: live pitch, persona outreach, why Cursor wins (Copilot + Claude Code)</a:t>
+              <a:t>•  Part 3 (10 min) — Craft: live pitch, personas, why Cursor wins (Copilot + Claude Code)</a:t>
             </a:r>
           </a:p>
           <a:p>
             <a:pPr algn="l">
               <a:spcAft>
-                <a:spcPts val="1200"/>
+                <a:spcPts val="1100"/>
               </a:spcAft>
             </a:pPr>
             <a:r>
-              <a:rPr sz="1800" b="0">
+              <a:rPr sz="1700" b="0">
                 <a:solidFill>
                   <a:srgbClr val="1A1C1E"/>
                 </a:solidFill>
@@ -11846,8 +11881,8 @@
         </p:nvSpPr>
         <p:spPr>
           <a:xfrm>
-            <a:off x="777240" y="2286000"/>
-            <a:ext cx="1280160" cy="73152"/>
+            <a:off x="731520" y="2240280"/>
+            <a:ext cx="1234440" cy="64008"/>
           </a:xfrm>
           <a:prstGeom prst="rect">
             <a:avLst/>
@@ -11889,8 +11924,8 @@
         </p:nvSpPr>
         <p:spPr>
           <a:xfrm>
-            <a:off x="777240" y="2468880"/>
-            <a:ext cx="10058400" cy="365760"/>
+            <a:off x="731520" y="2423160"/>
+            <a:ext cx="10058400" cy="320040"/>
           </a:xfrm>
           <a:prstGeom prst="rect">
             <a:avLst/>
@@ -11905,7 +11940,7 @@
           <a:p>
             <a:pPr algn="l"/>
             <a:r>
-              <a:rPr sz="1400" b="1">
+              <a:rPr sz="1300" b="1">
                 <a:solidFill>
                   <a:srgbClr val="D6F26A"/>
                 </a:solidFill>
@@ -11924,8 +11959,8 @@
         </p:nvSpPr>
         <p:spPr>
           <a:xfrm>
-            <a:off x="777240" y="2926080"/>
-            <a:ext cx="10515600" cy="1097280"/>
+            <a:off x="731520" y="2880360"/>
+            <a:ext cx="10607040" cy="1097280"/>
           </a:xfrm>
           <a:prstGeom prst="rect">
             <a:avLst/>
@@ -11940,7 +11975,7 @@
           <a:p>
             <a:pPr algn="l"/>
             <a:r>
-              <a:rPr sz="3200" b="1">
+              <a:rPr sz="3000" b="1">
                 <a:solidFill>
                   <a:srgbClr val="FFFFFF"/>
                 </a:solidFill>
@@ -12021,7 +12056,7 @@
         <p:spPr>
           <a:xfrm>
             <a:off x="0" y="0"/>
-            <a:ext cx="12191695" cy="1097280"/>
+            <a:ext cx="12191695" cy="1051560"/>
           </a:xfrm>
           <a:prstGeom prst="rect">
             <a:avLst/>
@@ -12063,8 +12098,8 @@
         </p:nvSpPr>
         <p:spPr>
           <a:xfrm>
-            <a:off x="731520" y="292608"/>
-            <a:ext cx="10698480" cy="548640"/>
+            <a:off x="685800" y="274320"/>
+            <a:ext cx="10789920" cy="502920"/>
           </a:xfrm>
           <a:prstGeom prst="rect">
             <a:avLst/>
@@ -12079,7 +12114,7 @@
           <a:p>
             <a:pPr algn="l"/>
             <a:r>
-              <a:rPr sz="2400" b="1">
+              <a:rPr sz="2300" b="1">
                 <a:solidFill>
                   <a:srgbClr val="FFFFFF"/>
                 </a:solidFill>
@@ -12098,8 +12133,8 @@
         </p:nvSpPr>
         <p:spPr>
           <a:xfrm>
-            <a:off x="594360" y="1325880"/>
-            <a:ext cx="5349240" cy="4754880"/>
+            <a:off x="548640" y="1280160"/>
+            <a:ext cx="5394960" cy="4800600"/>
           </a:xfrm>
           <a:prstGeom prst="rect">
             <a:avLst/>
@@ -12141,8 +12176,8 @@
         </p:nvSpPr>
         <p:spPr>
           <a:xfrm>
-            <a:off x="868680" y="1554480"/>
-            <a:ext cx="777240" cy="73152"/>
+            <a:off x="822960" y="1508760"/>
+            <a:ext cx="731520" cy="64008"/>
           </a:xfrm>
           <a:prstGeom prst="rect">
             <a:avLst/>
@@ -12184,8 +12219,8 @@
         </p:nvSpPr>
         <p:spPr>
           <a:xfrm>
-            <a:off x="868680" y="1783080"/>
-            <a:ext cx="4754880" cy="365760"/>
+            <a:off x="822960" y="1737360"/>
+            <a:ext cx="4846320" cy="320040"/>
           </a:xfrm>
           <a:prstGeom prst="rect">
             <a:avLst/>
@@ -12200,7 +12235,7 @@
           <a:p>
             <a:pPr algn="l"/>
             <a:r>
-              <a:rPr sz="1700" b="1">
+              <a:rPr sz="1600" b="1">
                 <a:solidFill>
                   <a:srgbClr val="141618"/>
                 </a:solidFill>
@@ -12219,8 +12254,8 @@
         </p:nvSpPr>
         <p:spPr>
           <a:xfrm>
-            <a:off x="868680" y="2286000"/>
-            <a:ext cx="4754880" cy="3474720"/>
+            <a:off x="822960" y="2194560"/>
+            <a:ext cx="4846320" cy="3566160"/>
           </a:xfrm>
           <a:prstGeom prst="rect">
             <a:avLst/>
@@ -12235,11 +12270,11 @@
           <a:p>
             <a:pPr algn="l">
               <a:spcAft>
-                <a:spcPts val="800"/>
+                <a:spcPts val="700"/>
               </a:spcAft>
             </a:pPr>
             <a:r>
-              <a:rPr sz="1500" b="0">
+              <a:rPr sz="1400" b="0">
                 <a:solidFill>
                   <a:srgbClr val="1A1C1E"/>
                 </a:solidFill>
@@ -12251,11 +12286,11 @@
           <a:p>
             <a:pPr algn="l">
               <a:spcAft>
-                <a:spcPts val="800"/>
+                <a:spcPts val="700"/>
               </a:spcAft>
             </a:pPr>
             <a:r>
-              <a:rPr sz="1500" b="0">
+              <a:rPr sz="1400" b="0">
                 <a:solidFill>
                   <a:srgbClr val="1A1C1E"/>
                 </a:solidFill>
@@ -12267,11 +12302,11 @@
           <a:p>
             <a:pPr algn="l">
               <a:spcAft>
-                <a:spcPts val="800"/>
+                <a:spcPts val="700"/>
               </a:spcAft>
             </a:pPr>
             <a:r>
-              <a:rPr sz="1500" b="0">
+              <a:rPr sz="1400" b="0">
                 <a:solidFill>
                   <a:srgbClr val="1A1C1E"/>
                 </a:solidFill>
@@ -12283,11 +12318,11 @@
           <a:p>
             <a:pPr algn="l">
               <a:spcAft>
-                <a:spcPts val="800"/>
+                <a:spcPts val="700"/>
               </a:spcAft>
             </a:pPr>
             <a:r>
-              <a:rPr sz="1500" b="0">
+              <a:rPr sz="1400" b="0">
                 <a:solidFill>
                   <a:srgbClr val="1A1C1E"/>
                 </a:solidFill>
@@ -12299,11 +12334,11 @@
           <a:p>
             <a:pPr algn="l">
               <a:spcAft>
-                <a:spcPts val="800"/>
+                <a:spcPts val="700"/>
               </a:spcAft>
             </a:pPr>
             <a:r>
-              <a:rPr sz="1500" b="0">
+              <a:rPr sz="1400" b="0">
                 <a:solidFill>
                   <a:srgbClr val="1A1C1E"/>
                 </a:solidFill>
@@ -12322,8 +12357,8 @@
         </p:nvSpPr>
         <p:spPr>
           <a:xfrm>
-            <a:off x="6217920" y="1325880"/>
-            <a:ext cx="5349240" cy="4754880"/>
+            <a:off x="6172200" y="1280160"/>
+            <a:ext cx="5394960" cy="4800600"/>
           </a:xfrm>
           <a:prstGeom prst="rect">
             <a:avLst/>
@@ -12365,8 +12400,8 @@
         </p:nvSpPr>
         <p:spPr>
           <a:xfrm>
-            <a:off x="6492240" y="1554480"/>
-            <a:ext cx="777240" cy="73152"/>
+            <a:off x="6446520" y="1508760"/>
+            <a:ext cx="731520" cy="64008"/>
           </a:xfrm>
           <a:prstGeom prst="rect">
             <a:avLst/>
@@ -12408,8 +12443,8 @@
         </p:nvSpPr>
         <p:spPr>
           <a:xfrm>
-            <a:off x="6492240" y="1783080"/>
-            <a:ext cx="4754880" cy="365760"/>
+            <a:off x="6446520" y="1737360"/>
+            <a:ext cx="4846320" cy="320040"/>
           </a:xfrm>
           <a:prstGeom prst="rect">
             <a:avLst/>
@@ -12424,7 +12459,7 @@
           <a:p>
             <a:pPr algn="l"/>
             <a:r>
-              <a:rPr sz="1700" b="1">
+              <a:rPr sz="1600" b="1">
                 <a:solidFill>
                   <a:srgbClr val="141618"/>
                 </a:solidFill>
@@ -12443,8 +12478,8 @@
         </p:nvSpPr>
         <p:spPr>
           <a:xfrm>
-            <a:off x="6492240" y="2286000"/>
-            <a:ext cx="4754880" cy="3474720"/>
+            <a:off x="6446520" y="2194560"/>
+            <a:ext cx="4846320" cy="3566160"/>
           </a:xfrm>
           <a:prstGeom prst="rect">
             <a:avLst/>
@@ -12459,11 +12494,11 @@
           <a:p>
             <a:pPr algn="l">
               <a:spcAft>
-                <a:spcPts val="800"/>
+                <a:spcPts val="700"/>
               </a:spcAft>
             </a:pPr>
             <a:r>
-              <a:rPr sz="1500" b="0">
+              <a:rPr sz="1400" b="0">
                 <a:solidFill>
                   <a:srgbClr val="1A1C1E"/>
                 </a:solidFill>
@@ -12475,11 +12510,11 @@
           <a:p>
             <a:pPr algn="l">
               <a:spcAft>
-                <a:spcPts val="800"/>
+                <a:spcPts val="700"/>
               </a:spcAft>
             </a:pPr>
             <a:r>
-              <a:rPr sz="1500" b="0">
+              <a:rPr sz="1400" b="0">
                 <a:solidFill>
                   <a:srgbClr val="1A1C1E"/>
                 </a:solidFill>
@@ -12491,11 +12526,11 @@
           <a:p>
             <a:pPr algn="l">
               <a:spcAft>
-                <a:spcPts val="800"/>
+                <a:spcPts val="700"/>
               </a:spcAft>
             </a:pPr>
             <a:r>
-              <a:rPr sz="1500" b="0">
+              <a:rPr sz="1400" b="0">
                 <a:solidFill>
                   <a:srgbClr val="1A1C1E"/>
                 </a:solidFill>
@@ -12507,11 +12542,11 @@
           <a:p>
             <a:pPr algn="l">
               <a:spcAft>
-                <a:spcPts val="800"/>
+                <a:spcPts val="700"/>
               </a:spcAft>
             </a:pPr>
             <a:r>
-              <a:rPr sz="1500" b="0">
+              <a:rPr sz="1400" b="0">
                 <a:solidFill>
                   <a:srgbClr val="1A1C1E"/>
                 </a:solidFill>
@@ -12523,11 +12558,11 @@
           <a:p>
             <a:pPr algn="l">
               <a:spcAft>
-                <a:spcPts val="800"/>
+                <a:spcPts val="700"/>
               </a:spcAft>
             </a:pPr>
             <a:r>
-              <a:rPr sz="1500" b="0">
+              <a:rPr sz="1400" b="0">
                 <a:solidFill>
                   <a:srgbClr val="1A1C1E"/>
                 </a:solidFill>
@@ -12608,7 +12643,7 @@
         <p:spPr>
           <a:xfrm>
             <a:off x="0" y="0"/>
-            <a:ext cx="12191695" cy="1097280"/>
+            <a:ext cx="12191695" cy="1051560"/>
           </a:xfrm>
           <a:prstGeom prst="rect">
             <a:avLst/>
@@ -12650,8 +12685,8 @@
         </p:nvSpPr>
         <p:spPr>
           <a:xfrm>
-            <a:off x="731520" y="292608"/>
-            <a:ext cx="10698480" cy="548640"/>
+            <a:off x="685800" y="274320"/>
+            <a:ext cx="10789920" cy="502920"/>
           </a:xfrm>
           <a:prstGeom prst="rect">
             <a:avLst/>
@@ -12666,7 +12701,7 @@
           <a:p>
             <a:pPr algn="l"/>
             <a:r>
-              <a:rPr sz="2400" b="1">
+              <a:rPr sz="2300" b="1">
                 <a:solidFill>
                   <a:srgbClr val="FFFFFF"/>
                 </a:solidFill>
@@ -12685,8 +12720,8 @@
         </p:nvSpPr>
         <p:spPr>
           <a:xfrm>
-            <a:off x="777240" y="1417320"/>
-            <a:ext cx="10515600" cy="4572000"/>
+            <a:off x="731520" y="1371600"/>
+            <a:ext cx="10607040" cy="4663440"/>
           </a:xfrm>
           <a:prstGeom prst="rect">
             <a:avLst/>
@@ -12701,11 +12736,11 @@
           <a:p>
             <a:pPr algn="l">
               <a:spcAft>
-                <a:spcPts val="1200"/>
+                <a:spcPts val="1100"/>
               </a:spcAft>
             </a:pPr>
             <a:r>
-              <a:rPr sz="1800" b="0">
+              <a:rPr sz="1700" b="0">
                 <a:solidFill>
                   <a:srgbClr val="1A1C1E"/>
                 </a:solidFill>
@@ -12717,11 +12752,11 @@
           <a:p>
             <a:pPr algn="l">
               <a:spcAft>
-                <a:spcPts val="1200"/>
+                <a:spcPts val="1100"/>
               </a:spcAft>
             </a:pPr>
             <a:r>
-              <a:rPr sz="1800" b="0">
+              <a:rPr sz="1700" b="0">
                 <a:solidFill>
                   <a:srgbClr val="1A1C1E"/>
                 </a:solidFill>
@@ -12733,11 +12768,11 @@
           <a:p>
             <a:pPr algn="l">
               <a:spcAft>
-                <a:spcPts val="1200"/>
+                <a:spcPts val="1100"/>
               </a:spcAft>
             </a:pPr>
             <a:r>
-              <a:rPr sz="1800" b="0">
+              <a:rPr sz="1700" b="0">
                 <a:solidFill>
                   <a:srgbClr val="1A1C1E"/>
                 </a:solidFill>
@@ -12749,11 +12784,11 @@
           <a:p>
             <a:pPr algn="l">
               <a:spcAft>
-                <a:spcPts val="1200"/>
+                <a:spcPts val="1100"/>
               </a:spcAft>
             </a:pPr>
             <a:r>
-              <a:rPr sz="1800" b="0">
+              <a:rPr sz="1700" b="0">
                 <a:solidFill>
                   <a:srgbClr val="1A1C1E"/>
                 </a:solidFill>
@@ -12765,11 +12800,11 @@
           <a:p>
             <a:pPr algn="l">
               <a:spcAft>
-                <a:spcPts val="1200"/>
+                <a:spcPts val="1100"/>
               </a:spcAft>
             </a:pPr>
             <a:r>
-              <a:rPr sz="1800" b="0">
+              <a:rPr sz="1700" b="0">
                 <a:solidFill>
                   <a:srgbClr val="1A1C1E"/>
                 </a:solidFill>
@@ -12781,11 +12816,11 @@
           <a:p>
             <a:pPr algn="l">
               <a:spcAft>
-                <a:spcPts val="1200"/>
+                <a:spcPts val="1100"/>
               </a:spcAft>
             </a:pPr>
             <a:r>
-              <a:rPr sz="1800" b="0">
+              <a:rPr sz="1700" b="0">
                 <a:solidFill>
                   <a:srgbClr val="1A1C1E"/>
                 </a:solidFill>
@@ -12866,7 +12901,7 @@
         <p:spPr>
           <a:xfrm>
             <a:off x="0" y="0"/>
-            <a:ext cx="12191695" cy="1097280"/>
+            <a:ext cx="12191695" cy="1051560"/>
           </a:xfrm>
           <a:prstGeom prst="rect">
             <a:avLst/>
@@ -12908,8 +12943,8 @@
         </p:nvSpPr>
         <p:spPr>
           <a:xfrm>
-            <a:off x="731520" y="292608"/>
-            <a:ext cx="10698480" cy="548640"/>
+            <a:off x="685800" y="274320"/>
+            <a:ext cx="10789920" cy="502920"/>
           </a:xfrm>
           <a:prstGeom prst="rect">
             <a:avLst/>
@@ -12924,13 +12959,13 @@
           <a:p>
             <a:pPr algn="l"/>
             <a:r>
-              <a:rPr sz="2400" b="1">
+              <a:rPr sz="2300" b="1">
                 <a:solidFill>
                   <a:srgbClr val="FFFFFF"/>
                 </a:solidFill>
                 <a:latin typeface="Georgia"/>
               </a:rPr>
-              <a:t>Where the next gains come from (quality compounding)</a:t>
+              <a:t>Where gains live — quality + the review/production bottleneck</a:t>
             </a:r>
           </a:p>
         </p:txBody>
@@ -12943,8 +12978,8 @@
         </p:nvSpPr>
         <p:spPr>
           <a:xfrm>
-            <a:off x="777240" y="1417320"/>
-            <a:ext cx="10515600" cy="4572000"/>
+            <a:off x="731520" y="1325880"/>
+            <a:ext cx="5760720" cy="3474720"/>
           </a:xfrm>
           <a:prstGeom prst="rect">
             <a:avLst/>
@@ -12963,13 +12998,13 @@
               </a:spcAft>
             </a:pPr>
             <a:r>
-              <a:rPr sz="1800" b="0">
+              <a:rPr sz="1600" b="0">
                 <a:solidFill>
                   <a:srgbClr val="1A1C1E"/>
                 </a:solidFill>
                 <a:latin typeface="Calibri"/>
               </a:rPr>
-              <a:t>•  Conversation quality — relevance speed + correct wedge for the buyer signal</a:t>
+              <a:t>•  Conversation quality — relevance speed + correct wedge</a:t>
             </a:r>
           </a:p>
           <a:p>
@@ -12979,7 +13014,7 @@
               </a:spcAft>
             </a:pPr>
             <a:r>
-              <a:rPr sz="1800" b="0">
+              <a:rPr sz="1600" b="0">
                 <a:solidFill>
                   <a:srgbClr val="1A1C1E"/>
                 </a:solidFill>
@@ -12995,13 +13030,13 @@
               </a:spcAft>
             </a:pPr>
             <a:r>
-              <a:rPr sz="1800" b="0">
+              <a:rPr sz="1600" b="0">
                 <a:solidFill>
                   <a:srgbClr val="1A1C1E"/>
                 </a:solidFill>
                 <a:latin typeface="Calibri"/>
               </a:rPr>
-              <a:t>•  Competitive fluency — clean Copilot / Claude Code / Windsurf frames (no trash talk)</a:t>
+              <a:t>•  Competitive fluency — Copilot / Claude Code / Windsurf frames</a:t>
             </a:r>
           </a:p>
           <a:p>
@@ -13011,29 +13046,171 @@
               </a:spcAft>
             </a:pPr>
             <a:r>
-              <a:rPr sz="1800" b="0">
+              <a:rPr sz="1600" b="0">
                 <a:solidFill>
                   <a:srgbClr val="1A1C1E"/>
                 </a:solidFill>
                 <a:latin typeface="Calibri"/>
               </a:rPr>
-              <a:t>•  Earlier multi-threading — Platform + Security on enterprise / regulated accounts</a:t>
-            </a:r>
-          </a:p>
-          <a:p>
-            <a:pPr algn="l">
-              <a:spcAft>
-                <a:spcPts val="1200"/>
-              </a:spcAft>
-            </a:pPr>
-            <a:r>
-              <a:rPr sz="1800" b="0">
-                <a:solidFill>
-                  <a:srgbClr val="1A1C1E"/>
+              <a:t>•  Earlier multi-threading — Platform + Security on enterprise accounts</a:t>
+            </a:r>
+          </a:p>
+        </p:txBody>
+      </p:sp>
+      <p:sp>
+        <p:nvSpPr>
+          <p:cNvPr id="6" name="Rectangle 5"/>
+          <p:cNvSpPr/>
+          <p:nvPr/>
+        </p:nvSpPr>
+        <p:spPr>
+          <a:xfrm>
+            <a:off x="6675120" y="1325880"/>
+            <a:ext cx="4846320" cy="4114800"/>
+          </a:xfrm>
+          <a:prstGeom prst="rect">
+            <a:avLst/>
+          </a:prstGeom>
+          <a:solidFill>
+            <a:srgbClr val="FFFFFF"/>
+          </a:solidFill>
+          <a:ln>
+            <a:noFill/>
+          </a:ln>
+        </p:spPr>
+        <p:style>
+          <a:lnRef idx="1">
+            <a:schemeClr val="accent1"/>
+          </a:lnRef>
+          <a:fillRef idx="3">
+            <a:schemeClr val="accent1"/>
+          </a:fillRef>
+          <a:effectRef idx="2">
+            <a:schemeClr val="accent1"/>
+          </a:effectRef>
+          <a:fontRef idx="minor">
+            <a:schemeClr val="lt1"/>
+          </a:fontRef>
+        </p:style>
+        <p:txBody>
+          <a:bodyPr rtlCol="0" anchor="ctr"/>
+          <a:lstStyle/>
+          <a:p>
+            <a:pPr algn="ctr"/>
+          </a:p>
+        </p:txBody>
+      </p:sp>
+      <p:sp>
+        <p:nvSpPr>
+          <p:cNvPr id="7" name="Rectangle 6"/>
+          <p:cNvSpPr/>
+          <p:nvPr/>
+        </p:nvSpPr>
+        <p:spPr>
+          <a:xfrm>
+            <a:off x="6903720" y="1554480"/>
+            <a:ext cx="731520" cy="64008"/>
+          </a:xfrm>
+          <a:prstGeom prst="rect">
+            <a:avLst/>
+          </a:prstGeom>
+          <a:solidFill>
+            <a:srgbClr val="D6F26A"/>
+          </a:solidFill>
+          <a:ln>
+            <a:noFill/>
+          </a:ln>
+        </p:spPr>
+        <p:style>
+          <a:lnRef idx="1">
+            <a:schemeClr val="accent1"/>
+          </a:lnRef>
+          <a:fillRef idx="3">
+            <a:schemeClr val="accent1"/>
+          </a:fillRef>
+          <a:effectRef idx="2">
+            <a:schemeClr val="accent1"/>
+          </a:effectRef>
+          <a:fontRef idx="minor">
+            <a:schemeClr val="lt1"/>
+          </a:fontRef>
+        </p:style>
+        <p:txBody>
+          <a:bodyPr rtlCol="0" anchor="ctr"/>
+          <a:lstStyle/>
+          <a:p>
+            <a:pPr algn="ctr"/>
+          </a:p>
+        </p:txBody>
+      </p:sp>
+      <p:sp>
+        <p:nvSpPr>
+          <p:cNvPr id="8" name="TextBox 7"/>
+          <p:cNvSpPr txBox="1"/>
+          <p:nvPr/>
+        </p:nvSpPr>
+        <p:spPr>
+          <a:xfrm>
+            <a:off x="6903720" y="1783080"/>
+            <a:ext cx="4389120" cy="320040"/>
+          </a:xfrm>
+          <a:prstGeom prst="rect">
+            <a:avLst/>
+          </a:prstGeom>
+          <a:noFill/>
+        </p:spPr>
+        <p:txBody>
+          <a:bodyPr wrap="square" anchor="t">
+            <a:spAutoFit/>
+          </a:bodyPr>
+          <a:lstStyle/>
+          <a:p>
+            <a:pPr algn="l"/>
+            <a:r>
+              <a:rPr sz="1500" b="1">
+                <a:solidFill>
+                  <a:srgbClr val="141618"/>
+                </a:solidFill>
+                <a:latin typeface="Georgia"/>
+              </a:rPr>
+              <a:t>Software factory insight</a:t>
+            </a:r>
+          </a:p>
+        </p:txBody>
+      </p:sp>
+      <p:sp>
+        <p:nvSpPr>
+          <p:cNvPr id="9" name="TextBox 8"/>
+          <p:cNvSpPr txBox="1"/>
+          <p:nvPr/>
+        </p:nvSpPr>
+        <p:spPr>
+          <a:xfrm>
+            <a:off x="6903720" y="2240280"/>
+            <a:ext cx="4389120" cy="2926080"/>
+          </a:xfrm>
+          <a:prstGeom prst="rect">
+            <a:avLst/>
+          </a:prstGeom>
+          <a:noFill/>
+        </p:spPr>
+        <p:txBody>
+          <a:bodyPr wrap="square" anchor="t">
+            <a:spAutoFit/>
+          </a:bodyPr>
+          <a:lstStyle/>
+          <a:p>
+            <a:pPr algn="l"/>
+            <a:r>
+              <a:rPr sz="1300" b="0">
+                <a:solidFill>
+                  <a:srgbClr val="5E646B"/>
                 </a:solidFill>
                 <a:latin typeface="Calibri"/>
               </a:rPr>
-              <a:t>•  Validate with diagnosis data before scaling changes</a:t>
+              <a:t>AI tools speed writing → bottleneck shifts to review &amp; production.
+Cursor helps by automating across the lifecycle — Bugbot / Agent Review, background agents, Composer efficiency — so teams ship outcomes, not just more PRs.
+Assisted → Agentic → Cloud agents → Governed factory.</a:t>
             </a:r>
           </a:p>
         </p:txBody>
@@ -13108,7 +13285,7 @@
         <p:spPr>
           <a:xfrm>
             <a:off x="0" y="0"/>
-            <a:ext cx="12191695" cy="1097280"/>
+            <a:ext cx="12191695" cy="1051560"/>
           </a:xfrm>
           <a:prstGeom prst="rect">
             <a:avLst/>
@@ -13150,8 +13327,8 @@
         </p:nvSpPr>
         <p:spPr>
           <a:xfrm>
-            <a:off x="731520" y="292608"/>
-            <a:ext cx="10698480" cy="548640"/>
+            <a:off x="685800" y="274320"/>
+            <a:ext cx="10789920" cy="502920"/>
           </a:xfrm>
           <a:prstGeom prst="rect">
             <a:avLst/>
@@ -13166,13 +13343,13 @@
           <a:p>
             <a:pPr algn="l"/>
             <a:r>
-              <a:rPr sz="2400" b="1">
+              <a:rPr sz="2300" b="1">
                 <a:solidFill>
                   <a:srgbClr val="FFFFFF"/>
                 </a:solidFill>
                 <a:latin typeface="Georgia"/>
               </a:rPr>
-              <a:t>Market context — agentic coding is a two-layer race</a:t>
+              <a:t>Competitor differentiation — market map</a:t>
             </a:r>
           </a:p>
         </p:txBody>
@@ -13185,8 +13362,8 @@
         </p:nvSpPr>
         <p:spPr>
           <a:xfrm>
-            <a:off x="594360" y="1325880"/>
-            <a:ext cx="5349240" cy="3063240"/>
+            <a:off x="548640" y="1234440"/>
+            <a:ext cx="5394960" cy="1417320"/>
           </a:xfrm>
           <a:prstGeom prst="rect">
             <a:avLst/>
@@ -13222,14 +13399,242 @@
       </p:sp>
       <p:sp>
         <p:nvSpPr>
-          <p:cNvPr id="6" name="Rectangle 5"/>
+          <p:cNvPr id="6" name="TextBox 5"/>
+          <p:cNvSpPr txBox="1"/>
+          <p:nvPr/>
+        </p:nvSpPr>
+        <p:spPr>
+          <a:xfrm>
+            <a:off x="731520" y="1325880"/>
+            <a:ext cx="5029200" cy="274320"/>
+          </a:xfrm>
+          <a:prstGeom prst="rect">
+            <a:avLst/>
+          </a:prstGeom>
+          <a:noFill/>
+        </p:spPr>
+        <p:txBody>
+          <a:bodyPr wrap="square" anchor="t">
+            <a:spAutoFit/>
+          </a:bodyPr>
+          <a:lstStyle/>
+          <a:p>
+            <a:pPr algn="l"/>
+            <a:r>
+              <a:rPr sz="1400" b="1">
+                <a:solidFill>
+                  <a:srgbClr val="141618"/>
+                </a:solidFill>
+                <a:latin typeface="Georgia"/>
+              </a:rPr>
+              <a:t>AI-native IDE</a:t>
+            </a:r>
+          </a:p>
+        </p:txBody>
+      </p:sp>
+      <p:sp>
+        <p:nvSpPr>
+          <p:cNvPr id="7" name="TextBox 6"/>
+          <p:cNvSpPr txBox="1"/>
+          <p:nvPr/>
+        </p:nvSpPr>
+        <p:spPr>
+          <a:xfrm>
+            <a:off x="731520" y="1645920"/>
+            <a:ext cx="5029200" cy="822960"/>
+          </a:xfrm>
+          <a:prstGeom prst="rect">
+            <a:avLst/>
+          </a:prstGeom>
+          <a:noFill/>
+        </p:spPr>
+        <p:txBody>
+          <a:bodyPr wrap="square" anchor="t">
+            <a:spAutoFit/>
+          </a:bodyPr>
+          <a:lstStyle/>
+          <a:p>
+            <a:pPr algn="l"/>
+            <a:r>
+              <a:rPr sz="1300" b="0">
+                <a:solidFill>
+                  <a:srgbClr val="5E646B"/>
+                </a:solidFill>
+                <a:latin typeface="Calibri"/>
+              </a:rPr>
+              <a:t>Cursor · Windsurf
+Rebuild the editor around agents — not bolt AI onto an existing one.</a:t>
+            </a:r>
+          </a:p>
+        </p:txBody>
+      </p:sp>
+      <p:sp>
+        <p:nvSpPr>
+          <p:cNvPr id="8" name="Rectangle 7"/>
           <p:cNvSpPr/>
           <p:nvPr/>
         </p:nvSpPr>
         <p:spPr>
           <a:xfrm>
-            <a:off x="594360" y="1325880"/>
-            <a:ext cx="5349240" cy="457200"/>
+            <a:off x="6172200" y="1234440"/>
+            <a:ext cx="5394960" cy="1417320"/>
+          </a:xfrm>
+          <a:prstGeom prst="rect">
+            <a:avLst/>
+          </a:prstGeom>
+          <a:solidFill>
+            <a:srgbClr val="FFFFFF"/>
+          </a:solidFill>
+          <a:ln>
+            <a:noFill/>
+          </a:ln>
+        </p:spPr>
+        <p:style>
+          <a:lnRef idx="1">
+            <a:schemeClr val="accent1"/>
+          </a:lnRef>
+          <a:fillRef idx="3">
+            <a:schemeClr val="accent1"/>
+          </a:fillRef>
+          <a:effectRef idx="2">
+            <a:schemeClr val="accent1"/>
+          </a:effectRef>
+          <a:fontRef idx="minor">
+            <a:schemeClr val="lt1"/>
+          </a:fontRef>
+        </p:style>
+        <p:txBody>
+          <a:bodyPr rtlCol="0" anchor="ctr"/>
+          <a:lstStyle/>
+          <a:p>
+            <a:pPr algn="ctr"/>
+          </a:p>
+        </p:txBody>
+      </p:sp>
+      <p:sp>
+        <p:nvSpPr>
+          <p:cNvPr id="9" name="TextBox 8"/>
+          <p:cNvSpPr txBox="1"/>
+          <p:nvPr/>
+        </p:nvSpPr>
+        <p:spPr>
+          <a:xfrm>
+            <a:off x="6355080" y="1325880"/>
+            <a:ext cx="5029200" cy="274320"/>
+          </a:xfrm>
+          <a:prstGeom prst="rect">
+            <a:avLst/>
+          </a:prstGeom>
+          <a:noFill/>
+        </p:spPr>
+        <p:txBody>
+          <a:bodyPr wrap="square" anchor="t">
+            <a:spAutoFit/>
+          </a:bodyPr>
+          <a:lstStyle/>
+          <a:p>
+            <a:pPr algn="l"/>
+            <a:r>
+              <a:rPr sz="1400" b="1">
+                <a:solidFill>
+                  <a:srgbClr val="141618"/>
+                </a:solidFill>
+                <a:latin typeface="Georgia"/>
+              </a:rPr>
+              <a:t>IDE plugin / extension</a:t>
+            </a:r>
+          </a:p>
+        </p:txBody>
+      </p:sp>
+      <p:sp>
+        <p:nvSpPr>
+          <p:cNvPr id="10" name="TextBox 9"/>
+          <p:cNvSpPr txBox="1"/>
+          <p:nvPr/>
+        </p:nvSpPr>
+        <p:spPr>
+          <a:xfrm>
+            <a:off x="6355080" y="1645920"/>
+            <a:ext cx="5029200" cy="822960"/>
+          </a:xfrm>
+          <a:prstGeom prst="rect">
+            <a:avLst/>
+          </a:prstGeom>
+          <a:noFill/>
+        </p:spPr>
+        <p:txBody>
+          <a:bodyPr wrap="square" anchor="t">
+            <a:spAutoFit/>
+          </a:bodyPr>
+          <a:lstStyle/>
+          <a:p>
+            <a:pPr algn="l"/>
+            <a:r>
+              <a:rPr sz="1300" b="0">
+                <a:solidFill>
+                  <a:srgbClr val="5E646B"/>
+                </a:solidFill>
+                <a:latin typeface="Calibri"/>
+              </a:rPr>
+              <a:t>GitHub Copilot · JetBrains AI · Amazon Q
+Keep the current toolchain; add AI as a layer.</a:t>
+            </a:r>
+          </a:p>
+        </p:txBody>
+      </p:sp>
+      <p:sp>
+        <p:nvSpPr>
+          <p:cNvPr id="11" name="Rectangle 10"/>
+          <p:cNvSpPr/>
+          <p:nvPr/>
+        </p:nvSpPr>
+        <p:spPr>
+          <a:xfrm>
+            <a:off x="548640" y="2834640"/>
+            <a:ext cx="5394960" cy="2148840"/>
+          </a:xfrm>
+          <a:prstGeom prst="rect">
+            <a:avLst/>
+          </a:prstGeom>
+          <a:solidFill>
+            <a:srgbClr val="FFFFFF"/>
+          </a:solidFill>
+          <a:ln>
+            <a:noFill/>
+          </a:ln>
+        </p:spPr>
+        <p:style>
+          <a:lnRef idx="1">
+            <a:schemeClr val="accent1"/>
+          </a:lnRef>
+          <a:fillRef idx="3">
+            <a:schemeClr val="accent1"/>
+          </a:fillRef>
+          <a:effectRef idx="2">
+            <a:schemeClr val="accent1"/>
+          </a:effectRef>
+          <a:fontRef idx="minor">
+            <a:schemeClr val="lt1"/>
+          </a:fontRef>
+        </p:style>
+        <p:txBody>
+          <a:bodyPr rtlCol="0" anchor="ctr"/>
+          <a:lstStyle/>
+          <a:p>
+            <a:pPr algn="ctr"/>
+          </a:p>
+        </p:txBody>
+      </p:sp>
+      <p:sp>
+        <p:nvSpPr>
+          <p:cNvPr id="12" name="Rectangle 11"/>
+          <p:cNvSpPr/>
+          <p:nvPr/>
+        </p:nvSpPr>
+        <p:spPr>
+          <a:xfrm>
+            <a:off x="548640" y="2834640"/>
+            <a:ext cx="5394960" cy="384048"/>
           </a:xfrm>
           <a:prstGeom prst="rect">
             <a:avLst/>
@@ -13265,14 +13670,14 @@
       </p:sp>
       <p:sp>
         <p:nvSpPr>
-          <p:cNvPr id="7" name="TextBox 6"/>
+          <p:cNvPr id="13" name="TextBox 12"/>
           <p:cNvSpPr txBox="1"/>
           <p:nvPr/>
         </p:nvSpPr>
         <p:spPr>
           <a:xfrm>
-            <a:off x="822960" y="1389888"/>
-            <a:ext cx="4846320" cy="365760"/>
+            <a:off x="731520" y="2880360"/>
+            <a:ext cx="5029200" cy="320040"/>
           </a:xfrm>
           <a:prstGeom prst="rect">
             <a:avLst/>
@@ -13287,11 +13692,11 @@
           <a:p>
             <a:pPr algn="l"/>
             <a:r>
-              <a:rPr sz="1500" b="1">
+              <a:rPr sz="1300" b="1">
                 <a:solidFill>
                   <a:srgbClr val="D6F26A"/>
                 </a:solidFill>
-                <a:latin typeface="Georgia"/>
+                <a:latin typeface="Calibri"/>
               </a:rPr>
               <a:t>Layer 1 — Harness / product</a:t>
             </a:r>
@@ -13300,14 +13705,14 @@
       </p:sp>
       <p:sp>
         <p:nvSpPr>
-          <p:cNvPr id="8" name="TextBox 7"/>
+          <p:cNvPr id="14" name="TextBox 13"/>
           <p:cNvSpPr txBox="1"/>
           <p:nvPr/>
         </p:nvSpPr>
         <p:spPr>
           <a:xfrm>
-            <a:off x="822960" y="1965960"/>
-            <a:ext cx="4846320" cy="2194560"/>
+            <a:off x="731520" y="3383280"/>
+            <a:ext cx="5029200" cy="1417320"/>
           </a:xfrm>
           <a:prstGeom prst="rect">
             <a:avLst/>
@@ -13322,43 +13727,43 @@
           <a:p>
             <a:pPr algn="l">
               <a:spcAft>
-                <a:spcPts val="700"/>
+                <a:spcPts val="500"/>
               </a:spcAft>
             </a:pPr>
             <a:r>
-              <a:rPr sz="1400" b="0">
+              <a:rPr sz="1300" b="0">
                 <a:solidFill>
                   <a:srgbClr val="1A1C1E"/>
                 </a:solidFill>
                 <a:latin typeface="Calibri"/>
               </a:rPr>
-              <a:t>•  Plans, tools, repo navigation, developer workflow</a:t>
+              <a:t>•  Plans, tools, repo navigation, workflow fit</a:t>
             </a:r>
           </a:p>
           <a:p>
             <a:pPr algn="l">
               <a:spcAft>
-                <a:spcPts val="700"/>
+                <a:spcPts val="500"/>
               </a:spcAft>
             </a:pPr>
             <a:r>
-              <a:rPr sz="1400" b="0">
+              <a:rPr sz="1300" b="0">
                 <a:solidFill>
                   <a:srgbClr val="1A1C1E"/>
                 </a:solidFill>
                 <a:latin typeface="Calibri"/>
               </a:rPr>
-              <a:t>•  What buyers feel in the first conversation</a:t>
+              <a:t>•  What buyers feel in first conversations</a:t>
             </a:r>
           </a:p>
           <a:p>
             <a:pPr algn="l">
               <a:spcAft>
-                <a:spcPts val="700"/>
+                <a:spcPts val="500"/>
               </a:spcAft>
             </a:pPr>
             <a:r>
-              <a:rPr sz="1400" b="0">
+              <a:rPr sz="1300" b="0">
                 <a:solidFill>
                   <a:srgbClr val="1A1C1E"/>
                 </a:solidFill>
@@ -13367,34 +13772,18 @@
               <a:t>•  Cursor’s established commercial strength</a:t>
             </a:r>
           </a:p>
-          <a:p>
-            <a:pPr algn="l">
-              <a:spcAft>
-                <a:spcPts val="700"/>
-              </a:spcAft>
-            </a:pPr>
-            <a:r>
-              <a:rPr sz="1400" b="0">
-                <a:solidFill>
-                  <a:srgbClr val="1A1C1E"/>
-                </a:solidFill>
-                <a:latin typeface="Calibri"/>
-              </a:rPr>
-              <a:t>•  Sell the system they can feel today</a:t>
-            </a:r>
-          </a:p>
-        </p:txBody>
-      </p:sp>
-      <p:sp>
-        <p:nvSpPr>
-          <p:cNvPr id="9" name="Rectangle 8"/>
+        </p:txBody>
+      </p:sp>
+      <p:sp>
+        <p:nvSpPr>
+          <p:cNvPr id="15" name="Rectangle 14"/>
           <p:cNvSpPr/>
           <p:nvPr/>
         </p:nvSpPr>
         <p:spPr>
           <a:xfrm>
-            <a:off x="6217920" y="1325880"/>
-            <a:ext cx="5349240" cy="3063240"/>
+            <a:off x="6172200" y="2834640"/>
+            <a:ext cx="5394960" cy="2148840"/>
           </a:xfrm>
           <a:prstGeom prst="rect">
             <a:avLst/>
@@ -13430,14 +13819,14 @@
       </p:sp>
       <p:sp>
         <p:nvSpPr>
-          <p:cNvPr id="10" name="Rectangle 9"/>
+          <p:cNvPr id="16" name="Rectangle 15"/>
           <p:cNvSpPr/>
           <p:nvPr/>
         </p:nvSpPr>
         <p:spPr>
           <a:xfrm>
-            <a:off x="6217920" y="1325880"/>
-            <a:ext cx="5349240" cy="457200"/>
+            <a:off x="6172200" y="2834640"/>
+            <a:ext cx="5394960" cy="384048"/>
           </a:xfrm>
           <a:prstGeom prst="rect">
             <a:avLst/>
@@ -13473,14 +13862,14 @@
       </p:sp>
       <p:sp>
         <p:nvSpPr>
-          <p:cNvPr id="11" name="TextBox 10"/>
+          <p:cNvPr id="17" name="TextBox 16"/>
           <p:cNvSpPr txBox="1"/>
           <p:nvPr/>
         </p:nvSpPr>
         <p:spPr>
           <a:xfrm>
-            <a:off x="6446520" y="1389888"/>
-            <a:ext cx="4846320" cy="365760"/>
+            <a:off x="6355080" y="2880360"/>
+            <a:ext cx="5029200" cy="320040"/>
           </a:xfrm>
           <a:prstGeom prst="rect">
             <a:avLst/>
@@ -13495,11 +13884,11 @@
           <a:p>
             <a:pPr algn="l"/>
             <a:r>
-              <a:rPr sz="1500" b="1">
+              <a:rPr sz="1300" b="1">
                 <a:solidFill>
                   <a:srgbClr val="FFFFFF"/>
                 </a:solidFill>
-                <a:latin typeface="Georgia"/>
+                <a:latin typeface="Calibri"/>
               </a:rPr>
               <a:t>Layer 2 — Model</a:t>
             </a:r>
@@ -13508,14 +13897,14 @@
       </p:sp>
       <p:sp>
         <p:nvSpPr>
-          <p:cNvPr id="12" name="TextBox 11"/>
+          <p:cNvPr id="18" name="TextBox 17"/>
           <p:cNvSpPr txBox="1"/>
           <p:nvPr/>
         </p:nvSpPr>
         <p:spPr>
           <a:xfrm>
-            <a:off x="6446520" y="1965960"/>
-            <a:ext cx="4846320" cy="2194560"/>
+            <a:off x="6355080" y="3383280"/>
+            <a:ext cx="5029200" cy="1417320"/>
           </a:xfrm>
           <a:prstGeom prst="rect">
             <a:avLst/>
@@ -13530,11 +13919,11 @@
           <a:p>
             <a:pPr algn="l">
               <a:spcAft>
-                <a:spcPts val="700"/>
+                <a:spcPts val="500"/>
               </a:spcAft>
             </a:pPr>
             <a:r>
-              <a:rPr sz="1400" b="0">
+              <a:rPr sz="1300" b="0">
                 <a:solidFill>
                   <a:srgbClr val="1A1C1E"/>
                 </a:solidFill>
@@ -13546,63 +13935,47 @@
           <a:p>
             <a:pPr algn="l">
               <a:spcAft>
-                <a:spcPts val="700"/>
+                <a:spcPts val="500"/>
               </a:spcAft>
             </a:pPr>
             <a:r>
-              <a:rPr sz="1400" b="0">
+              <a:rPr sz="1300" b="0">
                 <a:solidFill>
                   <a:srgbClr val="1A1C1E"/>
                 </a:solidFill>
                 <a:latin typeface="Calibri"/>
               </a:rPr>
-              <a:t>•  Composer = Cursor’s coding-specialist path</a:t>
+              <a:t>•  Composer = Cursor coding-specialist path</a:t>
             </a:r>
           </a:p>
           <a:p>
             <a:pPr algn="l">
               <a:spcAft>
-                <a:spcPts val="700"/>
+                <a:spcPts val="500"/>
               </a:spcAft>
             </a:pPr>
             <a:r>
-              <a:rPr sz="1400" b="0">
+              <a:rPr sz="1300" b="0">
                 <a:solidFill>
                   <a:srgbClr val="1A1C1E"/>
                 </a:solidFill>
                 <a:latin typeface="Calibri"/>
               </a:rPr>
-              <a:t>•  Best model changes over time</a:t>
-            </a:r>
-          </a:p>
-          <a:p>
-            <a:pPr algn="l">
-              <a:spcAft>
-                <a:spcPts val="700"/>
-              </a:spcAft>
-            </a:pPr>
-            <a:r>
-              <a:rPr sz="1400" b="0">
-                <a:solidFill>
-                  <a:srgbClr val="1A1C1E"/>
-                </a:solidFill>
-                <a:latin typeface="Calibri"/>
-              </a:rPr>
-              <a:t>•  Frontier labs = suppliers and competitors</a:t>
-            </a:r>
-          </a:p>
-        </p:txBody>
-      </p:sp>
-      <p:sp>
-        <p:nvSpPr>
-          <p:cNvPr id="13" name="Rectangle 12"/>
+              <a:t>•  Labs can be suppliers and competitors</a:t>
+            </a:r>
+          </a:p>
+        </p:txBody>
+      </p:sp>
+      <p:sp>
+        <p:nvSpPr>
+          <p:cNvPr id="19" name="Rectangle 18"/>
           <p:cNvSpPr/>
           <p:nvPr/>
         </p:nvSpPr>
         <p:spPr>
           <a:xfrm>
-            <a:off x="594360" y="4572000"/>
-            <a:ext cx="10927080" cy="1417320"/>
+            <a:off x="548640" y="5166360"/>
+            <a:ext cx="11018520" cy="1051560"/>
           </a:xfrm>
           <a:prstGeom prst="rect">
             <a:avLst/>
@@ -13638,14 +14011,14 @@
       </p:sp>
       <p:sp>
         <p:nvSpPr>
-          <p:cNvPr id="14" name="TextBox 13"/>
+          <p:cNvPr id="20" name="TextBox 19"/>
           <p:cNvSpPr txBox="1"/>
           <p:nvPr/>
         </p:nvSpPr>
         <p:spPr>
           <a:xfrm>
-            <a:off x="822960" y="4709160"/>
-            <a:ext cx="10424160" cy="320040"/>
+            <a:off x="731520" y="5303520"/>
+            <a:ext cx="10607040" cy="777240"/>
           </a:xfrm>
           <a:prstGeom prst="rect">
             <a:avLst/>
@@ -13660,48 +14033,13 @@
           <a:p>
             <a:pPr algn="l"/>
             <a:r>
-              <a:rPr sz="1300" b="1">
-                <a:solidFill>
-                  <a:srgbClr val="D6F26A"/>
+              <a:rPr sz="1300" b="0">
+                <a:solidFill>
+                  <a:srgbClr val="E8EAE4"/>
                 </a:solidFill>
                 <a:latin typeface="Calibri"/>
               </a:rPr>
-              <a:t>Competitive shapes (from differentiation history)</a:t>
-            </a:r>
-          </a:p>
-        </p:txBody>
-      </p:sp>
-      <p:sp>
-        <p:nvSpPr>
-          <p:cNvPr id="15" name="TextBox 14"/>
-          <p:cNvSpPr txBox="1"/>
-          <p:nvPr/>
-        </p:nvSpPr>
-        <p:spPr>
-          <a:xfrm>
-            <a:off x="822960" y="5074920"/>
-            <a:ext cx="10424160" cy="731520"/>
-          </a:xfrm>
-          <a:prstGeom prst="rect">
-            <a:avLst/>
-          </a:prstGeom>
-          <a:noFill/>
-        </p:spPr>
-        <p:txBody>
-          <a:bodyPr wrap="square" anchor="t">
-            <a:spAutoFit/>
-          </a:bodyPr>
-          <a:lstStyle/>
-          <a:p>
-            <a:pPr algn="l"/>
-            <a:r>
-              <a:rPr sz="1300" b="0">
-                <a:solidFill>
-                  <a:srgbClr val="E8EAE4"/>
-                </a:solidFill>
-                <a:latin typeface="Calibri"/>
-              </a:rPr>
-              <a:t>Cursor = AI-native IDE + enterprise platform   ·   Copilot = plugin / GitHub ecosystem   ·   Claude Code = terminal-first agent   ·   Windsurf = AI-IDE challenger (Cascade)   ·   Often the real competitor = ungoverned shadow AI</a:t>
+              <a:t>Shapes:  Cursor = platform  ·  Copilot = plugin / GitHub ecosystem  ·  Claude Code = terminal agent  ·  Windsurf = Cascade IDE challenger  ·  Codex = OpenAI async agents  ·  Often the real rival = ungoverned shadow AI</a:t>
             </a:r>
           </a:p>
         </p:txBody>
@@ -13776,7 +14114,7 @@
         <p:spPr>
           <a:xfrm>
             <a:off x="0" y="0"/>
-            <a:ext cx="12191695" cy="1097280"/>
+            <a:ext cx="12191695" cy="1051560"/>
           </a:xfrm>
           <a:prstGeom prst="rect">
             <a:avLst/>
@@ -13818,8 +14156,8 @@
         </p:nvSpPr>
         <p:spPr>
           <a:xfrm>
-            <a:off x="731520" y="292608"/>
-            <a:ext cx="10698480" cy="548640"/>
+            <a:off x="685800" y="274320"/>
+            <a:ext cx="10789920" cy="502920"/>
           </a:xfrm>
           <a:prstGeom prst="rect">
             <a:avLst/>
@@ -13834,7 +14172,7 @@
           <a:p>
             <a:pPr algn="l"/>
             <a:r>
-              <a:rPr sz="2400" b="1">
+              <a:rPr sz="2300" b="1">
                 <a:solidFill>
                   <a:srgbClr val="FFFFFF"/>
                 </a:solidFill>
@@ -13853,8 +14191,8 @@
         </p:nvSpPr>
         <p:spPr>
           <a:xfrm>
-            <a:off x="594360" y="1280160"/>
-            <a:ext cx="10927080" cy="914400"/>
+            <a:off x="548640" y="1234440"/>
+            <a:ext cx="11018520" cy="777240"/>
           </a:xfrm>
           <a:prstGeom prst="rect">
             <a:avLst/>
@@ -13896,8 +14234,8 @@
         </p:nvSpPr>
         <p:spPr>
           <a:xfrm>
-            <a:off x="822960" y="1417320"/>
-            <a:ext cx="10424160" cy="640080"/>
+            <a:off x="731520" y="1325880"/>
+            <a:ext cx="10607040" cy="594360"/>
           </a:xfrm>
           <a:prstGeom prst="rect">
             <a:avLst/>
@@ -13912,13 +14250,13 @@
           <a:p>
             <a:pPr algn="l"/>
             <a:r>
-              <a:rPr sz="1500" b="0">
+              <a:rPr sz="1300" b="0">
                 <a:solidFill>
                   <a:srgbClr val="E8EAE4"/>
                 </a:solidFill>
                 <a:latin typeface="Calibri"/>
               </a:rPr>
-              <a:t>Leading agentic coding platform — shared AI layer on the codebase that connects developers, tools, and agents so teams get more from frontier models.</a:t>
+              <a:t>Leading agentic coding platform — a coding agent across IDE, CLI, Automations, and Cloud Agents with a shared AI layer on the codebase. Helps teams get more from frontier models via better workflow, context, and integrated execution.</a:t>
             </a:r>
           </a:p>
         </p:txBody>
@@ -13931,8 +14269,8 @@
         </p:nvSpPr>
         <p:spPr>
           <a:xfrm>
-            <a:off x="594360" y="2423160"/>
-            <a:ext cx="2606040" cy="1143000"/>
+            <a:off x="548640" y="2194560"/>
+            <a:ext cx="2697480" cy="1005840"/>
           </a:xfrm>
           <a:prstGeom prst="rect">
             <a:avLst/>
@@ -13974,8 +14312,8 @@
         </p:nvSpPr>
         <p:spPr>
           <a:xfrm>
-            <a:off x="777240" y="2606040"/>
-            <a:ext cx="594360" cy="73152"/>
+            <a:off x="713232" y="2331720"/>
+            <a:ext cx="548640" cy="64008"/>
           </a:xfrm>
           <a:prstGeom prst="rect">
             <a:avLst/>
@@ -14017,8 +14355,8 @@
         </p:nvSpPr>
         <p:spPr>
           <a:xfrm>
-            <a:off x="777240" y="2788920"/>
-            <a:ext cx="2240280" cy="274320"/>
+            <a:off x="713232" y="2514600"/>
+            <a:ext cx="2331720" cy="256032"/>
           </a:xfrm>
           <a:prstGeom prst="rect">
             <a:avLst/>
@@ -14033,7 +14371,7 @@
           <a:p>
             <a:pPr algn="l"/>
             <a:r>
-              <a:rPr sz="1500" b="1">
+              <a:rPr sz="1400" b="1">
                 <a:solidFill>
                   <a:srgbClr val="141618"/>
                 </a:solidFill>
@@ -14052,8 +14390,8 @@
         </p:nvSpPr>
         <p:spPr>
           <a:xfrm>
-            <a:off x="777240" y="3108960"/>
-            <a:ext cx="2240280" cy="274320"/>
+            <a:off x="713232" y="2834640"/>
+            <a:ext cx="2331720" cy="228600"/>
           </a:xfrm>
           <a:prstGeom prst="rect">
             <a:avLst/>
@@ -14074,7 +14412,7 @@
                 </a:solidFill>
                 <a:latin typeface="Calibri"/>
               </a:rPr>
-              <a:t>Desktop agentic coding</a:t>
+              <a:t>Desktop agentic</a:t>
             </a:r>
           </a:p>
         </p:txBody>
@@ -14087,8 +14425,8 @@
         </p:nvSpPr>
         <p:spPr>
           <a:xfrm>
-            <a:off x="3383280" y="2423160"/>
-            <a:ext cx="2606040" cy="1143000"/>
+            <a:off x="3383280" y="2194560"/>
+            <a:ext cx="2697480" cy="1005840"/>
           </a:xfrm>
           <a:prstGeom prst="rect">
             <a:avLst/>
@@ -14130,8 +14468,8 @@
         </p:nvSpPr>
         <p:spPr>
           <a:xfrm>
-            <a:off x="3566160" y="2606040"/>
-            <a:ext cx="594360" cy="73152"/>
+            <a:off x="3547872" y="2331720"/>
+            <a:ext cx="548640" cy="64008"/>
           </a:xfrm>
           <a:prstGeom prst="rect">
             <a:avLst/>
@@ -14173,8 +14511,8 @@
         </p:nvSpPr>
         <p:spPr>
           <a:xfrm>
-            <a:off x="3566160" y="2788920"/>
-            <a:ext cx="2240280" cy="274320"/>
+            <a:off x="3547872" y="2514600"/>
+            <a:ext cx="2331720" cy="256032"/>
           </a:xfrm>
           <a:prstGeom prst="rect">
             <a:avLst/>
@@ -14189,7 +14527,7 @@
           <a:p>
             <a:pPr algn="l"/>
             <a:r>
-              <a:rPr sz="1500" b="1">
+              <a:rPr sz="1400" b="1">
                 <a:solidFill>
                   <a:srgbClr val="141618"/>
                 </a:solidFill>
@@ -14208,8 +14546,8 @@
         </p:nvSpPr>
         <p:spPr>
           <a:xfrm>
-            <a:off x="3566160" y="3108960"/>
-            <a:ext cx="2240280" cy="274320"/>
+            <a:off x="3547872" y="2834640"/>
+            <a:ext cx="2331720" cy="228600"/>
           </a:xfrm>
           <a:prstGeom prst="rect">
             <a:avLst/>
@@ -14230,7 +14568,7 @@
                 </a:solidFill>
                 <a:latin typeface="Calibri"/>
               </a:rPr>
-              <a:t>Terminal / any workflow</a:t>
+              <a:t>Terminal / scripts</a:t>
             </a:r>
           </a:p>
         </p:txBody>
@@ -14243,8 +14581,8 @@
         </p:nvSpPr>
         <p:spPr>
           <a:xfrm>
-            <a:off x="6172200" y="2423160"/>
-            <a:ext cx="2606040" cy="1143000"/>
+            <a:off x="6217920" y="2194560"/>
+            <a:ext cx="2697480" cy="1005840"/>
           </a:xfrm>
           <a:prstGeom prst="rect">
             <a:avLst/>
@@ -14286,8 +14624,8 @@
         </p:nvSpPr>
         <p:spPr>
           <a:xfrm>
-            <a:off x="6355080" y="2606040"/>
-            <a:ext cx="594360" cy="73152"/>
+            <a:off x="6382512" y="2331720"/>
+            <a:ext cx="548640" cy="64008"/>
           </a:xfrm>
           <a:prstGeom prst="rect">
             <a:avLst/>
@@ -14329,8 +14667,8 @@
         </p:nvSpPr>
         <p:spPr>
           <a:xfrm>
-            <a:off x="6355080" y="2788920"/>
-            <a:ext cx="2240280" cy="274320"/>
+            <a:off x="6382512" y="2514600"/>
+            <a:ext cx="2331720" cy="256032"/>
           </a:xfrm>
           <a:prstGeom prst="rect">
             <a:avLst/>
@@ -14345,7 +14683,7 @@
           <a:p>
             <a:pPr algn="l"/>
             <a:r>
-              <a:rPr sz="1500" b="1">
+              <a:rPr sz="1400" b="1">
                 <a:solidFill>
                   <a:srgbClr val="141618"/>
                 </a:solidFill>
@@ -14364,8 +14702,8 @@
         </p:nvSpPr>
         <p:spPr>
           <a:xfrm>
-            <a:off x="6355080" y="3108960"/>
-            <a:ext cx="2240280" cy="274320"/>
+            <a:off x="6382512" y="2834640"/>
+            <a:ext cx="2331720" cy="228600"/>
           </a:xfrm>
           <a:prstGeom prst="rect">
             <a:avLst/>
@@ -14386,7 +14724,7 @@
                 </a:solidFill>
                 <a:latin typeface="Calibri"/>
               </a:rPr>
-              <a:t>Event-driven agents</a:t>
+              <a:t>Event-driven</a:t>
             </a:r>
           </a:p>
         </p:txBody>
@@ -14399,8 +14737,8 @@
         </p:nvSpPr>
         <p:spPr>
           <a:xfrm>
-            <a:off x="8961120" y="2423160"/>
-            <a:ext cx="2606040" cy="1143000"/>
+            <a:off x="9052560" y="2194560"/>
+            <a:ext cx="2697480" cy="1005840"/>
           </a:xfrm>
           <a:prstGeom prst="rect">
             <a:avLst/>
@@ -14442,8 +14780,8 @@
         </p:nvSpPr>
         <p:spPr>
           <a:xfrm>
-            <a:off x="9144000" y="2606040"/>
-            <a:ext cx="594360" cy="73152"/>
+            <a:off x="9217152" y="2331720"/>
+            <a:ext cx="548640" cy="64008"/>
           </a:xfrm>
           <a:prstGeom prst="rect">
             <a:avLst/>
@@ -14485,8 +14823,8 @@
         </p:nvSpPr>
         <p:spPr>
           <a:xfrm>
-            <a:off x="9144000" y="2788920"/>
-            <a:ext cx="2240280" cy="274320"/>
+            <a:off x="9217152" y="2514600"/>
+            <a:ext cx="2331720" cy="256032"/>
           </a:xfrm>
           <a:prstGeom prst="rect">
             <a:avLst/>
@@ -14501,7 +14839,7 @@
           <a:p>
             <a:pPr algn="l"/>
             <a:r>
-              <a:rPr sz="1500" b="1">
+              <a:rPr sz="1400" b="1">
                 <a:solidFill>
                   <a:srgbClr val="141618"/>
                 </a:solidFill>
@@ -14520,8 +14858,8 @@
         </p:nvSpPr>
         <p:spPr>
           <a:xfrm>
-            <a:off x="9144000" y="3108960"/>
-            <a:ext cx="2240280" cy="274320"/>
+            <a:off x="9217152" y="2834640"/>
+            <a:ext cx="2331720" cy="228600"/>
           </a:xfrm>
           <a:prstGeom prst="rect">
             <a:avLst/>
@@ -14542,7 +14880,7 @@
                 </a:solidFill>
                 <a:latin typeface="Calibri"/>
               </a:rPr>
-              <a:t>Async / browser / mobile</a:t>
+              <a:t>Async / mobile</a:t>
             </a:r>
           </a:p>
         </p:txBody>
@@ -14555,8 +14893,8 @@
         </p:nvSpPr>
         <p:spPr>
           <a:xfrm>
-            <a:off x="594360" y="3840480"/>
-            <a:ext cx="3566160" cy="1234440"/>
+            <a:off x="548640" y="3383280"/>
+            <a:ext cx="3657600" cy="1417320"/>
           </a:xfrm>
           <a:prstGeom prst="rect">
             <a:avLst/>
@@ -14598,8 +14936,8 @@
         </p:nvSpPr>
         <p:spPr>
           <a:xfrm>
-            <a:off x="822960" y="4023360"/>
-            <a:ext cx="3108960" cy="320040"/>
+            <a:off x="731520" y="3520440"/>
+            <a:ext cx="3246120" cy="274320"/>
           </a:xfrm>
           <a:prstGeom prst="rect">
             <a:avLst/>
@@ -14614,13 +14952,13 @@
           <a:p>
             <a:pPr algn="l"/>
             <a:r>
-              <a:rPr sz="1600" b="1">
+              <a:rPr sz="1400" b="1">
                 <a:solidFill>
                   <a:srgbClr val="141618"/>
                 </a:solidFill>
                 <a:latin typeface="Georgia"/>
               </a:rPr>
-              <a:t>Workflow</a:t>
+              <a:t>Productivity</a:t>
             </a:r>
           </a:p>
         </p:txBody>
@@ -14633,8 +14971,8 @@
         </p:nvSpPr>
         <p:spPr>
           <a:xfrm>
-            <a:off x="822960" y="4434840"/>
-            <a:ext cx="3108960" cy="457200"/>
+            <a:off x="731520" y="3886200"/>
+            <a:ext cx="3246120" cy="731520"/>
           </a:xfrm>
           <a:prstGeom prst="rect">
             <a:avLst/>
@@ -14649,13 +14987,13 @@
           <a:p>
             <a:pPr algn="l"/>
             <a:r>
-              <a:rPr sz="1300" b="0">
+              <a:rPr sz="1200" b="0">
                 <a:solidFill>
                   <a:srgbClr val="5E646B"/>
                 </a:solidFill>
                 <a:latin typeface="Calibri"/>
               </a:rPr>
-              <a:t>How work actually gets done across the SDLC</a:t>
+              <a:t>Multi-file agents, codebase context, task completion — not just autocomplete</a:t>
             </a:r>
           </a:p>
         </p:txBody>
@@ -14668,8 +15006,8 @@
         </p:nvSpPr>
         <p:spPr>
           <a:xfrm>
-            <a:off x="4343399" y="3840480"/>
-            <a:ext cx="3566160" cy="1234440"/>
+            <a:off x="4343400" y="3383280"/>
+            <a:ext cx="3657600" cy="1417320"/>
           </a:xfrm>
           <a:prstGeom prst="rect">
             <a:avLst/>
@@ -14711,8 +15049,8 @@
         </p:nvSpPr>
         <p:spPr>
           <a:xfrm>
-            <a:off x="4571999" y="4023360"/>
-            <a:ext cx="3108960" cy="320040"/>
+            <a:off x="4526280" y="3520440"/>
+            <a:ext cx="3246120" cy="274320"/>
           </a:xfrm>
           <a:prstGeom prst="rect">
             <a:avLst/>
@@ -14727,13 +15065,13 @@
           <a:p>
             <a:pPr algn="l"/>
             <a:r>
-              <a:rPr sz="1600" b="1">
+              <a:rPr sz="1400" b="1">
                 <a:solidFill>
                   <a:srgbClr val="141618"/>
                 </a:solidFill>
                 <a:latin typeface="Georgia"/>
               </a:rPr>
-              <a:t>Context</a:t>
+              <a:t>Governance</a:t>
             </a:r>
           </a:p>
         </p:txBody>
@@ -14746,8 +15084,8 @@
         </p:nvSpPr>
         <p:spPr>
           <a:xfrm>
-            <a:off x="4571999" y="4434840"/>
-            <a:ext cx="3108960" cy="457200"/>
+            <a:off x="4526280" y="3886200"/>
+            <a:ext cx="3246120" cy="731520"/>
           </a:xfrm>
           <a:prstGeom prst="rect">
             <a:avLst/>
@@ -14762,13 +15100,13 @@
           <a:p>
             <a:pPr algn="l"/>
             <a:r>
-              <a:rPr sz="1300" b="0">
+              <a:rPr sz="1200" b="0">
                 <a:solidFill>
                   <a:srgbClr val="5E646B"/>
                 </a:solidFill>
                 <a:latin typeface="Calibri"/>
               </a:rPr>
-              <a:t>Codebase, dependencies, team systems</a:t>
+              <a:t>SSO · SCIM · RBAC · audit logs · admin controls over models / repos / MCP</a:t>
             </a:r>
           </a:p>
         </p:txBody>
@@ -14781,8 +15119,8 @@
         </p:nvSpPr>
         <p:spPr>
           <a:xfrm>
-            <a:off x="8092438" y="3840480"/>
-            <a:ext cx="3566160" cy="1234440"/>
+            <a:off x="8138160" y="3383280"/>
+            <a:ext cx="3657600" cy="1417320"/>
           </a:xfrm>
           <a:prstGeom prst="rect">
             <a:avLst/>
@@ -14824,8 +15162,8 @@
         </p:nvSpPr>
         <p:spPr>
           <a:xfrm>
-            <a:off x="8321038" y="4023360"/>
-            <a:ext cx="3108960" cy="320040"/>
+            <a:off x="8321040" y="3520440"/>
+            <a:ext cx="3246120" cy="274320"/>
           </a:xfrm>
           <a:prstGeom prst="rect">
             <a:avLst/>
@@ -14840,13 +15178,13 @@
           <a:p>
             <a:pPr algn="l"/>
             <a:r>
-              <a:rPr sz="1600" b="1">
+              <a:rPr sz="1400" b="1">
                 <a:solidFill>
                   <a:srgbClr val="141618"/>
                 </a:solidFill>
                 <a:latin typeface="Georgia"/>
               </a:rPr>
-              <a:t>Execution</a:t>
+              <a:t>Privacy &amp; security</a:t>
             </a:r>
           </a:p>
         </p:txBody>
@@ -14859,8 +15197,8 @@
         </p:nvSpPr>
         <p:spPr>
           <a:xfrm>
-            <a:off x="8321038" y="4434840"/>
-            <a:ext cx="3108960" cy="457200"/>
+            <a:off x="8321040" y="3886200"/>
+            <a:ext cx="3246120" cy="731520"/>
           </a:xfrm>
           <a:prstGeom prst="rect">
             <a:avLst/>
@@ -14875,13 +15213,13 @@
           <a:p>
             <a:pPr algn="l"/>
             <a:r>
-              <a:rPr sz="1300" b="0">
+              <a:rPr sz="1200" b="0">
                 <a:solidFill>
                   <a:srgbClr val="5E646B"/>
                 </a:solidFill>
                 <a:latin typeface="Calibri"/>
               </a:rPr>
-              <a:t>Plan → build → review → ship with less friction</a:t>
+              <a:t>Privacy Mode / ZDR · SOC 2 Type II · CMEK · reduce shadow AI risk</a:t>
             </a:r>
           </a:p>
         </p:txBody>
@@ -14894,8 +15232,8 @@
         </p:nvSpPr>
         <p:spPr>
           <a:xfrm>
-            <a:off x="777240" y="5303520"/>
-            <a:ext cx="10515600" cy="777240"/>
+            <a:off x="731520" y="5029200"/>
+            <a:ext cx="10607040" cy="1097280"/>
           </a:xfrm>
           <a:prstGeom prst="rect">
             <a:avLst/>
@@ -14916,8 +15254,8 @@
                 </a:solidFill>
                 <a:latin typeface="Calibri"/>
               </a:rPr>
-              <a:t>Enterprise 3 buckets:  Productivity (agents + multi-file)  ·  Governance (SSO / SCIM / audit / admin)  ·  Privacy &amp; security (Privacy Mode, SOC 2 Type II)
-Proof points: Coinbase · Stripe · PayPal — speed + governed adoption, not autocomplete vanity.</a:t>
+              <a:t>Harness = the engineering layer between developer and model (context packing, tool use, turn management, routing).
+Proof: Coinbase (agent-first) · Stripe (standardized rollout) · PayPal (enterprise velocity) — outcomes, not vanity AI metrics.</a:t>
             </a:r>
           </a:p>
         </p:txBody>

</xml_diff>

<commit_message>
Apply Parts 2–3 with whiteboard craft for live pitch
Part 2 now mirrors Lindsey’s hiring/coaching language. Part 3 stays light and live-ready, pulling open→diagnose→factory→ask moves from the Derek×Dave whiteboard into slides and speaker notes.

Co-authored-by: dempseli01-stack <dempseli01-stack@users.noreply.github.com>
</commit_message>
<xml_diff>
--- a/Lindsey_Presentation.pptx
+++ b/Lindsey_Presentation.pptx
@@ -27,6 +27,7 @@
     <p:sldId id="275" r:id="rId27"/>
     <p:sldId id="276" r:id="rId28"/>
     <p:sldId id="277" r:id="rId29"/>
+    <p:sldId id="278" r:id="rId30"/>
   </p:sldIdLst>
   <p:sldSz cx="12191695" cy="6858000" type="screen4x3"/>
   <p:notesSz cx="6858000" cy="9144000"/>
@@ -1045,44 +1046,19 @@
           <a:lstStyle/>
           <a:p>
             <a:r>
-              <a:t>In the AI era, a lot of rote research and first-draft personalization can be automated. So the exceptional SDR looks different.</a:t>
+              <a:t>The role has changed because AI can take the rote work — research, first drafts, list building — so SDRs can be as efficient as possible and focus on what humans are actually good at.</a:t>
             </a:r>
           </a:p>
           <a:p/>
           <a:p>
             <a:r>
-              <a:t>They win on judgment — which account and persona deserve the dial.</a:t>
-            </a:r>
-          </a:p>
-          <a:p>
-            <a:r>
-              <a:t>Relevance speed — earning thirty seconds with a technical buyer.</a:t>
-            </a:r>
-          </a:p>
-          <a:p>
-            <a:r>
-              <a:t>Positioning fluency — workflow, context, execution, and the correct wedge.</a:t>
-            </a:r>
-          </a:p>
-          <a:p>
-            <a:r>
-              <a:t>Competitive clarity — Copilot and Claude Code without trash talk.</a:t>
-            </a:r>
-          </a:p>
-          <a:p>
-            <a:r>
-              <a:t>Security instincts — calm and grounded on Privacy Mode and enterprise controls.</a:t>
-            </a:r>
-          </a:p>
-          <a:p>
-            <a:r>
-              <a:t>And execution discipline — trains on time.</a:t>
+              <a:t>Humans still want to be sold to by humans. Even with AI, messaging and cold calls need humanization. The way we stand out isn’t louder sequences — it’s talking to prospects from a place of help: start a real discussion so they can reap the benefits of Cursor.</a:t>
             </a:r>
           </a:p>
           <a:p/>
           <a:p>
             <a:r>
-              <a:t>My bar is simple: they don’t recite features. They diagnose the buyer’s constraint and match Cursor to it.</a:t>
+              <a:t>Exceptional is someone who uses AI for the rote work, then stands out through genuine discovery, care, understanding the current state and the pains underneath it, and knowing which customer story matches the use case. They need organization and time management, research and business intuition, written and verbal communication, active listening and adaptability — carry the conversation and react with value — objection handling, and storytelling that paints technical pain and business value.</a:t>
             </a:r>
           </a:p>
         </p:txBody>
@@ -1152,31 +1128,25 @@
           <a:lstStyle/>
           <a:p>
             <a:r>
-              <a:t>On hiring, I’m looking for coachable people who communicate clearly, are curious about technical buyers, have process discipline, and learn fast.</a:t>
+              <a:t>When I hire, I’m looking for someone who will be excited every single day — and someone I can see moving into the next role.</a:t>
             </a:r>
           </a:p>
           <a:p/>
           <a:p>
             <a:r>
-              <a:t>Hard nos: feature dumpers, activity theater without conversion ownership, people who can’t take critique, and anyone who overclaims the product.</a:t>
+              <a:t>My bar is usually one to two years in sales, or something technical that required intelligence. Some of my best hires have been teachers or people with real work experience who want into sales — they understand concepts quickly.</a:t>
             </a:r>
           </a:p>
           <a:p/>
           <a:p>
             <a:r>
-              <a:t>I’d assess with a mock call to a VP of Engineering or Platform lead, Copilot and Claude Code objections, a sixty-second Cursor pitch using the official framing, and a soft security question like, “Our CISO won’t allow AI on our code — what do you say?”</a:t>
+              <a:t>Every candidate needs four traits plus one non-negotiable: intelligence so they can gain knowledge, drive so they can gain the skills, coachable so they adapt, integrity so they’re honest — and a genuine passion for AI and Cursor. It’s not enough to want a fast-growing company. I want people who nerd out on which model is best and what’s changing in the space.</a:t>
             </a:r>
           </a:p>
           <a:p/>
           <a:p>
             <a:r>
-              <a:t>On coaching: daily scoreboard visibility and same-day course-correction if someone misses the standard. Weekly one-on-ones focused on one funnel leak only. Weekly team session with one win wire and one talk-track upgrade. Call reviews scored on opener, wedge, competitive frame, and clean ask.</a:t>
-            </a:r>
-          </a:p>
-          <a:p/>
-          <a:p>
-            <a:r>
-              <a:t>Underperformance gets a stage diagnosis, a skill plan, and a timeline — not vague pressure.</a:t>
+              <a:t>Process-wise I source through LinkedIn Recruiter, and I prefer native language for the role — I’ve seen non-native speakers struggle when they have to sell technically in a second language.</a:t>
             </a:r>
           </a:p>
         </p:txBody>
@@ -1246,7 +1216,25 @@
           <a:lstStyle/>
           <a:p>
             <a:r>
-              <a:t>Part three — craft and curiosity. This is where I’m happiest going live.</a:t>
+              <a:t>Coaching and development all follow the same framework: Tell — what, who, why. Show — what good looks like. Observe — let them struggle. Provide feedback — but first ask what they did well and what they’d do differently. Repeat until it’s mastered.</a:t>
+            </a:r>
+          </a:p>
+          <a:p/>
+          <a:p>
+            <a:r>
+              <a:t>For new reps I spend a lot of time with them — constant training, homework, fix gaps quickly, and always the why. I give a ninety-day ramp broken down by week so they know exactly what to do when the week starts, and a buddy on the team for questions and advice.</a:t>
+            </a:r>
+          </a:p>
+          <a:p/>
+          <a:p>
+            <a:r>
+              <a:t>For top people I learn their motivation early, catch them doing something good, let them mentor, and keep coaching the gaps in their workflow. For underperformance I put a coaching plan in place as soon as I see someone off track — structure before it becomes a bigger issue.</a:t>
+            </a:r>
+          </a:p>
+          <a:p/>
+          <a:p>
+            <a:r>
+              <a:t>Culture is scoreboards, competitions, collaboration, and ending every week with a shoutout for someone else on the team so collaboration doesn’t go unnoticed.</a:t>
             </a:r>
           </a:p>
         </p:txBody>
@@ -1316,43 +1304,7 @@
           <a:lstStyle/>
           <a:p>
             <a:r>
-              <a:t>If I’m cold-calling into this room, the spine is open, position, wedge, ask.</a:t>
-            </a:r>
-          </a:p>
-          <a:p/>
-          <a:p>
-            <a:r>
-              <a:t>Open: the reason I’m calling is engineering teams are moving from AI that helps write snippets to AI that helps complete work across the codebase — and most tools only cover part of that workflow.</a:t>
-            </a:r>
-          </a:p>
-          <a:p/>
-          <a:p>
-            <a:r>
-              <a:t>Position: Cursor is an agentic coding platform — a coding agent across the IDE, CLI, Automations, and Cloud Agents — with a shared AI layer that understands your codebase and workflows so planning, building, review, and shipping happen with less friction.</a:t>
-            </a:r>
-          </a:p>
-          <a:p/>
-          <a:p>
-            <a:r>
-              <a:t>Wedge: I pick one differentiator based on what I heard.</a:t>
-            </a:r>
-          </a:p>
-          <a:p/>
-          <a:p>
-            <a:r>
-              <a:t>Ask: worth twenty minutes to map where you’re getting leverage versus where workflow still breaks — write, review, or ship?</a:t>
-            </a:r>
-          </a:p>
-          <a:p/>
-          <a:p>
-            <a:r>
-              <a:t>If I get “just send an email,” I don’t collapse. I say: happy to — so I send the useful one: are you more focused on standardizing AI coding, or on the review bottleneck after Copilot?</a:t>
-            </a:r>
-          </a:p>
-          <a:p/>
-          <a:p>
-            <a:r>
-              <a:t>I’m happy to run this live on one of you right now if you’d like.</a:t>
+              <a:t>Part three — craft and curiosity. This is where I’m happiest going live.</a:t>
             </a:r>
           </a:p>
         </p:txBody>
@@ -1422,31 +1374,37 @@
           <a:lstStyle/>
           <a:p>
             <a:r>
-              <a:t>Technical buyers are saturated on LinkedIn and email, so persona-true outreach matters more than volume tricks.</a:t>
+              <a:t>This section is live — I’m happiest going here without slides doing the talking. Same craft as the whiteboard session with Derek and Dave at J&amp;J.</a:t>
             </a:r>
           </a:p>
           <a:p/>
           <a:p>
             <a:r>
-              <a:t>For a hands-on developer: lead with real-repo context and daily workflow. Avoid corporate ROI theater.</a:t>
+              <a:t>If I’m earning a first meeting with one of you, I’m listening and diagnosing, not pitching a deck. Permission first — not slide-ware. I’d open with: what prompted you to take the call — or, the reason I’m calling is teams are writing code faster with AI and then hitting a bottleneck getting work through review and into production.</a:t>
             </a:r>
           </a:p>
           <a:p/>
           <a:p>
             <a:r>
-              <a:t>For a VP of Engineering: lead with a shared AI layer, speed across the SDLC, and standardizing teams. Avoid feature laundry lists.</a:t>
+              <a:t>I’d ask where engineering time actually goes — keep-the-lights-on, refactor, innovate, moonshot — because that’s where capacity for the projects that matter is hiding. The software factory frame: ideas in, valuable outputs out. If Copilot, Claude Code, or Codex is already in, I don’t trash-talk. I meet them on the maturity curve: assisted, agentic, cloud agents, governed factory — and ask where the team is stuck.</a:t>
             </a:r>
           </a:p>
           <a:p/>
           <a:p>
             <a:r>
-              <a:t>For Security or Platform: lead with Privacy Mode, admin controls, and governed rollout so AI coding doesn’t become shadow IT. Avoid hype.</a:t>
+              <a:t>Brush-off: if I get “just send an email,” I don’t collapse. Happy to — so I send the useful one: are you more focused on standardizing AI coding, or on the review bottleneck after Copilot?</a:t>
             </a:r>
           </a:p>
           <a:p/>
           <a:p>
             <a:r>
-              <a:t>What still works is trigger-based relevance — Copilot sprawl, AI policy moments, migrations, DevEx ownership — and one sharp question. What fails is generic “quick chat” spam and fake personalization.</a:t>
+              <a:t>Ask: worth twenty minutes with you — and if useful, your platform lead — to map where AI coding helps versus where workflow still breaks. In a working session I’d close the way the whiteboard did: what’s the most important thing you saw today — for you personally, and for the company.</a:t>
+            </a:r>
+          </a:p>
+          <a:p/>
+          <a:p>
+            <a:r>
+              <a:t>I’m ready to do this live on one of you right now.</a:t>
             </a:r>
           </a:p>
         </p:txBody>
@@ -1604,25 +1562,31 @@
           <a:lstStyle/>
           <a:p>
             <a:r>
-              <a:t>For a skeptical engineering leader, my one-to-two sentence version is this:</a:t>
+              <a:t>Inboxes and LinkedIn are saturated, so I don’t believe volume tricks break through with this audience. Breaking through is persona-true relevance — one sharp question tied to a real trigger.</a:t>
             </a:r>
           </a:p>
           <a:p/>
           <a:p>
             <a:r>
-              <a:t>Cursor doesn’t win because we claim exclusive access to better intelligence forever. We win because we apply intelligence more effectively — through workflow, codebase context, and an integrated system across the SDLC — with model neutrality as capabilities and economics change.</a:t>
+              <a:t>For a hands-on developer: lead with real-repo context and daily workflow. Avoid corporate ROI theater. Peer proof and “try this on your actual pain” beat feature lists.</a:t>
             </a:r>
           </a:p>
           <a:p/>
           <a:p>
             <a:r>
-              <a:t>Versus GitHub Copilot: Copilot helps developers write faster. Cursor is the shift from snippet help to task completion, from local suggestions to broader codebase context, from a point solution to a more integrated development experience.</a:t>
+              <a:t>For a VP of Engineering: lead with standardization, shipping speed, and capacity — the whiteboard motion of freeing time from keep-the-lights-on into moonshots. Avoid feature laundry lists.</a:t>
             </a:r>
           </a:p>
           <a:p/>
           <a:p>
             <a:r>
-              <a:t>Versus Claude Code: Claude Code is strong, and I won’t argue it’s weak. Our edge usually isn’t exclusive smarter model access. It’s model neutrality instead of single-provider dependence, stronger integration across the SDLC, better support for large complex codebases, and faster time to value across a broader team.</a:t>
+              <a:t>For Security or Platform: lead with governed adoption — Privacy Mode, admin controls, SSO/SCIM/audit — so AI coding doesn’t become shadow IT. Avoid hype. Earn the right to go deep later.</a:t>
+            </a:r>
+          </a:p>
+          <a:p/>
+          <a:p>
+            <a:r>
+              <a:t>What still works: trigger-based relevance — Copilot sprawl, AI policy moments, migrations, DevEx ownership — plus a binary question that earns the next conversation. What fails: “quick chat” spam, fake personalization, and slide-ware before you’ve earned diagnosis.</a:t>
             </a:r>
           </a:p>
         </p:txBody>
@@ -1692,25 +1656,19 @@
           <a:lstStyle/>
           <a:p>
             <a:r>
-              <a:t>Security and privacy often decide enterprise evaluations, so SDRs need calm instincts, not a certification dump.</a:t>
+              <a:t>Getting attention right now is about earning thirty seconds with a technical buyer, not winning the inbox lottery.</a:t>
             </a:r>
           </a:p>
           <a:p/>
           <a:p>
             <a:r>
-              <a:t>On Privacy Mode: customer code is not stored or retained, not used to train models, and requests are isolated and ephemeral.</a:t>
+              <a:t>What works: a reason for the call tied to their world; diagnosing where time and bottlenecks actually sit; meeting them on the AI maturity curve; using customer stories that match the use case — Coinbase for agent-first, Stripe for rollout, PayPal for enterprise velocity, plus whiteboard stories like Nike RFID, Amplitude background agents, T-Mobile at scale; and asking for a working session, not a vague chat. Token efficiency and outcomes per dollar matter when finance is in the room — that’s attention currency too.</a:t>
             </a:r>
           </a:p>
           <a:p/>
           <a:p>
             <a:r>
-              <a:t>On enterprise posture: SOC 2, secure handling of code and metadata, admin controls and visibility, and the fact that security requirements influence product design.</a:t>
-            </a:r>
-          </a:p>
-          <a:p/>
-          <a:p>
-            <a:r>
-              <a:t>In a live cycle, security shows up as adoption confidence — “we can roll this out without creating shadow AI” — not as a slide war on the first call. If it gets deep, I bring in the right technical partner and stay precise.</a:t>
+              <a:t>What used to work that I’m confident will not work with Cursor’s audience: generic sequences, “just checking in,” ROI theater for developers, and feature dumps. Technical buyers smell fake personalization instantly, and they punish anyone who tries to out-engineer them on a cold call. Curiosity and diagnosis beat polish.</a:t>
             </a:r>
           </a:p>
         </p:txBody>
@@ -1780,13 +1738,95 @@
           <a:lstStyle/>
           <a:p>
             <a:r>
+              <a:t>My own read — not the company line — is this:</a:t>
+            </a:r>
+          </a:p>
+          <a:p/>
+          <a:p>
+            <a:r>
+              <a:t>Cursor wins because the market moved from “help me write code” to “help my org ship software with agents without losing control.” AI coding tools create speed and then move the bottleneck to review and production. Cursor wins when it becomes the governed software factory — workflow, codebase context, model neutrality, and execution across the SDLC — so teams free capacity for the work that actually changes the business.</a:t>
+            </a:r>
+          </a:p>
+          <a:p/>
+          <a:p>
+            <a:r>
+              <a:t>To a skeptical engineering leader in two sentences: Cursor doesn’t win by claiming the permanently smarter model. We win by applying intelligence better across real engineering workflows — and giving the enterprise the control plane to standardize that without shadow AI or wasted tokens.</a:t>
+            </a:r>
+          </a:p>
+        </p:txBody>
+      </p:sp>
+      <p:sp>
+        <p:nvSpPr>
+          <p:cNvPr id="4" name="Slide Number Placeholder 3"/>
+          <p:cNvSpPr>
+            <a:spLocks noGrp="1"/>
+          </p:cNvSpPr>
+          <p:nvPr>
+            <p:ph type="sldNum" idx="5" sz="quarter"/>
+          </p:nvPr>
+        </p:nvSpPr>
+        <p:spPr/>
+      </p:sp>
+    </p:spTree>
+  </p:cSld>
+  <p:clrMapOvr>
+    <a:masterClrMapping/>
+  </p:clrMapOvr>
+</p:notes>
+</file>
+
+<file path=ppt/notesSlides/notesSlide23.xml><?xml version="1.0" encoding="utf-8"?>
+<p:notes xmlns:a="http://schemas.openxmlformats.org/drawingml/2006/main" xmlns:p="http://schemas.openxmlformats.org/presentationml/2006/main" xmlns:r="http://schemas.openxmlformats.org/officeDocument/2006/relationships">
+  <p:cSld>
+    <p:spTree>
+      <p:nvGrpSpPr>
+        <p:cNvPr id="1" name=""/>
+        <p:cNvGrpSpPr/>
+        <p:nvPr/>
+      </p:nvGrpSpPr>
+      <p:grpSpPr>
+        <a:xfrm>
+          <a:off x="0" y="0"/>
+          <a:ext cx="0" cy="0"/>
+          <a:chOff x="0" y="0"/>
+          <a:chExt cx="0" cy="0"/>
+        </a:xfrm>
+      </p:grpSpPr>
+      <p:sp>
+        <p:nvSpPr>
+          <p:cNvPr id="2" name="Slide Image Placeholder 1"/>
+          <p:cNvSpPr>
+            <a:spLocks noGrp="1"/>
+          </p:cNvSpPr>
+          <p:nvPr>
+            <p:ph type="sldImg" idx="2"/>
+          </p:nvPr>
+        </p:nvSpPr>
+        <p:spPr/>
+      </p:sp>
+      <p:sp>
+        <p:nvSpPr>
+          <p:cNvPr id="3" name="Notes Placeholder 2"/>
+          <p:cNvSpPr>
+            <a:spLocks noGrp="1"/>
+          </p:cNvSpPr>
+          <p:nvPr>
+            <p:ph type="body" idx="3" sz="quarter"/>
+          </p:nvPr>
+        </p:nvSpPr>
+        <p:spPr/>
+        <p:txBody>
+          <a:bodyPr/>
+          <a:lstStyle/>
+          <a:p>
+            <a:r>
               <a:t>I’ll close where I started.</a:t>
             </a:r>
           </a:p>
           <a:p/>
           <a:p>
             <a:r>
-              <a:t>In the first sixty days I won’t invent a new EMEA. I’ll diagnose the real constraints with data and AE/SDR truth. I’ll protect the automation, ICP, and cadence already creating pipeline. I’ll train the team on workflow, context, and execution — four wedges, clean competitive frames. I’ll run one or two measured experiments and keep or kill them on metrics. And I’ll lead as a player-coach so the floor rises with the ceiling.</a:t>
+              <a:t>In the first sixty days I won’t invent a new EMEA. I’ll diagnose the real constraints with data and AE truth — especially qualified versus unqualified meetings. I’ll protect the pitch and the right-person discipline that’s already working. I’ll train and raise activity only after we fix openers, objections, and discovery. I’ll run faster loops with Growth, AEs, and SEs. And I’ll lead as a player-coach — Tell, Show, Observe, Feedback — so the floor rises with the ceiling.</a:t>
             </a:r>
           </a:p>
           <a:p/>
@@ -1886,7 +1926,7 @@
           <a:p/>
           <a:p>
             <a:r>
-              <a:t>Part three is craft — how I’d pitch, how we cut through noise by persona, and why Cursor wins, including Copilot and Claude Code.</a:t>
+              <a:t>Part three is lighter on slides and partly live — about ten minutes. I’ll show how I’d earn a first meeting, how that changes by persona, how I cut through noise, and why I believe Cursor wins. I’m drawing from the whiteboard motion, not a rehearsed script.</a:t>
             </a:r>
           </a:p>
           <a:p/>
@@ -9356,13 +9396,13 @@
               </a:spcAft>
             </a:pPr>
             <a:r>
-              <a:rPr sz="1700" b="0">
+              <a:rPr sz="1600" b="0">
                 <a:solidFill>
                   <a:srgbClr val="26251E"/>
                 </a:solidFill>
                 <a:latin typeface="Arial"/>
               </a:rPr>
-              <a:t>•  Judgment — which account and persona deserve the dial</a:t>
+              <a:t>•  AI takes the rote work — humans still want to be sold to by humans</a:t>
             </a:r>
           </a:p>
           <a:p>
@@ -9372,13 +9412,13 @@
               </a:spcAft>
             </a:pPr>
             <a:r>
-              <a:rPr sz="1700" b="0">
+              <a:rPr sz="1600" b="0">
                 <a:solidFill>
                   <a:srgbClr val="26251E"/>
                 </a:solidFill>
                 <a:latin typeface="Arial"/>
               </a:rPr>
-              <a:t>•  Relevance speed — earn 30 seconds with a technical buyer</a:t>
+              <a:t>•  Humanize messaging and cold calls — stand out by helping, not spamming</a:t>
             </a:r>
           </a:p>
           <a:p>
@@ -9388,13 +9428,13 @@
               </a:spcAft>
             </a:pPr>
             <a:r>
-              <a:rPr sz="1700" b="0">
+              <a:rPr sz="1600" b="0">
                 <a:solidFill>
                   <a:srgbClr val="26251E"/>
                 </a:solidFill>
                 <a:latin typeface="Arial"/>
               </a:rPr>
-              <a:t>•  Positioning fluency — workflow, context, execution, correct wedge</a:t>
+              <a:t>•  Exceptional: AI for prep + genuine discovery, care, current-state pain, use-case stories</a:t>
             </a:r>
           </a:p>
           <a:p>
@@ -9404,13 +9444,13 @@
               </a:spcAft>
             </a:pPr>
             <a:r>
-              <a:rPr sz="1700" b="0">
+              <a:rPr sz="1600" b="0">
                 <a:solidFill>
                   <a:srgbClr val="26251E"/>
                 </a:solidFill>
                 <a:latin typeface="Arial"/>
               </a:rPr>
-              <a:t>•  Competitive clarity — Copilot + Claude Code + Windsurf without trash talk</a:t>
+              <a:t>•  Skills: org/time management · research/intuition · written &amp; verbal</a:t>
             </a:r>
           </a:p>
           <a:p>
@@ -9420,13 +9460,13 @@
               </a:spcAft>
             </a:pPr>
             <a:r>
-              <a:rPr sz="1700" b="0">
+              <a:rPr sz="1600" b="0">
                 <a:solidFill>
                   <a:srgbClr val="26251E"/>
                 </a:solidFill>
                 <a:latin typeface="Arial"/>
               </a:rPr>
-              <a:t>•  Security instincts — calm on Privacy Mode and enterprise controls</a:t>
+              <a:t>•  Active listening + adaptability — carry the conversation and react with value</a:t>
             </a:r>
           </a:p>
           <a:p>
@@ -9436,29 +9476,13 @@
               </a:spcAft>
             </a:pPr>
             <a:r>
-              <a:rPr sz="1700" b="0">
+              <a:rPr sz="1600" b="0">
                 <a:solidFill>
                   <a:srgbClr val="26251E"/>
                 </a:solidFill>
                 <a:latin typeface="Arial"/>
               </a:rPr>
-              <a:t>•  Execution discipline — trains on time</a:t>
-            </a:r>
-          </a:p>
-          <a:p>
-            <a:pPr algn="l">
-              <a:spcAft>
-                <a:spcPts val="1100"/>
-              </a:spcAft>
-            </a:pPr>
-            <a:r>
-              <a:rPr sz="1700" b="0">
-                <a:solidFill>
-                  <a:srgbClr val="26251E"/>
-                </a:solidFill>
-                <a:latin typeface="Arial"/>
-              </a:rPr>
-              <a:t>•  Bar: diagnose the buyer’s constraint and match Cursor to it — don’t recite features</a:t>
+              <a:t>•  Objection handling + storytelling — technical pain and business value</a:t>
             </a:r>
           </a:p>
         </p:txBody>
@@ -9621,7 +9645,7 @@
                 </a:solidFill>
                 <a:latin typeface="Arial"/>
               </a:rPr>
-              <a:t>Hiring + coaching</a:t>
+              <a:t>Hiring great talent</a:t>
             </a:r>
           </a:p>
         </p:txBody>
@@ -9785,7 +9809,7 @@
                 </a:solidFill>
                 <a:latin typeface="Arial"/>
               </a:rPr>
-              <a:t>Hiring bar</a:t>
+              <a:t>Bar</a:t>
             </a:r>
           </a:p>
         </p:txBody>
@@ -9824,7 +9848,7 @@
                 </a:solidFill>
                 <a:latin typeface="Arial"/>
               </a:rPr>
-              <a:t>•  Coachable, clear communicators, curious about technical buyers, process discipline, learn fast</a:t>
+              <a:t>•  Excited every day — can I see them in the next role?</a:t>
             </a:r>
           </a:p>
           <a:p>
@@ -9840,7 +9864,7 @@
                 </a:solidFill>
                 <a:latin typeface="Arial"/>
               </a:rPr>
-              <a:t>•  Hard nos: feature dumpers, activity theater, can’t take critique, overclaim the product</a:t>
+              <a:t>•  1–2 years sales or technical / high-intelligence background</a:t>
             </a:r>
           </a:p>
           <a:p>
@@ -9856,7 +9880,23 @@
                 </a:solidFill>
                 <a:latin typeface="Arial"/>
               </a:rPr>
-              <a:t>•  Assess: mock call (VP Eng / Platform), Copilot + Claude Code objections, 60-sec Cursor pitch, soft security question</a:t>
+              <a:t>•  Teachers &amp; career-switchers often win — they learn concepts fast</a:t>
+            </a:r>
+          </a:p>
+          <a:p>
+            <a:pPr algn="l">
+              <a:spcAft>
+                <a:spcPts val="700"/>
+              </a:spcAft>
+            </a:pPr>
+            <a:r>
+              <a:rPr sz="1400" b="0">
+                <a:solidFill>
+                  <a:srgbClr val="26251E"/>
+                </a:solidFill>
+                <a:latin typeface="Arial"/>
+              </a:rPr>
+              <a:t>•  LinkedIn Recruiter · prefer native language for the role</a:t>
             </a:r>
           </a:p>
         </p:txBody>
@@ -9977,7 +10017,7 @@
                 </a:solidFill>
                 <a:latin typeface="Arial"/>
               </a:rPr>
-              <a:t>Coaching system</a:t>
+              <a:t>Must-haves</a:t>
             </a:r>
           </a:p>
         </p:txBody>
@@ -10016,7 +10056,7 @@
                 </a:solidFill>
                 <a:latin typeface="Arial"/>
               </a:rPr>
-              <a:t>•  Daily scoreboard + same-day course-correction</a:t>
+              <a:t>•  Intelligence — can gain knowledge</a:t>
             </a:r>
           </a:p>
           <a:p>
@@ -10032,7 +10072,7 @@
                 </a:solidFill>
                 <a:latin typeface="Arial"/>
               </a:rPr>
-              <a:t>•  Weekly 1:1s — one funnel leak only</a:t>
+              <a:t>•  Drive — will gain the skills</a:t>
             </a:r>
           </a:p>
           <a:p>
@@ -10048,7 +10088,7 @@
                 </a:solidFill>
                 <a:latin typeface="Arial"/>
               </a:rPr>
-              <a:t>•  Weekly team: one win wire + one talk-track upgrade</a:t>
+              <a:t>•  Coachable — adapt to change</a:t>
             </a:r>
           </a:p>
           <a:p>
@@ -10064,7 +10104,7 @@
                 </a:solidFill>
                 <a:latin typeface="Arial"/>
               </a:rPr>
-              <a:t>•  Call reviews: opener, wedge, competitive frame, clean ask</a:t>
+              <a:t>•  Integrity — honest</a:t>
             </a:r>
           </a:p>
           <a:p>
@@ -10080,7 +10120,7 @@
                 </a:solidFill>
                 <a:latin typeface="Arial"/>
               </a:rPr>
-              <a:t>•  Underperformance = stage diagnosis + skill plan + timeline</a:t>
+              <a:t>•  Obsessed with AI + Cursor — not just “hot company”</a:t>
             </a:r>
           </a:p>
         </p:txBody>
@@ -10146,9 +10186,52 @@
           </a:p>
         </p:txBody>
       </p:sp>
+      <p:sp>
+        <p:nvSpPr>
+          <p:cNvPr id="3" name="Rectangle 2"/>
+          <p:cNvSpPr/>
+          <p:nvPr/>
+        </p:nvSpPr>
+        <p:spPr>
+          <a:xfrm>
+            <a:off x="0" y="0"/>
+            <a:ext cx="12191695" cy="1051560"/>
+          </a:xfrm>
+          <a:prstGeom prst="rect">
+            <a:avLst/>
+          </a:prstGeom>
+          <a:solidFill>
+            <a:srgbClr val="26251E"/>
+          </a:solidFill>
+          <a:ln>
+            <a:noFill/>
+          </a:ln>
+        </p:spPr>
+        <p:style>
+          <a:lnRef idx="1">
+            <a:schemeClr val="accent1"/>
+          </a:lnRef>
+          <a:fillRef idx="3">
+            <a:schemeClr val="accent1"/>
+          </a:fillRef>
+          <a:effectRef idx="2">
+            <a:schemeClr val="accent1"/>
+          </a:effectRef>
+          <a:fontRef idx="minor">
+            <a:schemeClr val="lt1"/>
+          </a:fontRef>
+        </p:style>
+        <p:txBody>
+          <a:bodyPr rtlCol="0" anchor="ctr"/>
+          <a:lstStyle/>
+          <a:p>
+            <a:pPr algn="ctr"/>
+          </a:p>
+        </p:txBody>
+      </p:sp>
       <p:pic>
         <p:nvPicPr>
-          <p:cNvPr id="3" name="Picture 2" descr="cursor-lockup-dark.png"/>
+          <p:cNvPr id="4" name="Picture 3" descr="cursor-lockup-light.png"/>
           <p:cNvPicPr>
             <a:picLocks noChangeAspect="1"/>
           </p:cNvPicPr>
@@ -10162,8 +10245,8 @@
         </p:blipFill>
         <p:spPr>
           <a:xfrm>
-            <a:off x="777240" y="502920"/>
-            <a:ext cx="1645920" cy="391326"/>
+            <a:off x="640080" y="292608"/>
+            <a:ext cx="1234440" cy="293494"/>
           </a:xfrm>
           <a:prstGeom prst="rect">
             <a:avLst/>
@@ -10172,14 +10255,49 @@
       </p:pic>
       <p:sp>
         <p:nvSpPr>
-          <p:cNvPr id="4" name="Rectangle 3"/>
+          <p:cNvPr id="5" name="TextBox 4"/>
+          <p:cNvSpPr txBox="1"/>
+          <p:nvPr/>
+        </p:nvSpPr>
+        <p:spPr>
+          <a:xfrm>
+            <a:off x="2103120" y="292608"/>
+            <a:ext cx="9326880" cy="502920"/>
+          </a:xfrm>
+          <a:prstGeom prst="rect">
+            <a:avLst/>
+          </a:prstGeom>
+          <a:noFill/>
+        </p:spPr>
+        <p:txBody>
+          <a:bodyPr wrap="square" anchor="t">
+            <a:spAutoFit/>
+          </a:bodyPr>
+          <a:lstStyle/>
+          <a:p>
+            <a:pPr algn="l"/>
+            <a:r>
+              <a:rPr sz="2200" b="0">
+                <a:solidFill>
+                  <a:srgbClr val="FFFFFF"/>
+                </a:solidFill>
+                <a:latin typeface="Arial"/>
+              </a:rPr>
+              <a:t>Coaching system — Tell → Show → Observe → Feedback</a:t>
+            </a:r>
+          </a:p>
+        </p:txBody>
+      </p:sp>
+      <p:sp>
+        <p:nvSpPr>
+          <p:cNvPr id="6" name="Rectangle 5"/>
           <p:cNvSpPr/>
           <p:nvPr/>
         </p:nvSpPr>
         <p:spPr>
           <a:xfrm>
-            <a:off x="777240" y="2331720"/>
-            <a:ext cx="1234440" cy="54864"/>
+            <a:off x="0" y="1051560"/>
+            <a:ext cx="12191695" cy="54864"/>
           </a:xfrm>
           <a:prstGeom prst="rect">
             <a:avLst/>
@@ -10215,14 +10333,14 @@
       </p:sp>
       <p:sp>
         <p:nvSpPr>
-          <p:cNvPr id="5" name="TextBox 4"/>
+          <p:cNvPr id="7" name="TextBox 6"/>
           <p:cNvSpPr txBox="1"/>
           <p:nvPr/>
         </p:nvSpPr>
         <p:spPr>
           <a:xfrm>
-            <a:off x="777240" y="2560320"/>
-            <a:ext cx="10058400" cy="320040"/>
+            <a:off x="731520" y="1371600"/>
+            <a:ext cx="10607040" cy="4663440"/>
           </a:xfrm>
           <a:prstGeom prst="rect">
             <a:avLst/>
@@ -10230,55 +10348,88 @@
           <a:noFill/>
         </p:spPr>
         <p:txBody>
-          <a:bodyPr wrap="square" anchor="t">
+          <a:bodyPr wrap="square">
             <a:spAutoFit/>
           </a:bodyPr>
           <a:lstStyle/>
           <a:p>
-            <a:pPr algn="l"/>
-            <a:r>
-              <a:rPr sz="1300" b="1">
-                <a:solidFill>
-                  <a:srgbClr val="F54E00"/>
-                </a:solidFill>
-                <a:latin typeface="Arial"/>
-              </a:rPr>
-              <a:t>PART 3</a:t>
-            </a:r>
-          </a:p>
-        </p:txBody>
-      </p:sp>
-      <p:sp>
-        <p:nvSpPr>
-          <p:cNvPr id="6" name="TextBox 5"/>
-          <p:cNvSpPr txBox="1"/>
-          <p:nvPr/>
-        </p:nvSpPr>
-        <p:spPr>
-          <a:xfrm>
-            <a:off x="777240" y="3017520"/>
-            <a:ext cx="10607040" cy="1097280"/>
-          </a:xfrm>
-          <a:prstGeom prst="rect">
-            <a:avLst/>
-          </a:prstGeom>
-          <a:noFill/>
-        </p:spPr>
-        <p:txBody>
-          <a:bodyPr wrap="square" anchor="t">
-            <a:spAutoFit/>
-          </a:bodyPr>
-          <a:lstStyle/>
-          <a:p>
-            <a:pPr algn="l"/>
-            <a:r>
-              <a:rPr sz="3000" b="0">
+            <a:pPr algn="l">
+              <a:spcAft>
+                <a:spcPts val="1100"/>
+              </a:spcAft>
+            </a:pPr>
+            <a:r>
+              <a:rPr sz="1500" b="0">
                 <a:solidFill>
                   <a:srgbClr val="26251E"/>
                 </a:solidFill>
                 <a:latin typeface="Arial"/>
               </a:rPr>
-              <a:t>Craft and curiosity — happy to go live here</a:t>
+              <a:t>•  Tell (what / who / why) → Show good → Observe (let them struggle) → Feedback (ask them first) → Repeat</a:t>
+            </a:r>
+          </a:p>
+          <a:p>
+            <a:pPr algn="l">
+              <a:spcAft>
+                <a:spcPts val="1100"/>
+              </a:spcAft>
+            </a:pPr>
+            <a:r>
+              <a:rPr sz="1500" b="0">
+                <a:solidFill>
+                  <a:srgbClr val="26251E"/>
+                </a:solidFill>
+                <a:latin typeface="Arial"/>
+              </a:rPr>
+              <a:t>•  Ramp: 90-day plan by week + homework + buddy system + heavy on the why</a:t>
+            </a:r>
+          </a:p>
+          <a:p>
+            <a:pPr algn="l">
+              <a:spcAft>
+                <a:spcPts val="1100"/>
+              </a:spcAft>
+            </a:pPr>
+            <a:r>
+              <a:rPr sz="1500" b="0">
+                <a:solidFill>
+                  <a:srgbClr val="26251E"/>
+                </a:solidFill>
+                <a:latin typeface="Arial"/>
+              </a:rPr>
+              <a:t>•  Top performers: learn motivation early · catch them doing good · make them mentors</a:t>
+            </a:r>
+          </a:p>
+          <a:p>
+            <a:pPr algn="l">
+              <a:spcAft>
+                <a:spcPts val="1100"/>
+              </a:spcAft>
+            </a:pPr>
+            <a:r>
+              <a:rPr sz="1500" b="0">
+                <a:solidFill>
+                  <a:srgbClr val="26251E"/>
+                </a:solidFill>
+                <a:latin typeface="Arial"/>
+              </a:rPr>
+              <a:t>•  Underperformance: coaching plan as soon as someone is off track — structure early</a:t>
+            </a:r>
+          </a:p>
+          <a:p>
+            <a:pPr algn="l">
+              <a:spcAft>
+                <a:spcPts val="1100"/>
+              </a:spcAft>
+            </a:pPr>
+            <a:r>
+              <a:rPr sz="1500" b="0">
+                <a:solidFill>
+                  <a:srgbClr val="26251E"/>
+                </a:solidFill>
+                <a:latin typeface="Arial"/>
+              </a:rPr>
+              <a:t>•  Culture: scoreboards · competitions · collaboration · Friday shoutouts for someone else</a:t>
             </a:r>
           </a:p>
         </p:txBody>
@@ -10344,52 +10495,9 @@
           </a:p>
         </p:txBody>
       </p:sp>
-      <p:sp>
-        <p:nvSpPr>
-          <p:cNvPr id="3" name="Rectangle 2"/>
-          <p:cNvSpPr/>
-          <p:nvPr/>
-        </p:nvSpPr>
-        <p:spPr>
-          <a:xfrm>
-            <a:off x="0" y="0"/>
-            <a:ext cx="12191695" cy="1051560"/>
-          </a:xfrm>
-          <a:prstGeom prst="rect">
-            <a:avLst/>
-          </a:prstGeom>
-          <a:solidFill>
-            <a:srgbClr val="26251E"/>
-          </a:solidFill>
-          <a:ln>
-            <a:noFill/>
-          </a:ln>
-        </p:spPr>
-        <p:style>
-          <a:lnRef idx="1">
-            <a:schemeClr val="accent1"/>
-          </a:lnRef>
-          <a:fillRef idx="3">
-            <a:schemeClr val="accent1"/>
-          </a:fillRef>
-          <a:effectRef idx="2">
-            <a:schemeClr val="accent1"/>
-          </a:effectRef>
-          <a:fontRef idx="minor">
-            <a:schemeClr val="lt1"/>
-          </a:fontRef>
-        </p:style>
-        <p:txBody>
-          <a:bodyPr rtlCol="0" anchor="ctr"/>
-          <a:lstStyle/>
-          <a:p>
-            <a:pPr algn="ctr"/>
-          </a:p>
-        </p:txBody>
-      </p:sp>
       <p:pic>
         <p:nvPicPr>
-          <p:cNvPr id="4" name="Picture 3" descr="cursor-lockup-light.png"/>
+          <p:cNvPr id="3" name="Picture 2" descr="cursor-lockup-dark.png"/>
           <p:cNvPicPr>
             <a:picLocks noChangeAspect="1"/>
           </p:cNvPicPr>
@@ -10403,8 +10511,8 @@
         </p:blipFill>
         <p:spPr>
           <a:xfrm>
-            <a:off x="640080" y="292608"/>
-            <a:ext cx="1234440" cy="293494"/>
+            <a:off x="777240" y="502920"/>
+            <a:ext cx="1645920" cy="391326"/>
           </a:xfrm>
           <a:prstGeom prst="rect">
             <a:avLst/>
@@ -10413,49 +10521,14 @@
       </p:pic>
       <p:sp>
         <p:nvSpPr>
-          <p:cNvPr id="5" name="TextBox 4"/>
-          <p:cNvSpPr txBox="1"/>
-          <p:nvPr/>
-        </p:nvSpPr>
-        <p:spPr>
-          <a:xfrm>
-            <a:off x="2103120" y="292608"/>
-            <a:ext cx="9326880" cy="502920"/>
-          </a:xfrm>
-          <a:prstGeom prst="rect">
-            <a:avLst/>
-          </a:prstGeom>
-          <a:noFill/>
-        </p:spPr>
-        <p:txBody>
-          <a:bodyPr wrap="square" anchor="t">
-            <a:spAutoFit/>
-          </a:bodyPr>
-          <a:lstStyle/>
-          <a:p>
-            <a:pPr algn="l"/>
-            <a:r>
-              <a:rPr sz="2200" b="0">
-                <a:solidFill>
-                  <a:srgbClr val="FFFFFF"/>
-                </a:solidFill>
-                <a:latin typeface="Arial"/>
-              </a:rPr>
-              <a:t>Live pitch spine: open → position → wedge → ask</a:t>
-            </a:r>
-          </a:p>
-        </p:txBody>
-      </p:sp>
-      <p:sp>
-        <p:nvSpPr>
-          <p:cNvPr id="6" name="Rectangle 5"/>
+          <p:cNvPr id="4" name="Rectangle 3"/>
           <p:cNvSpPr/>
           <p:nvPr/>
         </p:nvSpPr>
         <p:spPr>
           <a:xfrm>
-            <a:off x="0" y="1051560"/>
-            <a:ext cx="12191695" cy="54864"/>
+            <a:off x="777240" y="2331720"/>
+            <a:ext cx="1234440" cy="54864"/>
           </a:xfrm>
           <a:prstGeom prst="rect">
             <a:avLst/>
@@ -10491,14 +10564,14 @@
       </p:sp>
       <p:sp>
         <p:nvSpPr>
-          <p:cNvPr id="7" name="TextBox 6"/>
+          <p:cNvPr id="5" name="TextBox 4"/>
           <p:cNvSpPr txBox="1"/>
           <p:nvPr/>
         </p:nvSpPr>
         <p:spPr>
           <a:xfrm>
-            <a:off x="731520" y="1280160"/>
-            <a:ext cx="594360" cy="292608"/>
+            <a:off x="777240" y="2560320"/>
+            <a:ext cx="10058400" cy="320040"/>
           </a:xfrm>
           <a:prstGeom prst="rect">
             <a:avLst/>
@@ -10513,27 +10586,27 @@
           <a:p>
             <a:pPr algn="l"/>
             <a:r>
-              <a:rPr sz="1600" b="1">
-                <a:solidFill>
-                  <a:srgbClr val="26251E"/>
-                </a:solidFill>
-                <a:latin typeface="Arial"/>
-              </a:rPr>
-              <a:t>01</a:t>
-            </a:r>
-          </a:p>
-        </p:txBody>
-      </p:sp>
-      <p:sp>
-        <p:nvSpPr>
-          <p:cNvPr id="8" name="TextBox 7"/>
+              <a:rPr sz="1300" b="1">
+                <a:solidFill>
+                  <a:srgbClr val="F54E00"/>
+                </a:solidFill>
+                <a:latin typeface="Arial"/>
+              </a:rPr>
+              <a:t>PART 3</a:t>
+            </a:r>
+          </a:p>
+        </p:txBody>
+      </p:sp>
+      <p:sp>
+        <p:nvSpPr>
+          <p:cNvPr id="6" name="TextBox 5"/>
           <p:cNvSpPr txBox="1"/>
           <p:nvPr/>
         </p:nvSpPr>
         <p:spPr>
           <a:xfrm>
-            <a:off x="1371600" y="1280160"/>
-            <a:ext cx="9966960" cy="274320"/>
+            <a:off x="777240" y="3017520"/>
+            <a:ext cx="10607040" cy="1097280"/>
           </a:xfrm>
           <a:prstGeom prst="rect">
             <a:avLst/>
@@ -10548,363 +10621,13 @@
           <a:p>
             <a:pPr algn="l"/>
             <a:r>
-              <a:rPr sz="1500" b="1">
+              <a:rPr sz="3000" b="0">
                 <a:solidFill>
                   <a:srgbClr val="26251E"/>
                 </a:solidFill>
                 <a:latin typeface="Arial"/>
               </a:rPr>
-              <a:t>Open</a:t>
-            </a:r>
-          </a:p>
-        </p:txBody>
-      </p:sp>
-      <p:sp>
-        <p:nvSpPr>
-          <p:cNvPr id="9" name="TextBox 8"/>
-          <p:cNvSpPr txBox="1"/>
-          <p:nvPr/>
-        </p:nvSpPr>
-        <p:spPr>
-          <a:xfrm>
-            <a:off x="1371600" y="1572768"/>
-            <a:ext cx="9966960" cy="457200"/>
-          </a:xfrm>
-          <a:prstGeom prst="rect">
-            <a:avLst/>
-          </a:prstGeom>
-          <a:noFill/>
-        </p:spPr>
-        <p:txBody>
-          <a:bodyPr wrap="square" anchor="t">
-            <a:spAutoFit/>
-          </a:bodyPr>
-          <a:lstStyle/>
-          <a:p>
-            <a:pPr algn="l"/>
-            <a:r>
-              <a:rPr sz="1300" b="0">
-                <a:solidFill>
-                  <a:srgbClr val="807D72"/>
-                </a:solidFill>
-                <a:latin typeface="Arial"/>
-              </a:rPr>
-              <a:t>From AI that helps write snippets → AI that helps complete work across the codebase.</a:t>
-            </a:r>
-          </a:p>
-        </p:txBody>
-      </p:sp>
-      <p:sp>
-        <p:nvSpPr>
-          <p:cNvPr id="10" name="TextBox 9"/>
-          <p:cNvSpPr txBox="1"/>
-          <p:nvPr/>
-        </p:nvSpPr>
-        <p:spPr>
-          <a:xfrm>
-            <a:off x="731520" y="2331720"/>
-            <a:ext cx="594360" cy="292608"/>
-          </a:xfrm>
-          <a:prstGeom prst="rect">
-            <a:avLst/>
-          </a:prstGeom>
-          <a:noFill/>
-        </p:spPr>
-        <p:txBody>
-          <a:bodyPr wrap="square" anchor="t">
-            <a:spAutoFit/>
-          </a:bodyPr>
-          <a:lstStyle/>
-          <a:p>
-            <a:pPr algn="l"/>
-            <a:r>
-              <a:rPr sz="1600" b="1">
-                <a:solidFill>
-                  <a:srgbClr val="26251E"/>
-                </a:solidFill>
-                <a:latin typeface="Arial"/>
-              </a:rPr>
-              <a:t>02</a:t>
-            </a:r>
-          </a:p>
-        </p:txBody>
-      </p:sp>
-      <p:sp>
-        <p:nvSpPr>
-          <p:cNvPr id="11" name="TextBox 10"/>
-          <p:cNvSpPr txBox="1"/>
-          <p:nvPr/>
-        </p:nvSpPr>
-        <p:spPr>
-          <a:xfrm>
-            <a:off x="1371600" y="2331720"/>
-            <a:ext cx="9966960" cy="274320"/>
-          </a:xfrm>
-          <a:prstGeom prst="rect">
-            <a:avLst/>
-          </a:prstGeom>
-          <a:noFill/>
-        </p:spPr>
-        <p:txBody>
-          <a:bodyPr wrap="square" anchor="t">
-            <a:spAutoFit/>
-          </a:bodyPr>
-          <a:lstStyle/>
-          <a:p>
-            <a:pPr algn="l"/>
-            <a:r>
-              <a:rPr sz="1500" b="1">
-                <a:solidFill>
-                  <a:srgbClr val="26251E"/>
-                </a:solidFill>
-                <a:latin typeface="Arial"/>
-              </a:rPr>
-              <a:t>Position</a:t>
-            </a:r>
-          </a:p>
-        </p:txBody>
-      </p:sp>
-      <p:sp>
-        <p:nvSpPr>
-          <p:cNvPr id="12" name="TextBox 11"/>
-          <p:cNvSpPr txBox="1"/>
-          <p:nvPr/>
-        </p:nvSpPr>
-        <p:spPr>
-          <a:xfrm>
-            <a:off x="1371600" y="2624328"/>
-            <a:ext cx="9966960" cy="457200"/>
-          </a:xfrm>
-          <a:prstGeom prst="rect">
-            <a:avLst/>
-          </a:prstGeom>
-          <a:noFill/>
-        </p:spPr>
-        <p:txBody>
-          <a:bodyPr wrap="square" anchor="t">
-            <a:spAutoFit/>
-          </a:bodyPr>
-          <a:lstStyle/>
-          <a:p>
-            <a:pPr algn="l"/>
-            <a:r>
-              <a:rPr sz="1300" b="0">
-                <a:solidFill>
-                  <a:srgbClr val="807D72"/>
-                </a:solidFill>
-                <a:latin typeface="Arial"/>
-              </a:rPr>
-              <a:t>Agentic coding platform across IDE, CLI, Automations, Cloud Agents — shared AI layer on your codebase.</a:t>
-            </a:r>
-          </a:p>
-        </p:txBody>
-      </p:sp>
-      <p:sp>
-        <p:nvSpPr>
-          <p:cNvPr id="13" name="TextBox 12"/>
-          <p:cNvSpPr txBox="1"/>
-          <p:nvPr/>
-        </p:nvSpPr>
-        <p:spPr>
-          <a:xfrm>
-            <a:off x="731520" y="3383280"/>
-            <a:ext cx="594360" cy="292608"/>
-          </a:xfrm>
-          <a:prstGeom prst="rect">
-            <a:avLst/>
-          </a:prstGeom>
-          <a:noFill/>
-        </p:spPr>
-        <p:txBody>
-          <a:bodyPr wrap="square" anchor="t">
-            <a:spAutoFit/>
-          </a:bodyPr>
-          <a:lstStyle/>
-          <a:p>
-            <a:pPr algn="l"/>
-            <a:r>
-              <a:rPr sz="1600" b="1">
-                <a:solidFill>
-                  <a:srgbClr val="26251E"/>
-                </a:solidFill>
-                <a:latin typeface="Arial"/>
-              </a:rPr>
-              <a:t>03</a:t>
-            </a:r>
-          </a:p>
-        </p:txBody>
-      </p:sp>
-      <p:sp>
-        <p:nvSpPr>
-          <p:cNvPr id="14" name="TextBox 13"/>
-          <p:cNvSpPr txBox="1"/>
-          <p:nvPr/>
-        </p:nvSpPr>
-        <p:spPr>
-          <a:xfrm>
-            <a:off x="1371600" y="3383280"/>
-            <a:ext cx="9966960" cy="274320"/>
-          </a:xfrm>
-          <a:prstGeom prst="rect">
-            <a:avLst/>
-          </a:prstGeom>
-          <a:noFill/>
-        </p:spPr>
-        <p:txBody>
-          <a:bodyPr wrap="square" anchor="t">
-            <a:spAutoFit/>
-          </a:bodyPr>
-          <a:lstStyle/>
-          <a:p>
-            <a:pPr algn="l"/>
-            <a:r>
-              <a:rPr sz="1500" b="1">
-                <a:solidFill>
-                  <a:srgbClr val="26251E"/>
-                </a:solidFill>
-                <a:latin typeface="Arial"/>
-              </a:rPr>
-              <a:t>Wedge</a:t>
-            </a:r>
-          </a:p>
-        </p:txBody>
-      </p:sp>
-      <p:sp>
-        <p:nvSpPr>
-          <p:cNvPr id="15" name="TextBox 14"/>
-          <p:cNvSpPr txBox="1"/>
-          <p:nvPr/>
-        </p:nvSpPr>
-        <p:spPr>
-          <a:xfrm>
-            <a:off x="1371600" y="3675888"/>
-            <a:ext cx="9966960" cy="457200"/>
-          </a:xfrm>
-          <a:prstGeom prst="rect">
-            <a:avLst/>
-          </a:prstGeom>
-          <a:noFill/>
-        </p:spPr>
-        <p:txBody>
-          <a:bodyPr wrap="square" anchor="t">
-            <a:spAutoFit/>
-          </a:bodyPr>
-          <a:lstStyle/>
-          <a:p>
-            <a:pPr algn="l"/>
-            <a:r>
-              <a:rPr sz="1300" b="0">
-                <a:solidFill>
-                  <a:srgbClr val="807D72"/>
-                </a:solidFill>
-                <a:latin typeface="Arial"/>
-              </a:rPr>
-              <a:t>Pick one differentiator based on what you heard.</a:t>
-            </a:r>
-          </a:p>
-        </p:txBody>
-      </p:sp>
-      <p:sp>
-        <p:nvSpPr>
-          <p:cNvPr id="16" name="TextBox 15"/>
-          <p:cNvSpPr txBox="1"/>
-          <p:nvPr/>
-        </p:nvSpPr>
-        <p:spPr>
-          <a:xfrm>
-            <a:off x="731520" y="4434840"/>
-            <a:ext cx="594360" cy="292608"/>
-          </a:xfrm>
-          <a:prstGeom prst="rect">
-            <a:avLst/>
-          </a:prstGeom>
-          <a:noFill/>
-        </p:spPr>
-        <p:txBody>
-          <a:bodyPr wrap="square" anchor="t">
-            <a:spAutoFit/>
-          </a:bodyPr>
-          <a:lstStyle/>
-          <a:p>
-            <a:pPr algn="l"/>
-            <a:r>
-              <a:rPr sz="1600" b="1">
-                <a:solidFill>
-                  <a:srgbClr val="26251E"/>
-                </a:solidFill>
-                <a:latin typeface="Arial"/>
-              </a:rPr>
-              <a:t>04</a:t>
-            </a:r>
-          </a:p>
-        </p:txBody>
-      </p:sp>
-      <p:sp>
-        <p:nvSpPr>
-          <p:cNvPr id="17" name="TextBox 16"/>
-          <p:cNvSpPr txBox="1"/>
-          <p:nvPr/>
-        </p:nvSpPr>
-        <p:spPr>
-          <a:xfrm>
-            <a:off x="1371600" y="4434840"/>
-            <a:ext cx="9966960" cy="274320"/>
-          </a:xfrm>
-          <a:prstGeom prst="rect">
-            <a:avLst/>
-          </a:prstGeom>
-          <a:noFill/>
-        </p:spPr>
-        <p:txBody>
-          <a:bodyPr wrap="square" anchor="t">
-            <a:spAutoFit/>
-          </a:bodyPr>
-          <a:lstStyle/>
-          <a:p>
-            <a:pPr algn="l"/>
-            <a:r>
-              <a:rPr sz="1500" b="1">
-                <a:solidFill>
-                  <a:srgbClr val="26251E"/>
-                </a:solidFill>
-                <a:latin typeface="Arial"/>
-              </a:rPr>
-              <a:t>Ask</a:t>
-            </a:r>
-          </a:p>
-        </p:txBody>
-      </p:sp>
-      <p:sp>
-        <p:nvSpPr>
-          <p:cNvPr id="18" name="TextBox 17"/>
-          <p:cNvSpPr txBox="1"/>
-          <p:nvPr/>
-        </p:nvSpPr>
-        <p:spPr>
-          <a:xfrm>
-            <a:off x="1371600" y="4727448"/>
-            <a:ext cx="9966960" cy="457200"/>
-          </a:xfrm>
-          <a:prstGeom prst="rect">
-            <a:avLst/>
-          </a:prstGeom>
-          <a:noFill/>
-        </p:spPr>
-        <p:txBody>
-          <a:bodyPr wrap="square" anchor="t">
-            <a:spAutoFit/>
-          </a:bodyPr>
-          <a:lstStyle/>
-          <a:p>
-            <a:pPr algn="l"/>
-            <a:r>
-              <a:rPr sz="1300" b="0">
-                <a:solidFill>
-                  <a:srgbClr val="807D72"/>
-                </a:solidFill>
-                <a:latin typeface="Arial"/>
-              </a:rPr>
-              <a:t>Worth 20 minutes to map leverage vs where workflow still breaks — write, review, or ship?</a:t>
+              <a:t>Craft &amp; curiosity — lighter slides, mostly live</a:t>
             </a:r>
           </a:p>
         </p:txBody>
@@ -11067,7 +10790,7 @@
                 </a:solidFill>
                 <a:latin typeface="Arial"/>
               </a:rPr>
-              <a:t>Cutting through noise — persona-true outreach</a:t>
+              <a:t>Live pitch — earn the first meeting (whiteboard craft)</a:t>
             </a:r>
           </a:p>
         </p:txBody>
@@ -11123,8 +10846,8 @@
         </p:nvSpPr>
         <p:spPr>
           <a:xfrm>
-            <a:off x="731520" y="1371600"/>
-            <a:ext cx="10607040" cy="4663440"/>
+            <a:off x="731520" y="1280160"/>
+            <a:ext cx="594360" cy="292608"/>
           </a:xfrm>
           <a:prstGeom prst="rect">
             <a:avLst/>
@@ -11132,104 +10855,405 @@
           <a:noFill/>
         </p:spPr>
         <p:txBody>
-          <a:bodyPr wrap="square">
+          <a:bodyPr wrap="square" anchor="t">
             <a:spAutoFit/>
           </a:bodyPr>
           <a:lstStyle/>
           <a:p>
-            <a:pPr algn="l">
-              <a:spcAft>
-                <a:spcPts val="1100"/>
-              </a:spcAft>
-            </a:pPr>
-            <a:r>
-              <a:rPr sz="1500" b="0">
+            <a:pPr algn="l"/>
+            <a:r>
+              <a:rPr sz="1600" b="1">
                 <a:solidFill>
                   <a:srgbClr val="26251E"/>
                 </a:solidFill>
                 <a:latin typeface="Arial"/>
               </a:rPr>
-              <a:t>•  Hands-on developer: real-repo context + daily workflow (avoid corporate ROI theater)</a:t>
-            </a:r>
-          </a:p>
-          <a:p>
-            <a:pPr algn="l">
-              <a:spcAft>
-                <a:spcPts val="1100"/>
-              </a:spcAft>
-            </a:pPr>
-            <a:r>
-              <a:rPr sz="1500" b="0">
+              <a:t>01</a:t>
+            </a:r>
+          </a:p>
+        </p:txBody>
+      </p:sp>
+      <p:sp>
+        <p:nvSpPr>
+          <p:cNvPr id="8" name="TextBox 7"/>
+          <p:cNvSpPr txBox="1"/>
+          <p:nvPr/>
+        </p:nvSpPr>
+        <p:spPr>
+          <a:xfrm>
+            <a:off x="1371600" y="1280160"/>
+            <a:ext cx="9966960" cy="274320"/>
+          </a:xfrm>
+          <a:prstGeom prst="rect">
+            <a:avLst/>
+          </a:prstGeom>
+          <a:noFill/>
+        </p:spPr>
+        <p:txBody>
+          <a:bodyPr wrap="square" anchor="t">
+            <a:spAutoFit/>
+          </a:bodyPr>
+          <a:lstStyle/>
+          <a:p>
+            <a:pPr algn="l"/>
+            <a:r>
+              <a:rPr sz="1500" b="1">
                 <a:solidFill>
                   <a:srgbClr val="26251E"/>
                 </a:solidFill>
                 <a:latin typeface="Arial"/>
               </a:rPr>
-              <a:t>•  VP of Engineering: shared AI layer, SDLC speed, standardizing teams (avoid feature laundry lists)</a:t>
-            </a:r>
-          </a:p>
-          <a:p>
-            <a:pPr algn="l">
-              <a:spcAft>
-                <a:spcPts val="1100"/>
-              </a:spcAft>
-            </a:pPr>
-            <a:r>
-              <a:rPr sz="1500" b="0">
+              <a:t>Open</a:t>
+            </a:r>
+          </a:p>
+        </p:txBody>
+      </p:sp>
+      <p:sp>
+        <p:nvSpPr>
+          <p:cNvPr id="9" name="TextBox 8"/>
+          <p:cNvSpPr txBox="1"/>
+          <p:nvPr/>
+        </p:nvSpPr>
+        <p:spPr>
+          <a:xfrm>
+            <a:off x="1371600" y="1572768"/>
+            <a:ext cx="9966960" cy="457200"/>
+          </a:xfrm>
+          <a:prstGeom prst="rect">
+            <a:avLst/>
+          </a:prstGeom>
+          <a:noFill/>
+        </p:spPr>
+        <p:txBody>
+          <a:bodyPr wrap="square" anchor="t">
+            <a:spAutoFit/>
+          </a:bodyPr>
+          <a:lstStyle/>
+          <a:p>
+            <a:pPr algn="l"/>
+            <a:r>
+              <a:rPr sz="1300" b="0">
+                <a:solidFill>
+                  <a:srgbClr val="807D72"/>
+                </a:solidFill>
+                <a:latin typeface="Arial"/>
+              </a:rPr>
+              <a:t>Permission, not slide-ware. “What prompted the call?” — or: writing faster → stuck before production.</a:t>
+            </a:r>
+          </a:p>
+        </p:txBody>
+      </p:sp>
+      <p:sp>
+        <p:nvSpPr>
+          <p:cNvPr id="10" name="TextBox 9"/>
+          <p:cNvSpPr txBox="1"/>
+          <p:nvPr/>
+        </p:nvSpPr>
+        <p:spPr>
+          <a:xfrm>
+            <a:off x="731520" y="2331720"/>
+            <a:ext cx="594360" cy="292608"/>
+          </a:xfrm>
+          <a:prstGeom prst="rect">
+            <a:avLst/>
+          </a:prstGeom>
+          <a:noFill/>
+        </p:spPr>
+        <p:txBody>
+          <a:bodyPr wrap="square" anchor="t">
+            <a:spAutoFit/>
+          </a:bodyPr>
+          <a:lstStyle/>
+          <a:p>
+            <a:pPr algn="l"/>
+            <a:r>
+              <a:rPr sz="1600" b="1">
                 <a:solidFill>
                   <a:srgbClr val="26251E"/>
                 </a:solidFill>
                 <a:latin typeface="Arial"/>
               </a:rPr>
-              <a:t>•  Security / Platform: Privacy Mode, admin controls, governed rollout (avoid hype)</a:t>
-            </a:r>
-          </a:p>
-          <a:p>
-            <a:pPr algn="l">
-              <a:spcAft>
-                <a:spcPts val="1100"/>
-              </a:spcAft>
-            </a:pPr>
-            <a:r>
-              <a:rPr sz="1500" b="0">
+              <a:t>02</a:t>
+            </a:r>
+          </a:p>
+        </p:txBody>
+      </p:sp>
+      <p:sp>
+        <p:nvSpPr>
+          <p:cNvPr id="11" name="TextBox 10"/>
+          <p:cNvSpPr txBox="1"/>
+          <p:nvPr/>
+        </p:nvSpPr>
+        <p:spPr>
+          <a:xfrm>
+            <a:off x="1371600" y="2331720"/>
+            <a:ext cx="9966960" cy="274320"/>
+          </a:xfrm>
+          <a:prstGeom prst="rect">
+            <a:avLst/>
+          </a:prstGeom>
+          <a:noFill/>
+        </p:spPr>
+        <p:txBody>
+          <a:bodyPr wrap="square" anchor="t">
+            <a:spAutoFit/>
+          </a:bodyPr>
+          <a:lstStyle/>
+          <a:p>
+            <a:pPr algn="l"/>
+            <a:r>
+              <a:rPr sz="1500" b="1">
                 <a:solidFill>
                   <a:srgbClr val="26251E"/>
                 </a:solidFill>
                 <a:latin typeface="Arial"/>
               </a:rPr>
-              <a:t>•  Triggers that work: Copilot sprawl, AI policy, migrations, DevEx ownership + one sharp question</a:t>
-            </a:r>
-          </a:p>
-          <a:p>
-            <a:pPr algn="l">
-              <a:spcAft>
-                <a:spcPts val="1100"/>
-              </a:spcAft>
-            </a:pPr>
-            <a:r>
-              <a:rPr sz="1500" b="0">
+              <a:t>Diagnose</a:t>
+            </a:r>
+          </a:p>
+        </p:txBody>
+      </p:sp>
+      <p:sp>
+        <p:nvSpPr>
+          <p:cNvPr id="12" name="TextBox 11"/>
+          <p:cNvSpPr txBox="1"/>
+          <p:nvPr/>
+        </p:nvSpPr>
+        <p:spPr>
+          <a:xfrm>
+            <a:off x="1371600" y="2624328"/>
+            <a:ext cx="9966960" cy="457200"/>
+          </a:xfrm>
+          <a:prstGeom prst="rect">
+            <a:avLst/>
+          </a:prstGeom>
+          <a:noFill/>
+        </p:spPr>
+        <p:txBody>
+          <a:bodyPr wrap="square" anchor="t">
+            <a:spAutoFit/>
+          </a:bodyPr>
+          <a:lstStyle/>
+          <a:p>
+            <a:pPr algn="l"/>
+            <a:r>
+              <a:rPr sz="1300" b="0">
+                <a:solidFill>
+                  <a:srgbClr val="807D72"/>
+                </a:solidFill>
+                <a:latin typeface="Arial"/>
+              </a:rPr>
+              <a:t>Time split: KTLO / refactor / innovate / moonshot. Maturity: assisted → agentic → cloud → governed factory.</a:t>
+            </a:r>
+          </a:p>
+        </p:txBody>
+      </p:sp>
+      <p:sp>
+        <p:nvSpPr>
+          <p:cNvPr id="13" name="TextBox 12"/>
+          <p:cNvSpPr txBox="1"/>
+          <p:nvPr/>
+        </p:nvSpPr>
+        <p:spPr>
+          <a:xfrm>
+            <a:off x="731520" y="3383280"/>
+            <a:ext cx="594360" cy="292608"/>
+          </a:xfrm>
+          <a:prstGeom prst="rect">
+            <a:avLst/>
+          </a:prstGeom>
+          <a:noFill/>
+        </p:spPr>
+        <p:txBody>
+          <a:bodyPr wrap="square" anchor="t">
+            <a:spAutoFit/>
+          </a:bodyPr>
+          <a:lstStyle/>
+          <a:p>
+            <a:pPr algn="l"/>
+            <a:r>
+              <a:rPr sz="1600" b="1">
                 <a:solidFill>
                   <a:srgbClr val="26251E"/>
                 </a:solidFill>
                 <a:latin typeface="Arial"/>
               </a:rPr>
-              <a:t>•  Arm reps with proof: Coinbase (agent-first) · Stripe (rollout) · PayPal (enterprise velocity)</a:t>
-            </a:r>
-          </a:p>
-          <a:p>
-            <a:pPr algn="l">
-              <a:spcAft>
-                <a:spcPts val="1100"/>
-              </a:spcAft>
-            </a:pPr>
-            <a:r>
-              <a:rPr sz="1500" b="0">
+              <a:t>03</a:t>
+            </a:r>
+          </a:p>
+        </p:txBody>
+      </p:sp>
+      <p:sp>
+        <p:nvSpPr>
+          <p:cNvPr id="14" name="TextBox 13"/>
+          <p:cNvSpPr txBox="1"/>
+          <p:nvPr/>
+        </p:nvSpPr>
+        <p:spPr>
+          <a:xfrm>
+            <a:off x="1371600" y="3383280"/>
+            <a:ext cx="9966960" cy="274320"/>
+          </a:xfrm>
+          <a:prstGeom prst="rect">
+            <a:avLst/>
+          </a:prstGeom>
+          <a:noFill/>
+        </p:spPr>
+        <p:txBody>
+          <a:bodyPr wrap="square" anchor="t">
+            <a:spAutoFit/>
+          </a:bodyPr>
+          <a:lstStyle/>
+          <a:p>
+            <a:pPr algn="l"/>
+            <a:r>
+              <a:rPr sz="1500" b="1">
                 <a:solidFill>
                   <a:srgbClr val="26251E"/>
                 </a:solidFill>
                 <a:latin typeface="Arial"/>
               </a:rPr>
-              <a:t>•  What fails: generic “quick chat” spam and fake personalization</a:t>
+              <a:t>Position</a:t>
+            </a:r>
+          </a:p>
+        </p:txBody>
+      </p:sp>
+      <p:sp>
+        <p:nvSpPr>
+          <p:cNvPr id="15" name="TextBox 14"/>
+          <p:cNvSpPr txBox="1"/>
+          <p:nvPr/>
+        </p:nvSpPr>
+        <p:spPr>
+          <a:xfrm>
+            <a:off x="1371600" y="3675888"/>
+            <a:ext cx="9966960" cy="457200"/>
+          </a:xfrm>
+          <a:prstGeom prst="rect">
+            <a:avLst/>
+          </a:prstGeom>
+          <a:noFill/>
+        </p:spPr>
+        <p:txBody>
+          <a:bodyPr wrap="square" anchor="t">
+            <a:spAutoFit/>
+          </a:bodyPr>
+          <a:lstStyle/>
+          <a:p>
+            <a:pPr algn="l"/>
+            <a:r>
+              <a:rPr sz="1300" b="0">
+                <a:solidFill>
+                  <a:srgbClr val="807D72"/>
+                </a:solidFill>
+                <a:latin typeface="Arial"/>
+              </a:rPr>
+              <a:t>Software factory: ideas in → valuable outputs out. Competitor in? Don’t trash-talk — meet them on the curve.</a:t>
+            </a:r>
+          </a:p>
+        </p:txBody>
+      </p:sp>
+      <p:sp>
+        <p:nvSpPr>
+          <p:cNvPr id="16" name="TextBox 15"/>
+          <p:cNvSpPr txBox="1"/>
+          <p:nvPr/>
+        </p:nvSpPr>
+        <p:spPr>
+          <a:xfrm>
+            <a:off x="731520" y="4434840"/>
+            <a:ext cx="594360" cy="292608"/>
+          </a:xfrm>
+          <a:prstGeom prst="rect">
+            <a:avLst/>
+          </a:prstGeom>
+          <a:noFill/>
+        </p:spPr>
+        <p:txBody>
+          <a:bodyPr wrap="square" anchor="t">
+            <a:spAutoFit/>
+          </a:bodyPr>
+          <a:lstStyle/>
+          <a:p>
+            <a:pPr algn="l"/>
+            <a:r>
+              <a:rPr sz="1600" b="1">
+                <a:solidFill>
+                  <a:srgbClr val="26251E"/>
+                </a:solidFill>
+                <a:latin typeface="Arial"/>
+              </a:rPr>
+              <a:t>04</a:t>
+            </a:r>
+          </a:p>
+        </p:txBody>
+      </p:sp>
+      <p:sp>
+        <p:nvSpPr>
+          <p:cNvPr id="17" name="TextBox 16"/>
+          <p:cNvSpPr txBox="1"/>
+          <p:nvPr/>
+        </p:nvSpPr>
+        <p:spPr>
+          <a:xfrm>
+            <a:off x="1371600" y="4434840"/>
+            <a:ext cx="9966960" cy="274320"/>
+          </a:xfrm>
+          <a:prstGeom prst="rect">
+            <a:avLst/>
+          </a:prstGeom>
+          <a:noFill/>
+        </p:spPr>
+        <p:txBody>
+          <a:bodyPr wrap="square" anchor="t">
+            <a:spAutoFit/>
+          </a:bodyPr>
+          <a:lstStyle/>
+          <a:p>
+            <a:pPr algn="l"/>
+            <a:r>
+              <a:rPr sz="1500" b="1">
+                <a:solidFill>
+                  <a:srgbClr val="26251E"/>
+                </a:solidFill>
+                <a:latin typeface="Arial"/>
+              </a:rPr>
+              <a:t>Ask</a:t>
+            </a:r>
+          </a:p>
+        </p:txBody>
+      </p:sp>
+      <p:sp>
+        <p:nvSpPr>
+          <p:cNvPr id="18" name="TextBox 17"/>
+          <p:cNvSpPr txBox="1"/>
+          <p:nvPr/>
+        </p:nvSpPr>
+        <p:spPr>
+          <a:xfrm>
+            <a:off x="1371600" y="4727448"/>
+            <a:ext cx="9966960" cy="457200"/>
+          </a:xfrm>
+          <a:prstGeom prst="rect">
+            <a:avLst/>
+          </a:prstGeom>
+          <a:noFill/>
+        </p:spPr>
+        <p:txBody>
+          <a:bodyPr wrap="square" anchor="t">
+            <a:spAutoFit/>
+          </a:bodyPr>
+          <a:lstStyle/>
+          <a:p>
+            <a:pPr algn="l"/>
+            <a:r>
+              <a:rPr sz="1300" b="0">
+                <a:solidFill>
+                  <a:srgbClr val="807D72"/>
+                </a:solidFill>
+                <a:latin typeface="Arial"/>
+              </a:rPr>
+              <a:t>20 min working session. Brush-off → binary useful email. Close: “Most important thing you saw today?”</a:t>
             </a:r>
           </a:p>
         </p:txBody>
@@ -11701,7 +11725,7 @@
                 </a:solidFill>
                 <a:latin typeface="Arial"/>
               </a:rPr>
-              <a:t>Why we win — competition differentiation battlecard</a:t>
+              <a:t>Cutting through noise — by persona</a:t>
             </a:r>
           </a:p>
         </p:txBody>
@@ -11751,213 +11775,14 @@
       </p:sp>
       <p:sp>
         <p:nvSpPr>
-          <p:cNvPr id="7" name="Rectangle 6"/>
-          <p:cNvSpPr/>
-          <p:nvPr/>
-        </p:nvSpPr>
-        <p:spPr>
-          <a:xfrm>
-            <a:off x="457200" y="1188720"/>
-            <a:ext cx="11201400" cy="640080"/>
-          </a:xfrm>
-          <a:prstGeom prst="rect">
-            <a:avLst/>
-          </a:prstGeom>
-          <a:solidFill>
-            <a:srgbClr val="26251E"/>
-          </a:solidFill>
-          <a:ln>
-            <a:noFill/>
-          </a:ln>
-        </p:spPr>
-        <p:style>
-          <a:lnRef idx="1">
-            <a:schemeClr val="accent1"/>
-          </a:lnRef>
-          <a:fillRef idx="3">
-            <a:schemeClr val="accent1"/>
-          </a:fillRef>
-          <a:effectRef idx="2">
-            <a:schemeClr val="accent1"/>
-          </a:effectRef>
-          <a:fontRef idx="minor">
-            <a:schemeClr val="lt1"/>
-          </a:fontRef>
-        </p:style>
-        <p:txBody>
-          <a:bodyPr rtlCol="0" anchor="ctr"/>
-          <a:lstStyle/>
-          <a:p>
-            <a:pPr algn="ctr"/>
-          </a:p>
-        </p:txBody>
-      </p:sp>
-      <p:sp>
-        <p:nvSpPr>
-          <p:cNvPr id="8" name="TextBox 7"/>
+          <p:cNvPr id="7" name="TextBox 6"/>
           <p:cNvSpPr txBox="1"/>
           <p:nvPr/>
         </p:nvSpPr>
         <p:spPr>
           <a:xfrm>
-            <a:off x="640080" y="1280160"/>
-            <a:ext cx="10789920" cy="457200"/>
-          </a:xfrm>
-          <a:prstGeom prst="rect">
-            <a:avLst/>
-          </a:prstGeom>
-          <a:noFill/>
-        </p:spPr>
-        <p:txBody>
-          <a:bodyPr wrap="square" anchor="t">
-            <a:spAutoFit/>
-          </a:bodyPr>
-          <a:lstStyle/>
-          <a:p>
-            <a:pPr algn="l"/>
-            <a:r>
-              <a:rPr sz="1200" b="0">
-                <a:solidFill>
-                  <a:srgbClr val="EFEEE8"/>
-                </a:solidFill>
-                <a:latin typeface="Arial"/>
-              </a:rPr>
-              <a:t>Not exclusive smarter intelligence forever — apply intelligence better: workflow + codebase context + SDLC integration + model neutrality.</a:t>
-            </a:r>
-          </a:p>
-        </p:txBody>
-      </p:sp>
-      <p:sp>
-        <p:nvSpPr>
-          <p:cNvPr id="9" name="Rectangle 8"/>
-          <p:cNvSpPr/>
-          <p:nvPr/>
-        </p:nvSpPr>
-        <p:spPr>
-          <a:xfrm>
-            <a:off x="457200" y="2011680"/>
-            <a:ext cx="2743200" cy="4023360"/>
-          </a:xfrm>
-          <a:prstGeom prst="rect">
-            <a:avLst/>
-          </a:prstGeom>
-          <a:solidFill>
-            <a:srgbClr val="FFFFFF"/>
-          </a:solidFill>
-          <a:ln>
-            <a:noFill/>
-          </a:ln>
-        </p:spPr>
-        <p:style>
-          <a:lnRef idx="1">
-            <a:schemeClr val="accent1"/>
-          </a:lnRef>
-          <a:fillRef idx="3">
-            <a:schemeClr val="accent1"/>
-          </a:fillRef>
-          <a:effectRef idx="2">
-            <a:schemeClr val="accent1"/>
-          </a:effectRef>
-          <a:fontRef idx="minor">
-            <a:schemeClr val="lt1"/>
-          </a:fontRef>
-        </p:style>
-        <p:txBody>
-          <a:bodyPr rtlCol="0" anchor="ctr"/>
-          <a:lstStyle/>
-          <a:p>
-            <a:pPr algn="ctr"/>
-          </a:p>
-        </p:txBody>
-      </p:sp>
-      <p:sp>
-        <p:nvSpPr>
-          <p:cNvPr id="10" name="Rectangle 9"/>
-          <p:cNvSpPr/>
-          <p:nvPr/>
-        </p:nvSpPr>
-        <p:spPr>
-          <a:xfrm>
-            <a:off x="457200" y="2011680"/>
-            <a:ext cx="2743200" cy="438912"/>
-          </a:xfrm>
-          <a:prstGeom prst="rect">
-            <a:avLst/>
-          </a:prstGeom>
-          <a:solidFill>
-            <a:srgbClr val="26251E"/>
-          </a:solidFill>
-          <a:ln>
-            <a:noFill/>
-          </a:ln>
-        </p:spPr>
-        <p:style>
-          <a:lnRef idx="1">
-            <a:schemeClr val="accent1"/>
-          </a:lnRef>
-          <a:fillRef idx="3">
-            <a:schemeClr val="accent1"/>
-          </a:fillRef>
-          <a:effectRef idx="2">
-            <a:schemeClr val="accent1"/>
-          </a:effectRef>
-          <a:fontRef idx="minor">
-            <a:schemeClr val="lt1"/>
-          </a:fontRef>
-        </p:style>
-        <p:txBody>
-          <a:bodyPr rtlCol="0" anchor="ctr"/>
-          <a:lstStyle/>
-          <a:p>
-            <a:pPr algn="ctr"/>
-          </a:p>
-        </p:txBody>
-      </p:sp>
-      <p:sp>
-        <p:nvSpPr>
-          <p:cNvPr id="11" name="TextBox 10"/>
-          <p:cNvSpPr txBox="1"/>
-          <p:nvPr/>
-        </p:nvSpPr>
-        <p:spPr>
-          <a:xfrm>
-            <a:off x="566928" y="2084831"/>
-            <a:ext cx="2514600" cy="320040"/>
-          </a:xfrm>
-          <a:prstGeom prst="rect">
-            <a:avLst/>
-          </a:prstGeom>
-          <a:noFill/>
-        </p:spPr>
-        <p:txBody>
-          <a:bodyPr wrap="square" anchor="t">
-            <a:spAutoFit/>
-          </a:bodyPr>
-          <a:lstStyle/>
-          <a:p>
-            <a:pPr algn="l"/>
-            <a:r>
-              <a:rPr sz="1200" b="1">
-                <a:solidFill>
-                  <a:srgbClr val="F54E00"/>
-                </a:solidFill>
-                <a:latin typeface="Arial"/>
-              </a:rPr>
-              <a:t>Cursor</a:t>
-            </a:r>
-          </a:p>
-        </p:txBody>
-      </p:sp>
-      <p:sp>
-        <p:nvSpPr>
-          <p:cNvPr id="12" name="TextBox 11"/>
-          <p:cNvSpPr txBox="1"/>
-          <p:nvPr/>
-        </p:nvSpPr>
-        <p:spPr>
-          <a:xfrm>
-            <a:off x="566928" y="2651760"/>
-            <a:ext cx="2514600" cy="3108960"/>
+            <a:off x="731520" y="1371600"/>
+            <a:ext cx="10607040" cy="4663440"/>
           </a:xfrm>
           <a:prstGeom prst="rect">
             <a:avLst/>
@@ -11972,817 +11797,81 @@
           <a:p>
             <a:pPr algn="l">
               <a:spcAft>
-                <a:spcPts val="500"/>
+                <a:spcPts val="1100"/>
               </a:spcAft>
             </a:pPr>
             <a:r>
-              <a:rPr sz="1100" b="0">
+              <a:rPr sz="1500" b="0">
                 <a:solidFill>
                   <a:srgbClr val="26251E"/>
                 </a:solidFill>
                 <a:latin typeface="Arial"/>
               </a:rPr>
-              <a:t>•  AI-native IDE + enterprise platform</a:t>
+              <a:t>•  Developer: real-repo context + daily workflow · peer proof · no ROI theater</a:t>
             </a:r>
           </a:p>
           <a:p>
             <a:pPr algn="l">
               <a:spcAft>
-                <a:spcPts val="500"/>
+                <a:spcPts val="1100"/>
               </a:spcAft>
             </a:pPr>
             <a:r>
-              <a:rPr sz="1100" b="0">
+              <a:rPr sz="1500" b="0">
                 <a:solidFill>
                   <a:srgbClr val="26251E"/>
                 </a:solidFill>
                 <a:latin typeface="Arial"/>
               </a:rPr>
-              <a:t>•  Full-repo context + agent-first</a:t>
+              <a:t>•  VP Engineering: standardize AI coding · free KTLO capacity for moonshots · shipping outcomes</a:t>
             </a:r>
           </a:p>
           <a:p>
             <a:pPr algn="l">
               <a:spcAft>
-                <a:spcPts val="500"/>
+                <a:spcPts val="1100"/>
               </a:spcAft>
             </a:pPr>
             <a:r>
-              <a:rPr sz="1100" b="0">
+              <a:rPr sz="1500" b="0">
                 <a:solidFill>
                   <a:srgbClr val="26251E"/>
                 </a:solidFill>
                 <a:latin typeface="Arial"/>
               </a:rPr>
-              <a:t>•  IDE · CLI · Automations · Cloud Agents</a:t>
+              <a:t>•  Security / Platform: governed adoption · Privacy Mode · SSO/SCIM/audit · kill shadow AI</a:t>
             </a:r>
           </a:p>
           <a:p>
             <a:pPr algn="l">
               <a:spcAft>
-                <a:spcPts val="500"/>
+                <a:spcPts val="1100"/>
               </a:spcAft>
             </a:pPr>
             <a:r>
-              <a:rPr sz="1100" b="0">
+              <a:rPr sz="1500" b="0">
                 <a:solidFill>
                   <a:srgbClr val="26251E"/>
                 </a:solidFill>
                 <a:latin typeface="Arial"/>
               </a:rPr>
-              <a:t>•  Multi-model + Composer path</a:t>
+              <a:t>•  Triggers that earn 30 seconds: Copilot sprawl · AI policy · migrations · DevEx ownership</a:t>
             </a:r>
           </a:p>
           <a:p>
             <a:pPr algn="l">
               <a:spcAft>
-                <a:spcPts val="500"/>
+                <a:spcPts val="1100"/>
               </a:spcAft>
             </a:pPr>
             <a:r>
-              <a:rPr sz="1100" b="0">
+              <a:rPr sz="1500" b="0">
                 <a:solidFill>
                   <a:srgbClr val="26251E"/>
                 </a:solidFill>
                 <a:latin typeface="Arial"/>
               </a:rPr>
-              <a:t>•  Bugbot clears PR bottleneck</a:t>
-            </a:r>
-          </a:p>
-          <a:p>
-            <a:pPr algn="l">
-              <a:spcAft>
-                <a:spcPts val="500"/>
-              </a:spcAft>
-            </a:pPr>
-            <a:r>
-              <a:rPr sz="1100" b="0">
-                <a:solidFill>
-                  <a:srgbClr val="26251E"/>
-                </a:solidFill>
-                <a:latin typeface="Arial"/>
-              </a:rPr>
-              <a:t>•  Governance: SSO / SCIM / audit</a:t>
-            </a:r>
-          </a:p>
-        </p:txBody>
-      </p:sp>
-      <p:sp>
-        <p:nvSpPr>
-          <p:cNvPr id="13" name="Rectangle 12"/>
-          <p:cNvSpPr/>
-          <p:nvPr/>
-        </p:nvSpPr>
-        <p:spPr>
-          <a:xfrm>
-            <a:off x="3337560" y="2011680"/>
-            <a:ext cx="2743200" cy="4023360"/>
-          </a:xfrm>
-          <a:prstGeom prst="rect">
-            <a:avLst/>
-          </a:prstGeom>
-          <a:solidFill>
-            <a:srgbClr val="FFFFFF"/>
-          </a:solidFill>
-          <a:ln>
-            <a:noFill/>
-          </a:ln>
-        </p:spPr>
-        <p:style>
-          <a:lnRef idx="1">
-            <a:schemeClr val="accent1"/>
-          </a:lnRef>
-          <a:fillRef idx="3">
-            <a:schemeClr val="accent1"/>
-          </a:fillRef>
-          <a:effectRef idx="2">
-            <a:schemeClr val="accent1"/>
-          </a:effectRef>
-          <a:fontRef idx="minor">
-            <a:schemeClr val="lt1"/>
-          </a:fontRef>
-        </p:style>
-        <p:txBody>
-          <a:bodyPr rtlCol="0" anchor="ctr"/>
-          <a:lstStyle/>
-          <a:p>
-            <a:pPr algn="ctr"/>
-          </a:p>
-        </p:txBody>
-      </p:sp>
-      <p:sp>
-        <p:nvSpPr>
-          <p:cNvPr id="14" name="Rectangle 13"/>
-          <p:cNvSpPr/>
-          <p:nvPr/>
-        </p:nvSpPr>
-        <p:spPr>
-          <a:xfrm>
-            <a:off x="3337560" y="2011680"/>
-            <a:ext cx="2743200" cy="438912"/>
-          </a:xfrm>
-          <a:prstGeom prst="rect">
-            <a:avLst/>
-          </a:prstGeom>
-          <a:solidFill>
-            <a:srgbClr val="3A3832"/>
-          </a:solidFill>
-          <a:ln>
-            <a:noFill/>
-          </a:ln>
-        </p:spPr>
-        <p:style>
-          <a:lnRef idx="1">
-            <a:schemeClr val="accent1"/>
-          </a:lnRef>
-          <a:fillRef idx="3">
-            <a:schemeClr val="accent1"/>
-          </a:fillRef>
-          <a:effectRef idx="2">
-            <a:schemeClr val="accent1"/>
-          </a:effectRef>
-          <a:fontRef idx="minor">
-            <a:schemeClr val="lt1"/>
-          </a:fontRef>
-        </p:style>
-        <p:txBody>
-          <a:bodyPr rtlCol="0" anchor="ctr"/>
-          <a:lstStyle/>
-          <a:p>
-            <a:pPr algn="ctr"/>
-          </a:p>
-        </p:txBody>
-      </p:sp>
-      <p:sp>
-        <p:nvSpPr>
-          <p:cNvPr id="15" name="TextBox 14"/>
-          <p:cNvSpPr txBox="1"/>
-          <p:nvPr/>
-        </p:nvSpPr>
-        <p:spPr>
-          <a:xfrm>
-            <a:off x="3447288" y="2084831"/>
-            <a:ext cx="2514600" cy="320040"/>
-          </a:xfrm>
-          <a:prstGeom prst="rect">
-            <a:avLst/>
-          </a:prstGeom>
-          <a:noFill/>
-        </p:spPr>
-        <p:txBody>
-          <a:bodyPr wrap="square" anchor="t">
-            <a:spAutoFit/>
-          </a:bodyPr>
-          <a:lstStyle/>
-          <a:p>
-            <a:pPr algn="l"/>
-            <a:r>
-              <a:rPr sz="1200" b="1">
-                <a:solidFill>
-                  <a:srgbClr val="FFFFFF"/>
-                </a:solidFill>
-                <a:latin typeface="Arial"/>
-              </a:rPr>
-              <a:t>vs Copilot</a:t>
-            </a:r>
-          </a:p>
-        </p:txBody>
-      </p:sp>
-      <p:sp>
-        <p:nvSpPr>
-          <p:cNvPr id="16" name="TextBox 15"/>
-          <p:cNvSpPr txBox="1"/>
-          <p:nvPr/>
-        </p:nvSpPr>
-        <p:spPr>
-          <a:xfrm>
-            <a:off x="3447288" y="2651760"/>
-            <a:ext cx="2514600" cy="3108960"/>
-          </a:xfrm>
-          <a:prstGeom prst="rect">
-            <a:avLst/>
-          </a:prstGeom>
-          <a:noFill/>
-        </p:spPr>
-        <p:txBody>
-          <a:bodyPr wrap="square">
-            <a:spAutoFit/>
-          </a:bodyPr>
-          <a:lstStyle/>
-          <a:p>
-            <a:pPr algn="l">
-              <a:spcAft>
-                <a:spcPts val="500"/>
-              </a:spcAft>
-            </a:pPr>
-            <a:r>
-              <a:rPr sz="1100" b="0">
-                <a:solidFill>
-                  <a:srgbClr val="26251E"/>
-                </a:solidFill>
-                <a:latin typeface="Arial"/>
-              </a:rPr>
-              <a:t>•  Biggest by market share</a:t>
-            </a:r>
-          </a:p>
-          <a:p>
-            <a:pPr algn="l">
-              <a:spcAft>
-                <a:spcPts val="500"/>
-              </a:spcAft>
-            </a:pPr>
-            <a:r>
-              <a:rPr sz="1100" b="0">
-                <a:solidFill>
-                  <a:srgbClr val="26251E"/>
-                </a:solidFill>
-                <a:latin typeface="Arial"/>
-              </a:rPr>
-              <a:t>•  Plugin in existing IDEs</a:t>
-            </a:r>
-          </a:p>
-          <a:p>
-            <a:pPr algn="l">
-              <a:spcAft>
-                <a:spcPts val="500"/>
-              </a:spcAft>
-            </a:pPr>
-            <a:r>
-              <a:rPr sz="1100" b="0">
-                <a:solidFill>
-                  <a:srgbClr val="26251E"/>
-                </a:solidFill>
-                <a:latin typeface="Arial"/>
-              </a:rPr>
-              <a:t>•  Wins: GitHub ecosystem + friction</a:t>
-            </a:r>
-          </a:p>
-          <a:p>
-            <a:pPr algn="l">
-              <a:spcAft>
-                <a:spcPts val="500"/>
-              </a:spcAft>
-            </a:pPr>
-            <a:r>
-              <a:rPr sz="1100" b="0">
-                <a:solidFill>
-                  <a:srgbClr val="26251E"/>
-                </a:solidFill>
-                <a:latin typeface="Arial"/>
-              </a:rPr>
-              <a:t>•  Often local / snippet help</a:t>
-            </a:r>
-          </a:p>
-          <a:p>
-            <a:pPr algn="l">
-              <a:spcAft>
-                <a:spcPts val="500"/>
-              </a:spcAft>
-            </a:pPr>
-            <a:r>
-              <a:rPr sz="1100" b="0">
-                <a:solidFill>
-                  <a:srgbClr val="26251E"/>
-                </a:solidFill>
-                <a:latin typeface="Arial"/>
-              </a:rPr>
-              <a:t>•  Our move: task completion</a:t>
-            </a:r>
-          </a:p>
-          <a:p>
-            <a:pPr algn="l">
-              <a:spcAft>
-                <a:spcPts val="500"/>
-              </a:spcAft>
-            </a:pPr>
-            <a:r>
-              <a:rPr sz="1100" b="0">
-                <a:solidFill>
-                  <a:srgbClr val="26251E"/>
-                </a:solidFill>
-                <a:latin typeface="Arial"/>
-              </a:rPr>
-              <a:t>•  Our move: codebase workflow</a:t>
-            </a:r>
-          </a:p>
-        </p:txBody>
-      </p:sp>
-      <p:sp>
-        <p:nvSpPr>
-          <p:cNvPr id="17" name="Rectangle 16"/>
-          <p:cNvSpPr/>
-          <p:nvPr/>
-        </p:nvSpPr>
-        <p:spPr>
-          <a:xfrm>
-            <a:off x="6217920" y="2011680"/>
-            <a:ext cx="2743200" cy="4023360"/>
-          </a:xfrm>
-          <a:prstGeom prst="rect">
-            <a:avLst/>
-          </a:prstGeom>
-          <a:solidFill>
-            <a:srgbClr val="FFFFFF"/>
-          </a:solidFill>
-          <a:ln>
-            <a:noFill/>
-          </a:ln>
-        </p:spPr>
-        <p:style>
-          <a:lnRef idx="1">
-            <a:schemeClr val="accent1"/>
-          </a:lnRef>
-          <a:fillRef idx="3">
-            <a:schemeClr val="accent1"/>
-          </a:fillRef>
-          <a:effectRef idx="2">
-            <a:schemeClr val="accent1"/>
-          </a:effectRef>
-          <a:fontRef idx="minor">
-            <a:schemeClr val="lt1"/>
-          </a:fontRef>
-        </p:style>
-        <p:txBody>
-          <a:bodyPr rtlCol="0" anchor="ctr"/>
-          <a:lstStyle/>
-          <a:p>
-            <a:pPr algn="ctr"/>
-          </a:p>
-        </p:txBody>
-      </p:sp>
-      <p:sp>
-        <p:nvSpPr>
-          <p:cNvPr id="18" name="Rectangle 17"/>
-          <p:cNvSpPr/>
-          <p:nvPr/>
-        </p:nvSpPr>
-        <p:spPr>
-          <a:xfrm>
-            <a:off x="6217920" y="2011680"/>
-            <a:ext cx="2743200" cy="438912"/>
-          </a:xfrm>
-          <a:prstGeom prst="rect">
-            <a:avLst/>
-          </a:prstGeom>
-          <a:solidFill>
-            <a:srgbClr val="3A3832"/>
-          </a:solidFill>
-          <a:ln>
-            <a:noFill/>
-          </a:ln>
-        </p:spPr>
-        <p:style>
-          <a:lnRef idx="1">
-            <a:schemeClr val="accent1"/>
-          </a:lnRef>
-          <a:fillRef idx="3">
-            <a:schemeClr val="accent1"/>
-          </a:fillRef>
-          <a:effectRef idx="2">
-            <a:schemeClr val="accent1"/>
-          </a:effectRef>
-          <a:fontRef idx="minor">
-            <a:schemeClr val="lt1"/>
-          </a:fontRef>
-        </p:style>
-        <p:txBody>
-          <a:bodyPr rtlCol="0" anchor="ctr"/>
-          <a:lstStyle/>
-          <a:p>
-            <a:pPr algn="ctr"/>
-          </a:p>
-        </p:txBody>
-      </p:sp>
-      <p:sp>
-        <p:nvSpPr>
-          <p:cNvPr id="19" name="TextBox 18"/>
-          <p:cNvSpPr txBox="1"/>
-          <p:nvPr/>
-        </p:nvSpPr>
-        <p:spPr>
-          <a:xfrm>
-            <a:off x="6327648" y="2084831"/>
-            <a:ext cx="2514600" cy="320040"/>
-          </a:xfrm>
-          <a:prstGeom prst="rect">
-            <a:avLst/>
-          </a:prstGeom>
-          <a:noFill/>
-        </p:spPr>
-        <p:txBody>
-          <a:bodyPr wrap="square" anchor="t">
-            <a:spAutoFit/>
-          </a:bodyPr>
-          <a:lstStyle/>
-          <a:p>
-            <a:pPr algn="l"/>
-            <a:r>
-              <a:rPr sz="1200" b="1">
-                <a:solidFill>
-                  <a:srgbClr val="FFFFFF"/>
-                </a:solidFill>
-                <a:latin typeface="Arial"/>
-              </a:rPr>
-              <a:t>vs Claude Code</a:t>
-            </a:r>
-          </a:p>
-        </p:txBody>
-      </p:sp>
-      <p:sp>
-        <p:nvSpPr>
-          <p:cNvPr id="20" name="TextBox 19"/>
-          <p:cNvSpPr txBox="1"/>
-          <p:nvPr/>
-        </p:nvSpPr>
-        <p:spPr>
-          <a:xfrm>
-            <a:off x="6327648" y="2651760"/>
-            <a:ext cx="2514600" cy="3108960"/>
-          </a:xfrm>
-          <a:prstGeom prst="rect">
-            <a:avLst/>
-          </a:prstGeom>
-          <a:noFill/>
-        </p:spPr>
-        <p:txBody>
-          <a:bodyPr wrap="square">
-            <a:spAutoFit/>
-          </a:bodyPr>
-          <a:lstStyle/>
-          <a:p>
-            <a:pPr algn="l">
-              <a:spcAft>
-                <a:spcPts val="500"/>
-              </a:spcAft>
-            </a:pPr>
-            <a:r>
-              <a:rPr sz="1100" b="0">
-                <a:solidFill>
-                  <a:srgbClr val="26251E"/>
-                </a:solidFill>
-                <a:latin typeface="Arial"/>
-              </a:rPr>
-              <a:t>•  Strong — don’t trash-talk</a:t>
-            </a:r>
-          </a:p>
-          <a:p>
-            <a:pPr algn="l">
-              <a:spcAft>
-                <a:spcPts val="500"/>
-              </a:spcAft>
-            </a:pPr>
-            <a:r>
-              <a:rPr sz="1100" b="0">
-                <a:solidFill>
-                  <a:srgbClr val="26251E"/>
-                </a:solidFill>
-                <a:latin typeface="Arial"/>
-              </a:rPr>
-              <a:t>•  Terminal-first agent shape</a:t>
-            </a:r>
-          </a:p>
-          <a:p>
-            <a:pPr algn="l">
-              <a:spcAft>
-                <a:spcPts val="500"/>
-              </a:spcAft>
-            </a:pPr>
-            <a:r>
-              <a:rPr sz="1100" b="0">
-                <a:solidFill>
-                  <a:srgbClr val="26251E"/>
-                </a:solidFill>
-                <a:latin typeface="Arial"/>
-              </a:rPr>
-              <a:t>•  Not a model-war pitch</a:t>
-            </a:r>
-          </a:p>
-          <a:p>
-            <a:pPr algn="l">
-              <a:spcAft>
-                <a:spcPts val="500"/>
-              </a:spcAft>
-            </a:pPr>
-            <a:r>
-              <a:rPr sz="1100" b="0">
-                <a:solidFill>
-                  <a:srgbClr val="26251E"/>
-                </a:solidFill>
-                <a:latin typeface="Arial"/>
-              </a:rPr>
-              <a:t>•  Our edge: neutrality</a:t>
-            </a:r>
-          </a:p>
-          <a:p>
-            <a:pPr algn="l">
-              <a:spcAft>
-                <a:spcPts val="500"/>
-              </a:spcAft>
-            </a:pPr>
-            <a:r>
-              <a:rPr sz="1100" b="0">
-                <a:solidFill>
-                  <a:srgbClr val="26251E"/>
-                </a:solidFill>
-                <a:latin typeface="Arial"/>
-              </a:rPr>
-              <a:t>•  Our edge: SDLC integration</a:t>
-            </a:r>
-          </a:p>
-          <a:p>
-            <a:pPr algn="l">
-              <a:spcAft>
-                <a:spcPts val="500"/>
-              </a:spcAft>
-            </a:pPr>
-            <a:r>
-              <a:rPr sz="1100" b="0">
-                <a:solidFill>
-                  <a:srgbClr val="26251E"/>
-                </a:solidFill>
-                <a:latin typeface="Arial"/>
-              </a:rPr>
-              <a:t>•  Our edge: team time-to-value</a:t>
-            </a:r>
-          </a:p>
-        </p:txBody>
-      </p:sp>
-      <p:sp>
-        <p:nvSpPr>
-          <p:cNvPr id="21" name="Rectangle 20"/>
-          <p:cNvSpPr/>
-          <p:nvPr/>
-        </p:nvSpPr>
-        <p:spPr>
-          <a:xfrm>
-            <a:off x="9098280" y="2011680"/>
-            <a:ext cx="2743200" cy="4023360"/>
-          </a:xfrm>
-          <a:prstGeom prst="rect">
-            <a:avLst/>
-          </a:prstGeom>
-          <a:solidFill>
-            <a:srgbClr val="FFFFFF"/>
-          </a:solidFill>
-          <a:ln>
-            <a:noFill/>
-          </a:ln>
-        </p:spPr>
-        <p:style>
-          <a:lnRef idx="1">
-            <a:schemeClr val="accent1"/>
-          </a:lnRef>
-          <a:fillRef idx="3">
-            <a:schemeClr val="accent1"/>
-          </a:fillRef>
-          <a:effectRef idx="2">
-            <a:schemeClr val="accent1"/>
-          </a:effectRef>
-          <a:fontRef idx="minor">
-            <a:schemeClr val="lt1"/>
-          </a:fontRef>
-        </p:style>
-        <p:txBody>
-          <a:bodyPr rtlCol="0" anchor="ctr"/>
-          <a:lstStyle/>
-          <a:p>
-            <a:pPr algn="ctr"/>
-          </a:p>
-        </p:txBody>
-      </p:sp>
-      <p:sp>
-        <p:nvSpPr>
-          <p:cNvPr id="22" name="Rectangle 21"/>
-          <p:cNvSpPr/>
-          <p:nvPr/>
-        </p:nvSpPr>
-        <p:spPr>
-          <a:xfrm>
-            <a:off x="9098280" y="2011680"/>
-            <a:ext cx="2743200" cy="438912"/>
-          </a:xfrm>
-          <a:prstGeom prst="rect">
-            <a:avLst/>
-          </a:prstGeom>
-          <a:solidFill>
-            <a:srgbClr val="3A3832"/>
-          </a:solidFill>
-          <a:ln>
-            <a:noFill/>
-          </a:ln>
-        </p:spPr>
-        <p:style>
-          <a:lnRef idx="1">
-            <a:schemeClr val="accent1"/>
-          </a:lnRef>
-          <a:fillRef idx="3">
-            <a:schemeClr val="accent1"/>
-          </a:fillRef>
-          <a:effectRef idx="2">
-            <a:schemeClr val="accent1"/>
-          </a:effectRef>
-          <a:fontRef idx="minor">
-            <a:schemeClr val="lt1"/>
-          </a:fontRef>
-        </p:style>
-        <p:txBody>
-          <a:bodyPr rtlCol="0" anchor="ctr"/>
-          <a:lstStyle/>
-          <a:p>
-            <a:pPr algn="ctr"/>
-          </a:p>
-        </p:txBody>
-      </p:sp>
-      <p:sp>
-        <p:nvSpPr>
-          <p:cNvPr id="23" name="TextBox 22"/>
-          <p:cNvSpPr txBox="1"/>
-          <p:nvPr/>
-        </p:nvSpPr>
-        <p:spPr>
-          <a:xfrm>
-            <a:off x="9208008" y="2084831"/>
-            <a:ext cx="2514600" cy="320040"/>
-          </a:xfrm>
-          <a:prstGeom prst="rect">
-            <a:avLst/>
-          </a:prstGeom>
-          <a:noFill/>
-        </p:spPr>
-        <p:txBody>
-          <a:bodyPr wrap="square" anchor="t">
-            <a:spAutoFit/>
-          </a:bodyPr>
-          <a:lstStyle/>
-          <a:p>
-            <a:pPr algn="l"/>
-            <a:r>
-              <a:rPr sz="1200" b="1">
-                <a:solidFill>
-                  <a:srgbClr val="FFFFFF"/>
-                </a:solidFill>
-                <a:latin typeface="Arial"/>
-              </a:rPr>
-              <a:t>Also / real rival</a:t>
-            </a:r>
-          </a:p>
-        </p:txBody>
-      </p:sp>
-      <p:sp>
-        <p:nvSpPr>
-          <p:cNvPr id="24" name="TextBox 23"/>
-          <p:cNvSpPr txBox="1"/>
-          <p:nvPr/>
-        </p:nvSpPr>
-        <p:spPr>
-          <a:xfrm>
-            <a:off x="9208008" y="2651760"/>
-            <a:ext cx="2514600" cy="3108960"/>
-          </a:xfrm>
-          <a:prstGeom prst="rect">
-            <a:avLst/>
-          </a:prstGeom>
-          <a:noFill/>
-        </p:spPr>
-        <p:txBody>
-          <a:bodyPr wrap="square">
-            <a:spAutoFit/>
-          </a:bodyPr>
-          <a:lstStyle/>
-          <a:p>
-            <a:pPr algn="l">
-              <a:spcAft>
-                <a:spcPts val="500"/>
-              </a:spcAft>
-            </a:pPr>
-            <a:r>
-              <a:rPr sz="1100" b="0">
-                <a:solidFill>
-                  <a:srgbClr val="26251E"/>
-                </a:solidFill>
-                <a:latin typeface="Arial"/>
-              </a:rPr>
-              <a:t>•  Windsurf: Cascade UX challenger</a:t>
-            </a:r>
-          </a:p>
-          <a:p>
-            <a:pPr algn="l">
-              <a:spcAft>
-                <a:spcPts val="500"/>
-              </a:spcAft>
-            </a:pPr>
-            <a:r>
-              <a:rPr sz="1100" b="0">
-                <a:solidFill>
-                  <a:srgbClr val="26251E"/>
-                </a:solidFill>
-                <a:latin typeface="Arial"/>
-              </a:rPr>
-              <a:t>•  Codex: OpenAI async agents</a:t>
-            </a:r>
-          </a:p>
-          <a:p>
-            <a:pPr algn="l">
-              <a:spcAft>
-                <a:spcPts val="500"/>
-              </a:spcAft>
-            </a:pPr>
-            <a:r>
-              <a:rPr sz="1100" b="0">
-                <a:solidFill>
-                  <a:srgbClr val="26251E"/>
-                </a:solidFill>
-                <a:latin typeface="Arial"/>
-              </a:rPr>
-              <a:t>•  Shadow AI = real enterprise rival</a:t>
-            </a:r>
-          </a:p>
-          <a:p>
-            <a:pPr algn="l">
-              <a:spcAft>
-                <a:spcPts val="500"/>
-              </a:spcAft>
-            </a:pPr>
-            <a:r>
-              <a:rPr sz="1100" b="0">
-                <a:solidFill>
-                  <a:srgbClr val="26251E"/>
-                </a:solidFill>
-                <a:latin typeface="Arial"/>
-              </a:rPr>
-              <a:t>•  Win = governed standardization</a:t>
-            </a:r>
-          </a:p>
-          <a:p>
-            <a:pPr algn="l">
-              <a:spcAft>
-                <a:spcPts val="500"/>
-              </a:spcAft>
-            </a:pPr>
-            <a:r>
-              <a:rPr sz="1100" b="0">
-                <a:solidFill>
-                  <a:srgbClr val="26251E"/>
-                </a:solidFill>
-                <a:latin typeface="Arial"/>
-              </a:rPr>
-              <a:t>•  Proof: Coinbase · Stripe · PayPal</a:t>
-            </a:r>
-          </a:p>
-          <a:p>
-            <a:pPr algn="l">
-              <a:spcAft>
-                <a:spcPts val="500"/>
-              </a:spcAft>
-            </a:pPr>
-            <a:r>
-              <a:rPr sz="1100" b="0">
-                <a:solidFill>
-                  <a:srgbClr val="26251E"/>
-                </a:solidFill>
-                <a:latin typeface="Arial"/>
-              </a:rPr>
-              <a:t>•  Outcomes per $ &gt; autocomplete</a:t>
+              <a:t>•  Fail: “quick chat,” fake personalization, feature dumps, slide-ware before diagnosis</a:t>
             </a:r>
           </a:p>
         </p:txBody>
@@ -12945,7 +12034,7 @@
                 </a:solidFill>
                 <a:latin typeface="Arial"/>
               </a:rPr>
-              <a:t>Security instincts (not a certification dump)</a:t>
+              <a:t>Getting attention — what works / what dies</a:t>
             </a:r>
           </a:p>
         </p:txBody>
@@ -13109,7 +12198,7 @@
                 </a:solidFill>
                 <a:latin typeface="Arial"/>
               </a:rPr>
-              <a:t>Privacy Mode</a:t>
+              <a:t>Works now</a:t>
             </a:r>
           </a:p>
         </p:txBody>
@@ -13142,13 +12231,13 @@
               </a:spcAft>
             </a:pPr>
             <a:r>
-              <a:rPr sz="1400" b="0">
+              <a:rPr sz="1300" b="0">
                 <a:solidFill>
                   <a:srgbClr val="26251E"/>
                 </a:solidFill>
                 <a:latin typeface="Arial"/>
               </a:rPr>
-              <a:t>•  Customer code is not stored or retained</a:t>
+              <a:t>•  Reason for the call tied to their world</a:t>
             </a:r>
           </a:p>
           <a:p>
@@ -13158,13 +12247,13 @@
               </a:spcAft>
             </a:pPr>
             <a:r>
-              <a:rPr sz="1400" b="0">
+              <a:rPr sz="1300" b="0">
                 <a:solidFill>
                   <a:srgbClr val="26251E"/>
                 </a:solidFill>
                 <a:latin typeface="Arial"/>
               </a:rPr>
-              <a:t>•  Not used to train models</a:t>
+              <a:t>•  Diagnose time split + bottleneck shift</a:t>
             </a:r>
           </a:p>
           <a:p>
@@ -13174,13 +12263,13 @@
               </a:spcAft>
             </a:pPr>
             <a:r>
-              <a:rPr sz="1400" b="0">
+              <a:rPr sz="1300" b="0">
                 <a:solidFill>
                   <a:srgbClr val="26251E"/>
                 </a:solidFill>
                 <a:latin typeface="Arial"/>
               </a:rPr>
-              <a:t>•  Requests are isolated and ephemeral</a:t>
+              <a:t>•  Meet them on the maturity curve</a:t>
             </a:r>
           </a:p>
           <a:p>
@@ -13190,13 +12279,45 @@
               </a:spcAft>
             </a:pPr>
             <a:r>
-              <a:rPr sz="1400" b="0">
+              <a:rPr sz="1300" b="0">
                 <a:solidFill>
                   <a:srgbClr val="26251E"/>
                 </a:solidFill>
                 <a:latin typeface="Arial"/>
               </a:rPr>
-              <a:t>•  Enforce org-wide so shadow AI doesn’t win</a:t>
+              <a:t>•  Use-case-true stories (Coinbase / Stripe / PayPal · Nike / Amplitude)</a:t>
+            </a:r>
+          </a:p>
+          <a:p>
+            <a:pPr algn="l">
+              <a:spcAft>
+                <a:spcPts val="700"/>
+              </a:spcAft>
+            </a:pPr>
+            <a:r>
+              <a:rPr sz="1300" b="0">
+                <a:solidFill>
+                  <a:srgbClr val="26251E"/>
+                </a:solidFill>
+                <a:latin typeface="Arial"/>
+              </a:rPr>
+              <a:t>•  Ask for a working session, not a “quick chat”</a:t>
+            </a:r>
+          </a:p>
+          <a:p>
+            <a:pPr algn="l">
+              <a:spcAft>
+                <a:spcPts val="700"/>
+              </a:spcAft>
+            </a:pPr>
+            <a:r>
+              <a:rPr sz="1300" b="0">
+                <a:solidFill>
+                  <a:srgbClr val="26251E"/>
+                </a:solidFill>
+                <a:latin typeface="Arial"/>
+              </a:rPr>
+              <a:t>•  Outcomes per dollar when finance pressure shows up</a:t>
             </a:r>
           </a:p>
         </p:txBody>
@@ -13317,7 +12438,7 @@
                 </a:solidFill>
                 <a:latin typeface="Arial"/>
               </a:rPr>
-              <a:t>Enterprise posture</a:t>
+              <a:t>Dies with this audience</a:t>
             </a:r>
           </a:p>
         </p:txBody>
@@ -13350,13 +12471,13 @@
               </a:spcAft>
             </a:pPr>
             <a:r>
-              <a:rPr sz="1400" b="0">
+              <a:rPr sz="1300" b="0">
                 <a:solidFill>
                   <a:srgbClr val="26251E"/>
                 </a:solidFill>
                 <a:latin typeface="Arial"/>
               </a:rPr>
-              <a:t>•  SOC 2 Type II; secure handling of code + metadata</a:t>
+              <a:t>•  Generic sequences / “just checking in”</a:t>
             </a:r>
           </a:p>
           <a:p>
@@ -13366,13 +12487,13 @@
               </a:spcAft>
             </a:pPr>
             <a:r>
-              <a:rPr sz="1400" b="0">
+              <a:rPr sz="1300" b="0">
                 <a:solidFill>
                   <a:srgbClr val="26251E"/>
                 </a:solidFill>
                 <a:latin typeface="Arial"/>
               </a:rPr>
-              <a:t>•  SSO / SCIM / audit logs / admin visibility</a:t>
+              <a:t>•  ROI theater aimed at developers</a:t>
             </a:r>
           </a:p>
           <a:p>
@@ -13382,13 +12503,13 @@
               </a:spcAft>
             </a:pPr>
             <a:r>
-              <a:rPr sz="1400" b="0">
+              <a:rPr sz="1300" b="0">
                 <a:solidFill>
                   <a:srgbClr val="26251E"/>
                 </a:solidFill>
                 <a:latin typeface="Arial"/>
               </a:rPr>
-              <a:t>•  Model, repo, and MCP governance controls</a:t>
+              <a:t>•  Feature laundry lists</a:t>
             </a:r>
           </a:p>
           <a:p>
@@ -13398,13 +12519,45 @@
               </a:spcAft>
             </a:pPr>
             <a:r>
-              <a:rPr sz="1400" b="0">
+              <a:rPr sz="1300" b="0">
                 <a:solidFill>
                   <a:srgbClr val="26251E"/>
                 </a:solidFill>
                 <a:latin typeface="Arial"/>
               </a:rPr>
-              <a:t>•  First-call frame: adoption confidence — bring partner when deep</a:t>
+              <a:t>•  Fake personalization</a:t>
+            </a:r>
+          </a:p>
+          <a:p>
+            <a:pPr algn="l">
+              <a:spcAft>
+                <a:spcPts val="700"/>
+              </a:spcAft>
+            </a:pPr>
+            <a:r>
+              <a:rPr sz="1300" b="0">
+                <a:solidFill>
+                  <a:srgbClr val="26251E"/>
+                </a:solidFill>
+                <a:latin typeface="Arial"/>
+              </a:rPr>
+              <a:t>•  Slide-ware before you’ve earned diagnosis</a:t>
+            </a:r>
+          </a:p>
+          <a:p>
+            <a:pPr algn="l">
+              <a:spcAft>
+                <a:spcPts val="700"/>
+              </a:spcAft>
+            </a:pPr>
+            <a:r>
+              <a:rPr sz="1300" b="0">
+                <a:solidFill>
+                  <a:srgbClr val="26251E"/>
+                </a:solidFill>
+                <a:latin typeface="Arial"/>
+              </a:rPr>
+              <a:t>•  Trying to out-engineer the room on a cold call</a:t>
             </a:r>
           </a:p>
         </p:txBody>
@@ -13567,7 +12720,7 @@
                 </a:solidFill>
                 <a:latin typeface="Arial"/>
               </a:rPr>
-              <a:t>Close — up-level, don’t rebuild</a:t>
+              <a:t>Why we win — my read for a skeptical eng leader</a:t>
             </a:r>
           </a:p>
         </p:txBody>
@@ -13643,13 +12796,13 @@
               </a:spcAft>
             </a:pPr>
             <a:r>
-              <a:rPr sz="1700" b="0">
+              <a:rPr sz="1600" b="0">
                 <a:solidFill>
                   <a:srgbClr val="26251E"/>
                 </a:solidFill>
                 <a:latin typeface="Arial"/>
               </a:rPr>
-              <a:t>•  Diagnose real constraints with data + AE/SDR truth</a:t>
+              <a:t>•  Market moved from “help me write code” → “help my org ship with agents — without losing control”</a:t>
             </a:r>
           </a:p>
           <a:p>
@@ -13659,13 +12812,13 @@
               </a:spcAft>
             </a:pPr>
             <a:r>
-              <a:rPr sz="1700" b="0">
+              <a:rPr sz="1600" b="0">
                 <a:solidFill>
                   <a:srgbClr val="26251E"/>
                 </a:solidFill>
                 <a:latin typeface="Arial"/>
               </a:rPr>
-              <a:t>•  Protect automation, ICP, and cadence already creating pipeline</a:t>
+              <a:t>•  AI creates speed, then moves the bottleneck to review and production</a:t>
             </a:r>
           </a:p>
           <a:p>
@@ -13675,13 +12828,13 @@
               </a:spcAft>
             </a:pPr>
             <a:r>
-              <a:rPr sz="1700" b="0">
+              <a:rPr sz="1600" b="0">
                 <a:solidFill>
                   <a:srgbClr val="26251E"/>
                 </a:solidFill>
                 <a:latin typeface="Arial"/>
               </a:rPr>
-              <a:t>•  Train workflow / context / execution — four wedges, clean competitive frames</a:t>
+              <a:t>•  Cursor wins as the governed software factory: workflow · context · neutrality · SDLC execution</a:t>
             </a:r>
           </a:p>
           <a:p>
@@ -13691,15 +12844,244 @@
               </a:spcAft>
             </a:pPr>
             <a:r>
-              <a:rPr sz="1700" b="0">
+              <a:rPr sz="1600" b="0">
                 <a:solidFill>
                   <a:srgbClr val="26251E"/>
                 </a:solidFill>
                 <a:latin typeface="Arial"/>
               </a:rPr>
-              <a:t>•  Run one or two measured experiments — keep or kill on metrics</a:t>
-            </a:r>
-          </a:p>
+              <a:t>•  One-liner: we don’t win by claiming the permanently smarter model — we win by applying intelligence better, with the control plane to standardize it</a:t>
+            </a:r>
+          </a:p>
+        </p:txBody>
+      </p:sp>
+    </p:spTree>
+  </p:cSld>
+  <p:clrMapOvr>
+    <a:masterClrMapping/>
+  </p:clrMapOvr>
+</p:sld>
+</file>
+
+<file path=ppt/slides/slide23.xml><?xml version="1.0" encoding="utf-8"?>
+<p:sld xmlns:a="http://schemas.openxmlformats.org/drawingml/2006/main" xmlns:p="http://schemas.openxmlformats.org/presentationml/2006/main" xmlns:r="http://schemas.openxmlformats.org/officeDocument/2006/relationships">
+  <p:cSld>
+    <p:spTree>
+      <p:nvGrpSpPr>
+        <p:cNvPr id="1" name=""/>
+        <p:cNvGrpSpPr/>
+        <p:nvPr/>
+      </p:nvGrpSpPr>
+      <p:grpSpPr/>
+      <p:sp>
+        <p:nvSpPr>
+          <p:cNvPr id="2" name="Rectangle 1"/>
+          <p:cNvSpPr/>
+          <p:nvPr/>
+        </p:nvSpPr>
+        <p:spPr>
+          <a:xfrm>
+            <a:off x="0" y="0"/>
+            <a:ext cx="12191695" cy="6858000"/>
+          </a:xfrm>
+          <a:prstGeom prst="rect">
+            <a:avLst/>
+          </a:prstGeom>
+          <a:solidFill>
+            <a:srgbClr val="F7F7F4"/>
+          </a:solidFill>
+          <a:ln>
+            <a:noFill/>
+          </a:ln>
+        </p:spPr>
+        <p:style>
+          <a:lnRef idx="1">
+            <a:schemeClr val="accent1"/>
+          </a:lnRef>
+          <a:fillRef idx="3">
+            <a:schemeClr val="accent1"/>
+          </a:fillRef>
+          <a:effectRef idx="2">
+            <a:schemeClr val="accent1"/>
+          </a:effectRef>
+          <a:fontRef idx="minor">
+            <a:schemeClr val="lt1"/>
+          </a:fontRef>
+        </p:style>
+        <p:txBody>
+          <a:bodyPr rtlCol="0" anchor="ctr"/>
+          <a:lstStyle/>
+          <a:p>
+            <a:pPr algn="ctr"/>
+          </a:p>
+        </p:txBody>
+      </p:sp>
+      <p:sp>
+        <p:nvSpPr>
+          <p:cNvPr id="3" name="Rectangle 2"/>
+          <p:cNvSpPr/>
+          <p:nvPr/>
+        </p:nvSpPr>
+        <p:spPr>
+          <a:xfrm>
+            <a:off x="0" y="0"/>
+            <a:ext cx="12191695" cy="1051560"/>
+          </a:xfrm>
+          <a:prstGeom prst="rect">
+            <a:avLst/>
+          </a:prstGeom>
+          <a:solidFill>
+            <a:srgbClr val="26251E"/>
+          </a:solidFill>
+          <a:ln>
+            <a:noFill/>
+          </a:ln>
+        </p:spPr>
+        <p:style>
+          <a:lnRef idx="1">
+            <a:schemeClr val="accent1"/>
+          </a:lnRef>
+          <a:fillRef idx="3">
+            <a:schemeClr val="accent1"/>
+          </a:fillRef>
+          <a:effectRef idx="2">
+            <a:schemeClr val="accent1"/>
+          </a:effectRef>
+          <a:fontRef idx="minor">
+            <a:schemeClr val="lt1"/>
+          </a:fontRef>
+        </p:style>
+        <p:txBody>
+          <a:bodyPr rtlCol="0" anchor="ctr"/>
+          <a:lstStyle/>
+          <a:p>
+            <a:pPr algn="ctr"/>
+          </a:p>
+        </p:txBody>
+      </p:sp>
+      <p:pic>
+        <p:nvPicPr>
+          <p:cNvPr id="4" name="Picture 3" descr="cursor-lockup-light.png"/>
+          <p:cNvPicPr>
+            <a:picLocks noChangeAspect="1"/>
+          </p:cNvPicPr>
+          <p:nvPr/>
+        </p:nvPicPr>
+        <p:blipFill>
+          <a:blip r:embed="rId2"/>
+          <a:stretch>
+            <a:fillRect/>
+          </a:stretch>
+        </p:blipFill>
+        <p:spPr>
+          <a:xfrm>
+            <a:off x="640080" y="292608"/>
+            <a:ext cx="1234440" cy="293494"/>
+          </a:xfrm>
+          <a:prstGeom prst="rect">
+            <a:avLst/>
+          </a:prstGeom>
+        </p:spPr>
+      </p:pic>
+      <p:sp>
+        <p:nvSpPr>
+          <p:cNvPr id="5" name="TextBox 4"/>
+          <p:cNvSpPr txBox="1"/>
+          <p:nvPr/>
+        </p:nvSpPr>
+        <p:spPr>
+          <a:xfrm>
+            <a:off x="2103120" y="292608"/>
+            <a:ext cx="9326880" cy="502920"/>
+          </a:xfrm>
+          <a:prstGeom prst="rect">
+            <a:avLst/>
+          </a:prstGeom>
+          <a:noFill/>
+        </p:spPr>
+        <p:txBody>
+          <a:bodyPr wrap="square" anchor="t">
+            <a:spAutoFit/>
+          </a:bodyPr>
+          <a:lstStyle/>
+          <a:p>
+            <a:pPr algn="l"/>
+            <a:r>
+              <a:rPr sz="2200" b="0">
+                <a:solidFill>
+                  <a:srgbClr val="FFFFFF"/>
+                </a:solidFill>
+                <a:latin typeface="Arial"/>
+              </a:rPr>
+              <a:t>Close — up-level, don’t rebuild</a:t>
+            </a:r>
+          </a:p>
+        </p:txBody>
+      </p:sp>
+      <p:sp>
+        <p:nvSpPr>
+          <p:cNvPr id="6" name="Rectangle 5"/>
+          <p:cNvSpPr/>
+          <p:nvPr/>
+        </p:nvSpPr>
+        <p:spPr>
+          <a:xfrm>
+            <a:off x="0" y="1051560"/>
+            <a:ext cx="12191695" cy="54864"/>
+          </a:xfrm>
+          <a:prstGeom prst="rect">
+            <a:avLst/>
+          </a:prstGeom>
+          <a:solidFill>
+            <a:srgbClr val="F54E00"/>
+          </a:solidFill>
+          <a:ln>
+            <a:noFill/>
+          </a:ln>
+        </p:spPr>
+        <p:style>
+          <a:lnRef idx="1">
+            <a:schemeClr val="accent1"/>
+          </a:lnRef>
+          <a:fillRef idx="3">
+            <a:schemeClr val="accent1"/>
+          </a:fillRef>
+          <a:effectRef idx="2">
+            <a:schemeClr val="accent1"/>
+          </a:effectRef>
+          <a:fontRef idx="minor">
+            <a:schemeClr val="lt1"/>
+          </a:fontRef>
+        </p:style>
+        <p:txBody>
+          <a:bodyPr rtlCol="0" anchor="ctr"/>
+          <a:lstStyle/>
+          <a:p>
+            <a:pPr algn="ctr"/>
+          </a:p>
+        </p:txBody>
+      </p:sp>
+      <p:sp>
+        <p:nvSpPr>
+          <p:cNvPr id="7" name="TextBox 6"/>
+          <p:cNvSpPr txBox="1"/>
+          <p:nvPr/>
+        </p:nvSpPr>
+        <p:spPr>
+          <a:xfrm>
+            <a:off x="731520" y="1371600"/>
+            <a:ext cx="10607040" cy="4663440"/>
+          </a:xfrm>
+          <a:prstGeom prst="rect">
+            <a:avLst/>
+          </a:prstGeom>
+          <a:noFill/>
+        </p:spPr>
+        <p:txBody>
+          <a:bodyPr wrap="square">
+            <a:spAutoFit/>
+          </a:bodyPr>
+          <a:lstStyle/>
           <a:p>
             <a:pPr algn="l">
               <a:spcAft>
@@ -13713,7 +13095,71 @@
                 </a:solidFill>
                 <a:latin typeface="Arial"/>
               </a:rPr>
-              <a:t>•  Lead as a player-coach so the floor rises with the ceiling</a:t>
+              <a:t>•  Diagnose qualified vs unqualified + funnel leaks with AE truth</a:t>
+            </a:r>
+          </a:p>
+          <a:p>
+            <a:pPr algn="l">
+              <a:spcAft>
+                <a:spcPts val="1100"/>
+              </a:spcAft>
+            </a:pPr>
+            <a:r>
+              <a:rPr sz="1700" b="0">
+                <a:solidFill>
+                  <a:srgbClr val="26251E"/>
+                </a:solidFill>
+                <a:latin typeface="Arial"/>
+              </a:rPr>
+              <a:t>•  Protect the Cursor pitch and right-person discipline already working</a:t>
+            </a:r>
+          </a:p>
+          <a:p>
+            <a:pPr algn="l">
+              <a:spcAft>
+                <a:spcPts val="1100"/>
+              </a:spcAft>
+            </a:pPr>
+            <a:r>
+              <a:rPr sz="1700" b="0">
+                <a:solidFill>
+                  <a:srgbClr val="26251E"/>
+                </a:solidFill>
+                <a:latin typeface="Arial"/>
+              </a:rPr>
+              <a:t>•  Train openers / objections / discovery — then raise activity</a:t>
+            </a:r>
+          </a:p>
+          <a:p>
+            <a:pPr algn="l">
+              <a:spcAft>
+                <a:spcPts val="1100"/>
+              </a:spcAft>
+            </a:pPr>
+            <a:r>
+              <a:rPr sz="1700" b="0">
+                <a:solidFill>
+                  <a:srgbClr val="26251E"/>
+                </a:solidFill>
+                <a:latin typeface="Arial"/>
+              </a:rPr>
+              <a:t>•  Faster loops with Growth, AEs, SEs — trains on time</a:t>
+            </a:r>
+          </a:p>
+          <a:p>
+            <a:pPr algn="l">
+              <a:spcAft>
+                <a:spcPts val="1100"/>
+              </a:spcAft>
+            </a:pPr>
+            <a:r>
+              <a:rPr sz="1700" b="0">
+                <a:solidFill>
+                  <a:srgbClr val="26251E"/>
+                </a:solidFill>
+                <a:latin typeface="Arial"/>
+              </a:rPr>
+              <a:t>•  Player-coach: Tell → Show → Observe → Feedback</a:t>
             </a:r>
           </a:p>
           <a:p>
@@ -13990,7 +13436,7 @@
                 </a:solidFill>
                 <a:latin typeface="Arial"/>
               </a:rPr>
-              <a:t>•  Part 2 (12 min) — Fundamentals: hire, coach, run as a player-coach</a:t>
+              <a:t>•  Part 2 (12 min) — AI-era SDR, hiring bar, Tell→Show→Observe coaching</a:t>
             </a:r>
           </a:p>
           <a:p>
@@ -14006,7 +13452,7 @@
                 </a:solidFill>
                 <a:latin typeface="Arial"/>
               </a:rPr>
-              <a:t>•  Part 3 (10 min) — Craft: live pitch, personas, why Cursor wins (Copilot + Claude Code)</a:t>
+              <a:t>•  Part 3 (~10 min, partly live) — Pitch, personas, attention, why we win</a:t>
             </a:r>
           </a:p>
           <a:p>

</xml_diff>

<commit_message>
Limit competitive framing to Copilot and Claude Code
Replace the broad market map with the challenge’s two frames only, and strip Windsurf, Codex, and other named competitors from slides, notes, and prep history.

Co-authored-by: dempseli01-stack <dempseli01-stack@users.noreply.github.com>
</commit_message>
<xml_diff>
--- a/Lindsey_Presentation.pptx
+++ b/Lindsey_Presentation.pptx
@@ -1386,7 +1386,7 @@
           <a:p/>
           <a:p>
             <a:r>
-              <a:t>I’d ask where engineering time actually goes — keep-the-lights-on, refactor, innovate, moonshot — because that’s where capacity for the projects that matter is hiding. The software factory frame: ideas in, valuable outputs out. If Copilot, Claude Code, or Codex is already in, I don’t trash-talk. I meet them on the maturity curve: assisted, agentic, cloud agents, governed factory — and ask where the team is stuck.</a:t>
+              <a:t>I’d ask where engineering time actually goes — keep-the-lights-on, refactor, innovate, moonshot — because that’s where capacity for the projects that matter is hiding. The software factory frame: ideas in, valuable outputs out. If Copilot or Claude Code is already in, I don’t trash-talk — I use the challenge frames. I meet them on the maturity curve: assisted, agentic, cloud agents, governed factory — and ask where the team is stuck.</a:t>
             </a:r>
           </a:p>
           <a:p/>
@@ -1750,7 +1750,7 @@
           <a:p/>
           <a:p>
             <a:r>
-              <a:t>To a skeptical engineering leader in two sentences: Cursor doesn’t win by claiming the permanently smarter model. We win by applying intelligence better across real engineering workflows — and giving the enterprise the control plane to standardize that without shadow AI or wasted tokens.</a:t>
+              <a:t>To a skeptical engineering leader in two sentences: Cursor doesn’t win by claiming the permanently smarter model. We win by applying intelligence better across real engineering workflows — and giving the enterprise the control plane to standardize that without ungoverned AI sprawl or wasted tokens.</a:t>
             </a:r>
           </a:p>
         </p:txBody>
@@ -2400,37 +2400,25 @@
           <a:lstStyle/>
           <a:p>
             <a:r>
-              <a:t>Quick market context, because it shapes how we coach messaging.</a:t>
+              <a:t>For competitive fluency, I’d train the team on two frames only — the ones that show up in the challenge and in the field: GitHub Copilot and Claude Code.</a:t>
             </a:r>
           </a:p>
           <a:p/>
           <a:p>
             <a:r>
-              <a:t>Agentic coding is now a two-layer race.</a:t>
+              <a:t>Versus GitHub Copilot: Copilot is often understood as helping developers write code faster. Cursor is an AI-native environment for completing broader tasks across a codebase. The themes are simple — snippet help to task completion, local suggestions to broader codebase context, isolated assistance to workflow support, point solution to a more integrated development experience.</a:t>
             </a:r>
           </a:p>
           <a:p/>
           <a:p>
             <a:r>
-              <a:t>Layer one is the harness and product layer — how the system plans, uses tools, navigates repositories, and fits developer workflow. That’s where Cursor has already built commercial strength, and it’s what buyers feel in a first conversation.</a:t>
+              <a:t>Versus Claude Code: it comes up most frequently in recent conversations. We do not need to argue that Claude Code is weak, and our edge is usually not that Cursor has exclusive access to better intelligence. It’s that Cursor applies intelligence more effectively across real engineering workflows — model neutrality instead of single-provider dependence, stronger SDLC integration through tools like Bugbot, better support for large complex codebases, faster time to value across a broader team, and a more complete environment for planning, writing, reviewing, and iterating.</a:t>
             </a:r>
           </a:p>
           <a:p/>
           <a:p>
             <a:r>
-              <a:t>Layer two is the model layer — reasoning quality and long-horizon coding performance. Composer is Cursor’s coding-specialist model path, and that layer continues to strengthen.</a:t>
-            </a:r>
-          </a:p>
-          <a:p/>
-          <a:p>
-            <a:r>
-              <a:t>Model neutrality still matters, because the best model changes over time, and the frontier labs can be both suppliers and competitors.</a:t>
-            </a:r>
-          </a:p>
-          <a:p/>
-          <a:p>
-            <a:r>
-              <a:t>For EMEA SDRs, the implication is simple: sell the system buyers can feel today — workflow, context, and execution — and stay fluent on where the model layer is going. I won’t turn customer calls into infrastructure or acquisition conversations.</a:t>
+              <a:t>Those are the only competitive frames I’d standardize. Everything else stays out of the talk track.</a:t>
             </a:r>
           </a:p>
         </p:txBody>
@@ -7006,7 +6994,7 @@
                 </a:solidFill>
                 <a:latin typeface="Arial"/>
               </a:rPr>
-              <a:t>Privacy Mode / ZDR · SOC 2 Type II · CMEK · reduce shadow AI risk</a:t>
+              <a:t>Privacy Mode / ZDR · SOC 2 Type II · CMEK · reduce ungoverned AI risk</a:t>
             </a:r>
           </a:p>
         </p:txBody>
@@ -7439,7 +7427,7 @@
                 </a:solidFill>
                 <a:latin typeface="Arial"/>
               </a:rPr>
-              <a:t>Best model changes. No single-vendor lock-in. Labs are suppliers and competitors — optionality is strategic.</a:t>
+              <a:t>Best model changes. No single-provider dependence — optionality as models and economics shift.</a:t>
             </a:r>
           </a:p>
         </p:txBody>
@@ -11148,7 +11136,7 @@
                 </a:solidFill>
                 <a:latin typeface="Arial"/>
               </a:rPr>
-              <a:t>Software factory: ideas in → valuable outputs out. Competitor in? Don’t trash-talk — meet them on the curve.</a:t>
+              <a:t>Software factory: ideas in → valuable outputs out. Copilot or Claude Code in? Don’t trash-talk — use the two frames.</a:t>
             </a:r>
           </a:p>
         </p:txBody>
@@ -11839,7 +11827,7 @@
                 </a:solidFill>
                 <a:latin typeface="Arial"/>
               </a:rPr>
-              <a:t>•  Security / Platform: governed adoption · Privacy Mode · SSO/SCIM/audit · kill shadow AI</a:t>
+              <a:t>•  Security / Platform: governed adoption · Privacy Mode · SSO/SCIM/audit · reduce ungoverned AI risk</a:t>
             </a:r>
           </a:p>
           <a:p>
@@ -12850,7 +12838,7 @@
                 </a:solidFill>
                 <a:latin typeface="Arial"/>
               </a:rPr>
-              <a:t>•  One-liner: we don’t win by claiming the permanently smarter model — we win by applying intelligence better, with the control plane to standardize it</a:t>
+              <a:t>•  One-liner: we don’t win by claiming the permanently smarter model — we win by applying intelligence better across real workflows, with a control plane to standardize it</a:t>
             </a:r>
           </a:p>
         </p:txBody>
@@ -16161,7 +16149,7 @@
                 </a:solidFill>
                 <a:latin typeface="Arial"/>
               </a:rPr>
-              <a:t>Competitor differentiation — market map</a:t>
+              <a:t>Competitive framing — Copilot &amp; Claude Code only</a:t>
             </a:r>
           </a:p>
         </p:txBody>
@@ -16217,8 +16205,86 @@
         </p:nvSpPr>
         <p:spPr>
           <a:xfrm>
-            <a:off x="548640" y="1234440"/>
-            <a:ext cx="5394960" cy="1417320"/>
+            <a:off x="548640" y="1188720"/>
+            <a:ext cx="11018520" cy="685800"/>
+          </a:xfrm>
+          <a:prstGeom prst="rect">
+            <a:avLst/>
+          </a:prstGeom>
+          <a:solidFill>
+            <a:srgbClr val="26251E"/>
+          </a:solidFill>
+          <a:ln>
+            <a:noFill/>
+          </a:ln>
+        </p:spPr>
+        <p:style>
+          <a:lnRef idx="1">
+            <a:schemeClr val="accent1"/>
+          </a:lnRef>
+          <a:fillRef idx="3">
+            <a:schemeClr val="accent1"/>
+          </a:fillRef>
+          <a:effectRef idx="2">
+            <a:schemeClr val="accent1"/>
+          </a:effectRef>
+          <a:fontRef idx="minor">
+            <a:schemeClr val="lt1"/>
+          </a:fontRef>
+        </p:style>
+        <p:txBody>
+          <a:bodyPr rtlCol="0" anchor="ctr"/>
+          <a:lstStyle/>
+          <a:p>
+            <a:pPr algn="ctr"/>
+          </a:p>
+        </p:txBody>
+      </p:sp>
+      <p:sp>
+        <p:nvSpPr>
+          <p:cNvPr id="8" name="TextBox 7"/>
+          <p:cNvSpPr txBox="1"/>
+          <p:nvPr/>
+        </p:nvSpPr>
+        <p:spPr>
+          <a:xfrm>
+            <a:off x="731520" y="1280160"/>
+            <a:ext cx="10607040" cy="502920"/>
+          </a:xfrm>
+          <a:prstGeom prst="rect">
+            <a:avLst/>
+          </a:prstGeom>
+          <a:noFill/>
+        </p:spPr>
+        <p:txBody>
+          <a:bodyPr wrap="square" anchor="t">
+            <a:spAutoFit/>
+          </a:bodyPr>
+          <a:lstStyle/>
+          <a:p>
+            <a:pPr algn="l"/>
+            <a:r>
+              <a:rPr sz="1300" b="0">
+                <a:solidFill>
+                  <a:srgbClr val="EFEEE8"/>
+                </a:solidFill>
+                <a:latin typeface="Arial"/>
+              </a:rPr>
+              <a:t>We don’t argue anyone is weak. Edge = apply intelligence more effectively across real engineering workflows — not exclusive smarter-model access.</a:t>
+            </a:r>
+          </a:p>
+        </p:txBody>
+      </p:sp>
+      <p:sp>
+        <p:nvSpPr>
+          <p:cNvPr id="9" name="Rectangle 8"/>
+          <p:cNvSpPr/>
+          <p:nvPr/>
+        </p:nvSpPr>
+        <p:spPr>
+          <a:xfrm>
+            <a:off x="548640" y="2057400"/>
+            <a:ext cx="5394960" cy="4160520"/>
           </a:xfrm>
           <a:prstGeom prst="rect">
             <a:avLst/>
@@ -16254,14 +16320,57 @@
       </p:sp>
       <p:sp>
         <p:nvSpPr>
-          <p:cNvPr id="8" name="TextBox 7"/>
+          <p:cNvPr id="10" name="Rectangle 9"/>
+          <p:cNvSpPr/>
+          <p:nvPr/>
+        </p:nvSpPr>
+        <p:spPr>
+          <a:xfrm>
+            <a:off x="777240" y="2286000"/>
+            <a:ext cx="822960" cy="54864"/>
+          </a:xfrm>
+          <a:prstGeom prst="rect">
+            <a:avLst/>
+          </a:prstGeom>
+          <a:solidFill>
+            <a:srgbClr val="F54E00"/>
+          </a:solidFill>
+          <a:ln>
+            <a:noFill/>
+          </a:ln>
+        </p:spPr>
+        <p:style>
+          <a:lnRef idx="1">
+            <a:schemeClr val="accent1"/>
+          </a:lnRef>
+          <a:fillRef idx="3">
+            <a:schemeClr val="accent1"/>
+          </a:fillRef>
+          <a:effectRef idx="2">
+            <a:schemeClr val="accent1"/>
+          </a:effectRef>
+          <a:fontRef idx="minor">
+            <a:schemeClr val="lt1"/>
+          </a:fontRef>
+        </p:style>
+        <p:txBody>
+          <a:bodyPr rtlCol="0" anchor="ctr"/>
+          <a:lstStyle/>
+          <a:p>
+            <a:pPr algn="ctr"/>
+          </a:p>
+        </p:txBody>
+      </p:sp>
+      <p:sp>
+        <p:nvSpPr>
+          <p:cNvPr id="11" name="TextBox 10"/>
           <p:cNvSpPr txBox="1"/>
           <p:nvPr/>
         </p:nvSpPr>
         <p:spPr>
           <a:xfrm>
-            <a:off x="731520" y="1325880"/>
-            <a:ext cx="5029200" cy="274320"/>
+            <a:off x="777240" y="2514600"/>
+            <a:ext cx="4937760" cy="320040"/>
           </a:xfrm>
           <a:prstGeom prst="rect">
             <a:avLst/>
@@ -16276,27 +16385,27 @@
           <a:p>
             <a:pPr algn="l"/>
             <a:r>
-              <a:rPr sz="1400" b="1">
+              <a:rPr sz="1600" b="1">
                 <a:solidFill>
                   <a:srgbClr val="26251E"/>
                 </a:solidFill>
                 <a:latin typeface="Arial"/>
               </a:rPr>
-              <a:t>AI-native IDE</a:t>
-            </a:r>
-          </a:p>
-        </p:txBody>
-      </p:sp>
-      <p:sp>
-        <p:nvSpPr>
-          <p:cNvPr id="9" name="TextBox 8"/>
+              <a:t>Cursor vs GitHub Copilot</a:t>
+            </a:r>
+          </a:p>
+        </p:txBody>
+      </p:sp>
+      <p:sp>
+        <p:nvSpPr>
+          <p:cNvPr id="12" name="TextBox 11"/>
           <p:cNvSpPr txBox="1"/>
           <p:nvPr/>
         </p:nvSpPr>
         <p:spPr>
           <a:xfrm>
-            <a:off x="731520" y="1645920"/>
-            <a:ext cx="5029200" cy="822960"/>
+            <a:off x="777240" y="2926080"/>
+            <a:ext cx="4937760" cy="640080"/>
           </a:xfrm>
           <a:prstGeom prst="rect">
             <a:avLst/>
@@ -16311,28 +16420,114 @@
           <a:p>
             <a:pPr algn="l"/>
             <a:r>
-              <a:rPr sz="1300" b="0">
+              <a:rPr sz="1200" b="0">
                 <a:solidFill>
                   <a:srgbClr val="807D72"/>
                 </a:solidFill>
                 <a:latin typeface="Arial"/>
               </a:rPr>
-              <a:t>Cursor · Windsurf
-Rebuild the editor around agents — not bolt AI onto an existing one.</a:t>
-            </a:r>
-          </a:p>
-        </p:txBody>
-      </p:sp>
-      <p:sp>
-        <p:nvSpPr>
-          <p:cNvPr id="10" name="Rectangle 9"/>
+              <a:t>Copilot is often understood as helping developers write code faster. Cursor is an AI-native environment for completing broader tasks across a codebase.</a:t>
+            </a:r>
+          </a:p>
+        </p:txBody>
+      </p:sp>
+      <p:sp>
+        <p:nvSpPr>
+          <p:cNvPr id="13" name="TextBox 12"/>
+          <p:cNvSpPr txBox="1"/>
+          <p:nvPr/>
+        </p:nvSpPr>
+        <p:spPr>
+          <a:xfrm>
+            <a:off x="777240" y="3703320"/>
+            <a:ext cx="4937760" cy="2286000"/>
+          </a:xfrm>
+          <a:prstGeom prst="rect">
+            <a:avLst/>
+          </a:prstGeom>
+          <a:noFill/>
+        </p:spPr>
+        <p:txBody>
+          <a:bodyPr wrap="square">
+            <a:spAutoFit/>
+          </a:bodyPr>
+          <a:lstStyle/>
+          <a:p>
+            <a:pPr algn="l">
+              <a:spcAft>
+                <a:spcPts val="800"/>
+              </a:spcAft>
+            </a:pPr>
+            <a:r>
+              <a:rPr sz="1400" b="0">
+                <a:solidFill>
+                  <a:srgbClr val="26251E"/>
+                </a:solidFill>
+                <a:latin typeface="Arial"/>
+              </a:rPr>
+              <a:t>•  Snippet help → task completion</a:t>
+            </a:r>
+          </a:p>
+          <a:p>
+            <a:pPr algn="l">
+              <a:spcAft>
+                <a:spcPts val="800"/>
+              </a:spcAft>
+            </a:pPr>
+            <a:r>
+              <a:rPr sz="1400" b="0">
+                <a:solidFill>
+                  <a:srgbClr val="26251E"/>
+                </a:solidFill>
+                <a:latin typeface="Arial"/>
+              </a:rPr>
+              <a:t>•  Local suggestions → broader codebase context</a:t>
+            </a:r>
+          </a:p>
+          <a:p>
+            <a:pPr algn="l">
+              <a:spcAft>
+                <a:spcPts val="800"/>
+              </a:spcAft>
+            </a:pPr>
+            <a:r>
+              <a:rPr sz="1400" b="0">
+                <a:solidFill>
+                  <a:srgbClr val="26251E"/>
+                </a:solidFill>
+                <a:latin typeface="Arial"/>
+              </a:rPr>
+              <a:t>•  Isolated assistance → workflow support</a:t>
+            </a:r>
+          </a:p>
+          <a:p>
+            <a:pPr algn="l">
+              <a:spcAft>
+                <a:spcPts val="800"/>
+              </a:spcAft>
+            </a:pPr>
+            <a:r>
+              <a:rPr sz="1400" b="0">
+                <a:solidFill>
+                  <a:srgbClr val="26251E"/>
+                </a:solidFill>
+                <a:latin typeface="Arial"/>
+              </a:rPr>
+              <a:t>•  Point solution → more integrated development experience</a:t>
+            </a:r>
+          </a:p>
+        </p:txBody>
+      </p:sp>
+      <p:sp>
+        <p:nvSpPr>
+          <p:cNvPr id="14" name="Rectangle 13"/>
           <p:cNvSpPr/>
           <p:nvPr/>
         </p:nvSpPr>
         <p:spPr>
           <a:xfrm>
-            <a:off x="6172200" y="1234440"/>
-            <a:ext cx="5394960" cy="1417320"/>
+            <a:off x="6172200" y="2057400"/>
+            <a:ext cx="5394960" cy="4160520"/>
           </a:xfrm>
           <a:prstGeom prst="rect">
             <a:avLst/>
@@ -16368,91 +16563,20 @@
       </p:sp>
       <p:sp>
         <p:nvSpPr>
-          <p:cNvPr id="11" name="TextBox 10"/>
-          <p:cNvSpPr txBox="1"/>
-          <p:nvPr/>
-        </p:nvSpPr>
-        <p:spPr>
-          <a:xfrm>
-            <a:off x="6355080" y="1325880"/>
-            <a:ext cx="5029200" cy="274320"/>
-          </a:xfrm>
-          <a:prstGeom prst="rect">
-            <a:avLst/>
-          </a:prstGeom>
-          <a:noFill/>
-        </p:spPr>
-        <p:txBody>
-          <a:bodyPr wrap="square" anchor="t">
-            <a:spAutoFit/>
-          </a:bodyPr>
-          <a:lstStyle/>
-          <a:p>
-            <a:pPr algn="l"/>
-            <a:r>
-              <a:rPr sz="1400" b="1">
-                <a:solidFill>
-                  <a:srgbClr val="26251E"/>
-                </a:solidFill>
-                <a:latin typeface="Arial"/>
-              </a:rPr>
-              <a:t>IDE plugin / extension</a:t>
-            </a:r>
-          </a:p>
-        </p:txBody>
-      </p:sp>
-      <p:sp>
-        <p:nvSpPr>
-          <p:cNvPr id="12" name="TextBox 11"/>
-          <p:cNvSpPr txBox="1"/>
-          <p:nvPr/>
-        </p:nvSpPr>
-        <p:spPr>
-          <a:xfrm>
-            <a:off x="6355080" y="1645920"/>
-            <a:ext cx="5029200" cy="822960"/>
-          </a:xfrm>
-          <a:prstGeom prst="rect">
-            <a:avLst/>
-          </a:prstGeom>
-          <a:noFill/>
-        </p:spPr>
-        <p:txBody>
-          <a:bodyPr wrap="square" anchor="t">
-            <a:spAutoFit/>
-          </a:bodyPr>
-          <a:lstStyle/>
-          <a:p>
-            <a:pPr algn="l"/>
-            <a:r>
-              <a:rPr sz="1300" b="0">
-                <a:solidFill>
-                  <a:srgbClr val="807D72"/>
-                </a:solidFill>
-                <a:latin typeface="Arial"/>
-              </a:rPr>
-              <a:t>GitHub Copilot · JetBrains AI · Amazon Q
-Keep the current toolchain; add AI as a layer.</a:t>
-            </a:r>
-          </a:p>
-        </p:txBody>
-      </p:sp>
-      <p:sp>
-        <p:nvSpPr>
-          <p:cNvPr id="13" name="Rectangle 12"/>
+          <p:cNvPr id="15" name="Rectangle 14"/>
           <p:cNvSpPr/>
           <p:nvPr/>
         </p:nvSpPr>
         <p:spPr>
           <a:xfrm>
-            <a:off x="548640" y="2834640"/>
-            <a:ext cx="5394960" cy="2148840"/>
+            <a:off x="6400800" y="2286000"/>
+            <a:ext cx="822960" cy="54864"/>
           </a:xfrm>
           <a:prstGeom prst="rect">
             <a:avLst/>
           </a:prstGeom>
           <a:solidFill>
-            <a:srgbClr val="FFFFFF"/>
+            <a:srgbClr val="F54E00"/>
           </a:solidFill>
           <a:ln>
             <a:noFill/>
@@ -16482,57 +16606,14 @@
       </p:sp>
       <p:sp>
         <p:nvSpPr>
-          <p:cNvPr id="14" name="Rectangle 13"/>
-          <p:cNvSpPr/>
-          <p:nvPr/>
-        </p:nvSpPr>
-        <p:spPr>
-          <a:xfrm>
-            <a:off x="548640" y="2834640"/>
-            <a:ext cx="5394960" cy="384048"/>
-          </a:xfrm>
-          <a:prstGeom prst="rect">
-            <a:avLst/>
-          </a:prstGeom>
-          <a:solidFill>
-            <a:srgbClr val="26251E"/>
-          </a:solidFill>
-          <a:ln>
-            <a:noFill/>
-          </a:ln>
-        </p:spPr>
-        <p:style>
-          <a:lnRef idx="1">
-            <a:schemeClr val="accent1"/>
-          </a:lnRef>
-          <a:fillRef idx="3">
-            <a:schemeClr val="accent1"/>
-          </a:fillRef>
-          <a:effectRef idx="2">
-            <a:schemeClr val="accent1"/>
-          </a:effectRef>
-          <a:fontRef idx="minor">
-            <a:schemeClr val="lt1"/>
-          </a:fontRef>
-        </p:style>
-        <p:txBody>
-          <a:bodyPr rtlCol="0" anchor="ctr"/>
-          <a:lstStyle/>
-          <a:p>
-            <a:pPr algn="ctr"/>
-          </a:p>
-        </p:txBody>
-      </p:sp>
-      <p:sp>
-        <p:nvSpPr>
-          <p:cNvPr id="15" name="TextBox 14"/>
+          <p:cNvPr id="16" name="TextBox 15"/>
           <p:cNvSpPr txBox="1"/>
           <p:nvPr/>
         </p:nvSpPr>
         <p:spPr>
           <a:xfrm>
-            <a:off x="731520" y="2880360"/>
-            <a:ext cx="5029200" cy="320040"/>
+            <a:off x="6400800" y="2514600"/>
+            <a:ext cx="4937760" cy="320040"/>
           </a:xfrm>
           <a:prstGeom prst="rect">
             <a:avLst/>
@@ -16547,27 +16628,62 @@
           <a:p>
             <a:pPr algn="l"/>
             <a:r>
-              <a:rPr sz="1300" b="1">
-                <a:solidFill>
-                  <a:srgbClr val="F54E00"/>
-                </a:solidFill>
-                <a:latin typeface="Arial"/>
-              </a:rPr>
-              <a:t>Layer 1 — Harness / product</a:t>
-            </a:r>
-          </a:p>
-        </p:txBody>
-      </p:sp>
-      <p:sp>
-        <p:nvSpPr>
-          <p:cNvPr id="16" name="TextBox 15"/>
+              <a:rPr sz="1600" b="1">
+                <a:solidFill>
+                  <a:srgbClr val="26251E"/>
+                </a:solidFill>
+                <a:latin typeface="Arial"/>
+              </a:rPr>
+              <a:t>Cursor vs Claude Code</a:t>
+            </a:r>
+          </a:p>
+        </p:txBody>
+      </p:sp>
+      <p:sp>
+        <p:nvSpPr>
+          <p:cNvPr id="17" name="TextBox 16"/>
           <p:cNvSpPr txBox="1"/>
           <p:nvPr/>
         </p:nvSpPr>
         <p:spPr>
           <a:xfrm>
-            <a:off x="731520" y="3383280"/>
-            <a:ext cx="5029200" cy="1417320"/>
+            <a:off x="6400800" y="2926080"/>
+            <a:ext cx="4937760" cy="640080"/>
+          </a:xfrm>
+          <a:prstGeom prst="rect">
+            <a:avLst/>
+          </a:prstGeom>
+          <a:noFill/>
+        </p:spPr>
+        <p:txBody>
+          <a:bodyPr wrap="square" anchor="t">
+            <a:spAutoFit/>
+          </a:bodyPr>
+          <a:lstStyle/>
+          <a:p>
+            <a:pPr algn="l"/>
+            <a:r>
+              <a:rPr sz="1200" b="0">
+                <a:solidFill>
+                  <a:srgbClr val="807D72"/>
+                </a:solidFill>
+                <a:latin typeface="Arial"/>
+              </a:rPr>
+              <a:t>Claude Code comes up most in recent conversations. Don’t trash-talk. Our edge usually isn’t exclusive better intelligence.</a:t>
+            </a:r>
+          </a:p>
+        </p:txBody>
+      </p:sp>
+      <p:sp>
+        <p:nvSpPr>
+          <p:cNvPr id="18" name="TextBox 17"/>
+          <p:cNvSpPr txBox="1"/>
+          <p:nvPr/>
+        </p:nvSpPr>
+        <p:spPr>
+          <a:xfrm>
+            <a:off x="6400800" y="3703320"/>
+            <a:ext cx="4937760" cy="2286000"/>
           </a:xfrm>
           <a:prstGeom prst="rect">
             <a:avLst/>
@@ -16582,7 +16698,7 @@
           <a:p>
             <a:pPr algn="l">
               <a:spcAft>
-                <a:spcPts val="500"/>
+                <a:spcPts val="600"/>
               </a:spcAft>
             </a:pPr>
             <a:r>
@@ -16592,13 +16708,13 @@
                 </a:solidFill>
                 <a:latin typeface="Arial"/>
               </a:rPr>
-              <a:t>•  Plans, tools, repo navigation, workflow fit</a:t>
+              <a:t>•  Model neutrality vs single-provider dependence</a:t>
             </a:r>
           </a:p>
           <a:p>
             <a:pPr algn="l">
               <a:spcAft>
-                <a:spcPts val="500"/>
+                <a:spcPts val="600"/>
               </a:spcAft>
             </a:pPr>
             <a:r>
@@ -16608,13 +16724,13 @@
                 </a:solidFill>
                 <a:latin typeface="Arial"/>
               </a:rPr>
-              <a:t>•  What buyers feel in first conversations</a:t>
+              <a:t>•  Stronger SDLC integration (e.g. Bugbot)</a:t>
             </a:r>
           </a:p>
           <a:p>
             <a:pPr algn="l">
               <a:spcAft>
-                <a:spcPts val="500"/>
+                <a:spcPts val="600"/>
               </a:spcAft>
             </a:pPr>
             <a:r>
@@ -16624,157 +16740,13 @@
                 </a:solidFill>
                 <a:latin typeface="Arial"/>
               </a:rPr>
-              <a:t>•  Cursor’s established commercial strength</a:t>
-            </a:r>
-          </a:p>
-        </p:txBody>
-      </p:sp>
-      <p:sp>
-        <p:nvSpPr>
-          <p:cNvPr id="17" name="Rectangle 16"/>
-          <p:cNvSpPr/>
-          <p:nvPr/>
-        </p:nvSpPr>
-        <p:spPr>
-          <a:xfrm>
-            <a:off x="6172200" y="2834640"/>
-            <a:ext cx="5394960" cy="2148840"/>
-          </a:xfrm>
-          <a:prstGeom prst="rect">
-            <a:avLst/>
-          </a:prstGeom>
-          <a:solidFill>
-            <a:srgbClr val="FFFFFF"/>
-          </a:solidFill>
-          <a:ln>
-            <a:noFill/>
-          </a:ln>
-        </p:spPr>
-        <p:style>
-          <a:lnRef idx="1">
-            <a:schemeClr val="accent1"/>
-          </a:lnRef>
-          <a:fillRef idx="3">
-            <a:schemeClr val="accent1"/>
-          </a:fillRef>
-          <a:effectRef idx="2">
-            <a:schemeClr val="accent1"/>
-          </a:effectRef>
-          <a:fontRef idx="minor">
-            <a:schemeClr val="lt1"/>
-          </a:fontRef>
-        </p:style>
-        <p:txBody>
-          <a:bodyPr rtlCol="0" anchor="ctr"/>
-          <a:lstStyle/>
-          <a:p>
-            <a:pPr algn="ctr"/>
-          </a:p>
-        </p:txBody>
-      </p:sp>
-      <p:sp>
-        <p:nvSpPr>
-          <p:cNvPr id="18" name="Rectangle 17"/>
-          <p:cNvSpPr/>
-          <p:nvPr/>
-        </p:nvSpPr>
-        <p:spPr>
-          <a:xfrm>
-            <a:off x="6172200" y="2834640"/>
-            <a:ext cx="5394960" cy="384048"/>
-          </a:xfrm>
-          <a:prstGeom prst="rect">
-            <a:avLst/>
-          </a:prstGeom>
-          <a:solidFill>
-            <a:srgbClr val="3A3832"/>
-          </a:solidFill>
-          <a:ln>
-            <a:noFill/>
-          </a:ln>
-        </p:spPr>
-        <p:style>
-          <a:lnRef idx="1">
-            <a:schemeClr val="accent1"/>
-          </a:lnRef>
-          <a:fillRef idx="3">
-            <a:schemeClr val="accent1"/>
-          </a:fillRef>
-          <a:effectRef idx="2">
-            <a:schemeClr val="accent1"/>
-          </a:effectRef>
-          <a:fontRef idx="minor">
-            <a:schemeClr val="lt1"/>
-          </a:fontRef>
-        </p:style>
-        <p:txBody>
-          <a:bodyPr rtlCol="0" anchor="ctr"/>
-          <a:lstStyle/>
-          <a:p>
-            <a:pPr algn="ctr"/>
-          </a:p>
-        </p:txBody>
-      </p:sp>
-      <p:sp>
-        <p:nvSpPr>
-          <p:cNvPr id="19" name="TextBox 18"/>
-          <p:cNvSpPr txBox="1"/>
-          <p:nvPr/>
-        </p:nvSpPr>
-        <p:spPr>
-          <a:xfrm>
-            <a:off x="6355080" y="2880360"/>
-            <a:ext cx="5029200" cy="320040"/>
-          </a:xfrm>
-          <a:prstGeom prst="rect">
-            <a:avLst/>
-          </a:prstGeom>
-          <a:noFill/>
-        </p:spPr>
-        <p:txBody>
-          <a:bodyPr wrap="square" anchor="t">
-            <a:spAutoFit/>
-          </a:bodyPr>
-          <a:lstStyle/>
-          <a:p>
-            <a:pPr algn="l"/>
-            <a:r>
-              <a:rPr sz="1300" b="1">
-                <a:solidFill>
-                  <a:srgbClr val="FFFFFF"/>
-                </a:solidFill>
-                <a:latin typeface="Arial"/>
-              </a:rPr>
-              <a:t>Layer 2 — Model</a:t>
-            </a:r>
-          </a:p>
-        </p:txBody>
-      </p:sp>
-      <p:sp>
-        <p:nvSpPr>
-          <p:cNvPr id="20" name="TextBox 19"/>
-          <p:cNvSpPr txBox="1"/>
-          <p:nvPr/>
-        </p:nvSpPr>
-        <p:spPr>
-          <a:xfrm>
-            <a:off x="6355080" y="3383280"/>
-            <a:ext cx="5029200" cy="1417320"/>
-          </a:xfrm>
-          <a:prstGeom prst="rect">
-            <a:avLst/>
-          </a:prstGeom>
-          <a:noFill/>
-        </p:spPr>
-        <p:txBody>
-          <a:bodyPr wrap="square">
-            <a:spAutoFit/>
-          </a:bodyPr>
-          <a:lstStyle/>
+              <a:t>•  Better support for large, complex codebases</a:t>
+            </a:r>
+          </a:p>
           <a:p>
             <a:pPr algn="l">
               <a:spcAft>
-                <a:spcPts val="500"/>
+                <a:spcPts val="600"/>
               </a:spcAft>
             </a:pPr>
             <a:r>
@@ -16784,13 +16756,13 @@
                 </a:solidFill>
                 <a:latin typeface="Arial"/>
               </a:rPr>
-              <a:t>•  Reasoning + long-horizon coding quality</a:t>
+              <a:t>•  Faster time to value across a broader team</a:t>
             </a:r>
           </a:p>
           <a:p>
             <a:pPr algn="l">
               <a:spcAft>
-                <a:spcPts val="500"/>
+                <a:spcPts val="600"/>
               </a:spcAft>
             </a:pPr>
             <a:r>
@@ -16800,101 +16772,7 @@
                 </a:solidFill>
                 <a:latin typeface="Arial"/>
               </a:rPr>
-              <a:t>•  Composer = Cursor coding-specialist path</a:t>
-            </a:r>
-          </a:p>
-          <a:p>
-            <a:pPr algn="l">
-              <a:spcAft>
-                <a:spcPts val="500"/>
-              </a:spcAft>
-            </a:pPr>
-            <a:r>
-              <a:rPr sz="1300" b="0">
-                <a:solidFill>
-                  <a:srgbClr val="26251E"/>
-                </a:solidFill>
-                <a:latin typeface="Arial"/>
-              </a:rPr>
-              <a:t>•  Labs can be suppliers and competitors</a:t>
-            </a:r>
-          </a:p>
-        </p:txBody>
-      </p:sp>
-      <p:sp>
-        <p:nvSpPr>
-          <p:cNvPr id="21" name="Rectangle 20"/>
-          <p:cNvSpPr/>
-          <p:nvPr/>
-        </p:nvSpPr>
-        <p:spPr>
-          <a:xfrm>
-            <a:off x="548640" y="5166360"/>
-            <a:ext cx="11018520" cy="1051560"/>
-          </a:xfrm>
-          <a:prstGeom prst="rect">
-            <a:avLst/>
-          </a:prstGeom>
-          <a:solidFill>
-            <a:srgbClr val="26251E"/>
-          </a:solidFill>
-          <a:ln>
-            <a:noFill/>
-          </a:ln>
-        </p:spPr>
-        <p:style>
-          <a:lnRef idx="1">
-            <a:schemeClr val="accent1"/>
-          </a:lnRef>
-          <a:fillRef idx="3">
-            <a:schemeClr val="accent1"/>
-          </a:fillRef>
-          <a:effectRef idx="2">
-            <a:schemeClr val="accent1"/>
-          </a:effectRef>
-          <a:fontRef idx="minor">
-            <a:schemeClr val="lt1"/>
-          </a:fontRef>
-        </p:style>
-        <p:txBody>
-          <a:bodyPr rtlCol="0" anchor="ctr"/>
-          <a:lstStyle/>
-          <a:p>
-            <a:pPr algn="ctr"/>
-          </a:p>
-        </p:txBody>
-      </p:sp>
-      <p:sp>
-        <p:nvSpPr>
-          <p:cNvPr id="22" name="TextBox 21"/>
-          <p:cNvSpPr txBox="1"/>
-          <p:nvPr/>
-        </p:nvSpPr>
-        <p:spPr>
-          <a:xfrm>
-            <a:off x="731520" y="5303520"/>
-            <a:ext cx="10607040" cy="777240"/>
-          </a:xfrm>
-          <a:prstGeom prst="rect">
-            <a:avLst/>
-          </a:prstGeom>
-          <a:noFill/>
-        </p:spPr>
-        <p:txBody>
-          <a:bodyPr wrap="square" anchor="t">
-            <a:spAutoFit/>
-          </a:bodyPr>
-          <a:lstStyle/>
-          <a:p>
-            <a:pPr algn="l"/>
-            <a:r>
-              <a:rPr sz="1300" b="0">
-                <a:solidFill>
-                  <a:srgbClr val="EFEEE8"/>
-                </a:solidFill>
-                <a:latin typeface="Arial"/>
-              </a:rPr>
-              <a:t>Shapes:  Cursor = platform  ·  Copilot = plugin / GitHub ecosystem  ·  Claude Code = terminal agent  ·  Windsurf = Cascade IDE challenger  ·  Codex = OpenAI async agents  ·  Often the real rival = ungoverned shadow AI</a:t>
+              <a:t>•  More complete planning → writing → reviewing → iterating</a:t>
             </a:r>
           </a:p>
         </p:txBody>

</xml_diff>